<commit_message>
Rewrite slides as continuous prose; limit sample to cities
Each slide now reads as connected paragraphs instead of cards and
bullets, and the research population is principals in northern cities
only. Speaker notes and outline updated to match.

Co-Authored-By: Claude Opus 5.5 <noreply@anthropic.com>
Claude-Session: https://claude.ai/code/session_016buQrLRQHjtd4YGfeSnksc
</commit_message>
<xml_diff>
--- a/presentation/היעדרויות-מורים-מצגת-סיום.pptx
+++ b/presentation/היעדרויות-מורים-מצגת-סיום.pptx
@@ -505,11 +505,11 @@
             <a:r>
               <a:rPr lang="en-US" dirty="0"/>
               <a:t>[חנון | כדקה ורבע]
-בוקר רגיל, 7:30. מורה מתקשרת ואומרת שהיא לא תגיע היום. בתוך כמה דקות המנהל צריך להחליט: מי נכנס לכיתה, מה יקרה בשיעור, ומי ישלם את המחיר.
-הנושא שלנו הוא היעדרויות מורים. היעדרות כשלעצמה היא לא הבעיה, היא חלק מהחיים של כל בית ספר. מה שמעניין אותנו הוא מה שהמנהל עושה ברגע הזה.
-שאלת המחקר שלנו: כיצד מנהלי בתי ספר בצפון הארץ מתארים את התמודדותם עם היעדרויות מורים, ואילו אסטרטגיות ושיקולים מנחים את החלטותיהם לשמירה על רצף לימודי?
-למה דווקא השאלה הזאת? כי בכל בית ספר ראינו שאותה היעדרות יכולה להסתיים בשיעור שממשיך כרגיל, או בשעה של השגחה בלבד. ההבדל תלוי בהחלטות של המנהל.
-המחקר שלנו חשוב כי היעדרות מורים קורית כמעט בכל יום, וההחלטה של המנהל באותו בוקר קובעת אם התלמידים יקבלו שיעור אמיתי או רק השגחה.
+בוקר רגיל, שבע וחצי. מורה מתקשרת ואומרת שהיא לא תגיע היום. בתוך כמה דקות המנהל צריך להחליט: מי נכנס לכיתה, מה יקרה בשיעור, ומי מהצוות ישלם את המחיר.
+המחקר שלנו עוסק בהיעדרויות מורים. ההיעדרות עצמה היא חלק מהחיים של כל בית ספר. מה שמעניין אותנו הוא מה שהמנהל עושה ברגע הזה.
+לכן שאלת המחקר שלנו היא: כיצד מנהלי בתי ספר בערים בצפון הארץ מתארים את התמודדותם עם היעדרויות מורים, ואילו אסטרטגיות ושיקולים מנחים את החלטותיהם לשמירה על רצף לימודי?
+השאלה הזאת מעסיקה אותנו כי ראינו שאותה היעדרות יכולה להסתיים בשיעור שממשיך כרגיל, או בשעה של השגחה בלבד. ההבדל תלוי בהחלטות של המנהל.
+המחקר שלנו חשוב כי הוא מאיר את מה שקורה מאחורי הקלעים של ההחלטות האלה, שמשפיעות ישירות על הלמידה של התלמידים.
 [מעבר לאולפת]</a:t>
             </a:r>
             <a:endParaRPr lang="en-US" dirty="0"/>
@@ -599,12 +599,10 @@
             <a:r>
               <a:rPr lang="en-US" dirty="0"/>
               <a:t>[אולפת | כדקה ושלושת רבעי]
-מה למדנו מהספרות? שתי תובנות.
-הראשונה: היעדרויות מורים פוגעות בלמידה, והפגיעה גדלה כשההיעדרויות מצטברות. מחקרים גדולים בארצות הברית, של מילר ועמיתיו ושל קלוטפלטר ועמיתיו, הראו קשר בין מספר ימי ההיעדרות של המורה לבין הישגי התלמידים.
-השנייה, שהפתיעה אותנו: המנהל לא רק מגיב להיעדרות. מחקר ישראלי של שפירא־לישצ'ינסקי ורוזנבלט מצא שהאקלים שהמנהל יוצר בבית הספר קשור גם להיקף ההיעדרויות.
-ואיפה המתח? בתיאוריה, רצף לימודי הוא עניין פדגוגי: שהחומר ימשיך, שהיחסים והשגרה יישמרו. אבל בשבע וחצי בבוקר המנהל צריך קודם כול שמישהו יהיה בכיתה.
-והפער: רוב המחקר בודק כמה מורים נעדרים, למה, ומה המחיר. מעט ידוע על מה שהמנהל עושה ושוקל ברגע ההיעדרות עצמו.
-זה גם שינה את החשיבה שלנו. בהתחלה חשבנו שהבעיה לוגיסטית, רק למצוא ממלא מקום. היום אנחנו מבינים שרצף הוא פדגוגי, ארגוני ורגשי, ושהמנהל פועל גם לפני ההיעדרות ולא רק אחריה.
+מה למדנו מהספרות? קודם כול, שהיעדרויות מורים אינן עניין טכני. מחקרים גדולים, של מילר ועמיתיו ושל קלוטפלטר ועמיתיו, מצאו שהיעדרויות פוגעות בהישגי התלמידים, והפגיעה גדלה ככל שהן מצטברות.
+מה שהפתיע אותנו הוא שהמנהל לא רק מגיב להיעדרות. מחקר ישראלי של שפירא־לישצ'ינסקי ורוזנבלט מצא שהאקלים שהמנהל יוצר בבית הספר קשור גם להיקף ההיעדרויות.
+אבל כאן נוצר מתח. בתיאוריה, רצף לימודי הוא עניין פדגוגי: שהחומר ימשיך, שהיחסים והשגרה יישמרו. במציאות, בשבע וחצי בבוקר, המנהל צריך קודם כול שמישהו יהיה בכיתה. ורוב המחקרים בודקים כמה מורים נעדרים ולמה, ולא מה המנהל עושה ושוקל ברגע ההיעדרות עצמו.
+הקריאה שינתה גם את החשיבה שלנו. בהתחלה חשבנו שהבעיה לוגיסטית, רק למצוא ממלא מקום. היום אנחנו מבינים שרצף הוא פדגוגי, ארגוני ורגשי, ושהמנהל פועל גם לפני ההיעדרות ולא רק אחריה.
 [מעבר לחנון]</a:t>
             </a:r>
             <a:endParaRPr lang="en-US" dirty="0"/>
@@ -694,17 +692,16 @@
             <a:r>
               <a:rPr lang="en-US" dirty="0"/>
               <a:t>[חנון | כדקה וחצי]
-איך נבדוק את זה? נצא לשטח ונשוחח עם 12 מנהלים ומנהלות מבתי ספר בצפון הארץ. בחרנו בתי ספר מאזורים שונים, עירוניים וכפריים, יסודיים ועל־יסודיים, ומנהלים עם ותק שונה, כדי לראות מגוון של דרכי פעולה. בחרנו במנהלים כי הם מקבלי ההחלטות.
-הכלי שלנו הוא ראיון חצי מובנה. נבקש מכל מנהל לתאר בוקר אחד של היעדרות, צעד אחר צעד, ונשאל גם על היעדרות ממושכת. ראיון מאפשר לנו להבין את השיקולים ואת הדילמות, ולא רק את הנוהל הכתוב.
-מה נחפש? אסטרטגיות מונעות לעומת אסטרטגיות מגיבות, הבדלים בין היעדרות קצרה לממושכת, ובעיקר את השיקולים: פדגוגיה, תקציב, הוגנות כלפי הצוות שמחליף, ורווחת המורה הנעדרת.
-האתגר הגדול: מנהלים עלולים להציג תמונה יפה מהמציאות. לכן נבקש דוגמאות מוחשיות ולא רק עקרונות.
+איך נבדוק את זה? נשוחח עם 12 מנהלים ומנהלות של בתי ספר בערים בצפון הארץ, יסודיים ועל־יסודיים, עם ותק שונה. בחרנו במנהלים כי הם מקבלי ההחלטות בבוקר ההיעדרות, ובחרנו בערים כדי לבחון את התופעה בהקשר אחיד ולהשוות בין ערים שונות.
+הכלי שלנו הוא ראיון חצי מובנה. נבקש מכל מנהל לתאר בוקר אחד של היעדרות, צעד אחר צעד, ונשאל גם על היעדרות ממושכת. כך נבין את השיקולים ואת הדילמות, ולא רק את הנוהל הכתוב. בניתוח נחפש אסטרטגיות מונעות לעומת מגיבות, ואת האיזון בין פדגוגיה, תקציב, הוגנות כלפי הצוות שמחליף, ורווחת המורה הנעדרת.
+האתגר המרכזי: מנהלים עלולים להציג תמונה יפה מהמציאות. לכן נבקש דוגמאות מוחשיות ולא רק עקרונות.
 [אולפת | כחצי דקה]
-ומה יפתיע אותנו? אם יתברר שמה שמנחה את ההחלטה הוא בעיקר השקט והסדר בבית הספר ולא רצף לימודי. זה יערער הנחה שלנו.
+ומה יפתיע אותנו? אם יתברר שמה שמנחה את ההחלטה בפועל הוא השקט והסדר בבית הספר ולא הרצף הלימודי. זה יערער הנחה שלנו.
 אם המחקר שלנו יהיה מוצלח, בסופו נבין טוב יותר איך מנהלים מאזנים, בזמן אמת, בין הצורך שמישהו יהיה בכיתה לבין הזכות של התלמידים לרצף לימודי אמיתי.
 תודה.
 [שאלות המשך אפשריות]
 למה רק מנהלים? כי השאלה היא על קבלת החלטות, והם אלה שמחליטים. במחקר המשך אפשר לשמוע גם את המורים המחליפים.
-למה צפון? יש לנו גישה, ויש בצפון מגוון רחב של יישובים ומגזרים.</a:t>
+למה רק ערים? כדי לבחון את התופעה בהקשר אחיד. בתי ספר בכפרים פועלים בתנאים אחרים, וזה יכול להיות כיוון למחקר המשך.</a:t>
             </a:r>
             <a:endParaRPr lang="en-US" dirty="0"/>
           </a:p>
@@ -1227,7 +1224,7 @@
         </p:nvSpPr>
         <p:spPr>
           <a:xfrm>
-            <a:off x="548640" y="1188720"/>
+            <a:off x="548640" y="1143000"/>
             <a:ext cx="11091672" cy="777240"/>
           </a:xfrm>
           <a:prstGeom prst="rect">
@@ -1260,200 +1257,14 @@
       </p:sp>
       <p:sp>
         <p:nvSpPr>
-          <p:cNvPr id="7" name="Text 5"/>
-          <p:cNvSpPr txBox="1"/>
-          <p:nvPr/>
-        </p:nvSpPr>
-        <p:spPr>
-          <a:xfrm>
-            <a:off x="548640" y="2011680"/>
-            <a:ext cx="11091672" cy="411480"/>
-          </a:xfrm>
-          <a:prstGeom prst="rect">
-            <a:avLst/>
-          </a:prstGeom>
-          <a:noFill/>
-          <a:ln/>
-        </p:spPr>
-        <p:txBody>
-          <a:bodyPr wrap="square" lIns="0" tIns="0" rIns="0" bIns="0" rtlCol="0" anchor="ctr"/>
-          <a:lstStyle/>
-          <a:p>
-            <a:pPr rtl="1" algn="r" indent="0" marL="0">
-              <a:buNone/>
-            </a:pPr>
-            <a:r>
-              <a:rPr lang="he-IL" altLang="en-US" sz="1800" dirty="0">
-                <a:solidFill>
-                  <a:srgbClr val="A9D2D5"/>
-                </a:solidFill>
-                <a:latin typeface="Arial" pitchFamily="34" charset="0"/>
-                <a:ea typeface="Arial" pitchFamily="34" charset="-122"/>
-                <a:cs typeface="Arial" pitchFamily="34" charset="-120"/>
-              </a:rPr>
-              <a:t>הנושא: אסטרטגיות ניהוליות בהתמודדות עם היעדרויות מורים ושמירה על רצף לימודי</a:t>
-            </a:r>
-            <a:endParaRPr lang="he-IL" sz="1800" dirty="0"/>
-          </a:p>
-        </p:txBody>
-      </p:sp>
-      <p:sp>
-        <p:nvSpPr>
-          <p:cNvPr id="8" name="Shape 6"/>
+          <p:cNvPr id="7" name="Shape 5"/>
           <p:cNvSpPr/>
           <p:nvPr/>
         </p:nvSpPr>
         <p:spPr>
           <a:xfrm>
-            <a:off x="4572000" y="2697480"/>
-            <a:ext cx="7068312" cy="2103120"/>
-          </a:xfrm>
-          <a:prstGeom prst="roundRect">
-            <a:avLst>
-              <a:gd name="adj" fmla="val 5217"/>
-            </a:avLst>
-          </a:prstGeom>
-          <a:solidFill>
-            <a:srgbClr val="1D4A52"/>
-          </a:solidFill>
-          <a:ln w="12700">
-            <a:solidFill>
-              <a:srgbClr val="1D4A52"/>
-            </a:solidFill>
-            <a:prstDash val="solid"/>
-          </a:ln>
-        </p:spPr>
-      </p:sp>
-      <p:sp>
-        <p:nvSpPr>
-          <p:cNvPr id="9" name="Text 7"/>
-          <p:cNvSpPr txBox="1"/>
-          <p:nvPr/>
-        </p:nvSpPr>
-        <p:spPr>
-          <a:xfrm>
-            <a:off x="4892040" y="2880360"/>
-            <a:ext cx="6428232" cy="320040"/>
-          </a:xfrm>
-          <a:prstGeom prst="rect">
-            <a:avLst/>
-          </a:prstGeom>
-          <a:noFill/>
-          <a:ln/>
-        </p:spPr>
-        <p:txBody>
-          <a:bodyPr wrap="square" lIns="0" tIns="0" rIns="0" bIns="0" rtlCol="0" anchor="t"/>
-          <a:lstStyle/>
-          <a:p>
-            <a:pPr rtl="1" algn="r" indent="0" marL="0">
-              <a:buNone/>
-            </a:pPr>
-            <a:r>
-              <a:rPr lang="he-IL" altLang="en-US" sz="1400" b="1" dirty="0">
-                <a:solidFill>
-                  <a:srgbClr val="E9A23B"/>
-                </a:solidFill>
-                <a:latin typeface="Arial" pitchFamily="34" charset="0"/>
-                <a:ea typeface="Arial" pitchFamily="34" charset="-122"/>
-                <a:cs typeface="Arial" pitchFamily="34" charset="-120"/>
-              </a:rPr>
-              <a:t>שאלת המחקר</a:t>
-            </a:r>
-            <a:endParaRPr lang="he-IL" sz="1400" dirty="0"/>
-          </a:p>
-        </p:txBody>
-      </p:sp>
-      <p:sp>
-        <p:nvSpPr>
-          <p:cNvPr id="10" name="Text 8"/>
-          <p:cNvSpPr txBox="1"/>
-          <p:nvPr/>
-        </p:nvSpPr>
-        <p:spPr>
-          <a:xfrm>
-            <a:off x="4892040" y="3246120"/>
-            <a:ext cx="6428232" cy="1371600"/>
-          </a:xfrm>
-          <a:prstGeom prst="rect">
-            <a:avLst/>
-          </a:prstGeom>
-          <a:noFill/>
-          <a:ln/>
-        </p:spPr>
-        <p:txBody>
-          <a:bodyPr wrap="square" lIns="0" tIns="0" rIns="0" bIns="0" rtlCol="0" anchor="t"/>
-          <a:lstStyle/>
-          <a:p>
-            <a:pPr rtl="1" algn="r" indent="0" marL="0">
-              <a:lnSpc>
-                <a:spcPct val="110000"/>
-              </a:lnSpc>
-              <a:buNone/>
-            </a:pPr>
-            <a:r>
-              <a:rPr lang="he-IL" altLang="en-US" sz="2000" b="1" dirty="0">
-                <a:solidFill>
-                  <a:srgbClr val="FFFFFF"/>
-                </a:solidFill>
-                <a:latin typeface="Arial" pitchFamily="34" charset="0"/>
-                <a:ea typeface="Arial" pitchFamily="34" charset="-122"/>
-                <a:cs typeface="Arial" pitchFamily="34" charset="-120"/>
-              </a:rPr>
-              <a:t>כיצד מנהלי בתי ספר בצפון הארץ מתארים את התמודדותם עם היעדרויות מורים, ואילו אסטרטגיות ושיקולים מנחים את החלטותיהם לשמירה על רצף לימודי?</a:t>
-            </a:r>
-            <a:endParaRPr lang="he-IL" sz="2000" dirty="0"/>
-          </a:p>
-        </p:txBody>
-      </p:sp>
-      <p:sp>
-        <p:nvSpPr>
-          <p:cNvPr id="11" name="Text 9"/>
-          <p:cNvSpPr txBox="1"/>
-          <p:nvPr/>
-        </p:nvSpPr>
-        <p:spPr>
-          <a:xfrm>
-            <a:off x="548640" y="2697480"/>
-            <a:ext cx="3703320" cy="320040"/>
-          </a:xfrm>
-          <a:prstGeom prst="rect">
-            <a:avLst/>
-          </a:prstGeom>
-          <a:noFill/>
-          <a:ln/>
-        </p:spPr>
-        <p:txBody>
-          <a:bodyPr wrap="square" lIns="0" tIns="0" rIns="0" bIns="0" rtlCol="0" anchor="t"/>
-          <a:lstStyle/>
-          <a:p>
-            <a:pPr rtl="1" algn="r" indent="0" marL="0">
-              <a:buNone/>
-            </a:pPr>
-            <a:r>
-              <a:rPr lang="he-IL" altLang="en-US" sz="1400" b="1" dirty="0">
-                <a:solidFill>
-                  <a:srgbClr val="E9A23B"/>
-                </a:solidFill>
-                <a:latin typeface="Arial" pitchFamily="34" charset="0"/>
-                <a:ea typeface="Arial" pitchFamily="34" charset="-122"/>
-                <a:cs typeface="Arial" pitchFamily="34" charset="-120"/>
-              </a:rPr>
-              <a:t>למה דווקא השאלה הזאת?</a:t>
-            </a:r>
-            <a:endParaRPr lang="he-IL" sz="1400" dirty="0"/>
-          </a:p>
-        </p:txBody>
-      </p:sp>
-      <p:sp>
-        <p:nvSpPr>
-          <p:cNvPr id="12" name="Shape 10"/>
-          <p:cNvSpPr/>
-          <p:nvPr/>
-        </p:nvSpPr>
-        <p:spPr>
-          <a:xfrm>
-            <a:off x="3904488" y="3127248"/>
-            <a:ext cx="347472" cy="347472"/>
+            <a:off x="11183112" y="2350008"/>
+            <a:ext cx="457200" cy="457200"/>
           </a:xfrm>
           <a:prstGeom prst="ellipse">
             <a:avLst/>
@@ -1471,7 +1282,7 @@
       </p:sp>
       <p:pic>
         <p:nvPicPr>
-          <p:cNvPr id="13" name="Image 0" descr="preencoded.png">    </p:cNvPr>
+          <p:cNvPr id="8" name="Image 0" descr="preencoded.png">    </p:cNvPr>
           <p:cNvPicPr>
             <a:picLocks noChangeAspect="1"/>
           </p:cNvPicPr>
@@ -1485,8 +1296,8 @@
         </p:blipFill>
         <p:spPr>
           <a:xfrm>
-            <a:off x="3991356" y="3214116"/>
-            <a:ext cx="173736" cy="173736"/>
+            <a:off x="11297412" y="2464308"/>
+            <a:ext cx="228600" cy="228600"/>
           </a:xfrm>
           <a:prstGeom prst="rect">
             <a:avLst/>
@@ -1495,14 +1306,14 @@
       </p:pic>
       <p:sp>
         <p:nvSpPr>
-          <p:cNvPr id="14" name="Text 11"/>
+          <p:cNvPr id="9" name="Text 6"/>
           <p:cNvSpPr txBox="1"/>
           <p:nvPr/>
         </p:nvSpPr>
         <p:spPr>
           <a:xfrm>
-            <a:off x="548640" y="3127248"/>
-            <a:ext cx="3200400" cy="347472"/>
+            <a:off x="548640" y="2331720"/>
+            <a:ext cx="10405872" cy="1143000"/>
           </a:xfrm>
           <a:prstGeom prst="rect">
             <a:avLst/>
@@ -1511,14 +1322,34 @@
           <a:ln/>
         </p:spPr>
         <p:txBody>
-          <a:bodyPr wrap="square" lIns="0" tIns="0" rIns="0" bIns="0" rtlCol="0" anchor="ctr"/>
+          <a:bodyPr wrap="square" lIns="0" tIns="0" rIns="0" bIns="0" rtlCol="0" anchor="t"/>
           <a:lstStyle/>
           <a:p>
-            <a:pPr rtl="1" algn="r" indent="0" marL="0">
-              <a:buNone/>
-            </a:pPr>
-            <a:r>
-              <a:rPr lang="he-IL" altLang="en-US" sz="1400" dirty="0">
+            <a:pPr algn="r" indent="0" marL="0">
+              <a:lnSpc>
+                <a:spcPct val="115000"/>
+              </a:lnSpc>
+              <a:buNone/>
+            </a:pPr>
+            <a:r>
+              <a:rPr lang="he-IL" altLang="en-US" sz="1700" b="1" dirty="0">
+                <a:solidFill>
+                  <a:srgbClr val="E9A23B"/>
+                </a:solidFill>
+                <a:latin typeface="Arial" pitchFamily="34" charset="0"/>
+                <a:ea typeface="Arial" pitchFamily="34" charset="-122"/>
+                <a:cs typeface="Arial" pitchFamily="34" charset="-120"/>
+              </a:rPr>
+              <a:t>המחקר שלנו עוסק בהיעדרויות מורים, </a:t>
+            </a:r>
+            <a:pPr algn="r" indent="0" marL="0">
+              <a:lnSpc>
+                <a:spcPct val="115000"/>
+              </a:lnSpc>
+              <a:buNone/>
+            </a:pPr>
+            <a:r>
+              <a:rPr lang="he-IL" altLang="en-US" sz="1700" dirty="0">
                 <a:solidFill>
                   <a:srgbClr val="FFFFFF"/>
                 </a:solidFill>
@@ -1526,22 +1357,22 @@
                 <a:ea typeface="Arial" pitchFamily="34" charset="-122"/>
                 <a:cs typeface="Arial" pitchFamily="34" charset="-120"/>
               </a:rPr>
-              <a:t>מי נכנס לכיתה במקום המורה?</a:t>
-            </a:r>
-            <a:endParaRPr lang="he-IL" sz="1400" dirty="0"/>
-          </a:p>
-        </p:txBody>
-      </p:sp>
-      <p:sp>
-        <p:nvSpPr>
-          <p:cNvPr id="15" name="Shape 12"/>
+              <a:t>תופעה שמוכרת לכל בית ספר ומתרחשת כמעט בכל יום. ההיעדרות עצמה אינה הבעיה. המורכבות מתחילה ברגע שבו המנהל צריך להחליט בתוך דקות מי ייכנס לכיתה, מה יקרה בשיעור ומי מהצוות ישלם את המחיר.</a:t>
+            </a:r>
+            <a:endParaRPr lang="he-IL" sz="1700" dirty="0"/>
+          </a:p>
+        </p:txBody>
+      </p:sp>
+      <p:sp>
+        <p:nvSpPr>
+          <p:cNvPr id="10" name="Shape 7"/>
           <p:cNvSpPr/>
           <p:nvPr/>
         </p:nvSpPr>
         <p:spPr>
           <a:xfrm>
-            <a:off x="3904488" y="3557016"/>
-            <a:ext cx="347472" cy="347472"/>
+            <a:off x="11183112" y="3675888"/>
+            <a:ext cx="457200" cy="457200"/>
           </a:xfrm>
           <a:prstGeom prst="ellipse">
             <a:avLst/>
@@ -1559,7 +1390,7 @@
       </p:sp>
       <p:pic>
         <p:nvPicPr>
-          <p:cNvPr id="16" name="Image 1" descr="preencoded.png">    </p:cNvPr>
+          <p:cNvPr id="11" name="Image 1" descr="preencoded.png">    </p:cNvPr>
           <p:cNvPicPr>
             <a:picLocks noChangeAspect="1"/>
           </p:cNvPicPr>
@@ -1573,8 +1404,8 @@
         </p:blipFill>
         <p:spPr>
           <a:xfrm>
-            <a:off x="3991356" y="3643884"/>
-            <a:ext cx="173736" cy="173736"/>
+            <a:off x="11297412" y="3790188"/>
+            <a:ext cx="228600" cy="228600"/>
           </a:xfrm>
           <a:prstGeom prst="rect">
             <a:avLst/>
@@ -1583,14 +1414,14 @@
       </p:pic>
       <p:sp>
         <p:nvSpPr>
-          <p:cNvPr id="17" name="Text 13"/>
+          <p:cNvPr id="12" name="Text 8"/>
           <p:cNvSpPr txBox="1"/>
           <p:nvPr/>
         </p:nvSpPr>
         <p:spPr>
           <a:xfrm>
-            <a:off x="548640" y="3557016"/>
-            <a:ext cx="3200400" cy="347472"/>
+            <a:off x="548640" y="3657600"/>
+            <a:ext cx="10405872" cy="1143000"/>
           </a:xfrm>
           <a:prstGeom prst="rect">
             <a:avLst/>
@@ -1599,14 +1430,17 @@
           <a:ln/>
         </p:spPr>
         <p:txBody>
-          <a:bodyPr wrap="square" lIns="0" tIns="0" rIns="0" bIns="0" rtlCol="0" anchor="ctr"/>
+          <a:bodyPr wrap="square" lIns="0" tIns="0" rIns="0" bIns="0" rtlCol="0" anchor="t"/>
           <a:lstStyle/>
           <a:p>
-            <a:pPr rtl="1" algn="r" indent="0" marL="0">
-              <a:buNone/>
-            </a:pPr>
-            <a:r>
-              <a:rPr lang="he-IL" altLang="en-US" sz="1400" dirty="0">
+            <a:pPr algn="r" indent="0" marL="0">
+              <a:lnSpc>
+                <a:spcPct val="115000"/>
+              </a:lnSpc>
+              <a:buNone/>
+            </a:pPr>
+            <a:r>
+              <a:rPr lang="he-IL" altLang="en-US" sz="1700" dirty="0">
                 <a:solidFill>
                   <a:srgbClr val="FFFFFF"/>
                 </a:solidFill>
@@ -1614,22 +1448,39 @@
                 <a:ea typeface="Arial" pitchFamily="34" charset="-122"/>
                 <a:cs typeface="Arial" pitchFamily="34" charset="-120"/>
               </a:rPr>
-              <a:t>מי מחליט, ולפי אילו שיקולים?</a:t>
-            </a:r>
-            <a:endParaRPr lang="he-IL" sz="1400" dirty="0"/>
-          </a:p>
-        </p:txBody>
-      </p:sp>
-      <p:sp>
-        <p:nvSpPr>
-          <p:cNvPr id="18" name="Shape 14"/>
+              <a:t>לכן אנחנו שואלים: </a:t>
+            </a:r>
+            <a:pPr algn="r" indent="0" marL="0">
+              <a:lnSpc>
+                <a:spcPct val="115000"/>
+              </a:lnSpc>
+              <a:buNone/>
+            </a:pPr>
+            <a:r>
+              <a:rPr lang="he-IL" altLang="en-US" sz="1700" b="1" dirty="0">
+                <a:solidFill>
+                  <a:srgbClr val="FFFFFF"/>
+                </a:solidFill>
+                <a:latin typeface="Arial" pitchFamily="34" charset="0"/>
+                <a:ea typeface="Arial" pitchFamily="34" charset="-122"/>
+                <a:cs typeface="Arial" pitchFamily="34" charset="-120"/>
+              </a:rPr>
+              <a:t>כיצד מנהלי בתי ספר בערים בצפון הארץ מתארים את התמודדותם עם היעדרויות מורים, ואילו אסטרטגיות ושיקולים מנחים את החלטותיהם לשמירה על רצף לימודי?</a:t>
+            </a:r>
+            <a:endParaRPr lang="he-IL" sz="1700" dirty="0"/>
+          </a:p>
+        </p:txBody>
+      </p:sp>
+      <p:sp>
+        <p:nvSpPr>
+          <p:cNvPr id="13" name="Shape 9"/>
           <p:cNvSpPr/>
           <p:nvPr/>
         </p:nvSpPr>
         <p:spPr>
           <a:xfrm>
-            <a:off x="3904488" y="3986784"/>
-            <a:ext cx="347472" cy="347472"/>
+            <a:off x="11183112" y="4773168"/>
+            <a:ext cx="457200" cy="457200"/>
           </a:xfrm>
           <a:prstGeom prst="ellipse">
             <a:avLst/>
@@ -1647,7 +1498,7 @@
       </p:sp>
       <p:pic>
         <p:nvPicPr>
-          <p:cNvPr id="19" name="Image 2" descr="preencoded.png">    </p:cNvPr>
+          <p:cNvPr id="14" name="Image 2" descr="preencoded.png">    </p:cNvPr>
           <p:cNvPicPr>
             <a:picLocks noChangeAspect="1"/>
           </p:cNvPicPr>
@@ -1661,8 +1512,8 @@
         </p:blipFill>
         <p:spPr>
           <a:xfrm>
-            <a:off x="3991356" y="4073652"/>
-            <a:ext cx="173736" cy="173736"/>
+            <a:off x="11297412" y="4887468"/>
+            <a:ext cx="228600" cy="228600"/>
           </a:xfrm>
           <a:prstGeom prst="rect">
             <a:avLst/>
@@ -1671,14 +1522,14 @@
       </p:pic>
       <p:sp>
         <p:nvSpPr>
-          <p:cNvPr id="20" name="Text 15"/>
+          <p:cNvPr id="15" name="Text 10"/>
           <p:cNvSpPr txBox="1"/>
           <p:nvPr/>
         </p:nvSpPr>
         <p:spPr>
           <a:xfrm>
-            <a:off x="548640" y="3986784"/>
-            <a:ext cx="3200400" cy="347472"/>
+            <a:off x="548640" y="4754880"/>
+            <a:ext cx="10405872" cy="1463040"/>
           </a:xfrm>
           <a:prstGeom prst="rect">
             <a:avLst/>
@@ -1687,14 +1538,34 @@
           <a:ln/>
         </p:spPr>
         <p:txBody>
-          <a:bodyPr wrap="square" lIns="0" tIns="0" rIns="0" bIns="0" rtlCol="0" anchor="ctr"/>
+          <a:bodyPr wrap="square" lIns="0" tIns="0" rIns="0" bIns="0" rtlCol="0" anchor="t"/>
           <a:lstStyle/>
           <a:p>
-            <a:pPr rtl="1" algn="r" indent="0" marL="0">
-              <a:buNone/>
-            </a:pPr>
-            <a:r>
-              <a:rPr lang="he-IL" altLang="en-US" sz="1400" dirty="0">
+            <a:pPr algn="r" indent="0" marL="0">
+              <a:lnSpc>
+                <a:spcPct val="115000"/>
+              </a:lnSpc>
+              <a:buNone/>
+            </a:pPr>
+            <a:r>
+              <a:rPr lang="he-IL" altLang="en-US" sz="1700" b="1" dirty="0">
+                <a:solidFill>
+                  <a:srgbClr val="E9A23B"/>
+                </a:solidFill>
+                <a:latin typeface="Arial" pitchFamily="34" charset="0"/>
+                <a:ea typeface="Arial" pitchFamily="34" charset="-122"/>
+                <a:cs typeface="Arial" pitchFamily="34" charset="-120"/>
+              </a:rPr>
+              <a:t>השאלה הזאת מעסיקה אותנו </a:t>
+            </a:r>
+            <a:pPr algn="r" indent="0" marL="0">
+              <a:lnSpc>
+                <a:spcPct val="115000"/>
+              </a:lnSpc>
+              <a:buNone/>
+            </a:pPr>
+            <a:r>
+              <a:rPr lang="he-IL" altLang="en-US" sz="1700" dirty="0">
                 <a:solidFill>
                   <a:srgbClr val="FFFFFF"/>
                 </a:solidFill>
@@ -1702,226 +1573,9 @@
                 <a:ea typeface="Arial" pitchFamily="34" charset="-122"/>
                 <a:cs typeface="Arial" pitchFamily="34" charset="-120"/>
               </a:rPr>
-              <a:t>מה קורה לשיעור עצמו?</a:t>
-            </a:r>
-            <a:endParaRPr lang="he-IL" sz="1400" dirty="0"/>
-          </a:p>
-        </p:txBody>
-      </p:sp>
-      <p:sp>
-        <p:nvSpPr>
-          <p:cNvPr id="21" name="Shape 16"/>
-          <p:cNvSpPr/>
-          <p:nvPr/>
-        </p:nvSpPr>
-        <p:spPr>
-          <a:xfrm>
-            <a:off x="3904488" y="4416552"/>
-            <a:ext cx="347472" cy="347472"/>
-          </a:xfrm>
-          <a:prstGeom prst="ellipse">
-            <a:avLst/>
-          </a:prstGeom>
-          <a:solidFill>
-            <a:srgbClr val="E9A23B"/>
-          </a:solidFill>
-          <a:ln w="12700">
-            <a:solidFill>
-              <a:srgbClr val="E9A23B"/>
-            </a:solidFill>
-            <a:prstDash val="solid"/>
-          </a:ln>
-        </p:spPr>
-      </p:sp>
-      <p:pic>
-        <p:nvPicPr>
-          <p:cNvPr id="22" name="Image 3" descr="preencoded.png">    </p:cNvPr>
-          <p:cNvPicPr>
-            <a:picLocks noChangeAspect="1"/>
-          </p:cNvPicPr>
-          <p:nvPr/>
-        </p:nvPicPr>
-        <p:blipFill>
-          <a:blip r:embed="rId4"/>
-          <a:stretch>
-            <a:fillRect/>
-          </a:stretch>
-        </p:blipFill>
-        <p:spPr>
-          <a:xfrm>
-            <a:off x="3991356" y="4503420"/>
-            <a:ext cx="173736" cy="173736"/>
-          </a:xfrm>
-          <a:prstGeom prst="rect">
-            <a:avLst/>
-          </a:prstGeom>
-        </p:spPr>
-      </p:pic>
-      <p:sp>
-        <p:nvSpPr>
-          <p:cNvPr id="23" name="Text 17"/>
-          <p:cNvSpPr txBox="1"/>
-          <p:nvPr/>
-        </p:nvSpPr>
-        <p:spPr>
-          <a:xfrm>
-            <a:off x="548640" y="4416552"/>
-            <a:ext cx="3200400" cy="347472"/>
-          </a:xfrm>
-          <a:prstGeom prst="rect">
-            <a:avLst/>
-          </a:prstGeom>
-          <a:noFill/>
-          <a:ln/>
-        </p:spPr>
-        <p:txBody>
-          <a:bodyPr wrap="square" lIns="0" tIns="0" rIns="0" bIns="0" rtlCol="0" anchor="ctr"/>
-          <a:lstStyle/>
-          <a:p>
-            <a:pPr rtl="1" algn="r" indent="0" marL="0">
-              <a:buNone/>
-            </a:pPr>
-            <a:r>
-              <a:rPr lang="he-IL" altLang="en-US" sz="1400" dirty="0">
-                <a:solidFill>
-                  <a:srgbClr val="FFFFFF"/>
-                </a:solidFill>
-                <a:latin typeface="Arial" pitchFamily="34" charset="0"/>
-                <a:ea typeface="Arial" pitchFamily="34" charset="-122"/>
-                <a:cs typeface="Arial" pitchFamily="34" charset="-120"/>
-              </a:rPr>
-              <a:t>מה המחיר לצוות שמחליף?</a:t>
-            </a:r>
-            <a:endParaRPr lang="he-IL" sz="1400" dirty="0"/>
-          </a:p>
-        </p:txBody>
-      </p:sp>
-      <p:sp>
-        <p:nvSpPr>
-          <p:cNvPr id="24" name="Shape 18"/>
-          <p:cNvSpPr/>
-          <p:nvPr/>
-        </p:nvSpPr>
-        <p:spPr>
-          <a:xfrm>
-            <a:off x="548640" y="5120640"/>
-            <a:ext cx="11091672" cy="1143000"/>
-          </a:xfrm>
-          <a:prstGeom prst="roundRect">
-            <a:avLst>
-              <a:gd name="adj" fmla="val 9600"/>
-            </a:avLst>
-          </a:prstGeom>
-          <a:solidFill>
-            <a:srgbClr val="12343B"/>
-          </a:solidFill>
-          <a:ln w="19050">
-            <a:solidFill>
-              <a:srgbClr val="E9A23B"/>
-            </a:solidFill>
-            <a:prstDash val="solid"/>
-          </a:ln>
-        </p:spPr>
-      </p:sp>
-      <p:sp>
-        <p:nvSpPr>
-          <p:cNvPr id="25" name="Shape 19"/>
-          <p:cNvSpPr/>
-          <p:nvPr/>
-        </p:nvSpPr>
-        <p:spPr>
-          <a:xfrm>
-            <a:off x="10927080" y="5330952"/>
-            <a:ext cx="502920" cy="502920"/>
-          </a:xfrm>
-          <a:prstGeom prst="ellipse">
-            <a:avLst/>
-          </a:prstGeom>
-          <a:solidFill>
-            <a:srgbClr val="E9A23B"/>
-          </a:solidFill>
-          <a:ln w="12700">
-            <a:solidFill>
-              <a:srgbClr val="E9A23B"/>
-            </a:solidFill>
-            <a:prstDash val="solid"/>
-          </a:ln>
-        </p:spPr>
-      </p:sp>
-      <p:pic>
-        <p:nvPicPr>
-          <p:cNvPr id="26" name="Image 4" descr="preencoded.png">    </p:cNvPr>
-          <p:cNvPicPr>
-            <a:picLocks noChangeAspect="1"/>
-          </p:cNvPicPr>
-          <p:nvPr/>
-        </p:nvPicPr>
-        <p:blipFill>
-          <a:blip r:embed="rId5"/>
-          <a:stretch>
-            <a:fillRect/>
-          </a:stretch>
-        </p:blipFill>
-        <p:spPr>
-          <a:xfrm>
-            <a:off x="11052810" y="5456682"/>
-            <a:ext cx="251460" cy="251460"/>
-          </a:xfrm>
-          <a:prstGeom prst="rect">
-            <a:avLst/>
-          </a:prstGeom>
-        </p:spPr>
-      </p:pic>
-      <p:sp>
-        <p:nvSpPr>
-          <p:cNvPr id="27" name="Text 20"/>
-          <p:cNvSpPr txBox="1"/>
-          <p:nvPr/>
-        </p:nvSpPr>
-        <p:spPr>
-          <a:xfrm>
-            <a:off x="822960" y="5257800"/>
-            <a:ext cx="9921240" cy="868680"/>
-          </a:xfrm>
-          <a:prstGeom prst="rect">
-            <a:avLst/>
-          </a:prstGeom>
-          <a:noFill/>
-          <a:ln/>
-        </p:spPr>
-        <p:txBody>
-          <a:bodyPr wrap="square" lIns="0" tIns="0" rIns="0" bIns="0" rtlCol="0" anchor="ctr"/>
-          <a:lstStyle/>
-          <a:p>
-            <a:pPr algn="r" indent="0" marL="0">
-              <a:buNone/>
-            </a:pPr>
-            <a:r>
-              <a:rPr lang="he-IL" altLang="en-US" sz="1800" b="1" dirty="0">
-                <a:solidFill>
-                  <a:srgbClr val="E9A23B"/>
-                </a:solidFill>
-                <a:latin typeface="Arial" pitchFamily="34" charset="0"/>
-                <a:ea typeface="Arial" pitchFamily="34" charset="-122"/>
-                <a:cs typeface="Arial" pitchFamily="34" charset="-120"/>
-              </a:rPr>
-              <a:t>המחקר שלנו חשוב כי </a:t>
-            </a:r>
-            <a:pPr algn="r" indent="0" marL="0">
-              <a:buNone/>
-            </a:pPr>
-            <a:r>
-              <a:rPr lang="he-IL" altLang="en-US" sz="1800" dirty="0">
-                <a:solidFill>
-                  <a:srgbClr val="FFFFFF"/>
-                </a:solidFill>
-                <a:latin typeface="Arial" pitchFamily="34" charset="0"/>
-                <a:ea typeface="Arial" pitchFamily="34" charset="-122"/>
-                <a:cs typeface="Arial" pitchFamily="34" charset="-120"/>
-              </a:rPr>
-              <a:t>היעדרות מורים קורית כמעט בכל יום, וההחלטה של המנהל באותו בוקר קובעת אם התלמידים יקבלו שיעור אמיתי או רק השגחה.</a:t>
-            </a:r>
-            <a:endParaRPr lang="he-IL" sz="1800" dirty="0"/>
+              <a:t>משום שראינו שאותה היעדרות יכולה להסתיים בשיעור שממשיך כרגיל, או בשעה של השגחה בלבד, וההבדל נקבע בהחלטות של המנהל. המחקר שלנו חשוב כי הוא מאיר את מה שקורה מאחורי הקלעים של ההחלטות האלה, שמשפיעות ישירות על הלמידה של התלמידים.</a:t>
+            </a:r>
+            <a:endParaRPr lang="he-IL" sz="1700" dirty="0"/>
           </a:p>
         </p:txBody>
       </p:sp>
@@ -2107,34 +1761,7 @@
         </p:nvSpPr>
         <p:spPr>
           <a:xfrm>
-            <a:off x="8119872" y="1965960"/>
-            <a:ext cx="3520440" cy="2331720"/>
-          </a:xfrm>
-          <a:prstGeom prst="roundRect">
-            <a:avLst>
-              <a:gd name="adj" fmla="val 4706"/>
-            </a:avLst>
-          </a:prstGeom>
-          <a:solidFill>
-            <a:srgbClr val="E4F0F0"/>
-          </a:solidFill>
-          <a:ln w="12700">
-            <a:solidFill>
-              <a:srgbClr val="E4F0F0"/>
-            </a:solidFill>
-            <a:prstDash val="solid"/>
-          </a:ln>
-        </p:spPr>
-      </p:sp>
-      <p:sp>
-        <p:nvSpPr>
-          <p:cNvPr id="7" name="Shape 5"/>
-          <p:cNvSpPr/>
-          <p:nvPr/>
-        </p:nvSpPr>
-        <p:spPr>
-          <a:xfrm>
-            <a:off x="10954512" y="2167128"/>
+            <a:off x="11183112" y="2029968"/>
             <a:ext cx="457200" cy="457200"/>
           </a:xfrm>
           <a:prstGeom prst="ellipse">
@@ -2153,7 +1780,7 @@
       </p:sp>
       <p:pic>
         <p:nvPicPr>
-          <p:cNvPr id="8" name="Image 0" descr="preencoded.png">    </p:cNvPr>
+          <p:cNvPr id="7" name="Image 0" descr="preencoded.png">    </p:cNvPr>
           <p:cNvPicPr>
             <a:picLocks noChangeAspect="1"/>
           </p:cNvPicPr>
@@ -2167,7 +1794,7 @@
         </p:blipFill>
         <p:spPr>
           <a:xfrm>
-            <a:off x="11068812" y="2281428"/>
+            <a:off x="11297412" y="2144268"/>
             <a:ext cx="228600" cy="228600"/>
           </a:xfrm>
           <a:prstGeom prst="rect">
@@ -2175,6 +1802,65 @@
           </a:prstGeom>
         </p:spPr>
       </p:pic>
+      <p:sp>
+        <p:nvSpPr>
+          <p:cNvPr id="8" name="Text 5"/>
+          <p:cNvSpPr txBox="1"/>
+          <p:nvPr/>
+        </p:nvSpPr>
+        <p:spPr>
+          <a:xfrm>
+            <a:off x="548640" y="2011680"/>
+            <a:ext cx="10405872" cy="1005840"/>
+          </a:xfrm>
+          <a:prstGeom prst="rect">
+            <a:avLst/>
+          </a:prstGeom>
+          <a:noFill/>
+          <a:ln/>
+        </p:spPr>
+        <p:txBody>
+          <a:bodyPr wrap="square" lIns="0" tIns="0" rIns="0" bIns="0" rtlCol="0" anchor="t"/>
+          <a:lstStyle/>
+          <a:p>
+            <a:pPr algn="r" indent="0" marL="0">
+              <a:lnSpc>
+                <a:spcPct val="115000"/>
+              </a:lnSpc>
+              <a:buNone/>
+            </a:pPr>
+            <a:r>
+              <a:rPr lang="he-IL" altLang="en-US" sz="1600" b="1" dirty="0">
+                <a:solidFill>
+                  <a:srgbClr val="12343B"/>
+                </a:solidFill>
+                <a:latin typeface="Arial" pitchFamily="34" charset="0"/>
+                <a:ea typeface="Arial" pitchFamily="34" charset="-122"/>
+                <a:cs typeface="Arial" pitchFamily="34" charset="-120"/>
+              </a:rPr>
+              <a:t>הספרות מלמדת שהיעדרויות מורים אינן עניין טכני בלבד: </a:t>
+            </a:r>
+            <a:pPr algn="r" indent="0" marL="0">
+              <a:lnSpc>
+                <a:spcPct val="115000"/>
+              </a:lnSpc>
+              <a:buNone/>
+            </a:pPr>
+            <a:r>
+              <a:rPr lang="he-IL" altLang="en-US" sz="1600" dirty="0">
+                <a:solidFill>
+                  <a:srgbClr val="1B2B2E"/>
+                </a:solidFill>
+                <a:latin typeface="Arial" pitchFamily="34" charset="0"/>
+                <a:ea typeface="Arial" pitchFamily="34" charset="-122"/>
+                <a:cs typeface="Arial" pitchFamily="34" charset="-120"/>
+              </a:rPr>
+              <a:t>מילר ועמיתיו (2008) וקלוטפלטר ועמיתיו (2009) מצאו שהן פוגעות בהישגי התלמידים, והפגיעה גדלה ככל שההיעדרויות מצטברות. שפירא־לישצ'ינסקי ורוזנבלט (2010) הראו שהמנהל אינו רק מגיב להיעדרות, שכן האקלים שהוא מעצב בבית הספר קשור גם להיקף ההיעדרויות.</a:t>
+            </a:r>
+            <a:endParaRPr lang="he-IL" sz="1600" dirty="0"/>
+          </a:p>
+        </p:txBody>
+      </p:sp>
       <p:sp>
         <p:nvSpPr>
           <p:cNvPr id="9" name="Text 6"/>
@@ -2183,8 +1869,8 @@
         </p:nvSpPr>
         <p:spPr>
           <a:xfrm>
-            <a:off x="8348472" y="2194560"/>
-            <a:ext cx="2468880" cy="411480"/>
+            <a:off x="548640" y="3017520"/>
+            <a:ext cx="10405872" cy="274320"/>
           </a:xfrm>
           <a:prstGeom prst="rect">
             <a:avLst/>
@@ -2196,21 +1882,21 @@
           <a:bodyPr wrap="square" lIns="0" tIns="0" rIns="0" bIns="0" rtlCol="0" anchor="ctr"/>
           <a:lstStyle/>
           <a:p>
-            <a:pPr rtl="1" algn="r" indent="0" marL="0">
-              <a:buNone/>
-            </a:pPr>
-            <a:r>
-              <a:rPr lang="he-IL" altLang="en-US" sz="1800" b="1" dirty="0">
-                <a:solidFill>
-                  <a:srgbClr val="12343B"/>
-                </a:solidFill>
-                <a:latin typeface="Arial" pitchFamily="34" charset="0"/>
-                <a:ea typeface="Arial" pitchFamily="34" charset="-122"/>
-                <a:cs typeface="Arial" pitchFamily="34" charset="-120"/>
-              </a:rPr>
-              <a:t>מה כבר ידוע</a:t>
-            </a:r>
-            <a:endParaRPr lang="he-IL" sz="1800" dirty="0"/>
+            <a:pPr algn="r" indent="0" marL="0">
+              <a:buNone/>
+            </a:pPr>
+            <a:r>
+              <a:rPr lang="en-US" sz="1000" dirty="0">
+                <a:solidFill>
+                  <a:srgbClr val="4F6A6E"/>
+                </a:solidFill>
+                <a:latin typeface="Arial" pitchFamily="34" charset="0"/>
+                <a:ea typeface="Arial" pitchFamily="34" charset="-122"/>
+                <a:cs typeface="Arial" pitchFamily="34" charset="-120"/>
+              </a:rPr>
+              <a:t>Miller et al., 2008 · Clotfelter et al., 2009 · Shapira-Lishchinsky &amp; Rosenblatt, 2010</a:t>
+            </a:r>
+            <a:endParaRPr lang="en-US" sz="1000" dirty="0"/>
           </a:p>
         </p:txBody>
       </p:sp>
@@ -2222,34 +1908,7 @@
         </p:nvSpPr>
         <p:spPr>
           <a:xfrm>
-            <a:off x="4334256" y="1965960"/>
-            <a:ext cx="3520440" cy="2331720"/>
-          </a:xfrm>
-          <a:prstGeom prst="roundRect">
-            <a:avLst>
-              <a:gd name="adj" fmla="val 4706"/>
-            </a:avLst>
-          </a:prstGeom>
-          <a:solidFill>
-            <a:srgbClr val="E4F0F0"/>
-          </a:solidFill>
-          <a:ln w="12700">
-            <a:solidFill>
-              <a:srgbClr val="E4F0F0"/>
-            </a:solidFill>
-            <a:prstDash val="solid"/>
-          </a:ln>
-        </p:spPr>
-      </p:sp>
-      <p:sp>
-        <p:nvSpPr>
-          <p:cNvPr id="11" name="Shape 8"/>
-          <p:cNvSpPr/>
-          <p:nvPr/>
-        </p:nvSpPr>
-        <p:spPr>
-          <a:xfrm>
-            <a:off x="7168896" y="2167128"/>
+            <a:off x="11183112" y="3447288"/>
             <a:ext cx="457200" cy="457200"/>
           </a:xfrm>
           <a:prstGeom prst="ellipse">
@@ -2268,7 +1927,7 @@
       </p:sp>
       <p:pic>
         <p:nvPicPr>
-          <p:cNvPr id="12" name="Image 1" descr="preencoded.png">    </p:cNvPr>
+          <p:cNvPr id="11" name="Image 1" descr="preencoded.png">    </p:cNvPr>
           <p:cNvPicPr>
             <a:picLocks noChangeAspect="1"/>
           </p:cNvPicPr>
@@ -2282,7 +1941,7 @@
         </p:blipFill>
         <p:spPr>
           <a:xfrm>
-            <a:off x="7283196" y="2281428"/>
+            <a:off x="11297412" y="3561588"/>
             <a:ext cx="228600" cy="228600"/>
           </a:xfrm>
           <a:prstGeom prst="rect">
@@ -2292,14 +1951,14 @@
       </p:pic>
       <p:sp>
         <p:nvSpPr>
-          <p:cNvPr id="13" name="Text 9"/>
+          <p:cNvPr id="12" name="Text 8"/>
           <p:cNvSpPr txBox="1"/>
           <p:nvPr/>
         </p:nvSpPr>
         <p:spPr>
           <a:xfrm>
-            <a:off x="4562856" y="2194560"/>
-            <a:ext cx="2468880" cy="411480"/>
+            <a:off x="548640" y="3429000"/>
+            <a:ext cx="10405872" cy="1234440"/>
           </a:xfrm>
           <a:prstGeom prst="rect">
             <a:avLst/>
@@ -2308,14 +1967,17 @@
           <a:ln/>
         </p:spPr>
         <p:txBody>
-          <a:bodyPr wrap="square" lIns="0" tIns="0" rIns="0" bIns="0" rtlCol="0" anchor="ctr"/>
+          <a:bodyPr wrap="square" lIns="0" tIns="0" rIns="0" bIns="0" rtlCol="0" anchor="t"/>
           <a:lstStyle/>
           <a:p>
-            <a:pPr rtl="1" algn="r" indent="0" marL="0">
-              <a:buNone/>
-            </a:pPr>
-            <a:r>
-              <a:rPr lang="he-IL" altLang="en-US" sz="1800" b="1" dirty="0">
+            <a:pPr algn="r" indent="0" marL="0">
+              <a:lnSpc>
+                <a:spcPct val="115000"/>
+              </a:lnSpc>
+              <a:buNone/>
+            </a:pPr>
+            <a:r>
+              <a:rPr lang="he-IL" altLang="en-US" sz="1600" b="1" dirty="0">
                 <a:solidFill>
                   <a:srgbClr val="12343B"/>
                 </a:solidFill>
@@ -2323,52 +1985,44 @@
                 <a:ea typeface="Arial" pitchFamily="34" charset="-122"/>
                 <a:cs typeface="Arial" pitchFamily="34" charset="-120"/>
               </a:rPr>
-              <a:t>איפה המתח</a:t>
-            </a:r>
-            <a:endParaRPr lang="he-IL" sz="1800" dirty="0"/>
-          </a:p>
-        </p:txBody>
-      </p:sp>
-      <p:sp>
-        <p:nvSpPr>
-          <p:cNvPr id="14" name="Shape 10"/>
+              <a:t>אלא שכאן נוצר מתח: </a:t>
+            </a:r>
+            <a:pPr algn="r" indent="0" marL="0">
+              <a:lnSpc>
+                <a:spcPct val="115000"/>
+              </a:lnSpc>
+              <a:buNone/>
+            </a:pPr>
+            <a:r>
+              <a:rPr lang="he-IL" altLang="en-US" sz="1600" dirty="0">
+                <a:solidFill>
+                  <a:srgbClr val="1B2B2E"/>
+                </a:solidFill>
+                <a:latin typeface="Arial" pitchFamily="34" charset="0"/>
+                <a:ea typeface="Arial" pitchFamily="34" charset="-122"/>
+                <a:cs typeface="Arial" pitchFamily="34" charset="-120"/>
+              </a:rPr>
+              <a:t>בתיאוריה, רצף לימודי הוא עניין פדגוגי של המשך תוכן, יחסים ושגרה. במציאות, בשבע וחצי בבוקר, המנהל צריך קודם כול שמישהו יהיה בכיתה. רוב המחקרים בודקים כמה מורים נעדרים, מדוע ומה המחיר, ומעט ידוע על מה שהמנהל עושה ושוקל ברגע ההיעדרות עצמו.</a:t>
+            </a:r>
+            <a:endParaRPr lang="he-IL" sz="1600" dirty="0"/>
+          </a:p>
+        </p:txBody>
+      </p:sp>
+      <p:sp>
+        <p:nvSpPr>
+          <p:cNvPr id="13" name="Shape 9"/>
           <p:cNvSpPr/>
           <p:nvPr/>
         </p:nvSpPr>
         <p:spPr>
           <a:xfrm>
-            <a:off x="548640" y="1965960"/>
-            <a:ext cx="3520440" cy="2331720"/>
+            <a:off x="548640" y="4892040"/>
+            <a:ext cx="11091672" cy="1143000"/>
           </a:xfrm>
           <a:prstGeom prst="roundRect">
             <a:avLst>
-              <a:gd name="adj" fmla="val 4706"/>
+              <a:gd name="adj" fmla="val 9600"/>
             </a:avLst>
-          </a:prstGeom>
-          <a:solidFill>
-            <a:srgbClr val="E4F0F0"/>
-          </a:solidFill>
-          <a:ln w="12700">
-            <a:solidFill>
-              <a:srgbClr val="E4F0F0"/>
-            </a:solidFill>
-            <a:prstDash val="solid"/>
-          </a:ln>
-        </p:spPr>
-      </p:sp>
-      <p:sp>
-        <p:nvSpPr>
-          <p:cNvPr id="15" name="Shape 11"/>
-          <p:cNvSpPr/>
-          <p:nvPr/>
-        </p:nvSpPr>
-        <p:spPr>
-          <a:xfrm>
-            <a:off x="3383280" y="2167128"/>
-            <a:ext cx="457200" cy="457200"/>
-          </a:xfrm>
-          <a:prstGeom prst="ellipse">
-            <a:avLst/>
           </a:prstGeom>
           <a:solidFill>
             <a:srgbClr val="12343B"/>
@@ -2381,9 +2035,34 @@
           </a:ln>
         </p:spPr>
       </p:sp>
+      <p:sp>
+        <p:nvSpPr>
+          <p:cNvPr id="14" name="Shape 10"/>
+          <p:cNvSpPr/>
+          <p:nvPr/>
+        </p:nvSpPr>
+        <p:spPr>
+          <a:xfrm>
+            <a:off x="10908792" y="5047488"/>
+            <a:ext cx="457200" cy="457200"/>
+          </a:xfrm>
+          <a:prstGeom prst="ellipse">
+            <a:avLst/>
+          </a:prstGeom>
+          <a:solidFill>
+            <a:srgbClr val="E9A23B"/>
+          </a:solidFill>
+          <a:ln w="12700">
+            <a:solidFill>
+              <a:srgbClr val="E9A23B"/>
+            </a:solidFill>
+            <a:prstDash val="solid"/>
+          </a:ln>
+        </p:spPr>
+      </p:sp>
       <p:pic>
         <p:nvPicPr>
-          <p:cNvPr id="16" name="Image 2" descr="preencoded.png">    </p:cNvPr>
+          <p:cNvPr id="15" name="Image 2" descr="preencoded.png">    </p:cNvPr>
           <p:cNvPicPr>
             <a:picLocks noChangeAspect="1"/>
           </p:cNvPicPr>
@@ -2397,7 +2076,7 @@
         </p:blipFill>
         <p:spPr>
           <a:xfrm>
-            <a:off x="3497580" y="2281428"/>
+            <a:off x="11023092" y="5161788"/>
             <a:ext cx="228600" cy="228600"/>
           </a:xfrm>
           <a:prstGeom prst="rect">
@@ -2407,14 +2086,14 @@
       </p:pic>
       <p:sp>
         <p:nvSpPr>
-          <p:cNvPr id="17" name="Text 12"/>
+          <p:cNvPr id="16" name="Text 11"/>
           <p:cNvSpPr txBox="1"/>
           <p:nvPr/>
         </p:nvSpPr>
         <p:spPr>
           <a:xfrm>
-            <a:off x="777240" y="2194560"/>
-            <a:ext cx="2468880" cy="411480"/>
+            <a:off x="868680" y="5029200"/>
+            <a:ext cx="9811512" cy="868680"/>
           </a:xfrm>
           <a:prstGeom prst="rect">
             <a:avLst/>
@@ -2423,684 +2102,42 @@
           <a:ln/>
         </p:spPr>
         <p:txBody>
-          <a:bodyPr wrap="square" lIns="0" tIns="0" rIns="0" bIns="0" rtlCol="0" anchor="ctr"/>
-          <a:lstStyle/>
-          <a:p>
-            <a:pPr rtl="1" algn="r" indent="0" marL="0">
-              <a:buNone/>
-            </a:pPr>
-            <a:r>
-              <a:rPr lang="he-IL" altLang="en-US" sz="1800" b="1" dirty="0">
-                <a:solidFill>
-                  <a:srgbClr val="12343B"/>
-                </a:solidFill>
-                <a:latin typeface="Arial" pitchFamily="34" charset="0"/>
-                <a:ea typeface="Arial" pitchFamily="34" charset="-122"/>
-                <a:cs typeface="Arial" pitchFamily="34" charset="-120"/>
-              </a:rPr>
-              <a:t>מה עדיין לא ברור</a:t>
-            </a:r>
-            <a:endParaRPr lang="he-IL" sz="1800" dirty="0"/>
-          </a:p>
-        </p:txBody>
-      </p:sp>
-      <p:sp>
-        <p:nvSpPr>
-          <p:cNvPr id="18" name="Shape 13"/>
-          <p:cNvSpPr/>
-          <p:nvPr/>
-        </p:nvSpPr>
-        <p:spPr>
-          <a:xfrm>
-            <a:off x="7827264" y="2971800"/>
-            <a:ext cx="320040" cy="320040"/>
-          </a:xfrm>
-          <a:prstGeom prst="ellipse">
-            <a:avLst/>
-          </a:prstGeom>
-          <a:solidFill>
-            <a:srgbClr val="E9A23B"/>
-          </a:solidFill>
-          <a:ln w="12700">
-            <a:solidFill>
-              <a:srgbClr val="E9A23B"/>
-            </a:solidFill>
-            <a:prstDash val="solid"/>
-          </a:ln>
-        </p:spPr>
-      </p:sp>
-      <p:pic>
-        <p:nvPicPr>
-          <p:cNvPr id="19" name="Image 3" descr="preencoded.png">    </p:cNvPr>
-          <p:cNvPicPr>
-            <a:picLocks noChangeAspect="1"/>
-          </p:cNvPicPr>
-          <p:nvPr/>
-        </p:nvPicPr>
-        <p:blipFill>
-          <a:blip r:embed="rId4"/>
-          <a:stretch>
-            <a:fillRect/>
-          </a:stretch>
-        </p:blipFill>
-        <p:spPr>
-          <a:xfrm>
-            <a:off x="7907274" y="3051810"/>
-            <a:ext cx="160020" cy="160020"/>
-          </a:xfrm>
-          <a:prstGeom prst="rect">
-            <a:avLst/>
-          </a:prstGeom>
-        </p:spPr>
-      </p:pic>
-      <p:sp>
-        <p:nvSpPr>
-          <p:cNvPr id="20" name="Shape 14"/>
-          <p:cNvSpPr/>
-          <p:nvPr/>
-        </p:nvSpPr>
-        <p:spPr>
-          <a:xfrm>
-            <a:off x="4041648" y="2971800"/>
-            <a:ext cx="320040" cy="320040"/>
-          </a:xfrm>
-          <a:prstGeom prst="ellipse">
-            <a:avLst/>
-          </a:prstGeom>
-          <a:solidFill>
-            <a:srgbClr val="E9A23B"/>
-          </a:solidFill>
-          <a:ln w="12700">
-            <a:solidFill>
-              <a:srgbClr val="E9A23B"/>
-            </a:solidFill>
-            <a:prstDash val="solid"/>
-          </a:ln>
-        </p:spPr>
-      </p:sp>
-      <p:pic>
-        <p:nvPicPr>
-          <p:cNvPr id="21" name="Image 4" descr="preencoded.png">    </p:cNvPr>
-          <p:cNvPicPr>
-            <a:picLocks noChangeAspect="1"/>
-          </p:cNvPicPr>
-          <p:nvPr/>
-        </p:nvPicPr>
-        <p:blipFill>
-          <a:blip r:embed="rId5"/>
-          <a:stretch>
-            <a:fillRect/>
-          </a:stretch>
-        </p:blipFill>
-        <p:spPr>
-          <a:xfrm>
-            <a:off x="4121658" y="3051810"/>
-            <a:ext cx="160020" cy="160020"/>
-          </a:xfrm>
-          <a:prstGeom prst="rect">
-            <a:avLst/>
-          </a:prstGeom>
-        </p:spPr>
-      </p:pic>
-      <p:sp>
-        <p:nvSpPr>
-          <p:cNvPr id="22" name="Text 15"/>
-          <p:cNvSpPr txBox="1"/>
-          <p:nvPr/>
-        </p:nvSpPr>
-        <p:spPr>
-          <a:xfrm>
-            <a:off x="8348472" y="2788920"/>
-            <a:ext cx="3063240" cy="1371600"/>
-          </a:xfrm>
-          <a:prstGeom prst="rect">
-            <a:avLst/>
-          </a:prstGeom>
-          <a:noFill/>
-          <a:ln/>
-        </p:spPr>
-        <p:txBody>
           <a:bodyPr wrap="square" lIns="0" tIns="0" rIns="0" bIns="0" rtlCol="0" anchor="t"/>
           <a:lstStyle/>
           <a:p>
             <a:pPr algn="r" indent="0" marL="0">
-              <a:buNone/>
-            </a:pPr>
-            <a:r>
-              <a:rPr lang="he-IL" altLang="en-US" sz="1350" b="1" dirty="0">
-                <a:solidFill>
-                  <a:srgbClr val="1B2B2E"/>
-                </a:solidFill>
-                <a:latin typeface="Arial" pitchFamily="34" charset="0"/>
-                <a:ea typeface="Arial" pitchFamily="34" charset="-122"/>
-                <a:cs typeface="Arial" pitchFamily="34" charset="-120"/>
-              </a:rPr>
-              <a:t>היעדרויות פוגעות בלמידה, במיוחד כשהן מצטברות</a:t>
-            </a:r>
-            <a:endParaRPr lang="he-IL" sz="1350" dirty="0"/>
-          </a:p>
-          <a:p>
+              <a:lnSpc>
+                <a:spcPct val="115000"/>
+              </a:lnSpc>
+              <a:buNone/>
+            </a:pPr>
+            <a:r>
+              <a:rPr lang="he-IL" altLang="en-US" sz="1600" b="1" dirty="0">
+                <a:solidFill>
+                  <a:srgbClr val="E9A23B"/>
+                </a:solidFill>
+                <a:latin typeface="Arial" pitchFamily="34" charset="0"/>
+                <a:ea typeface="Arial" pitchFamily="34" charset="-122"/>
+                <a:cs typeface="Arial" pitchFamily="34" charset="-120"/>
+              </a:rPr>
+              <a:t>הקריאה שינתה גם את החשיבה שלנו. </a:t>
+            </a:r>
             <a:pPr algn="r" indent="0" marL="0">
-              <a:buNone/>
-            </a:pPr>
-            <a:r>
-              <a:rPr lang="he-IL" altLang="en-US" sz="1000" dirty="0">
-                <a:solidFill>
-                  <a:srgbClr val="4F6A6E"/>
-                </a:solidFill>
-                <a:latin typeface="Arial" pitchFamily="34" charset="0"/>
-                <a:ea typeface="Arial" pitchFamily="34" charset="-122"/>
-                <a:cs typeface="Arial" pitchFamily="34" charset="-120"/>
-              </a:rPr>
-              <a:t>Miller et al., 2008; Clotfelter et al., 2009</a:t>
-            </a:r>
-            <a:endParaRPr lang="he-IL" sz="1350" dirty="0"/>
-          </a:p>
-          <a:p>
-            <a:pPr algn="r" indent="0" marL="0">
-              <a:buNone/>
-            </a:pPr>
-            <a:r>
-              <a:rPr lang="he-IL" altLang="en-US" sz="600" dirty="0">
-                <a:solidFill>
-                  <a:srgbClr val="1B2B2E"/>
-                </a:solidFill>
-                <a:latin typeface="Arial" pitchFamily="34" charset="0"/>
-                <a:ea typeface="Arial" pitchFamily="34" charset="-122"/>
-                <a:cs typeface="Arial" pitchFamily="34" charset="-120"/>
-              </a:rPr>
-              <a:t> </a:t>
-            </a:r>
-            <a:endParaRPr lang="he-IL" sz="1350" dirty="0"/>
-          </a:p>
-          <a:p>
-            <a:pPr algn="r" indent="0" marL="0">
-              <a:buNone/>
-            </a:pPr>
-            <a:r>
-              <a:rPr lang="he-IL" altLang="en-US" sz="1350" b="1" dirty="0">
-                <a:solidFill>
-                  <a:srgbClr val="1B2B2E"/>
-                </a:solidFill>
-                <a:latin typeface="Arial" pitchFamily="34" charset="0"/>
-                <a:ea typeface="Arial" pitchFamily="34" charset="-122"/>
-                <a:cs typeface="Arial" pitchFamily="34" charset="-120"/>
-              </a:rPr>
-              <a:t>המנהל לא רק מגיב: האקלים שהוא יוצר קשור גם להיקף ההיעדרויות</a:t>
-            </a:r>
-            <a:endParaRPr lang="he-IL" sz="1350" dirty="0"/>
-          </a:p>
-          <a:p>
-            <a:pPr algn="r" indent="0" marL="0">
-              <a:buNone/>
-            </a:pPr>
-            <a:r>
-              <a:rPr lang="he-IL" altLang="en-US" sz="1000" dirty="0">
-                <a:solidFill>
-                  <a:srgbClr val="4F6A6E"/>
-                </a:solidFill>
-                <a:latin typeface="Arial" pitchFamily="34" charset="0"/>
-                <a:ea typeface="Arial" pitchFamily="34" charset="-122"/>
-                <a:cs typeface="Arial" pitchFamily="34" charset="-120"/>
-              </a:rPr>
-              <a:t>Shapira-Lishchinsky &amp; Rosenblatt, 2010</a:t>
-            </a:r>
-            <a:endParaRPr lang="he-IL" sz="1350" dirty="0"/>
-          </a:p>
-        </p:txBody>
-      </p:sp>
-      <p:sp>
-        <p:nvSpPr>
-          <p:cNvPr id="23" name="Text 16"/>
-          <p:cNvSpPr txBox="1"/>
-          <p:nvPr/>
-        </p:nvSpPr>
-        <p:spPr>
-          <a:xfrm>
-            <a:off x="4562856" y="2788920"/>
-            <a:ext cx="3063240" cy="1371600"/>
-          </a:xfrm>
-          <a:prstGeom prst="rect">
-            <a:avLst/>
-          </a:prstGeom>
-          <a:noFill/>
-          <a:ln/>
-        </p:spPr>
-        <p:txBody>
-          <a:bodyPr wrap="square" lIns="0" tIns="0" rIns="0" bIns="0" rtlCol="0" anchor="t"/>
-          <a:lstStyle/>
-          <a:p>
-            <a:pPr algn="r" indent="0" marL="0">
-              <a:buNone/>
-            </a:pPr>
-            <a:r>
-              <a:rPr lang="he-IL" altLang="en-US" sz="1350" b="1" dirty="0">
-                <a:solidFill>
-                  <a:srgbClr val="1B2B2E"/>
-                </a:solidFill>
-                <a:latin typeface="Arial" pitchFamily="34" charset="0"/>
-                <a:ea typeface="Arial" pitchFamily="34" charset="-122"/>
-                <a:cs typeface="Arial" pitchFamily="34" charset="-120"/>
-              </a:rPr>
-              <a:t>בתיאוריה: </a:t>
-            </a:r>
-            <a:pPr algn="r" indent="0" marL="0">
-              <a:buNone/>
-            </a:pPr>
-            <a:r>
-              <a:rPr lang="he-IL" altLang="en-US" sz="1350" dirty="0">
-                <a:solidFill>
-                  <a:srgbClr val="1B2B2E"/>
-                </a:solidFill>
-                <a:latin typeface="Arial" pitchFamily="34" charset="0"/>
-                <a:ea typeface="Arial" pitchFamily="34" charset="-122"/>
-                <a:cs typeface="Arial" pitchFamily="34" charset="-120"/>
-              </a:rPr>
-              <a:t>רצף לימודי הוא עניין פדגוגי, כלומר המשך תוכן, יחסים ושגרה.</a:t>
-            </a:r>
-            <a:endParaRPr lang="he-IL" sz="1350" dirty="0"/>
-          </a:p>
-          <a:p>
-            <a:pPr algn="r" indent="0" marL="0">
-              <a:buNone/>
-            </a:pPr>
-            <a:r>
-              <a:rPr lang="he-IL" altLang="en-US" sz="600" dirty="0">
-                <a:solidFill>
-                  <a:srgbClr val="1B2B2E"/>
-                </a:solidFill>
-                <a:latin typeface="Arial" pitchFamily="34" charset="0"/>
-                <a:ea typeface="Arial" pitchFamily="34" charset="-122"/>
-                <a:cs typeface="Arial" pitchFamily="34" charset="-120"/>
-              </a:rPr>
-              <a:t> </a:t>
-            </a:r>
-            <a:endParaRPr lang="he-IL" sz="1350" dirty="0"/>
-          </a:p>
-          <a:p>
-            <a:pPr algn="r" indent="0" marL="0">
-              <a:buNone/>
-            </a:pPr>
-            <a:r>
-              <a:rPr lang="he-IL" altLang="en-US" sz="1350" b="1" dirty="0">
-                <a:solidFill>
-                  <a:srgbClr val="1B2B2E"/>
-                </a:solidFill>
-                <a:latin typeface="Arial" pitchFamily="34" charset="0"/>
-                <a:ea typeface="Arial" pitchFamily="34" charset="-122"/>
-                <a:cs typeface="Arial" pitchFamily="34" charset="-120"/>
-              </a:rPr>
-              <a:t>במציאות, ב־7:30 בבוקר: </a:t>
-            </a:r>
-            <a:pPr algn="r" indent="0" marL="0">
-              <a:buNone/>
-            </a:pPr>
-            <a:r>
-              <a:rPr lang="he-IL" altLang="en-US" sz="1350" dirty="0">
-                <a:solidFill>
-                  <a:srgbClr val="1B2B2E"/>
-                </a:solidFill>
-                <a:latin typeface="Arial" pitchFamily="34" charset="0"/>
-                <a:ea typeface="Arial" pitchFamily="34" charset="-122"/>
-                <a:cs typeface="Arial" pitchFamily="34" charset="-120"/>
-              </a:rPr>
-              <a:t>קודם כול צריך שמישהו יהיה בכיתה.</a:t>
-            </a:r>
-            <a:endParaRPr lang="he-IL" sz="1350" dirty="0"/>
-          </a:p>
-        </p:txBody>
-      </p:sp>
-      <p:sp>
-        <p:nvSpPr>
-          <p:cNvPr id="24" name="Text 17"/>
-          <p:cNvSpPr txBox="1"/>
-          <p:nvPr/>
-        </p:nvSpPr>
-        <p:spPr>
-          <a:xfrm>
-            <a:off x="777240" y="2788920"/>
-            <a:ext cx="3063240" cy="1371600"/>
-          </a:xfrm>
-          <a:prstGeom prst="rect">
-            <a:avLst/>
-          </a:prstGeom>
-          <a:noFill/>
-          <a:ln/>
-        </p:spPr>
-        <p:txBody>
-          <a:bodyPr wrap="square" lIns="0" tIns="0" rIns="0" bIns="0" rtlCol="0" anchor="t"/>
-          <a:lstStyle/>
-          <a:p>
-            <a:pPr algn="r" indent="0" marL="0">
-              <a:buNone/>
-            </a:pPr>
-            <a:r>
-              <a:rPr lang="he-IL" altLang="en-US" sz="1350" dirty="0">
-                <a:solidFill>
-                  <a:srgbClr val="1B2B2E"/>
-                </a:solidFill>
-                <a:latin typeface="Arial" pitchFamily="34" charset="0"/>
-                <a:ea typeface="Arial" pitchFamily="34" charset="-122"/>
-                <a:cs typeface="Arial" pitchFamily="34" charset="-120"/>
-              </a:rPr>
-              <a:t>המחקר בודק בעיקר </a:t>
-            </a:r>
-            <a:pPr algn="r" indent="0" marL="0">
-              <a:buNone/>
-            </a:pPr>
-            <a:r>
-              <a:rPr lang="he-IL" altLang="en-US" sz="1350" b="1" dirty="0">
-                <a:solidFill>
-                  <a:srgbClr val="1B2B2E"/>
-                </a:solidFill>
-                <a:latin typeface="Arial" pitchFamily="34" charset="0"/>
-                <a:ea typeface="Arial" pitchFamily="34" charset="-122"/>
-                <a:cs typeface="Arial" pitchFamily="34" charset="-120"/>
-              </a:rPr>
-              <a:t>כמה ולמה</a:t>
-            </a:r>
-            <a:pPr algn="r" indent="0" marL="0">
-              <a:buNone/>
-            </a:pPr>
-            <a:r>
-              <a:rPr lang="he-IL" altLang="en-US" sz="1350" dirty="0">
-                <a:solidFill>
-                  <a:srgbClr val="1B2B2E"/>
-                </a:solidFill>
-                <a:latin typeface="Arial" pitchFamily="34" charset="0"/>
-                <a:ea typeface="Arial" pitchFamily="34" charset="-122"/>
-                <a:cs typeface="Arial" pitchFamily="34" charset="-120"/>
-              </a:rPr>
-              <a:t> מורים נעדרים ומה המחיר.</a:t>
-            </a:r>
-            <a:endParaRPr lang="he-IL" sz="1350" dirty="0"/>
-          </a:p>
-          <a:p>
-            <a:pPr algn="r" indent="0" marL="0">
-              <a:buNone/>
-            </a:pPr>
-            <a:r>
-              <a:rPr lang="he-IL" altLang="en-US" sz="600" dirty="0">
-                <a:solidFill>
-                  <a:srgbClr val="1B2B2E"/>
-                </a:solidFill>
-                <a:latin typeface="Arial" pitchFamily="34" charset="0"/>
-                <a:ea typeface="Arial" pitchFamily="34" charset="-122"/>
-                <a:cs typeface="Arial" pitchFamily="34" charset="-120"/>
-              </a:rPr>
-              <a:t> </a:t>
-            </a:r>
-            <a:endParaRPr lang="he-IL" sz="1350" dirty="0"/>
-          </a:p>
-          <a:p>
-            <a:pPr algn="r" indent="0" marL="0">
-              <a:buNone/>
-            </a:pPr>
-            <a:r>
-              <a:rPr lang="he-IL" altLang="en-US" sz="1350" dirty="0">
-                <a:solidFill>
-                  <a:srgbClr val="1B2B2E"/>
-                </a:solidFill>
-                <a:latin typeface="Arial" pitchFamily="34" charset="0"/>
-                <a:ea typeface="Arial" pitchFamily="34" charset="-122"/>
-                <a:cs typeface="Arial" pitchFamily="34" charset="-120"/>
-              </a:rPr>
-              <a:t>מעט ידוע על מה שהמנהל </a:t>
-            </a:r>
-            <a:pPr algn="r" indent="0" marL="0">
-              <a:buNone/>
-            </a:pPr>
-            <a:r>
-              <a:rPr lang="he-IL" altLang="en-US" sz="1350" b="1" dirty="0">
-                <a:solidFill>
-                  <a:srgbClr val="1B2B2E"/>
-                </a:solidFill>
-                <a:latin typeface="Arial" pitchFamily="34" charset="0"/>
-                <a:ea typeface="Arial" pitchFamily="34" charset="-122"/>
-                <a:cs typeface="Arial" pitchFamily="34" charset="-120"/>
-              </a:rPr>
-              <a:t>עושה ושוקל</a:t>
-            </a:r>
-            <a:pPr algn="r" indent="0" marL="0">
-              <a:buNone/>
-            </a:pPr>
-            <a:r>
-              <a:rPr lang="he-IL" altLang="en-US" sz="1350" dirty="0">
-                <a:solidFill>
-                  <a:srgbClr val="1B2B2E"/>
-                </a:solidFill>
-                <a:latin typeface="Arial" pitchFamily="34" charset="0"/>
-                <a:ea typeface="Arial" pitchFamily="34" charset="-122"/>
-                <a:cs typeface="Arial" pitchFamily="34" charset="-120"/>
-              </a:rPr>
-              <a:t> ברגע ההיעדרות עצמו.</a:t>
-            </a:r>
-            <a:endParaRPr lang="he-IL" sz="1350" dirty="0"/>
-          </a:p>
-        </p:txBody>
-      </p:sp>
-      <p:sp>
-        <p:nvSpPr>
-          <p:cNvPr id="25" name="Shape 18"/>
-          <p:cNvSpPr/>
-          <p:nvPr/>
-        </p:nvSpPr>
-        <p:spPr>
-          <a:xfrm>
-            <a:off x="548640" y="4617720"/>
-            <a:ext cx="11091672" cy="1645920"/>
-          </a:xfrm>
-          <a:prstGeom prst="roundRect">
-            <a:avLst>
-              <a:gd name="adj" fmla="val 6667"/>
-            </a:avLst>
-          </a:prstGeom>
-          <a:solidFill>
-            <a:srgbClr val="12343B"/>
-          </a:solidFill>
-          <a:ln w="12700">
-            <a:solidFill>
-              <a:srgbClr val="12343B"/>
-            </a:solidFill>
-            <a:prstDash val="solid"/>
-          </a:ln>
-        </p:spPr>
-      </p:sp>
-      <p:sp>
-        <p:nvSpPr>
-          <p:cNvPr id="26" name="Text 19"/>
-          <p:cNvSpPr txBox="1"/>
-          <p:nvPr/>
-        </p:nvSpPr>
-        <p:spPr>
-          <a:xfrm>
-            <a:off x="868680" y="4754880"/>
-            <a:ext cx="10451592" cy="365760"/>
-          </a:xfrm>
-          <a:prstGeom prst="rect">
-            <a:avLst/>
-          </a:prstGeom>
-          <a:noFill/>
-          <a:ln/>
-        </p:spPr>
-        <p:txBody>
-          <a:bodyPr wrap="square" lIns="0" tIns="0" rIns="0" bIns="0" rtlCol="0" anchor="t"/>
-          <a:lstStyle/>
-          <a:p>
-            <a:pPr rtl="1" algn="r" indent="0" marL="0">
-              <a:buNone/>
-            </a:pPr>
-            <a:r>
-              <a:rPr lang="he-IL" altLang="en-US" sz="1400" b="1" dirty="0">
-                <a:solidFill>
-                  <a:srgbClr val="E9A23B"/>
-                </a:solidFill>
-                <a:latin typeface="Arial" pitchFamily="34" charset="0"/>
-                <a:ea typeface="Arial" pitchFamily="34" charset="-122"/>
-                <a:cs typeface="Arial" pitchFamily="34" charset="-120"/>
-              </a:rPr>
-              <a:t>השינוי בחשיבה שלנו</a:t>
-            </a:r>
-            <a:endParaRPr lang="he-IL" sz="1400" dirty="0"/>
-          </a:p>
-        </p:txBody>
-      </p:sp>
-      <p:sp>
-        <p:nvSpPr>
-          <p:cNvPr id="27" name="Text 20"/>
-          <p:cNvSpPr txBox="1"/>
-          <p:nvPr/>
-        </p:nvSpPr>
-        <p:spPr>
-          <a:xfrm>
-            <a:off x="6720840" y="5166360"/>
-            <a:ext cx="4599432" cy="914400"/>
-          </a:xfrm>
-          <a:prstGeom prst="rect">
-            <a:avLst/>
-          </a:prstGeom>
-          <a:noFill/>
-          <a:ln/>
-        </p:spPr>
-        <p:txBody>
-          <a:bodyPr wrap="square" lIns="0" tIns="0" rIns="0" bIns="0" rtlCol="0" anchor="ctr"/>
-          <a:lstStyle/>
-          <a:p>
-            <a:pPr algn="r" indent="0" marL="0">
-              <a:buNone/>
-            </a:pPr>
-            <a:r>
-              <a:rPr lang="he-IL" altLang="en-US" sz="1600" b="1" dirty="0">
-                <a:solidFill>
-                  <a:srgbClr val="A9D2D5"/>
-                </a:solidFill>
-                <a:latin typeface="Arial" pitchFamily="34" charset="0"/>
-                <a:ea typeface="Arial" pitchFamily="34" charset="-122"/>
-                <a:cs typeface="Arial" pitchFamily="34" charset="-120"/>
-              </a:rPr>
-              <a:t>בתחילת הדרך חשבנו</a:t>
-            </a:r>
-            <a:endParaRPr lang="he-IL" sz="1600" dirty="0"/>
-          </a:p>
-          <a:p>
-            <a:pPr algn="r" indent="0" marL="0">
+              <a:lnSpc>
+                <a:spcPct val="115000"/>
+              </a:lnSpc>
               <a:buNone/>
             </a:pPr>
             <a:r>
               <a:rPr lang="he-IL" altLang="en-US" sz="1600" dirty="0">
                 <a:solidFill>
-                  <a:srgbClr val="A9D2D5"/>
-                </a:solidFill>
-                <a:latin typeface="Arial" pitchFamily="34" charset="0"/>
-                <a:ea typeface="Arial" pitchFamily="34" charset="-122"/>
-                <a:cs typeface="Arial" pitchFamily="34" charset="-120"/>
-              </a:rPr>
-              <a:t>שהבעיה לוגיסטית: למצוא ממלא מקום.</a:t>
-            </a:r>
-            <a:endParaRPr lang="he-IL" sz="1600" dirty="0"/>
-          </a:p>
-        </p:txBody>
-      </p:sp>
-      <p:sp>
-        <p:nvSpPr>
-          <p:cNvPr id="28" name="Shape 21"/>
-          <p:cNvSpPr/>
-          <p:nvPr/>
-        </p:nvSpPr>
-        <p:spPr>
-          <a:xfrm>
-            <a:off x="5852160" y="5394960"/>
-            <a:ext cx="457200" cy="457200"/>
-          </a:xfrm>
-          <a:prstGeom prst="ellipse">
-            <a:avLst/>
-          </a:prstGeom>
-          <a:solidFill>
-            <a:srgbClr val="E9A23B"/>
-          </a:solidFill>
-          <a:ln w="12700">
-            <a:solidFill>
-              <a:srgbClr val="E9A23B"/>
-            </a:solidFill>
-            <a:prstDash val="solid"/>
-          </a:ln>
-        </p:spPr>
-      </p:sp>
-      <p:pic>
-        <p:nvPicPr>
-          <p:cNvPr id="29" name="Image 5" descr="preencoded.png">    </p:cNvPr>
-          <p:cNvPicPr>
-            <a:picLocks noChangeAspect="1"/>
-          </p:cNvPicPr>
-          <p:nvPr/>
-        </p:nvPicPr>
-        <p:blipFill>
-          <a:blip r:embed="rId6"/>
-          <a:stretch>
-            <a:fillRect/>
-          </a:stretch>
-        </p:blipFill>
-        <p:spPr>
-          <a:xfrm>
-            <a:off x="5966460" y="5509260"/>
-            <a:ext cx="228600" cy="228600"/>
-          </a:xfrm>
-          <a:prstGeom prst="rect">
-            <a:avLst/>
-          </a:prstGeom>
-        </p:spPr>
-      </p:pic>
-      <p:sp>
-        <p:nvSpPr>
-          <p:cNvPr id="30" name="Text 22"/>
-          <p:cNvSpPr txBox="1"/>
-          <p:nvPr/>
-        </p:nvSpPr>
-        <p:spPr>
-          <a:xfrm>
-            <a:off x="868680" y="5166360"/>
-            <a:ext cx="4754880" cy="914400"/>
-          </a:xfrm>
-          <a:prstGeom prst="rect">
-            <a:avLst/>
-          </a:prstGeom>
-          <a:noFill/>
-          <a:ln/>
-        </p:spPr>
-        <p:txBody>
-          <a:bodyPr wrap="square" lIns="0" tIns="0" rIns="0" bIns="0" rtlCol="0" anchor="ctr"/>
-          <a:lstStyle/>
-          <a:p>
-            <a:pPr algn="r" indent="0" marL="0">
-              <a:buNone/>
-            </a:pPr>
-            <a:r>
-              <a:rPr lang="he-IL" altLang="en-US" sz="1600" b="1" dirty="0">
-                <a:solidFill>
-                  <a:srgbClr val="E9A23B"/>
-                </a:solidFill>
-                <a:latin typeface="Arial" pitchFamily="34" charset="0"/>
-                <a:ea typeface="Arial" pitchFamily="34" charset="-122"/>
-                <a:cs typeface="Arial" pitchFamily="34" charset="-120"/>
-              </a:rPr>
-              <a:t>היום אנחנו מבינים</a:t>
-            </a:r>
-            <a:endParaRPr lang="he-IL" sz="1600" dirty="0"/>
-          </a:p>
-          <a:p>
-            <a:pPr algn="r" indent="0" marL="0">
-              <a:buNone/>
-            </a:pPr>
-            <a:r>
-              <a:rPr lang="he-IL" altLang="en-US" sz="1600" b="1" dirty="0">
-                <a:solidFill>
                   <a:srgbClr val="FFFFFF"/>
                 </a:solidFill>
                 <a:latin typeface="Arial" pitchFamily="34" charset="0"/>
                 <a:ea typeface="Arial" pitchFamily="34" charset="-122"/>
                 <a:cs typeface="Arial" pitchFamily="34" charset="-120"/>
               </a:rPr>
-              <a:t>שרצף הוא פדגוגי, ארגוני ורגשי, ושהמנהל פועל גם לפני ההיעדרות ולא רק אחריה.</a:t>
+              <a:t>בתחילת הדרך ראינו בבעיה עניין לוגיסטי של מציאת ממלא מקום. היום אנחנו מבינים שרצף לימודי הוא פדגוגי, ארגוני ורגשי, ושהמנהל פועל גם לפני ההיעדרות ולא רק אחריה.</a:t>
             </a:r>
             <a:endParaRPr lang="he-IL" sz="1600" dirty="0"/>
           </a:p>
@@ -3288,12 +2325,12 @@
         </p:nvSpPr>
         <p:spPr>
           <a:xfrm>
-            <a:off x="8778240" y="1965960"/>
-            <a:ext cx="2862072" cy="2880360"/>
+            <a:off x="548640" y="2011680"/>
+            <a:ext cx="2377440" cy="2743200"/>
           </a:xfrm>
           <a:prstGeom prst="roundRect">
             <a:avLst>
-              <a:gd name="adj" fmla="val 3834"/>
+              <a:gd name="adj" fmla="val 4615"/>
             </a:avLst>
           </a:prstGeom>
           <a:solidFill>
@@ -3315,8 +2352,8 @@
         </p:nvSpPr>
         <p:spPr>
           <a:xfrm>
-            <a:off x="9006840" y="2148840"/>
-            <a:ext cx="2404872" cy="320040"/>
+            <a:off x="548640" y="2514600"/>
+            <a:ext cx="2377440" cy="1005840"/>
           </a:xfrm>
           <a:prstGeom prst="rect">
             <a:avLst/>
@@ -3325,53 +2362,53 @@
           <a:ln/>
         </p:spPr>
         <p:txBody>
+          <a:bodyPr wrap="square" lIns="0" tIns="0" rIns="0" bIns="0" rtlCol="0" anchor="ctr"/>
+          <a:lstStyle/>
+          <a:p>
+            <a:pPr algn="ctr" indent="0" marL="0">
+              <a:buNone/>
+            </a:pPr>
+            <a:r>
+              <a:rPr lang="en-US" sz="6600" b="1" dirty="0">
+                <a:solidFill>
+                  <a:srgbClr val="E9A23B"/>
+                </a:solidFill>
+                <a:latin typeface="Arial" pitchFamily="34" charset="0"/>
+                <a:ea typeface="Arial" pitchFamily="34" charset="-122"/>
+                <a:cs typeface="Arial" pitchFamily="34" charset="-120"/>
+              </a:rPr>
+              <a:t>12</a:t>
+            </a:r>
+            <a:endParaRPr lang="en-US" sz="6600" dirty="0"/>
+          </a:p>
+        </p:txBody>
+      </p:sp>
+      <p:sp>
+        <p:nvSpPr>
+          <p:cNvPr id="8" name="Text 6"/>
+          <p:cNvSpPr txBox="1"/>
+          <p:nvPr/>
+        </p:nvSpPr>
+        <p:spPr>
+          <a:xfrm>
+            <a:off x="731520" y="3611880"/>
+            <a:ext cx="2011680" cy="914400"/>
+          </a:xfrm>
+          <a:prstGeom prst="rect">
+            <a:avLst/>
+          </a:prstGeom>
+          <a:noFill/>
+          <a:ln/>
+        </p:spPr>
+        <p:txBody>
           <a:bodyPr wrap="square" lIns="0" tIns="0" rIns="0" bIns="0" rtlCol="0" anchor="t"/>
           <a:lstStyle/>
           <a:p>
-            <a:pPr rtl="1" algn="r" indent="0" marL="0">
-              <a:buNone/>
-            </a:pPr>
-            <a:r>
-              <a:rPr lang="he-IL" altLang="en-US" sz="1400" b="1" dirty="0">
-                <a:solidFill>
-                  <a:srgbClr val="E9A23B"/>
-                </a:solidFill>
-                <a:latin typeface="Arial" pitchFamily="34" charset="0"/>
-                <a:ea typeface="Arial" pitchFamily="34" charset="-122"/>
-                <a:cs typeface="Arial" pitchFamily="34" charset="-120"/>
-              </a:rPr>
-              <a:t>את מי נחקור</a:t>
-            </a:r>
-            <a:endParaRPr lang="he-IL" sz="1400" dirty="0"/>
-          </a:p>
-        </p:txBody>
-      </p:sp>
-      <p:sp>
-        <p:nvSpPr>
-          <p:cNvPr id="8" name="Text 6"/>
-          <p:cNvSpPr txBox="1"/>
-          <p:nvPr/>
-        </p:nvSpPr>
-        <p:spPr>
-          <a:xfrm>
-            <a:off x="9006840" y="2423160"/>
-            <a:ext cx="2404872" cy="868680"/>
-          </a:xfrm>
-          <a:prstGeom prst="rect">
-            <a:avLst/>
-          </a:prstGeom>
-          <a:noFill/>
-          <a:ln/>
-        </p:spPr>
-        <p:txBody>
-          <a:bodyPr wrap="square" lIns="0" tIns="0" rIns="0" bIns="0" rtlCol="0" anchor="ctr"/>
-          <a:lstStyle/>
-          <a:p>
-            <a:pPr algn="r" indent="0" marL="0">
-              <a:buNone/>
-            </a:pPr>
-            <a:r>
-              <a:rPr lang="en-US" sz="6000" b="1" dirty="0">
+            <a:pPr algn="ctr" indent="0" marL="0">
+              <a:buNone/>
+            </a:pPr>
+            <a:r>
+              <a:rPr lang="en-US" sz="1600" b="1" dirty="0">
                 <a:solidFill>
                   <a:srgbClr val="FFFFFF"/>
                 </a:solidFill>
@@ -3379,55 +2416,16 @@
                 <a:ea typeface="Arial" pitchFamily="34" charset="-122"/>
                 <a:cs typeface="Arial" pitchFamily="34" charset="-120"/>
               </a:rPr>
-              <a:t>12</a:t>
-            </a:r>
-            <a:endParaRPr lang="en-US" sz="6000" dirty="0"/>
-          </a:p>
-        </p:txBody>
-      </p:sp>
-      <p:sp>
-        <p:nvSpPr>
-          <p:cNvPr id="9" name="Text 7"/>
-          <p:cNvSpPr txBox="1"/>
-          <p:nvPr/>
-        </p:nvSpPr>
-        <p:spPr>
-          <a:xfrm>
-            <a:off x="9006840" y="3429000"/>
-            <a:ext cx="2404872" cy="1280160"/>
-          </a:xfrm>
-          <a:prstGeom prst="rect">
-            <a:avLst/>
-          </a:prstGeom>
-          <a:noFill/>
-          <a:ln/>
-        </p:spPr>
-        <p:txBody>
-          <a:bodyPr wrap="square" lIns="0" tIns="0" rIns="0" bIns="0" rtlCol="0" anchor="t"/>
-          <a:lstStyle/>
-          <a:p>
-            <a:pPr algn="r" indent="0" marL="0">
-              <a:buNone/>
-            </a:pPr>
-            <a:r>
-              <a:rPr lang="he-IL" altLang="en-US" sz="1600" b="1" dirty="0">
-                <a:solidFill>
-                  <a:srgbClr val="FFFFFF"/>
-                </a:solidFill>
-                <a:latin typeface="Arial" pitchFamily="34" charset="0"/>
-                <a:ea typeface="Arial" pitchFamily="34" charset="-122"/>
-                <a:cs typeface="Arial" pitchFamily="34" charset="-120"/>
-              </a:rPr>
               <a:t>מנהלים ומנהלות</a:t>
             </a:r>
-            <a:endParaRPr lang="he-IL" sz="1600" dirty="0"/>
-          </a:p>
-          <a:p>
-            <a:pPr algn="r" indent="0" marL="0">
-              <a:buNone/>
-            </a:pPr>
-            <a:r>
-              <a:rPr lang="he-IL" altLang="en-US" sz="1200" dirty="0">
+            <a:endParaRPr lang="en-US" sz="1600" dirty="0"/>
+          </a:p>
+          <a:p>
+            <a:pPr algn="ctr" indent="0" marL="0">
+              <a:buNone/>
+            </a:pPr>
+            <a:r>
+              <a:rPr lang="en-US" sz="1400" dirty="0">
                 <a:solidFill>
                   <a:srgbClr val="A9D2D5"/>
                 </a:solidFill>
@@ -3435,83 +2433,22 @@
                 <a:ea typeface="Arial" pitchFamily="34" charset="-122"/>
                 <a:cs typeface="Arial" pitchFamily="34" charset="-120"/>
               </a:rPr>
-              <a:t>בצפון הארץ, מאזורים ויישובים שונים: עירוני וכפרי, יסודי ועל־יסודי, ותק שונה</a:t>
-            </a:r>
-            <a:endParaRPr lang="he-IL" sz="1600" dirty="0"/>
-          </a:p>
-          <a:p>
-            <a:pPr algn="r" indent="0" marL="0">
-              <a:buNone/>
-            </a:pPr>
-            <a:r>
-              <a:rPr lang="he-IL" altLang="en-US" sz="500" dirty="0">
-                <a:solidFill>
-                  <a:srgbClr val="FFFFFF"/>
-                </a:solidFill>
-                <a:latin typeface="Arial" pitchFamily="34" charset="0"/>
-                <a:ea typeface="Arial" pitchFamily="34" charset="-122"/>
-                <a:cs typeface="Arial" pitchFamily="34" charset="-120"/>
-              </a:rPr>
-              <a:t> </a:t>
-            </a:r>
-            <a:endParaRPr lang="he-IL" sz="1600" dirty="0"/>
-          </a:p>
-          <a:p>
-            <a:pPr algn="r" indent="0" marL="0">
-              <a:buNone/>
-            </a:pPr>
-            <a:r>
-              <a:rPr lang="he-IL" altLang="en-US" sz="1200" b="1" dirty="0">
-                <a:solidFill>
-                  <a:srgbClr val="E9A23B"/>
-                </a:solidFill>
-                <a:latin typeface="Arial" pitchFamily="34" charset="0"/>
-                <a:ea typeface="Arial" pitchFamily="34" charset="-122"/>
-                <a:cs typeface="Arial" pitchFamily="34" charset="-120"/>
-              </a:rPr>
-              <a:t>למה הם? הם מקבלי ההחלטות.</a:t>
-            </a:r>
-            <a:endParaRPr lang="he-IL" sz="1600" dirty="0"/>
-          </a:p>
-        </p:txBody>
-      </p:sp>
-      <p:sp>
-        <p:nvSpPr>
-          <p:cNvPr id="10" name="Shape 8"/>
+              <a:t>בערים בצפון הארץ</a:t>
+            </a:r>
+            <a:endParaRPr lang="en-US" sz="1600" dirty="0"/>
+          </a:p>
+        </p:txBody>
+      </p:sp>
+      <p:sp>
+        <p:nvSpPr>
+          <p:cNvPr id="9" name="Shape 7"/>
           <p:cNvSpPr/>
           <p:nvPr/>
         </p:nvSpPr>
         <p:spPr>
           <a:xfrm>
-            <a:off x="4663440" y="1965960"/>
-            <a:ext cx="3840480" cy="1371600"/>
-          </a:xfrm>
-          <a:prstGeom prst="roundRect">
-            <a:avLst>
-              <a:gd name="adj" fmla="val 6667"/>
-            </a:avLst>
-          </a:prstGeom>
-          <a:solidFill>
-            <a:srgbClr val="E4F0F0"/>
-          </a:solidFill>
-          <a:ln w="12700">
-            <a:solidFill>
-              <a:srgbClr val="E4F0F0"/>
-            </a:solidFill>
-            <a:prstDash val="solid"/>
-          </a:ln>
-        </p:spPr>
-      </p:sp>
-      <p:sp>
-        <p:nvSpPr>
-          <p:cNvPr id="11" name="Shape 9"/>
-          <p:cNvSpPr/>
-          <p:nvPr/>
-        </p:nvSpPr>
-        <p:spPr>
-          <a:xfrm>
-            <a:off x="7936992" y="2121408"/>
-            <a:ext cx="402336" cy="402336"/>
+            <a:off x="11183112" y="2029968"/>
+            <a:ext cx="457200" cy="457200"/>
           </a:xfrm>
           <a:prstGeom prst="ellipse">
             <a:avLst/>
@@ -3529,7 +2466,7 @@
       </p:sp>
       <p:pic>
         <p:nvPicPr>
-          <p:cNvPr id="12" name="Image 0" descr="preencoded.png">    </p:cNvPr>
+          <p:cNvPr id="10" name="Image 0" descr="preencoded.png">    </p:cNvPr>
           <p:cNvPicPr>
             <a:picLocks noChangeAspect="1"/>
           </p:cNvPicPr>
@@ -3543,8 +2480,8 @@
         </p:blipFill>
         <p:spPr>
           <a:xfrm>
-            <a:off x="8037576" y="2221992"/>
-            <a:ext cx="201168" cy="201168"/>
+            <a:off x="11297412" y="2144268"/>
+            <a:ext cx="228600" cy="228600"/>
           </a:xfrm>
           <a:prstGeom prst="rect">
             <a:avLst/>
@@ -3553,14 +2490,14 @@
       </p:pic>
       <p:sp>
         <p:nvSpPr>
-          <p:cNvPr id="13" name="Text 10"/>
+          <p:cNvPr id="11" name="Text 8"/>
           <p:cNvSpPr txBox="1"/>
           <p:nvPr/>
         </p:nvSpPr>
         <p:spPr>
           <a:xfrm>
-            <a:off x="4846320" y="2121408"/>
-            <a:ext cx="2971800" cy="402336"/>
+            <a:off x="3200400" y="2011680"/>
+            <a:ext cx="7754112" cy="914400"/>
           </a:xfrm>
           <a:prstGeom prst="rect">
             <a:avLst/>
@@ -3569,53 +2506,34 @@
           <a:ln/>
         </p:spPr>
         <p:txBody>
-          <a:bodyPr wrap="square" lIns="0" tIns="0" rIns="0" bIns="0" rtlCol="0" anchor="ctr"/>
-          <a:lstStyle/>
-          <a:p>
-            <a:pPr rtl="1" algn="r" indent="0" marL="0">
-              <a:buNone/>
-            </a:pPr>
-            <a:r>
-              <a:rPr lang="he-IL" altLang="en-US" sz="1500" b="1" dirty="0">
-                <a:solidFill>
-                  <a:srgbClr val="12343B"/>
-                </a:solidFill>
-                <a:latin typeface="Arial" pitchFamily="34" charset="0"/>
-                <a:ea typeface="Arial" pitchFamily="34" charset="-122"/>
-                <a:cs typeface="Arial" pitchFamily="34" charset="-120"/>
-              </a:rPr>
-              <a:t>איך נחקור</a:t>
-            </a:r>
-            <a:endParaRPr lang="he-IL" sz="1500" dirty="0"/>
-          </a:p>
-        </p:txBody>
-      </p:sp>
-      <p:sp>
-        <p:nvSpPr>
-          <p:cNvPr id="14" name="Text 11"/>
-          <p:cNvSpPr txBox="1"/>
-          <p:nvPr/>
-        </p:nvSpPr>
-        <p:spPr>
-          <a:xfrm>
-            <a:off x="4846320" y="2569464"/>
-            <a:ext cx="3474720" cy="713232"/>
-          </a:xfrm>
-          <a:prstGeom prst="rect">
-            <a:avLst/>
-          </a:prstGeom>
-          <a:noFill/>
-          <a:ln/>
-        </p:spPr>
-        <p:txBody>
           <a:bodyPr wrap="square" lIns="0" tIns="0" rIns="0" bIns="0" rtlCol="0" anchor="t"/>
           <a:lstStyle/>
           <a:p>
-            <a:pPr rtl="1" algn="r" indent="0" marL="0">
-              <a:buNone/>
-            </a:pPr>
-            <a:r>
-              <a:rPr lang="he-IL" altLang="en-US" sz="1200" dirty="0">
+            <a:pPr algn="r" indent="0" marL="0">
+              <a:lnSpc>
+                <a:spcPct val="115000"/>
+              </a:lnSpc>
+              <a:buNone/>
+            </a:pPr>
+            <a:r>
+              <a:rPr lang="he-IL" altLang="en-US" sz="1500" b="1" dirty="0">
+                <a:solidFill>
+                  <a:srgbClr val="12343B"/>
+                </a:solidFill>
+                <a:latin typeface="Arial" pitchFamily="34" charset="0"/>
+                <a:ea typeface="Arial" pitchFamily="34" charset="-122"/>
+                <a:cs typeface="Arial" pitchFamily="34" charset="-120"/>
+              </a:rPr>
+              <a:t>נשוחח עם 12 מנהלים ומנהלות </a:t>
+            </a:r>
+            <a:pPr algn="r" indent="0" marL="0">
+              <a:lnSpc>
+                <a:spcPct val="115000"/>
+              </a:lnSpc>
+              <a:buNone/>
+            </a:pPr>
+            <a:r>
+              <a:rPr lang="he-IL" altLang="en-US" sz="1500" dirty="0">
                 <a:solidFill>
                   <a:srgbClr val="1B2B2E"/>
                 </a:solidFill>
@@ -3623,49 +2541,22 @@
                 <a:ea typeface="Arial" pitchFamily="34" charset="-122"/>
                 <a:cs typeface="Arial" pitchFamily="34" charset="-120"/>
               </a:rPr>
-              <a:t>ראיון חצי מובנה (45 עד 60 דקות). נבקש מכל מנהל: "ספר/י לי על בוקר אחד של היעדרות". אחר כך ניתוח תמטי.</a:t>
-            </a:r>
-            <a:endParaRPr lang="he-IL" sz="1200" dirty="0"/>
-          </a:p>
-        </p:txBody>
-      </p:sp>
-      <p:sp>
-        <p:nvSpPr>
-          <p:cNvPr id="15" name="Shape 12"/>
+              <a:t>של בתי ספר בערים בצפון הארץ, יסודיים ועל־יסודיים ובעלי ותק שונה. בחרנו במנהלים כי הם מקבלי ההחלטות בבוקר ההיעדרות, ובערים כדי לבחון את התופעה בהקשר אחיד ולהשוות בין ערים שונות.</a:t>
+            </a:r>
+            <a:endParaRPr lang="he-IL" sz="1500" dirty="0"/>
+          </a:p>
+        </p:txBody>
+      </p:sp>
+      <p:sp>
+        <p:nvSpPr>
+          <p:cNvPr id="12" name="Shape 9"/>
           <p:cNvSpPr/>
           <p:nvPr/>
         </p:nvSpPr>
         <p:spPr>
           <a:xfrm>
-            <a:off x="548640" y="1965960"/>
-            <a:ext cx="3840480" cy="1371600"/>
-          </a:xfrm>
-          <a:prstGeom prst="roundRect">
-            <a:avLst>
-              <a:gd name="adj" fmla="val 6667"/>
-            </a:avLst>
-          </a:prstGeom>
-          <a:solidFill>
-            <a:srgbClr val="E4F0F0"/>
-          </a:solidFill>
-          <a:ln w="12700">
-            <a:solidFill>
-              <a:srgbClr val="E4F0F0"/>
-            </a:solidFill>
-            <a:prstDash val="solid"/>
-          </a:ln>
-        </p:spPr>
-      </p:sp>
-      <p:sp>
-        <p:nvSpPr>
-          <p:cNvPr id="16" name="Shape 13"/>
-          <p:cNvSpPr/>
-          <p:nvPr/>
-        </p:nvSpPr>
-        <p:spPr>
-          <a:xfrm>
-            <a:off x="3822192" y="2121408"/>
-            <a:ext cx="402336" cy="402336"/>
+            <a:off x="11183112" y="3081528"/>
+            <a:ext cx="457200" cy="457200"/>
           </a:xfrm>
           <a:prstGeom prst="ellipse">
             <a:avLst/>
@@ -3683,7 +2574,7 @@
       </p:sp>
       <p:pic>
         <p:nvPicPr>
-          <p:cNvPr id="17" name="Image 1" descr="preencoded.png">    </p:cNvPr>
+          <p:cNvPr id="13" name="Image 1" descr="preencoded.png">    </p:cNvPr>
           <p:cNvPicPr>
             <a:picLocks noChangeAspect="1"/>
           </p:cNvPicPr>
@@ -3697,8 +2588,8 @@
         </p:blipFill>
         <p:spPr>
           <a:xfrm>
-            <a:off x="3922776" y="2221992"/>
-            <a:ext cx="201168" cy="201168"/>
+            <a:off x="11297412" y="3195828"/>
+            <a:ext cx="228600" cy="228600"/>
           </a:xfrm>
           <a:prstGeom prst="rect">
             <a:avLst/>
@@ -3707,14 +2598,14 @@
       </p:pic>
       <p:sp>
         <p:nvSpPr>
-          <p:cNvPr id="18" name="Text 14"/>
+          <p:cNvPr id="14" name="Text 10"/>
           <p:cNvSpPr txBox="1"/>
           <p:nvPr/>
         </p:nvSpPr>
         <p:spPr>
           <a:xfrm>
-            <a:off x="731520" y="2121408"/>
-            <a:ext cx="2971800" cy="402336"/>
+            <a:off x="3200400" y="3063240"/>
+            <a:ext cx="7754112" cy="1143000"/>
           </a:xfrm>
           <a:prstGeom prst="rect">
             <a:avLst/>
@@ -3723,53 +2614,34 @@
           <a:ln/>
         </p:spPr>
         <p:txBody>
-          <a:bodyPr wrap="square" lIns="0" tIns="0" rIns="0" bIns="0" rtlCol="0" anchor="ctr"/>
-          <a:lstStyle/>
-          <a:p>
-            <a:pPr rtl="1" algn="r" indent="0" marL="0">
-              <a:buNone/>
-            </a:pPr>
-            <a:r>
-              <a:rPr lang="he-IL" altLang="en-US" sz="1500" b="1" dirty="0">
-                <a:solidFill>
-                  <a:srgbClr val="12343B"/>
-                </a:solidFill>
-                <a:latin typeface="Arial" pitchFamily="34" charset="0"/>
-                <a:ea typeface="Arial" pitchFamily="34" charset="-122"/>
-                <a:cs typeface="Arial" pitchFamily="34" charset="-120"/>
-              </a:rPr>
-              <a:t>מה אנחנו מחפשים</a:t>
-            </a:r>
-            <a:endParaRPr lang="he-IL" sz="1500" dirty="0"/>
-          </a:p>
-        </p:txBody>
-      </p:sp>
-      <p:sp>
-        <p:nvSpPr>
-          <p:cNvPr id="19" name="Text 15"/>
-          <p:cNvSpPr txBox="1"/>
-          <p:nvPr/>
-        </p:nvSpPr>
-        <p:spPr>
-          <a:xfrm>
-            <a:off x="731520" y="2569464"/>
-            <a:ext cx="3474720" cy="713232"/>
-          </a:xfrm>
-          <a:prstGeom prst="rect">
-            <a:avLst/>
-          </a:prstGeom>
-          <a:noFill/>
-          <a:ln/>
-        </p:spPr>
-        <p:txBody>
           <a:bodyPr wrap="square" lIns="0" tIns="0" rIns="0" bIns="0" rtlCol="0" anchor="t"/>
           <a:lstStyle/>
           <a:p>
-            <a:pPr rtl="1" algn="r" indent="0" marL="0">
-              <a:buNone/>
-            </a:pPr>
-            <a:r>
-              <a:rPr lang="he-IL" altLang="en-US" sz="1200" dirty="0">
+            <a:pPr algn="r" indent="0" marL="0">
+              <a:lnSpc>
+                <a:spcPct val="115000"/>
+              </a:lnSpc>
+              <a:buNone/>
+            </a:pPr>
+            <a:r>
+              <a:rPr lang="he-IL" altLang="en-US" sz="1500" b="1" dirty="0">
+                <a:solidFill>
+                  <a:srgbClr val="12343B"/>
+                </a:solidFill>
+                <a:latin typeface="Arial" pitchFamily="34" charset="0"/>
+                <a:ea typeface="Arial" pitchFamily="34" charset="-122"/>
+                <a:cs typeface="Arial" pitchFamily="34" charset="-120"/>
+              </a:rPr>
+              <a:t>בראיונות חצי מובנים </a:t>
+            </a:r>
+            <a:pPr algn="r" indent="0" marL="0">
+              <a:lnSpc>
+                <a:spcPct val="115000"/>
+              </a:lnSpc>
+              <a:buNone/>
+            </a:pPr>
+            <a:r>
+              <a:rPr lang="he-IL" altLang="en-US" sz="1500" dirty="0">
                 <a:solidFill>
                   <a:srgbClr val="1B2B2E"/>
                 </a:solidFill>
@@ -3777,49 +2649,22 @@
                 <a:ea typeface="Arial" pitchFamily="34" charset="-122"/>
                 <a:cs typeface="Arial" pitchFamily="34" charset="-120"/>
               </a:rPr>
-              <a:t>אסטרטגיות מונעות או מגיבות; היעדרות קצרה או ממושכת; שיקולים: פדגוגיה, תקציב, הוגנות לצוות, רווחת המורה.</a:t>
-            </a:r>
-            <a:endParaRPr lang="he-IL" sz="1200" dirty="0"/>
-          </a:p>
-        </p:txBody>
-      </p:sp>
-      <p:sp>
-        <p:nvSpPr>
-          <p:cNvPr id="20" name="Shape 16"/>
+              <a:t>נבקש מכל מנהל לתאר בוקר אחד של היעדרות וגם היעדרות ממושכת. כך נוכל להבין שיקולים ודילמות ולא רק נהלים כתובים. בניתוח תמטי נחפש אסטרטגיות מונעות לעומת מגיבות, ואת האיזון בין פדגוגיה, תקציב, הוגנות כלפי הצוות ורווחת המורה.</a:t>
+            </a:r>
+            <a:endParaRPr lang="he-IL" sz="1500" dirty="0"/>
+          </a:p>
+        </p:txBody>
+      </p:sp>
+      <p:sp>
+        <p:nvSpPr>
+          <p:cNvPr id="15" name="Shape 11"/>
           <p:cNvSpPr/>
           <p:nvPr/>
         </p:nvSpPr>
         <p:spPr>
           <a:xfrm>
-            <a:off x="4663440" y="3474720"/>
-            <a:ext cx="3840480" cy="1371600"/>
-          </a:xfrm>
-          <a:prstGeom prst="roundRect">
-            <a:avLst>
-              <a:gd name="adj" fmla="val 6667"/>
-            </a:avLst>
-          </a:prstGeom>
-          <a:solidFill>
-            <a:srgbClr val="E4F0F0"/>
-          </a:solidFill>
-          <a:ln w="12700">
-            <a:solidFill>
-              <a:srgbClr val="E4F0F0"/>
-            </a:solidFill>
-            <a:prstDash val="solid"/>
-          </a:ln>
-        </p:spPr>
-      </p:sp>
-      <p:sp>
-        <p:nvSpPr>
-          <p:cNvPr id="21" name="Shape 17"/>
-          <p:cNvSpPr/>
-          <p:nvPr/>
-        </p:nvSpPr>
-        <p:spPr>
-          <a:xfrm>
-            <a:off x="7936992" y="3630168"/>
-            <a:ext cx="402336" cy="402336"/>
+            <a:off x="11183112" y="4178808"/>
+            <a:ext cx="457200" cy="457200"/>
           </a:xfrm>
           <a:prstGeom prst="ellipse">
             <a:avLst/>
@@ -3837,7 +2682,7 @@
       </p:sp>
       <p:pic>
         <p:nvPicPr>
-          <p:cNvPr id="22" name="Image 2" descr="preencoded.png">    </p:cNvPr>
+          <p:cNvPr id="16" name="Image 2" descr="preencoded.png">    </p:cNvPr>
           <p:cNvPicPr>
             <a:picLocks noChangeAspect="1"/>
           </p:cNvPicPr>
@@ -3851,8 +2696,8 @@
         </p:blipFill>
         <p:spPr>
           <a:xfrm>
-            <a:off x="8037576" y="3730752"/>
-            <a:ext cx="201168" cy="201168"/>
+            <a:off x="11297412" y="4293108"/>
+            <a:ext cx="228600" cy="228600"/>
           </a:xfrm>
           <a:prstGeom prst="rect">
             <a:avLst/>
@@ -3861,14 +2706,14 @@
       </p:pic>
       <p:sp>
         <p:nvSpPr>
-          <p:cNvPr id="23" name="Text 18"/>
+          <p:cNvPr id="17" name="Text 12"/>
           <p:cNvSpPr txBox="1"/>
           <p:nvPr/>
         </p:nvSpPr>
         <p:spPr>
           <a:xfrm>
-            <a:off x="4846320" y="3630168"/>
-            <a:ext cx="2971800" cy="402336"/>
+            <a:off x="3200400" y="4160520"/>
+            <a:ext cx="7754112" cy="868680"/>
           </a:xfrm>
           <a:prstGeom prst="rect">
             <a:avLst/>
@@ -3877,53 +2722,34 @@
           <a:ln/>
         </p:spPr>
         <p:txBody>
-          <a:bodyPr wrap="square" lIns="0" tIns="0" rIns="0" bIns="0" rtlCol="0" anchor="ctr"/>
-          <a:lstStyle/>
-          <a:p>
-            <a:pPr rtl="1" algn="r" indent="0" marL="0">
-              <a:buNone/>
-            </a:pPr>
-            <a:r>
-              <a:rPr lang="he-IL" altLang="en-US" sz="1500" b="1" dirty="0">
-                <a:solidFill>
-                  <a:srgbClr val="12343B"/>
-                </a:solidFill>
-                <a:latin typeface="Arial" pitchFamily="34" charset="0"/>
-                <a:ea typeface="Arial" pitchFamily="34" charset="-122"/>
-                <a:cs typeface="Arial" pitchFamily="34" charset="-120"/>
-              </a:rPr>
-              <a:t>האתגר הגדול</a:t>
-            </a:r>
-            <a:endParaRPr lang="he-IL" sz="1500" dirty="0"/>
-          </a:p>
-        </p:txBody>
-      </p:sp>
-      <p:sp>
-        <p:nvSpPr>
-          <p:cNvPr id="24" name="Text 19"/>
-          <p:cNvSpPr txBox="1"/>
-          <p:nvPr/>
-        </p:nvSpPr>
-        <p:spPr>
-          <a:xfrm>
-            <a:off x="4846320" y="4078224"/>
-            <a:ext cx="3474720" cy="713232"/>
-          </a:xfrm>
-          <a:prstGeom prst="rect">
-            <a:avLst/>
-          </a:prstGeom>
-          <a:noFill/>
-          <a:ln/>
-        </p:spPr>
-        <p:txBody>
           <a:bodyPr wrap="square" lIns="0" tIns="0" rIns="0" bIns="0" rtlCol="0" anchor="t"/>
           <a:lstStyle/>
           <a:p>
-            <a:pPr rtl="1" algn="r" indent="0" marL="0">
-              <a:buNone/>
-            </a:pPr>
-            <a:r>
-              <a:rPr lang="he-IL" altLang="en-US" sz="1200" dirty="0">
+            <a:pPr algn="r" indent="0" marL="0">
+              <a:lnSpc>
+                <a:spcPct val="115000"/>
+              </a:lnSpc>
+              <a:buNone/>
+            </a:pPr>
+            <a:r>
+              <a:rPr lang="he-IL" altLang="en-US" sz="1500" b="1" dirty="0">
+                <a:solidFill>
+                  <a:srgbClr val="12343B"/>
+                </a:solidFill>
+                <a:latin typeface="Arial" pitchFamily="34" charset="0"/>
+                <a:ea typeface="Arial" pitchFamily="34" charset="-122"/>
+                <a:cs typeface="Arial" pitchFamily="34" charset="-120"/>
+              </a:rPr>
+              <a:t>האתגר המרכזי </a:t>
+            </a:r>
+            <a:pPr algn="r" indent="0" marL="0">
+              <a:lnSpc>
+                <a:spcPct val="115000"/>
+              </a:lnSpc>
+              <a:buNone/>
+            </a:pPr>
+            <a:r>
+              <a:rPr lang="he-IL" altLang="en-US" sz="1500" dirty="0">
                 <a:solidFill>
                   <a:srgbClr val="1B2B2E"/>
                 </a:solidFill>
@@ -3931,52 +2757,27 @@
                 <a:ea typeface="Arial" pitchFamily="34" charset="-122"/>
                 <a:cs typeface="Arial" pitchFamily="34" charset="-120"/>
               </a:rPr>
-              <a:t>מנהלים עלולים להציג תמונה יפה מהמציאות, ומה שהם מתארים לא תמיד זהה למה שקורה. קשה גם למצוא זמן ביומן שלהם.</a:t>
-            </a:r>
-            <a:endParaRPr lang="he-IL" sz="1200" dirty="0"/>
-          </a:p>
-        </p:txBody>
-      </p:sp>
-      <p:sp>
-        <p:nvSpPr>
-          <p:cNvPr id="25" name="Shape 20"/>
+              <a:t>הוא שמנהלים עלולים להציג תמונה יפה מהמציאות, ולכן נבקש דוגמאות מוחשיות. ממצא שיפתיע אותנו: שמה שמנחה את ההחלטה בפועל הוא השקט והסדר ולא הרצף הלימודי.</a:t>
+            </a:r>
+            <a:endParaRPr lang="he-IL" sz="1500" dirty="0"/>
+          </a:p>
+        </p:txBody>
+      </p:sp>
+      <p:sp>
+        <p:nvSpPr>
+          <p:cNvPr id="18" name="Shape 13"/>
           <p:cNvSpPr/>
           <p:nvPr/>
         </p:nvSpPr>
         <p:spPr>
           <a:xfrm>
-            <a:off x="548640" y="3474720"/>
-            <a:ext cx="3840480" cy="1371600"/>
+            <a:off x="548640" y="5394960"/>
+            <a:ext cx="11091672" cy="960120"/>
           </a:xfrm>
           <a:prstGeom prst="roundRect">
             <a:avLst>
-              <a:gd name="adj" fmla="val 6667"/>
+              <a:gd name="adj" fmla="val 11429"/>
             </a:avLst>
-          </a:prstGeom>
-          <a:solidFill>
-            <a:srgbClr val="E4F0F0"/>
-          </a:solidFill>
-          <a:ln w="12700">
-            <a:solidFill>
-              <a:srgbClr val="E4F0F0"/>
-            </a:solidFill>
-            <a:prstDash val="solid"/>
-          </a:ln>
-        </p:spPr>
-      </p:sp>
-      <p:sp>
-        <p:nvSpPr>
-          <p:cNvPr id="26" name="Shape 21"/>
-          <p:cNvSpPr/>
-          <p:nvPr/>
-        </p:nvSpPr>
-        <p:spPr>
-          <a:xfrm>
-            <a:off x="3822192" y="3630168"/>
-            <a:ext cx="402336" cy="402336"/>
-          </a:xfrm>
-          <a:prstGeom prst="ellipse">
-            <a:avLst/>
           </a:prstGeom>
           <a:solidFill>
             <a:srgbClr val="12343B"/>
@@ -3989,40 +2790,16 @@
           </a:ln>
         </p:spPr>
       </p:sp>
-      <p:pic>
-        <p:nvPicPr>
-          <p:cNvPr id="27" name="Image 3" descr="preencoded.png">    </p:cNvPr>
-          <p:cNvPicPr>
-            <a:picLocks noChangeAspect="1"/>
-          </p:cNvPicPr>
-          <p:nvPr/>
-        </p:nvPicPr>
-        <p:blipFill>
-          <a:blip r:embed="rId4"/>
-          <a:stretch>
-            <a:fillRect/>
-          </a:stretch>
-        </p:blipFill>
-        <p:spPr>
-          <a:xfrm>
-            <a:off x="3922776" y="3730752"/>
-            <a:ext cx="201168" cy="201168"/>
-          </a:xfrm>
-          <a:prstGeom prst="rect">
-            <a:avLst/>
-          </a:prstGeom>
-        </p:spPr>
-      </p:pic>
-      <p:sp>
-        <p:nvSpPr>
-          <p:cNvPr id="28" name="Text 22"/>
+      <p:sp>
+        <p:nvSpPr>
+          <p:cNvPr id="19" name="Text 14"/>
           <p:cNvSpPr txBox="1"/>
           <p:nvPr/>
         </p:nvSpPr>
         <p:spPr>
           <a:xfrm>
-            <a:off x="731520" y="3630168"/>
-            <a:ext cx="2971800" cy="402336"/>
+            <a:off x="868680" y="5468112"/>
+            <a:ext cx="10451592" cy="822960"/>
           </a:xfrm>
           <a:prstGeom prst="rect">
             <a:avLst/>
@@ -4034,116 +2811,11 @@
           <a:bodyPr wrap="square" lIns="0" tIns="0" rIns="0" bIns="0" rtlCol="0" anchor="ctr"/>
           <a:lstStyle/>
           <a:p>
-            <a:pPr rtl="1" algn="r" indent="0" marL="0">
-              <a:buNone/>
-            </a:pPr>
-            <a:r>
-              <a:rPr lang="he-IL" altLang="en-US" sz="1500" b="1" dirty="0">
-                <a:solidFill>
-                  <a:srgbClr val="12343B"/>
-                </a:solidFill>
-                <a:latin typeface="Arial" pitchFamily="34" charset="0"/>
-                <a:ea typeface="Arial" pitchFamily="34" charset="-122"/>
-                <a:cs typeface="Arial" pitchFamily="34" charset="-120"/>
-              </a:rPr>
-              <a:t>מה יפתיע אותנו</a:t>
-            </a:r>
-            <a:endParaRPr lang="he-IL" sz="1500" dirty="0"/>
-          </a:p>
-        </p:txBody>
-      </p:sp>
-      <p:sp>
-        <p:nvSpPr>
-          <p:cNvPr id="29" name="Text 23"/>
-          <p:cNvSpPr txBox="1"/>
-          <p:nvPr/>
-        </p:nvSpPr>
-        <p:spPr>
-          <a:xfrm>
-            <a:off x="731520" y="4078224"/>
-            <a:ext cx="3474720" cy="713232"/>
-          </a:xfrm>
-          <a:prstGeom prst="rect">
-            <a:avLst/>
-          </a:prstGeom>
-          <a:noFill/>
-          <a:ln/>
-        </p:spPr>
-        <p:txBody>
-          <a:bodyPr wrap="square" lIns="0" tIns="0" rIns="0" bIns="0" rtlCol="0" anchor="t"/>
-          <a:lstStyle/>
-          <a:p>
-            <a:pPr rtl="1" algn="r" indent="0" marL="0">
-              <a:buNone/>
-            </a:pPr>
-            <a:r>
-              <a:rPr lang="he-IL" altLang="en-US" sz="1200" dirty="0">
-                <a:solidFill>
-                  <a:srgbClr val="1B2B2E"/>
-                </a:solidFill>
-                <a:latin typeface="Arial" pitchFamily="34" charset="0"/>
-                <a:ea typeface="Arial" pitchFamily="34" charset="-122"/>
-                <a:cs typeface="Arial" pitchFamily="34" charset="-120"/>
-              </a:rPr>
-              <a:t>אם יתברר שמה שמנחה את ההחלטה הוא בעיקר "שקט וסדר" ולא רצף לימודי.</a:t>
-            </a:r>
-            <a:endParaRPr lang="he-IL" sz="1200" dirty="0"/>
-          </a:p>
-        </p:txBody>
-      </p:sp>
-      <p:sp>
-        <p:nvSpPr>
-          <p:cNvPr id="30" name="Shape 24"/>
-          <p:cNvSpPr/>
-          <p:nvPr/>
-        </p:nvSpPr>
-        <p:spPr>
-          <a:xfrm>
-            <a:off x="548640" y="5074920"/>
-            <a:ext cx="11091672" cy="1188720"/>
-          </a:xfrm>
-          <a:prstGeom prst="roundRect">
-            <a:avLst>
-              <a:gd name="adj" fmla="val 9231"/>
-            </a:avLst>
-          </a:prstGeom>
-          <a:solidFill>
-            <a:srgbClr val="12343B"/>
-          </a:solidFill>
-          <a:ln w="12700">
-            <a:solidFill>
-              <a:srgbClr val="12343B"/>
-            </a:solidFill>
-            <a:prstDash val="solid"/>
-          </a:ln>
-        </p:spPr>
-      </p:sp>
-      <p:sp>
-        <p:nvSpPr>
-          <p:cNvPr id="31" name="Text 25"/>
-          <p:cNvSpPr txBox="1"/>
-          <p:nvPr/>
-        </p:nvSpPr>
-        <p:spPr>
-          <a:xfrm>
-            <a:off x="868680" y="5166360"/>
-            <a:ext cx="10451592" cy="1005840"/>
-          </a:xfrm>
-          <a:prstGeom prst="rect">
-            <a:avLst/>
-          </a:prstGeom>
-          <a:noFill/>
-          <a:ln/>
-        </p:spPr>
-        <p:txBody>
-          <a:bodyPr wrap="square" lIns="0" tIns="0" rIns="0" bIns="0" rtlCol="0" anchor="ctr"/>
-          <a:lstStyle/>
-          <a:p>
             <a:pPr algn="r" indent="0" marL="0">
               <a:buNone/>
             </a:pPr>
             <a:r>
-              <a:rPr lang="he-IL" altLang="en-US" sz="1800" b="1" dirty="0">
+              <a:rPr lang="he-IL" altLang="en-US" sz="1700" b="1" dirty="0">
                 <a:solidFill>
                   <a:srgbClr val="E9A23B"/>
                 </a:solidFill>
@@ -4157,7 +2829,7 @@
               <a:buNone/>
             </a:pPr>
             <a:r>
-              <a:rPr lang="he-IL" altLang="en-US" sz="1800" dirty="0">
+              <a:rPr lang="he-IL" altLang="en-US" sz="1700" dirty="0">
                 <a:solidFill>
                   <a:srgbClr val="FFFFFF"/>
                 </a:solidFill>
@@ -4167,7 +2839,7 @@
               </a:rPr>
               <a:t>איך מנהלים מאזנים, בזמן אמת, בין הצורך שמישהו יהיה בכיתה לבין הזכות של התלמידים לרצף לימודי אמיתי.</a:t>
             </a:r>
-            <a:endParaRPr lang="he-IL" sz="1800" dirty="0"/>
+            <a:endParaRPr lang="he-IL" sz="1700" dirty="0"/>
           </a:p>
         </p:txBody>
       </p:sp>

</xml_diff>

<commit_message>
Expand presentation to 5 slides
Add a literature-map slide (absence -> continuity -> decision making ->
strategies) and an interview-guide slide with ethics; move the closing
sentence to the final slide and rebalance speaker notes and timing.

Co-Authored-By: Claude Opus 5.5 <noreply@anthropic.com>
Claude-Session: https://claude.ai/code/session_016buQrLRQHjtd4YGfeSnksc
</commit_message>
<xml_diff>
--- a/presentation/היעדרויות-מורים-מצגת-סיום.pptx
+++ b/presentation/היעדרויות-מורים-מצגת-סיום.pptx
@@ -8,9 +8,11 @@
     <p:sldId id="256" r:id="rId2"/>
     <p:sldId id="257" r:id="rId3"/>
     <p:sldId id="258" r:id="rId4"/>
+    <p:sldId id="259" r:id="rId5"/>
+    <p:sldId id="260" r:id="rId6"/>
   </p:sldIdLst>
   <p:notesMasterIdLst>
-    <p:notesMasterId r:id="rId5"/>
+    <p:notesMasterId r:id="rId7"/>
   </p:notesMasterIdLst>
   <p:sldSz cx="12192000" cy="6858000"/>
   <p:notesSz cx="6858000" cy="12192000"/>
@@ -504,7 +506,7 @@
           <a:p>
             <a:r>
               <a:rPr lang="en-US" dirty="0"/>
-              <a:t>[חנון | כדקה ורבע]
+              <a:t>[חנון | כדקה]
 בוקר רגיל, שבע וחצי. מורה מתקשרת ואומרת שהיא לא תגיע היום. בתוך כמה דקות המנהל צריך להחליט: מי נכנס לכיתה, מה יקרה בשיעור, ומי מהצוות ישלם את המחיר.
 המחקר שלנו עוסק בהיעדרויות מורים. ההיעדרות עצמה היא חלק מהחיים של כל בית ספר. מה שמעניין אותנו הוא מה שהמנהל עושה ברגע הזה.
 לכן שאלת המחקר שלנו היא: כיצד מנהלי בתי ספר בערים בצפון הארץ מתארים את התמודדותם עם היעדרויות מורים, ואילו אסטרטגיות ושיקולים מנחים את החלטותיהם לשמירה על רצף לימודי?
@@ -598,7 +600,7 @@
           <a:p>
             <a:r>
               <a:rPr lang="en-US" dirty="0"/>
-              <a:t>[אולפת | כדקה ושלושת רבעי]
+              <a:t>[אולפת | כדקה ורבע]
 מה למדנו מהספרות? קודם כול, שהיעדרויות מורים אינן עניין טכני. מחקרים גדולים, של מילר ועמיתיו ושל קלוטפלטר ועמיתיו, מצאו שהיעדרויות פוגעות בהישגי התלמידים, והפגיעה גדלה ככל שהן מצטברות.
 מה שהפתיע אותנו הוא שהמנהל לא רק מגיב להיעדרות. מחקר ישראלי של שפירא־לישצ'ינסקי ורוזנבלט מצא שהאקלים שהמנהל יוצר בבית הספר קשור גם להיקף ההיעדרויות.
 אבל כאן נוצר מתח. בתיאוריה, רצף לימודי הוא עניין פדגוגי: שהחומר ימשיך, שהיחסים והשגרה יישמרו. במציאות, בשבע וחצי בבוקר, המנהל צריך קודם כול שמישהו יהיה בכיתה. ורוב המחקרים בודקים כמה מורים נעדרים ולמה, ולא מה המנהל עושה ושוקל ברגע ההיעדרות עצמו.
@@ -691,17 +693,12 @@
           <a:p>
             <a:r>
               <a:rPr lang="en-US" dirty="0"/>
-              <a:t>[חנון | כדקה וחצי]
-איך נבדוק את זה? נשוחח עם 12 מנהלים ומנהלות של בתי ספר בערים בצפון הארץ, יסודיים ועל־יסודיים, עם ותק שונה. בחרנו במנהלים כי הם מקבלי ההחלטות בבוקר ההיעדרות, ובחרנו בערים כדי לבחון את התופעה בהקשר אחיד ולהשוות בין ערים שונות.
-הכלי שלנו הוא ראיון חצי מובנה. נבקש מכל מנהל לתאר בוקר אחד של היעדרות, צעד אחר צעד, ונשאל גם על היעדרות ממושכת. כך נבין את השיקולים ואת הדילמות, ולא רק את הנוהל הכתוב. בניתוח נחפש אסטרטגיות מונעות לעומת מגיבות, ואת האיזון בין פדגוגיה, תקציב, הוגנות כלפי הצוות שמחליף, ורווחת המורה הנעדרת.
-האתגר המרכזי: מנהלים עלולים להציג תמונה יפה מהמציאות. לכן נבקש דוגמאות מוחשיות ולא רק עקרונות.
-[אולפת | כחצי דקה]
-ומה יפתיע אותנו? אם יתברר שמה שמנחה את ההחלטה בפועל הוא השקט והסדר בבית הספר ולא הרצף הלימודי. זה יערער הנחה שלנו.
-אם המחקר שלנו יהיה מוצלח, בסופו נבין טוב יותר איך מנהלים מאזנים, בזמן אמת, בין הצורך שמישהו יהיה בכיתה לבין הזכות של התלמידים לרצף לימודי אמיתי.
-תודה.
-[שאלות המשך אפשריות]
-למה רק מנהלים? כי השאלה היא על קבלת החלטות, והם אלה שמחליטים. במחקר המשך אפשר לשמוע גם את המורים המחליפים.
-למה רק ערים? כדי לבחון את התופעה בהקשר אחיד. בתי ספר בכפרים פועלים בתנאים אחרים, וזה יכול להיות כיוון למחקר המשך.</a:t>
+              <a:t>[חנון | כחמישים שניות]
+כך נראה הסיפור התיאורטי שלנו, מימין לשמאל.
+הוא מתחיל בהיעדרות מורים, ועובר אל המושג המרכזי: רצף לימודי. אנחנו מבינים את הרצף בשלושה ממדים. פדגוגי: שהתוכן והלמידה ממשיכים. ארגוני: שיבוץ, מערכת שעות, והעומס על הצוות שמחליף. ורגשי: שהתלמידים נשארים עם מבוגר מוכר ומרגישים ביטחון.
+הרצף הזה תלוי בקבלת החלטות ניהולית. המנהל שוקל צרכים מתחרים, בזמן קצר ובמשאבים מוגבלים.
+מתוך ההחלטות האלה נגזרות האסטרטגיות. יש אסטרטגיות מגיבות, כמו ממלא מקום, איחוד כיתות או שעה פרטנית, ויש אסטרטגיות מונעות, כמו מאגר ממלאי מקום קבוע וחומרי עבודה מוכנים מראש. את החוליה האחרונה הזאת, איך בדיוק זה קורה בשטח, אנחנו רוצים לחקור.
+[מעבר לאולפת]</a:t>
             </a:r>
             <a:endParaRPr lang="en-US" dirty="0"/>
           </a:p>
@@ -725,6 +722,196 @@
             <a:fld id="{F7021451-1387-4CA6-816F-3879F97B5CBC}" type="slidenum">
               <a:rPr lang="en-US"/>
               <a:t>3</a:t>
+            </a:fld>
+            <a:endParaRPr lang="en-US"/>
+          </a:p>
+        </p:txBody>
+      </p:sp>
+    </p:spTree>
+    <p:extLst>
+      <p:ext uri="{BB962C8B-B14F-4D97-AF65-F5344CB8AC3E}">
+        <p14:creationId xmlns:p14="http://schemas.microsoft.com/office/powerpoint/2010/main" val="1024086991"/>
+      </p:ext>
+    </p:extLst>
+  </p:cSld>
+  <p:clrMapOvr>
+    <a:masterClrMapping/>
+  </p:clrMapOvr>
+</p:notes>
+</file>
+
+<file path=ppt/notesSlides/notesSlide4.xml><?xml version="1.0" encoding="utf-8"?>
+<p:notes xmlns:a="http://schemas.openxmlformats.org/drawingml/2006/main" xmlns:r="http://schemas.openxmlformats.org/officeDocument/2006/relationships" xmlns:p="http://schemas.openxmlformats.org/presentationml/2006/main">
+  <p:cSld>
+    <p:spTree>
+      <p:nvGrpSpPr>
+        <p:cNvPr id="1" name=""/>
+        <p:cNvGrpSpPr/>
+        <p:nvPr/>
+      </p:nvGrpSpPr>
+      <p:grpSpPr>
+        <a:xfrm>
+          <a:off x="0" y="0"/>
+          <a:ext cx="0" cy="0"/>
+          <a:chOff x="0" y="0"/>
+          <a:chExt cx="0" cy="0"/>
+        </a:xfrm>
+      </p:grpSpPr>
+      <p:sp>
+        <p:nvSpPr>
+          <p:cNvPr id="2" name="Slide Image Placeholder 1"/>
+          <p:cNvSpPr>
+            <a:spLocks noGrp="1" noRot="1" noChangeAspect="1"/>
+          </p:cNvSpPr>
+          <p:nvPr>
+            <p:ph type="sldImg"/>
+          </p:nvPr>
+        </p:nvSpPr>
+        <p:spPr/>
+      </p:sp>
+      <p:sp>
+        <p:nvSpPr>
+          <p:cNvPr id="3" name="Notes Placeholder 2"/>
+          <p:cNvSpPr>
+            <a:spLocks noGrp="1"/>
+          </p:cNvSpPr>
+          <p:nvPr>
+            <p:ph type="body" idx="1"/>
+          </p:nvPr>
+        </p:nvSpPr>
+        <p:spPr/>
+        <p:txBody>
+          <a:bodyPr/>
+          <a:lstStyle/>
+          <a:p>
+            <a:r>
+              <a:rPr lang="en-US" dirty="0"/>
+              <a:t>[אולפת | כדקה]
+איך נבדוק את זה? נשוחח עם 12 מנהלים ומנהלות של בתי ספר בערים בצפון הארץ, יסודיים ועל־יסודיים, עם ותק שונה. בחרנו במנהלים כי הם מקבלי ההחלטות בבוקר ההיעדרות, ובחרנו בערים כדי לבחון את התופעה בהקשר אחיד ולהשוות בין ערים שונות.
+בניתוח הראיונות נחפש תמות: אסטרטגיות מונעות לעומת מגיבות, הבדלים בין היעדרות קצרה לממושכת, ואת האיזון בין פדגוגיה, תקציב, הוגנות כלפי הצוות שמחליף, ורווחת המורה הנעדרת.
+האתגר המרכזי: מנהלים עלולים להציג תמונה יפה מהמציאות. לכן נבקש דוגמאות מוחשיות ולא רק עקרונות.
+ומה יפתיע אותנו? אם יתברר שמה שמנחה את ההחלטה בפועל הוא השקט והסדר בבית הספר ולא הרצף הלימודי. זה יערער הנחה שלנו.
+[מעבר לחנון]</a:t>
+            </a:r>
+            <a:endParaRPr lang="en-US" dirty="0"/>
+          </a:p>
+        </p:txBody>
+      </p:sp>
+      <p:sp>
+        <p:nvSpPr>
+          <p:cNvPr id="4" name="Slide Number Placeholder 3"/>
+          <p:cNvSpPr>
+            <a:spLocks noGrp="1"/>
+          </p:cNvSpPr>
+          <p:nvPr>
+            <p:ph type="sldNum" sz="quarter" idx="10"/>
+          </p:nvPr>
+        </p:nvSpPr>
+        <p:spPr/>
+        <p:txBody>
+          <a:bodyPr/>
+          <a:lstStyle/>
+          <a:p>
+            <a:fld id="{F7021451-1387-4CA6-816F-3879F97B5CBC}" type="slidenum">
+              <a:rPr lang="en-US"/>
+              <a:t>4</a:t>
+            </a:fld>
+            <a:endParaRPr lang="en-US"/>
+          </a:p>
+        </p:txBody>
+      </p:sp>
+    </p:spTree>
+    <p:extLst>
+      <p:ext uri="{BB962C8B-B14F-4D97-AF65-F5344CB8AC3E}">
+        <p14:creationId xmlns:p14="http://schemas.microsoft.com/office/powerpoint/2010/main" val="1024086991"/>
+      </p:ext>
+    </p:extLst>
+  </p:cSld>
+  <p:clrMapOvr>
+    <a:masterClrMapping/>
+  </p:clrMapOvr>
+</p:notes>
+</file>
+
+<file path=ppt/notesSlides/notesSlide5.xml><?xml version="1.0" encoding="utf-8"?>
+<p:notes xmlns:a="http://schemas.openxmlformats.org/drawingml/2006/main" xmlns:r="http://schemas.openxmlformats.org/officeDocument/2006/relationships" xmlns:p="http://schemas.openxmlformats.org/presentationml/2006/main">
+  <p:cSld>
+    <p:spTree>
+      <p:nvGrpSpPr>
+        <p:cNvPr id="1" name=""/>
+        <p:cNvGrpSpPr/>
+        <p:nvPr/>
+      </p:nvGrpSpPr>
+      <p:grpSpPr>
+        <a:xfrm>
+          <a:off x="0" y="0"/>
+          <a:ext cx="0" cy="0"/>
+          <a:chOff x="0" y="0"/>
+          <a:chExt cx="0" cy="0"/>
+        </a:xfrm>
+      </p:grpSpPr>
+      <p:sp>
+        <p:nvSpPr>
+          <p:cNvPr id="2" name="Slide Image Placeholder 1"/>
+          <p:cNvSpPr>
+            <a:spLocks noGrp="1" noRot="1" noChangeAspect="1"/>
+          </p:cNvSpPr>
+          <p:nvPr>
+            <p:ph type="sldImg"/>
+          </p:nvPr>
+        </p:nvSpPr>
+        <p:spPr/>
+      </p:sp>
+      <p:sp>
+        <p:nvSpPr>
+          <p:cNvPr id="3" name="Notes Placeholder 2"/>
+          <p:cNvSpPr>
+            <a:spLocks noGrp="1"/>
+          </p:cNvSpPr>
+          <p:nvPr>
+            <p:ph type="body" idx="1"/>
+          </p:nvPr>
+        </p:nvSpPr>
+        <p:spPr/>
+        <p:txBody>
+          <a:bodyPr/>
+          <a:lstStyle/>
+          <a:p>
+            <a:r>
+              <a:rPr lang="en-US" dirty="0"/>
+              <a:t>[חנון | כארבעים שניות]
+איך ייראה הראיון? נפתח בשאלות רקע על בית הספר, על הצוות ועל הדרך של המנהל לתפקיד, כדי ליצור אמון ולהבין את ההקשר.
+בלב הראיון נבקש סיפור מוחשי: ספר לי על הבוקר האחרון שבו מורה לא הגיע. מה עשית, צעד אחר צעד? מה היה שונה כשההיעדרות נמשכה כמה שבועות? במה התחשבת כשהחלטת מי יחליף? כך נשמע את השיקולים ואת הדילמות, ולא רק את הנוהל הכתוב.
+ונקפיד על אתיקה: הסכמה מדעת, הקלטה רק באישור, ואנונימיות מלאה.
+[אולפת | כרבע דקה]
+אם המחקר שלנו יהיה מוצלח, בסופו נבין טוב יותר איך מנהלים מאזנים, בזמן אמת, בין הצורך שמישהו יהיה בכיתה לבין הזכות של התלמידים לרצף לימודי אמיתי.
+תודה.
+[שאלות המשך אפשריות]
+למה רק מנהלים? כי השאלה היא על קבלת החלטות, והם אלה שמחליטים. במחקר המשך אפשר לשמוע גם את המורים המחליפים.
+למה רק ערים? כדי לבחון את התופעה בהקשר אחיד. בתי ספר בכפרים פועלים בתנאים אחרים, וזה יכול להיות כיוון למחקר המשך.</a:t>
+            </a:r>
+            <a:endParaRPr lang="en-US" dirty="0"/>
+          </a:p>
+        </p:txBody>
+      </p:sp>
+      <p:sp>
+        <p:nvSpPr>
+          <p:cNvPr id="4" name="Slide Number Placeholder 3"/>
+          <p:cNvSpPr>
+            <a:spLocks noGrp="1"/>
+          </p:cNvSpPr>
+          <p:nvPr>
+            <p:ph type="sldNum" sz="quarter" idx="10"/>
+          </p:nvPr>
+        </p:nvSpPr>
+        <p:spPr/>
+        <p:txBody>
+          <a:bodyPr/>
+          <a:lstStyle/>
+          <a:p>
+            <a:fld id="{F7021451-1387-4CA6-816F-3879F97B5CBC}" type="slidenum">
+              <a:rPr lang="en-US"/>
+              <a:t>5</a:t>
             </a:fld>
             <a:endParaRPr lang="en-US"/>
           </a:p>
@@ -2272,7 +2459,7 @@
                 <a:ea typeface="Arial" pitchFamily="34" charset="-122"/>
                 <a:cs typeface="Arial" pitchFamily="34" charset="-120"/>
               </a:rPr>
-              <a:t>יוצאים לשטח</a:t>
+              <a:t>מפת הספרות</a:t>
             </a:r>
             <a:endParaRPr lang="he-IL" sz="1300" dirty="0"/>
           </a:p>
@@ -2311,7 +2498,7 @@
                 <a:ea typeface="Arial" pitchFamily="34" charset="-122"/>
                 <a:cs typeface="Arial" pitchFamily="34" charset="-120"/>
               </a:rPr>
-              <a:t>12 שיחות עם מי שמחליטים בבוקר</a:t>
+              <a:t>הסיפור התיאורטי שלנו</a:t>
             </a:r>
             <a:endParaRPr lang="he-IL" sz="3600" dirty="0"/>
           </a:p>
@@ -2325,13 +2512,38 @@
         </p:nvSpPr>
         <p:spPr>
           <a:xfrm>
-            <a:off x="548640" y="2011680"/>
-            <a:ext cx="2377440" cy="2743200"/>
+            <a:off x="9262872" y="2011680"/>
+            <a:ext cx="2377440" cy="1234440"/>
           </a:xfrm>
           <a:prstGeom prst="roundRect">
             <a:avLst>
-              <a:gd name="adj" fmla="val 4615"/>
+              <a:gd name="adj" fmla="val 8889"/>
             </a:avLst>
+          </a:prstGeom>
+          <a:solidFill>
+            <a:srgbClr val="E4F0F0"/>
+          </a:solidFill>
+          <a:ln w="12700">
+            <a:solidFill>
+              <a:srgbClr val="E4F0F0"/>
+            </a:solidFill>
+            <a:prstDash val="solid"/>
+          </a:ln>
+        </p:spPr>
+      </p:sp>
+      <p:sp>
+        <p:nvSpPr>
+          <p:cNvPr id="7" name="Shape 5"/>
+          <p:cNvSpPr/>
+          <p:nvPr/>
+        </p:nvSpPr>
+        <p:spPr>
+          <a:xfrm>
+            <a:off x="10222992" y="2176272"/>
+            <a:ext cx="457200" cy="457200"/>
+          </a:xfrm>
+          <a:prstGeom prst="ellipse">
+            <a:avLst/>
           </a:prstGeom>
           <a:solidFill>
             <a:srgbClr val="12343B"/>
@@ -2344,129 +2556,9 @@
           </a:ln>
         </p:spPr>
       </p:sp>
-      <p:sp>
-        <p:nvSpPr>
-          <p:cNvPr id="7" name="Text 5"/>
-          <p:cNvSpPr txBox="1"/>
-          <p:nvPr/>
-        </p:nvSpPr>
-        <p:spPr>
-          <a:xfrm>
-            <a:off x="548640" y="2514600"/>
-            <a:ext cx="2377440" cy="1005840"/>
-          </a:xfrm>
-          <a:prstGeom prst="rect">
-            <a:avLst/>
-          </a:prstGeom>
-          <a:noFill/>
-          <a:ln/>
-        </p:spPr>
-        <p:txBody>
-          <a:bodyPr wrap="square" lIns="0" tIns="0" rIns="0" bIns="0" rtlCol="0" anchor="ctr"/>
-          <a:lstStyle/>
-          <a:p>
-            <a:pPr algn="ctr" indent="0" marL="0">
-              <a:buNone/>
-            </a:pPr>
-            <a:r>
-              <a:rPr lang="en-US" sz="6600" b="1" dirty="0">
-                <a:solidFill>
-                  <a:srgbClr val="E9A23B"/>
-                </a:solidFill>
-                <a:latin typeface="Arial" pitchFamily="34" charset="0"/>
-                <a:ea typeface="Arial" pitchFamily="34" charset="-122"/>
-                <a:cs typeface="Arial" pitchFamily="34" charset="-120"/>
-              </a:rPr>
-              <a:t>12</a:t>
-            </a:r>
-            <a:endParaRPr lang="en-US" sz="6600" dirty="0"/>
-          </a:p>
-        </p:txBody>
-      </p:sp>
-      <p:sp>
-        <p:nvSpPr>
-          <p:cNvPr id="8" name="Text 6"/>
-          <p:cNvSpPr txBox="1"/>
-          <p:nvPr/>
-        </p:nvSpPr>
-        <p:spPr>
-          <a:xfrm>
-            <a:off x="731520" y="3611880"/>
-            <a:ext cx="2011680" cy="914400"/>
-          </a:xfrm>
-          <a:prstGeom prst="rect">
-            <a:avLst/>
-          </a:prstGeom>
-          <a:noFill/>
-          <a:ln/>
-        </p:spPr>
-        <p:txBody>
-          <a:bodyPr wrap="square" lIns="0" tIns="0" rIns="0" bIns="0" rtlCol="0" anchor="t"/>
-          <a:lstStyle/>
-          <a:p>
-            <a:pPr algn="ctr" indent="0" marL="0">
-              <a:buNone/>
-            </a:pPr>
-            <a:r>
-              <a:rPr lang="en-US" sz="1600" b="1" dirty="0">
-                <a:solidFill>
-                  <a:srgbClr val="FFFFFF"/>
-                </a:solidFill>
-                <a:latin typeface="Arial" pitchFamily="34" charset="0"/>
-                <a:ea typeface="Arial" pitchFamily="34" charset="-122"/>
-                <a:cs typeface="Arial" pitchFamily="34" charset="-120"/>
-              </a:rPr>
-              <a:t>מנהלים ומנהלות</a:t>
-            </a:r>
-            <a:endParaRPr lang="en-US" sz="1600" dirty="0"/>
-          </a:p>
-          <a:p>
-            <a:pPr algn="ctr" indent="0" marL="0">
-              <a:buNone/>
-            </a:pPr>
-            <a:r>
-              <a:rPr lang="en-US" sz="1400" dirty="0">
-                <a:solidFill>
-                  <a:srgbClr val="A9D2D5"/>
-                </a:solidFill>
-                <a:latin typeface="Arial" pitchFamily="34" charset="0"/>
-                <a:ea typeface="Arial" pitchFamily="34" charset="-122"/>
-                <a:cs typeface="Arial" pitchFamily="34" charset="-120"/>
-              </a:rPr>
-              <a:t>בערים בצפון הארץ</a:t>
-            </a:r>
-            <a:endParaRPr lang="en-US" sz="1600" dirty="0"/>
-          </a:p>
-        </p:txBody>
-      </p:sp>
-      <p:sp>
-        <p:nvSpPr>
-          <p:cNvPr id="9" name="Shape 7"/>
-          <p:cNvSpPr/>
-          <p:nvPr/>
-        </p:nvSpPr>
-        <p:spPr>
-          <a:xfrm>
-            <a:off x="11183112" y="2029968"/>
-            <a:ext cx="457200" cy="457200"/>
-          </a:xfrm>
-          <a:prstGeom prst="ellipse">
-            <a:avLst/>
-          </a:prstGeom>
-          <a:solidFill>
-            <a:srgbClr val="12343B"/>
-          </a:solidFill>
-          <a:ln w="12700">
-            <a:solidFill>
-              <a:srgbClr val="12343B"/>
-            </a:solidFill>
-            <a:prstDash val="solid"/>
-          </a:ln>
-        </p:spPr>
-      </p:sp>
       <p:pic>
         <p:nvPicPr>
-          <p:cNvPr id="10" name="Image 0" descr="preencoded.png">    </p:cNvPr>
+          <p:cNvPr id="8" name="Image 0" descr="preencoded.png">    </p:cNvPr>
           <p:cNvPicPr>
             <a:picLocks noChangeAspect="1"/>
           </p:cNvPicPr>
@@ -2480,7 +2572,7 @@
         </p:blipFill>
         <p:spPr>
           <a:xfrm>
-            <a:off x="11297412" y="2144268"/>
+            <a:off x="10337292" y="2290572"/>
             <a:ext cx="228600" cy="228600"/>
           </a:xfrm>
           <a:prstGeom prst="rect">
@@ -2490,14 +2582,14 @@
       </p:pic>
       <p:sp>
         <p:nvSpPr>
-          <p:cNvPr id="11" name="Text 8"/>
+          <p:cNvPr id="9" name="Text 6"/>
           <p:cNvSpPr txBox="1"/>
           <p:nvPr/>
         </p:nvSpPr>
         <p:spPr>
           <a:xfrm>
-            <a:off x="3200400" y="2011680"/>
-            <a:ext cx="7754112" cy="914400"/>
+            <a:off x="9354312" y="2697480"/>
+            <a:ext cx="2194560" cy="411480"/>
           </a:xfrm>
           <a:prstGeom prst="rect">
             <a:avLst/>
@@ -2506,17 +2598,14 @@
           <a:ln/>
         </p:spPr>
         <p:txBody>
-          <a:bodyPr wrap="square" lIns="0" tIns="0" rIns="0" bIns="0" rtlCol="0" anchor="t"/>
-          <a:lstStyle/>
-          <a:p>
-            <a:pPr algn="r" indent="0" marL="0">
-              <a:lnSpc>
-                <a:spcPct val="115000"/>
-              </a:lnSpc>
-              <a:buNone/>
-            </a:pPr>
-            <a:r>
-              <a:rPr lang="he-IL" altLang="en-US" sz="1500" b="1" dirty="0">
+          <a:bodyPr wrap="square" lIns="0" tIns="0" rIns="0" bIns="0" rtlCol="0" anchor="ctr"/>
+          <a:lstStyle/>
+          <a:p>
+            <a:pPr rtl="1" algn="ctr" indent="0" marL="0">
+              <a:buNone/>
+            </a:pPr>
+            <a:r>
+              <a:rPr lang="en-US" sz="1500" b="1" dirty="0">
                 <a:solidFill>
                   <a:srgbClr val="12343B"/>
                 </a:solidFill>
@@ -2524,49 +2613,32 @@
                 <a:ea typeface="Arial" pitchFamily="34" charset="-122"/>
                 <a:cs typeface="Arial" pitchFamily="34" charset="-120"/>
               </a:rPr>
-              <a:t>נשוחח עם 12 מנהלים ומנהלות </a:t>
-            </a:r>
-            <a:pPr algn="r" indent="0" marL="0">
-              <a:lnSpc>
-                <a:spcPct val="115000"/>
-              </a:lnSpc>
-              <a:buNone/>
-            </a:pPr>
-            <a:r>
-              <a:rPr lang="he-IL" altLang="en-US" sz="1500" dirty="0">
-                <a:solidFill>
-                  <a:srgbClr val="1B2B2E"/>
-                </a:solidFill>
-                <a:latin typeface="Arial" pitchFamily="34" charset="0"/>
-                <a:ea typeface="Arial" pitchFamily="34" charset="-122"/>
-                <a:cs typeface="Arial" pitchFamily="34" charset="-120"/>
-              </a:rPr>
-              <a:t>של בתי ספר בערים בצפון הארץ, יסודיים ועל־יסודיים ובעלי ותק שונה. בחרנו במנהלים כי הם מקבלי ההחלטות בבוקר ההיעדרות, ובערים כדי לבחון את התופעה בהקשר אחיד ולהשוות בין ערים שונות.</a:t>
-            </a:r>
-            <a:endParaRPr lang="he-IL" sz="1500" dirty="0"/>
-          </a:p>
-        </p:txBody>
-      </p:sp>
-      <p:sp>
-        <p:nvSpPr>
-          <p:cNvPr id="12" name="Shape 9"/>
+              <a:t>היעדרות מורים</a:t>
+            </a:r>
+            <a:endParaRPr lang="en-US" sz="1500" dirty="0"/>
+          </a:p>
+        </p:txBody>
+      </p:sp>
+      <p:sp>
+        <p:nvSpPr>
+          <p:cNvPr id="10" name="Shape 7"/>
           <p:cNvSpPr/>
           <p:nvPr/>
         </p:nvSpPr>
         <p:spPr>
           <a:xfrm>
-            <a:off x="11183112" y="3081528"/>
-            <a:ext cx="457200" cy="457200"/>
+            <a:off x="8833104" y="2464308"/>
+            <a:ext cx="329184" cy="329184"/>
           </a:xfrm>
           <a:prstGeom prst="ellipse">
             <a:avLst/>
           </a:prstGeom>
           <a:solidFill>
-            <a:srgbClr val="12343B"/>
+            <a:srgbClr val="E9A23B"/>
           </a:solidFill>
           <a:ln w="12700">
             <a:solidFill>
-              <a:srgbClr val="12343B"/>
+              <a:srgbClr val="E9A23B"/>
             </a:solidFill>
             <a:prstDash val="solid"/>
           </a:ln>
@@ -2574,7 +2646,7 @@
       </p:sp>
       <p:pic>
         <p:nvPicPr>
-          <p:cNvPr id="13" name="Image 1" descr="preencoded.png">    </p:cNvPr>
+          <p:cNvPr id="11" name="Image 1" descr="preencoded.png">    </p:cNvPr>
           <p:cNvPicPr>
             <a:picLocks noChangeAspect="1"/>
           </p:cNvPicPr>
@@ -2588,8 +2660,8 @@
         </p:blipFill>
         <p:spPr>
           <a:xfrm>
-            <a:off x="11297412" y="3195828"/>
-            <a:ext cx="228600" cy="228600"/>
+            <a:off x="8915400" y="2546604"/>
+            <a:ext cx="164592" cy="164592"/>
           </a:xfrm>
           <a:prstGeom prst="rect">
             <a:avLst/>
@@ -2598,72 +2670,40 @@
       </p:pic>
       <p:sp>
         <p:nvSpPr>
-          <p:cNvPr id="14" name="Text 10"/>
-          <p:cNvSpPr txBox="1"/>
-          <p:nvPr/>
-        </p:nvSpPr>
-        <p:spPr>
-          <a:xfrm>
-            <a:off x="3200400" y="3063240"/>
-            <a:ext cx="7754112" cy="1143000"/>
-          </a:xfrm>
-          <a:prstGeom prst="rect">
-            <a:avLst/>
-          </a:prstGeom>
-          <a:noFill/>
-          <a:ln/>
-        </p:spPr>
-        <p:txBody>
-          <a:bodyPr wrap="square" lIns="0" tIns="0" rIns="0" bIns="0" rtlCol="0" anchor="t"/>
-          <a:lstStyle/>
-          <a:p>
-            <a:pPr algn="r" indent="0" marL="0">
-              <a:lnSpc>
-                <a:spcPct val="115000"/>
-              </a:lnSpc>
-              <a:buNone/>
-            </a:pPr>
-            <a:r>
-              <a:rPr lang="he-IL" altLang="en-US" sz="1500" b="1" dirty="0">
-                <a:solidFill>
-                  <a:srgbClr val="12343B"/>
-                </a:solidFill>
-                <a:latin typeface="Arial" pitchFamily="34" charset="0"/>
-                <a:ea typeface="Arial" pitchFamily="34" charset="-122"/>
-                <a:cs typeface="Arial" pitchFamily="34" charset="-120"/>
-              </a:rPr>
-              <a:t>בראיונות חצי מובנים </a:t>
-            </a:r>
-            <a:pPr algn="r" indent="0" marL="0">
-              <a:lnSpc>
-                <a:spcPct val="115000"/>
-              </a:lnSpc>
-              <a:buNone/>
-            </a:pPr>
-            <a:r>
-              <a:rPr lang="he-IL" altLang="en-US" sz="1500" dirty="0">
-                <a:solidFill>
-                  <a:srgbClr val="1B2B2E"/>
-                </a:solidFill>
-                <a:latin typeface="Arial" pitchFamily="34" charset="0"/>
-                <a:ea typeface="Arial" pitchFamily="34" charset="-122"/>
-                <a:cs typeface="Arial" pitchFamily="34" charset="-120"/>
-              </a:rPr>
-              <a:t>נבקש מכל מנהל לתאר בוקר אחד של היעדרות וגם היעדרות ממושכת. כך נוכל להבין שיקולים ודילמות ולא רק נהלים כתובים. בניתוח תמטי נחפש אסטרטגיות מונעות לעומת מגיבות, ואת האיזון בין פדגוגיה, תקציב, הוגנות כלפי הצוות ורווחת המורה.</a:t>
-            </a:r>
-            <a:endParaRPr lang="he-IL" sz="1500" dirty="0"/>
-          </a:p>
-        </p:txBody>
-      </p:sp>
-      <p:sp>
-        <p:nvSpPr>
-          <p:cNvPr id="15" name="Shape 11"/>
+          <p:cNvPr id="12" name="Shape 8"/>
           <p:cNvSpPr/>
           <p:nvPr/>
         </p:nvSpPr>
         <p:spPr>
           <a:xfrm>
-            <a:off x="11183112" y="4178808"/>
+            <a:off x="6355080" y="2011680"/>
+            <a:ext cx="2377440" cy="1234440"/>
+          </a:xfrm>
+          <a:prstGeom prst="roundRect">
+            <a:avLst>
+              <a:gd name="adj" fmla="val 8889"/>
+            </a:avLst>
+          </a:prstGeom>
+          <a:solidFill>
+            <a:srgbClr val="E4F0F0"/>
+          </a:solidFill>
+          <a:ln w="12700">
+            <a:solidFill>
+              <a:srgbClr val="E4F0F0"/>
+            </a:solidFill>
+            <a:prstDash val="solid"/>
+          </a:ln>
+        </p:spPr>
+      </p:sp>
+      <p:sp>
+        <p:nvSpPr>
+          <p:cNvPr id="13" name="Shape 9"/>
+          <p:cNvSpPr/>
+          <p:nvPr/>
+        </p:nvSpPr>
+        <p:spPr>
+          <a:xfrm>
+            <a:off x="7315200" y="2176272"/>
             <a:ext cx="457200" cy="457200"/>
           </a:xfrm>
           <a:prstGeom prst="ellipse">
@@ -2682,7 +2722,7 @@
       </p:sp>
       <p:pic>
         <p:nvPicPr>
-          <p:cNvPr id="16" name="Image 2" descr="preencoded.png">    </p:cNvPr>
+          <p:cNvPr id="14" name="Image 2" descr="preencoded.png">    </p:cNvPr>
           <p:cNvPicPr>
             <a:picLocks noChangeAspect="1"/>
           </p:cNvPicPr>
@@ -2696,7 +2736,7 @@
         </p:blipFill>
         <p:spPr>
           <a:xfrm>
-            <a:off x="11297412" y="4293108"/>
+            <a:off x="7429500" y="2290572"/>
             <a:ext cx="228600" cy="228600"/>
           </a:xfrm>
           <a:prstGeom prst="rect">
@@ -2706,14 +2746,14 @@
       </p:pic>
       <p:sp>
         <p:nvSpPr>
-          <p:cNvPr id="17" name="Text 12"/>
+          <p:cNvPr id="15" name="Text 10"/>
           <p:cNvSpPr txBox="1"/>
           <p:nvPr/>
         </p:nvSpPr>
         <p:spPr>
           <a:xfrm>
-            <a:off x="3200400" y="4160520"/>
-            <a:ext cx="7754112" cy="868680"/>
+            <a:off x="6446520" y="2697480"/>
+            <a:ext cx="2194560" cy="411480"/>
           </a:xfrm>
           <a:prstGeom prst="rect">
             <a:avLst/>
@@ -2722,17 +2762,14 @@
           <a:ln/>
         </p:spPr>
         <p:txBody>
-          <a:bodyPr wrap="square" lIns="0" tIns="0" rIns="0" bIns="0" rtlCol="0" anchor="t"/>
-          <a:lstStyle/>
-          <a:p>
-            <a:pPr algn="r" indent="0" marL="0">
-              <a:lnSpc>
-                <a:spcPct val="115000"/>
-              </a:lnSpc>
-              <a:buNone/>
-            </a:pPr>
-            <a:r>
-              <a:rPr lang="he-IL" altLang="en-US" sz="1500" b="1" dirty="0">
+          <a:bodyPr wrap="square" lIns="0" tIns="0" rIns="0" bIns="0" rtlCol="0" anchor="ctr"/>
+          <a:lstStyle/>
+          <a:p>
+            <a:pPr rtl="1" algn="ctr" indent="0" marL="0">
+              <a:buNone/>
+            </a:pPr>
+            <a:r>
+              <a:rPr lang="en-US" sz="1500" b="1" dirty="0">
                 <a:solidFill>
                   <a:srgbClr val="12343B"/>
                 </a:solidFill>
@@ -2740,44 +2777,101 @@
                 <a:ea typeface="Arial" pitchFamily="34" charset="-122"/>
                 <a:cs typeface="Arial" pitchFamily="34" charset="-120"/>
               </a:rPr>
-              <a:t>האתגר המרכזי </a:t>
-            </a:r>
-            <a:pPr algn="r" indent="0" marL="0">
-              <a:lnSpc>
-                <a:spcPct val="115000"/>
-              </a:lnSpc>
-              <a:buNone/>
-            </a:pPr>
-            <a:r>
-              <a:rPr lang="he-IL" altLang="en-US" sz="1500" dirty="0">
-                <a:solidFill>
-                  <a:srgbClr val="1B2B2E"/>
-                </a:solidFill>
-                <a:latin typeface="Arial" pitchFamily="34" charset="0"/>
-                <a:ea typeface="Arial" pitchFamily="34" charset="-122"/>
-                <a:cs typeface="Arial" pitchFamily="34" charset="-120"/>
-              </a:rPr>
-              <a:t>הוא שמנהלים עלולים להציג תמונה יפה מהמציאות, ולכן נבקש דוגמאות מוחשיות. ממצא שיפתיע אותנו: שמה שמנחה את ההחלטה בפועל הוא השקט והסדר ולא הרצף הלימודי.</a:t>
-            </a:r>
-            <a:endParaRPr lang="he-IL" sz="1500" dirty="0"/>
-          </a:p>
-        </p:txBody>
-      </p:sp>
-      <p:sp>
-        <p:nvSpPr>
-          <p:cNvPr id="18" name="Shape 13"/>
+              <a:t>רצף לימודי</a:t>
+            </a:r>
+            <a:endParaRPr lang="en-US" sz="1500" dirty="0"/>
+          </a:p>
+        </p:txBody>
+      </p:sp>
+      <p:sp>
+        <p:nvSpPr>
+          <p:cNvPr id="16" name="Shape 11"/>
           <p:cNvSpPr/>
           <p:nvPr/>
         </p:nvSpPr>
         <p:spPr>
           <a:xfrm>
-            <a:off x="548640" y="5394960"/>
-            <a:ext cx="11091672" cy="960120"/>
+            <a:off x="5925312" y="2464308"/>
+            <a:ext cx="329184" cy="329184"/>
+          </a:xfrm>
+          <a:prstGeom prst="ellipse">
+            <a:avLst/>
+          </a:prstGeom>
+          <a:solidFill>
+            <a:srgbClr val="E9A23B"/>
+          </a:solidFill>
+          <a:ln w="12700">
+            <a:solidFill>
+              <a:srgbClr val="E9A23B"/>
+            </a:solidFill>
+            <a:prstDash val="solid"/>
+          </a:ln>
+        </p:spPr>
+      </p:sp>
+      <p:pic>
+        <p:nvPicPr>
+          <p:cNvPr id="17" name="Image 3" descr="preencoded.png">    </p:cNvPr>
+          <p:cNvPicPr>
+            <a:picLocks noChangeAspect="1"/>
+          </p:cNvPicPr>
+          <p:nvPr/>
+        </p:nvPicPr>
+        <p:blipFill>
+          <a:blip r:embed="rId4"/>
+          <a:stretch>
+            <a:fillRect/>
+          </a:stretch>
+        </p:blipFill>
+        <p:spPr>
+          <a:xfrm>
+            <a:off x="6007608" y="2546604"/>
+            <a:ext cx="164592" cy="164592"/>
+          </a:xfrm>
+          <a:prstGeom prst="rect">
+            <a:avLst/>
+          </a:prstGeom>
+        </p:spPr>
+      </p:pic>
+      <p:sp>
+        <p:nvSpPr>
+          <p:cNvPr id="18" name="Shape 12"/>
+          <p:cNvSpPr/>
+          <p:nvPr/>
+        </p:nvSpPr>
+        <p:spPr>
+          <a:xfrm>
+            <a:off x="3447288" y="2011680"/>
+            <a:ext cx="2377440" cy="1234440"/>
           </a:xfrm>
           <a:prstGeom prst="roundRect">
             <a:avLst>
-              <a:gd name="adj" fmla="val 11429"/>
+              <a:gd name="adj" fmla="val 8889"/>
             </a:avLst>
+          </a:prstGeom>
+          <a:solidFill>
+            <a:srgbClr val="E4F0F0"/>
+          </a:solidFill>
+          <a:ln w="12700">
+            <a:solidFill>
+              <a:srgbClr val="E4F0F0"/>
+            </a:solidFill>
+            <a:prstDash val="solid"/>
+          </a:ln>
+        </p:spPr>
+      </p:sp>
+      <p:sp>
+        <p:nvSpPr>
+          <p:cNvPr id="19" name="Shape 13"/>
+          <p:cNvSpPr/>
+          <p:nvPr/>
+        </p:nvSpPr>
+        <p:spPr>
+          <a:xfrm>
+            <a:off x="4407408" y="2176272"/>
+            <a:ext cx="457200" cy="457200"/>
+          </a:xfrm>
+          <a:prstGeom prst="ellipse">
+            <a:avLst/>
           </a:prstGeom>
           <a:solidFill>
             <a:srgbClr val="12343B"/>
@@ -2790,16 +2884,1604 @@
           </a:ln>
         </p:spPr>
       </p:sp>
-      <p:sp>
-        <p:nvSpPr>
-          <p:cNvPr id="19" name="Text 14"/>
+      <p:pic>
+        <p:nvPicPr>
+          <p:cNvPr id="20" name="Image 4" descr="preencoded.png">    </p:cNvPr>
+          <p:cNvPicPr>
+            <a:picLocks noChangeAspect="1"/>
+          </p:cNvPicPr>
+          <p:nvPr/>
+        </p:nvPicPr>
+        <p:blipFill>
+          <a:blip r:embed="rId5"/>
+          <a:stretch>
+            <a:fillRect/>
+          </a:stretch>
+        </p:blipFill>
+        <p:spPr>
+          <a:xfrm>
+            <a:off x="4521708" y="2290572"/>
+            <a:ext cx="228600" cy="228600"/>
+          </a:xfrm>
+          <a:prstGeom prst="rect">
+            <a:avLst/>
+          </a:prstGeom>
+        </p:spPr>
+      </p:pic>
+      <p:sp>
+        <p:nvSpPr>
+          <p:cNvPr id="21" name="Text 14"/>
           <p:cNvSpPr txBox="1"/>
           <p:nvPr/>
         </p:nvSpPr>
         <p:spPr>
           <a:xfrm>
-            <a:off x="868680" y="5468112"/>
-            <a:ext cx="10451592" cy="822960"/>
+            <a:off x="3538728" y="2697480"/>
+            <a:ext cx="2194560" cy="411480"/>
+          </a:xfrm>
+          <a:prstGeom prst="rect">
+            <a:avLst/>
+          </a:prstGeom>
+          <a:noFill/>
+          <a:ln/>
+        </p:spPr>
+        <p:txBody>
+          <a:bodyPr wrap="square" lIns="0" tIns="0" rIns="0" bIns="0" rtlCol="0" anchor="ctr"/>
+          <a:lstStyle/>
+          <a:p>
+            <a:pPr rtl="1" algn="ctr" indent="0" marL="0">
+              <a:buNone/>
+            </a:pPr>
+            <a:r>
+              <a:rPr lang="en-US" sz="1500" b="1" dirty="0">
+                <a:solidFill>
+                  <a:srgbClr val="12343B"/>
+                </a:solidFill>
+                <a:latin typeface="Arial" pitchFamily="34" charset="0"/>
+                <a:ea typeface="Arial" pitchFamily="34" charset="-122"/>
+                <a:cs typeface="Arial" pitchFamily="34" charset="-120"/>
+              </a:rPr>
+              <a:t>קבלת החלטות ניהולית</a:t>
+            </a:r>
+            <a:endParaRPr lang="en-US" sz="1500" dirty="0"/>
+          </a:p>
+        </p:txBody>
+      </p:sp>
+      <p:sp>
+        <p:nvSpPr>
+          <p:cNvPr id="22" name="Shape 15"/>
+          <p:cNvSpPr/>
+          <p:nvPr/>
+        </p:nvSpPr>
+        <p:spPr>
+          <a:xfrm>
+            <a:off x="3017520" y="2464308"/>
+            <a:ext cx="329184" cy="329184"/>
+          </a:xfrm>
+          <a:prstGeom prst="ellipse">
+            <a:avLst/>
+          </a:prstGeom>
+          <a:solidFill>
+            <a:srgbClr val="E9A23B"/>
+          </a:solidFill>
+          <a:ln w="12700">
+            <a:solidFill>
+              <a:srgbClr val="E9A23B"/>
+            </a:solidFill>
+            <a:prstDash val="solid"/>
+          </a:ln>
+        </p:spPr>
+      </p:sp>
+      <p:pic>
+        <p:nvPicPr>
+          <p:cNvPr id="23" name="Image 5" descr="preencoded.png">    </p:cNvPr>
+          <p:cNvPicPr>
+            <a:picLocks noChangeAspect="1"/>
+          </p:cNvPicPr>
+          <p:nvPr/>
+        </p:nvPicPr>
+        <p:blipFill>
+          <a:blip r:embed="rId6"/>
+          <a:stretch>
+            <a:fillRect/>
+          </a:stretch>
+        </p:blipFill>
+        <p:spPr>
+          <a:xfrm>
+            <a:off x="3099816" y="2546604"/>
+            <a:ext cx="164592" cy="164592"/>
+          </a:xfrm>
+          <a:prstGeom prst="rect">
+            <a:avLst/>
+          </a:prstGeom>
+        </p:spPr>
+      </p:pic>
+      <p:sp>
+        <p:nvSpPr>
+          <p:cNvPr id="24" name="Shape 16"/>
+          <p:cNvSpPr/>
+          <p:nvPr/>
+        </p:nvSpPr>
+        <p:spPr>
+          <a:xfrm>
+            <a:off x="539496" y="2011680"/>
+            <a:ext cx="2377440" cy="1234440"/>
+          </a:xfrm>
+          <a:prstGeom prst="roundRect">
+            <a:avLst>
+              <a:gd name="adj" fmla="val 8889"/>
+            </a:avLst>
+          </a:prstGeom>
+          <a:solidFill>
+            <a:srgbClr val="12343B"/>
+          </a:solidFill>
+          <a:ln w="12700">
+            <a:solidFill>
+              <a:srgbClr val="12343B"/>
+            </a:solidFill>
+            <a:prstDash val="solid"/>
+          </a:ln>
+        </p:spPr>
+      </p:sp>
+      <p:sp>
+        <p:nvSpPr>
+          <p:cNvPr id="25" name="Shape 17"/>
+          <p:cNvSpPr/>
+          <p:nvPr/>
+        </p:nvSpPr>
+        <p:spPr>
+          <a:xfrm>
+            <a:off x="1499616" y="2176272"/>
+            <a:ext cx="457200" cy="457200"/>
+          </a:xfrm>
+          <a:prstGeom prst="ellipse">
+            <a:avLst/>
+          </a:prstGeom>
+          <a:solidFill>
+            <a:srgbClr val="E9A23B"/>
+          </a:solidFill>
+          <a:ln w="12700">
+            <a:solidFill>
+              <a:srgbClr val="E9A23B"/>
+            </a:solidFill>
+            <a:prstDash val="solid"/>
+          </a:ln>
+        </p:spPr>
+      </p:sp>
+      <p:pic>
+        <p:nvPicPr>
+          <p:cNvPr id="26" name="Image 6" descr="preencoded.png">    </p:cNvPr>
+          <p:cNvPicPr>
+            <a:picLocks noChangeAspect="1"/>
+          </p:cNvPicPr>
+          <p:nvPr/>
+        </p:nvPicPr>
+        <p:blipFill>
+          <a:blip r:embed="rId7"/>
+          <a:stretch>
+            <a:fillRect/>
+          </a:stretch>
+        </p:blipFill>
+        <p:spPr>
+          <a:xfrm>
+            <a:off x="1613916" y="2290572"/>
+            <a:ext cx="228600" cy="228600"/>
+          </a:xfrm>
+          <a:prstGeom prst="rect">
+            <a:avLst/>
+          </a:prstGeom>
+        </p:spPr>
+      </p:pic>
+      <p:sp>
+        <p:nvSpPr>
+          <p:cNvPr id="27" name="Text 18"/>
+          <p:cNvSpPr txBox="1"/>
+          <p:nvPr/>
+        </p:nvSpPr>
+        <p:spPr>
+          <a:xfrm>
+            <a:off x="630936" y="2697480"/>
+            <a:ext cx="2194560" cy="411480"/>
+          </a:xfrm>
+          <a:prstGeom prst="rect">
+            <a:avLst/>
+          </a:prstGeom>
+          <a:noFill/>
+          <a:ln/>
+        </p:spPr>
+        <p:txBody>
+          <a:bodyPr wrap="square" lIns="0" tIns="0" rIns="0" bIns="0" rtlCol="0" anchor="ctr"/>
+          <a:lstStyle/>
+          <a:p>
+            <a:pPr rtl="1" algn="ctr" indent="0" marL="0">
+              <a:buNone/>
+            </a:pPr>
+            <a:r>
+              <a:rPr lang="en-US" sz="1500" b="1" dirty="0">
+                <a:solidFill>
+                  <a:srgbClr val="FFFFFF"/>
+                </a:solidFill>
+                <a:latin typeface="Arial" pitchFamily="34" charset="0"/>
+                <a:ea typeface="Arial" pitchFamily="34" charset="-122"/>
+                <a:cs typeface="Arial" pitchFamily="34" charset="-120"/>
+              </a:rPr>
+              <a:t>אסטרטגיות</a:t>
+            </a:r>
+            <a:endParaRPr lang="en-US" sz="1500" dirty="0"/>
+          </a:p>
+        </p:txBody>
+      </p:sp>
+      <p:sp>
+        <p:nvSpPr>
+          <p:cNvPr id="28" name="Shape 19"/>
+          <p:cNvSpPr/>
+          <p:nvPr/>
+        </p:nvSpPr>
+        <p:spPr>
+          <a:xfrm>
+            <a:off x="11183112" y="3767328"/>
+            <a:ext cx="457200" cy="457200"/>
+          </a:xfrm>
+          <a:prstGeom prst="ellipse">
+            <a:avLst/>
+          </a:prstGeom>
+          <a:solidFill>
+            <a:srgbClr val="12343B"/>
+          </a:solidFill>
+          <a:ln w="12700">
+            <a:solidFill>
+              <a:srgbClr val="12343B"/>
+            </a:solidFill>
+            <a:prstDash val="solid"/>
+          </a:ln>
+        </p:spPr>
+      </p:sp>
+      <p:pic>
+        <p:nvPicPr>
+          <p:cNvPr id="29" name="Image 7" descr="preencoded.png">    </p:cNvPr>
+          <p:cNvPicPr>
+            <a:picLocks noChangeAspect="1"/>
+          </p:cNvPicPr>
+          <p:nvPr/>
+        </p:nvPicPr>
+        <p:blipFill>
+          <a:blip r:embed="rId8"/>
+          <a:stretch>
+            <a:fillRect/>
+          </a:stretch>
+        </p:blipFill>
+        <p:spPr>
+          <a:xfrm>
+            <a:off x="11297412" y="3881628"/>
+            <a:ext cx="228600" cy="228600"/>
+          </a:xfrm>
+          <a:prstGeom prst="rect">
+            <a:avLst/>
+          </a:prstGeom>
+        </p:spPr>
+      </p:pic>
+      <p:sp>
+        <p:nvSpPr>
+          <p:cNvPr id="30" name="Text 20"/>
+          <p:cNvSpPr txBox="1"/>
+          <p:nvPr/>
+        </p:nvSpPr>
+        <p:spPr>
+          <a:xfrm>
+            <a:off x="548640" y="3749040"/>
+            <a:ext cx="10405872" cy="1234440"/>
+          </a:xfrm>
+          <a:prstGeom prst="rect">
+            <a:avLst/>
+          </a:prstGeom>
+          <a:noFill/>
+          <a:ln/>
+        </p:spPr>
+        <p:txBody>
+          <a:bodyPr wrap="square" lIns="0" tIns="0" rIns="0" bIns="0" rtlCol="0" anchor="t"/>
+          <a:lstStyle/>
+          <a:p>
+            <a:pPr algn="r" indent="0" marL="0">
+              <a:lnSpc>
+                <a:spcPct val="115000"/>
+              </a:lnSpc>
+              <a:buNone/>
+            </a:pPr>
+            <a:r>
+              <a:rPr lang="he-IL" altLang="en-US" sz="1600" b="1" dirty="0">
+                <a:solidFill>
+                  <a:srgbClr val="12343B"/>
+                </a:solidFill>
+                <a:latin typeface="Arial" pitchFamily="34" charset="0"/>
+                <a:ea typeface="Arial" pitchFamily="34" charset="-122"/>
+                <a:cs typeface="Arial" pitchFamily="34" charset="-120"/>
+              </a:rPr>
+              <a:t>הסיפור מתחיל בהיעדרות מורים ועובר אל הרצף הלימודי, </a:t>
+            </a:r>
+            <a:pPr algn="r" indent="0" marL="0">
+              <a:lnSpc>
+                <a:spcPct val="115000"/>
+              </a:lnSpc>
+              <a:buNone/>
+            </a:pPr>
+            <a:r>
+              <a:rPr lang="he-IL" altLang="en-US" sz="1600" dirty="0">
+                <a:solidFill>
+                  <a:srgbClr val="1B2B2E"/>
+                </a:solidFill>
+                <a:latin typeface="Arial" pitchFamily="34" charset="0"/>
+                <a:ea typeface="Arial" pitchFamily="34" charset="-122"/>
+                <a:cs typeface="Arial" pitchFamily="34" charset="-120"/>
+              </a:rPr>
+              <a:t>שאנחנו מבינים בשלושה ממדים: פדגוגי, כלומר המשך התוכן והלמידה; ארגוני, כלומר שיבוץ, מערכת שעות ועומס על הצוות; ורגשי, כלומר היחסים והביטחון של התלמידים עם מבוגר מוכר.</a:t>
+            </a:r>
+            <a:endParaRPr lang="he-IL" sz="1600" dirty="0"/>
+          </a:p>
+        </p:txBody>
+      </p:sp>
+      <p:sp>
+        <p:nvSpPr>
+          <p:cNvPr id="31" name="Shape 21"/>
+          <p:cNvSpPr/>
+          <p:nvPr/>
+        </p:nvSpPr>
+        <p:spPr>
+          <a:xfrm>
+            <a:off x="11183112" y="4773168"/>
+            <a:ext cx="457200" cy="457200"/>
+          </a:xfrm>
+          <a:prstGeom prst="ellipse">
+            <a:avLst/>
+          </a:prstGeom>
+          <a:solidFill>
+            <a:srgbClr val="12343B"/>
+          </a:solidFill>
+          <a:ln w="12700">
+            <a:solidFill>
+              <a:srgbClr val="12343B"/>
+            </a:solidFill>
+            <a:prstDash val="solid"/>
+          </a:ln>
+        </p:spPr>
+      </p:sp>
+      <p:pic>
+        <p:nvPicPr>
+          <p:cNvPr id="32" name="Image 8" descr="preencoded.png">    </p:cNvPr>
+          <p:cNvPicPr>
+            <a:picLocks noChangeAspect="1"/>
+          </p:cNvPicPr>
+          <p:nvPr/>
+        </p:nvPicPr>
+        <p:blipFill>
+          <a:blip r:embed="rId9"/>
+          <a:stretch>
+            <a:fillRect/>
+          </a:stretch>
+        </p:blipFill>
+        <p:spPr>
+          <a:xfrm>
+            <a:off x="11297412" y="4887468"/>
+            <a:ext cx="228600" cy="228600"/>
+          </a:xfrm>
+          <a:prstGeom prst="rect">
+            <a:avLst/>
+          </a:prstGeom>
+        </p:spPr>
+      </p:pic>
+      <p:sp>
+        <p:nvSpPr>
+          <p:cNvPr id="33" name="Text 22"/>
+          <p:cNvSpPr txBox="1"/>
+          <p:nvPr/>
+        </p:nvSpPr>
+        <p:spPr>
+          <a:xfrm>
+            <a:off x="548640" y="4754880"/>
+            <a:ext cx="10405872" cy="1234440"/>
+          </a:xfrm>
+          <a:prstGeom prst="rect">
+            <a:avLst/>
+          </a:prstGeom>
+          <a:noFill/>
+          <a:ln/>
+        </p:spPr>
+        <p:txBody>
+          <a:bodyPr wrap="square" lIns="0" tIns="0" rIns="0" bIns="0" rtlCol="0" anchor="t"/>
+          <a:lstStyle/>
+          <a:p>
+            <a:pPr algn="r" indent="0" marL="0">
+              <a:lnSpc>
+                <a:spcPct val="115000"/>
+              </a:lnSpc>
+              <a:buNone/>
+            </a:pPr>
+            <a:r>
+              <a:rPr lang="he-IL" altLang="en-US" sz="1600" b="1" dirty="0">
+                <a:solidFill>
+                  <a:srgbClr val="12343B"/>
+                </a:solidFill>
+                <a:latin typeface="Arial" pitchFamily="34" charset="0"/>
+                <a:ea typeface="Arial" pitchFamily="34" charset="-122"/>
+                <a:cs typeface="Arial" pitchFamily="34" charset="-120"/>
+              </a:rPr>
+              <a:t>הרצף הזה תלוי בקבלת החלטות ניהולית, </a:t>
+            </a:r>
+            <a:pPr algn="r" indent="0" marL="0">
+              <a:lnSpc>
+                <a:spcPct val="115000"/>
+              </a:lnSpc>
+              <a:buNone/>
+            </a:pPr>
+            <a:r>
+              <a:rPr lang="he-IL" altLang="en-US" sz="1600" dirty="0">
+                <a:solidFill>
+                  <a:srgbClr val="1B2B2E"/>
+                </a:solidFill>
+                <a:latin typeface="Arial" pitchFamily="34" charset="0"/>
+                <a:ea typeface="Arial" pitchFamily="34" charset="-122"/>
+                <a:cs typeface="Arial" pitchFamily="34" charset="-120"/>
+              </a:rPr>
+              <a:t>שבה המנהל שוקל צרכים מתחרים בזמן קצר ובמשאבים מוגבלים. מתוך ההחלטות האלה נגזרות האסטרטגיות: חלקן מגיבות, כמו ממלא מקום, איחוד כיתות או שעה פרטנית, וחלקן מונעות, כמו מאגר ממלאי מקום קבוע וחומרי עבודה מוכנים מראש.</a:t>
+            </a:r>
+            <a:endParaRPr lang="he-IL" sz="1600" dirty="0"/>
+          </a:p>
+        </p:txBody>
+      </p:sp>
+    </p:spTree>
+  </p:cSld>
+  <p:clrMapOvr>
+    <a:masterClrMapping/>
+  </p:clrMapOvr>
+</p:sld>
+</file>
+
+<file path=ppt/slides/slide4.xml><?xml version="1.0" encoding="utf-8"?>
+<p:sld xmlns:a="http://schemas.openxmlformats.org/drawingml/2006/main" xmlns:r="http://schemas.openxmlformats.org/officeDocument/2006/relationships" xmlns:p="http://schemas.openxmlformats.org/presentationml/2006/main">
+  <p:cSld name="Slide 4">
+    <p:bg>
+      <p:bgPr>
+        <a:solidFill>
+          <a:srgbClr val="FFFFFF"/>
+        </a:solidFill>
+      </p:bgPr>
+    </p:bg>
+    <p:spTree>
+      <p:nvGrpSpPr>
+        <p:cNvPr id="1" name=""/>
+        <p:cNvGrpSpPr/>
+        <p:nvPr/>
+      </p:nvGrpSpPr>
+      <p:grpSpPr>
+        <a:xfrm>
+          <a:off x="0" y="0"/>
+          <a:ext cx="0" cy="0"/>
+          <a:chOff x="0" y="0"/>
+          <a:chExt cx="0" cy="0"/>
+        </a:xfrm>
+      </p:grpSpPr>
+      <p:sp>
+        <p:nvSpPr>
+          <p:cNvPr id="2" name="Shape 0"/>
+          <p:cNvSpPr/>
+          <p:nvPr/>
+        </p:nvSpPr>
+        <p:spPr>
+          <a:xfrm>
+            <a:off x="11091672" y="411480"/>
+            <a:ext cx="548640" cy="548640"/>
+          </a:xfrm>
+          <a:prstGeom prst="ellipse">
+            <a:avLst/>
+          </a:prstGeom>
+          <a:solidFill>
+            <a:srgbClr val="E9A23B"/>
+          </a:solidFill>
+          <a:ln w="12700">
+            <a:solidFill>
+              <a:srgbClr val="E9A23B"/>
+            </a:solidFill>
+            <a:prstDash val="solid"/>
+          </a:ln>
+        </p:spPr>
+      </p:sp>
+      <p:sp>
+        <p:nvSpPr>
+          <p:cNvPr id="3" name="Text 1"/>
+          <p:cNvSpPr txBox="1"/>
+          <p:nvPr/>
+        </p:nvSpPr>
+        <p:spPr>
+          <a:xfrm>
+            <a:off x="11091672" y="411480"/>
+            <a:ext cx="548640" cy="548640"/>
+          </a:xfrm>
+          <a:prstGeom prst="rect">
+            <a:avLst/>
+          </a:prstGeom>
+          <a:noFill/>
+          <a:ln/>
+        </p:spPr>
+        <p:txBody>
+          <a:bodyPr wrap="square" lIns="0" tIns="0" rIns="0" bIns="0" rtlCol="0" anchor="ctr"/>
+          <a:lstStyle/>
+          <a:p>
+            <a:pPr algn="ctr" indent="0" marL="0">
+              <a:buNone/>
+            </a:pPr>
+            <a:r>
+              <a:rPr lang="en-US" sz="2000" b="1" dirty="0">
+                <a:solidFill>
+                  <a:srgbClr val="12343B"/>
+                </a:solidFill>
+                <a:latin typeface="Arial" pitchFamily="34" charset="0"/>
+                <a:ea typeface="Arial" pitchFamily="34" charset="-122"/>
+                <a:cs typeface="Arial" pitchFamily="34" charset="-120"/>
+              </a:rPr>
+              <a:t>4</a:t>
+            </a:r>
+            <a:endParaRPr lang="en-US" sz="2000" dirty="0"/>
+          </a:p>
+        </p:txBody>
+      </p:sp>
+      <p:sp>
+        <p:nvSpPr>
+          <p:cNvPr id="4" name="Text 2"/>
+          <p:cNvSpPr txBox="1"/>
+          <p:nvPr/>
+        </p:nvSpPr>
+        <p:spPr>
+          <a:xfrm>
+            <a:off x="5943600" y="502920"/>
+            <a:ext cx="4983480" cy="365760"/>
+          </a:xfrm>
+          <a:prstGeom prst="rect">
+            <a:avLst/>
+          </a:prstGeom>
+          <a:noFill/>
+          <a:ln/>
+        </p:spPr>
+        <p:txBody>
+          <a:bodyPr wrap="square" lIns="0" tIns="0" rIns="0" bIns="0" rtlCol="0" anchor="ctr"/>
+          <a:lstStyle/>
+          <a:p>
+            <a:pPr rtl="1" algn="r" indent="0" marL="0">
+              <a:buNone/>
+            </a:pPr>
+            <a:r>
+              <a:rPr lang="he-IL" altLang="en-US" sz="1300" b="1" dirty="0">
+                <a:solidFill>
+                  <a:srgbClr val="4F6A6E"/>
+                </a:solidFill>
+                <a:latin typeface="Arial" pitchFamily="34" charset="0"/>
+                <a:ea typeface="Arial" pitchFamily="34" charset="-122"/>
+                <a:cs typeface="Arial" pitchFamily="34" charset="-120"/>
+              </a:rPr>
+              <a:t>יוצאים לשטח</a:t>
+            </a:r>
+            <a:endParaRPr lang="he-IL" sz="1300" dirty="0"/>
+          </a:p>
+        </p:txBody>
+      </p:sp>
+      <p:sp>
+        <p:nvSpPr>
+          <p:cNvPr id="5" name="Text 3"/>
+          <p:cNvSpPr txBox="1"/>
+          <p:nvPr/>
+        </p:nvSpPr>
+        <p:spPr>
+          <a:xfrm>
+            <a:off x="548640" y="1051560"/>
+            <a:ext cx="11091672" cy="685800"/>
+          </a:xfrm>
+          <a:prstGeom prst="rect">
+            <a:avLst/>
+          </a:prstGeom>
+          <a:noFill/>
+          <a:ln/>
+        </p:spPr>
+        <p:txBody>
+          <a:bodyPr wrap="square" lIns="0" tIns="0" rIns="0" bIns="0" rtlCol="0" anchor="ctr"/>
+          <a:lstStyle/>
+          <a:p>
+            <a:pPr rtl="1" algn="r" indent="0" marL="0">
+              <a:buNone/>
+            </a:pPr>
+            <a:r>
+              <a:rPr lang="he-IL" altLang="en-US" sz="3600" b="1" dirty="0">
+                <a:solidFill>
+                  <a:srgbClr val="12343B"/>
+                </a:solidFill>
+                <a:latin typeface="Arial" pitchFamily="34" charset="0"/>
+                <a:ea typeface="Arial" pitchFamily="34" charset="-122"/>
+                <a:cs typeface="Arial" pitchFamily="34" charset="-120"/>
+              </a:rPr>
+              <a:t>12 שיחות עם מי שמחליטים בבוקר</a:t>
+            </a:r>
+            <a:endParaRPr lang="he-IL" sz="3600" dirty="0"/>
+          </a:p>
+        </p:txBody>
+      </p:sp>
+      <p:sp>
+        <p:nvSpPr>
+          <p:cNvPr id="6" name="Shape 4"/>
+          <p:cNvSpPr/>
+          <p:nvPr/>
+        </p:nvSpPr>
+        <p:spPr>
+          <a:xfrm>
+            <a:off x="548640" y="2011680"/>
+            <a:ext cx="2377440" cy="4206240"/>
+          </a:xfrm>
+          <a:prstGeom prst="roundRect">
+            <a:avLst>
+              <a:gd name="adj" fmla="val 4615"/>
+            </a:avLst>
+          </a:prstGeom>
+          <a:solidFill>
+            <a:srgbClr val="12343B"/>
+          </a:solidFill>
+          <a:ln w="12700">
+            <a:solidFill>
+              <a:srgbClr val="12343B"/>
+            </a:solidFill>
+            <a:prstDash val="solid"/>
+          </a:ln>
+        </p:spPr>
+      </p:sp>
+      <p:sp>
+        <p:nvSpPr>
+          <p:cNvPr id="7" name="Text 5"/>
+          <p:cNvSpPr txBox="1"/>
+          <p:nvPr/>
+        </p:nvSpPr>
+        <p:spPr>
+          <a:xfrm>
+            <a:off x="548640" y="3017520"/>
+            <a:ext cx="2377440" cy="1005840"/>
+          </a:xfrm>
+          <a:prstGeom prst="rect">
+            <a:avLst/>
+          </a:prstGeom>
+          <a:noFill/>
+          <a:ln/>
+        </p:spPr>
+        <p:txBody>
+          <a:bodyPr wrap="square" lIns="0" tIns="0" rIns="0" bIns="0" rtlCol="0" anchor="ctr"/>
+          <a:lstStyle/>
+          <a:p>
+            <a:pPr algn="ctr" indent="0" marL="0">
+              <a:buNone/>
+            </a:pPr>
+            <a:r>
+              <a:rPr lang="en-US" sz="6600" b="1" dirty="0">
+                <a:solidFill>
+                  <a:srgbClr val="E9A23B"/>
+                </a:solidFill>
+                <a:latin typeface="Arial" pitchFamily="34" charset="0"/>
+                <a:ea typeface="Arial" pitchFamily="34" charset="-122"/>
+                <a:cs typeface="Arial" pitchFamily="34" charset="-120"/>
+              </a:rPr>
+              <a:t>12</a:t>
+            </a:r>
+            <a:endParaRPr lang="en-US" sz="6600" dirty="0"/>
+          </a:p>
+        </p:txBody>
+      </p:sp>
+      <p:sp>
+        <p:nvSpPr>
+          <p:cNvPr id="8" name="Text 6"/>
+          <p:cNvSpPr txBox="1"/>
+          <p:nvPr/>
+        </p:nvSpPr>
+        <p:spPr>
+          <a:xfrm>
+            <a:off x="731520" y="4114800"/>
+            <a:ext cx="2011680" cy="914400"/>
+          </a:xfrm>
+          <a:prstGeom prst="rect">
+            <a:avLst/>
+          </a:prstGeom>
+          <a:noFill/>
+          <a:ln/>
+        </p:spPr>
+        <p:txBody>
+          <a:bodyPr wrap="square" lIns="0" tIns="0" rIns="0" bIns="0" rtlCol="0" anchor="t"/>
+          <a:lstStyle/>
+          <a:p>
+            <a:pPr algn="ctr" indent="0" marL="0">
+              <a:buNone/>
+            </a:pPr>
+            <a:r>
+              <a:rPr lang="en-US" sz="1600" b="1" dirty="0">
+                <a:solidFill>
+                  <a:srgbClr val="FFFFFF"/>
+                </a:solidFill>
+                <a:latin typeface="Arial" pitchFamily="34" charset="0"/>
+                <a:ea typeface="Arial" pitchFamily="34" charset="-122"/>
+                <a:cs typeface="Arial" pitchFamily="34" charset="-120"/>
+              </a:rPr>
+              <a:t>מנהלים ומנהלות</a:t>
+            </a:r>
+            <a:endParaRPr lang="en-US" sz="1600" dirty="0"/>
+          </a:p>
+          <a:p>
+            <a:pPr algn="ctr" indent="0" marL="0">
+              <a:buNone/>
+            </a:pPr>
+            <a:r>
+              <a:rPr lang="en-US" sz="1400" dirty="0">
+                <a:solidFill>
+                  <a:srgbClr val="A9D2D5"/>
+                </a:solidFill>
+                <a:latin typeface="Arial" pitchFamily="34" charset="0"/>
+                <a:ea typeface="Arial" pitchFamily="34" charset="-122"/>
+                <a:cs typeface="Arial" pitchFamily="34" charset="-120"/>
+              </a:rPr>
+              <a:t>בערים בצפון הארץ</a:t>
+            </a:r>
+            <a:endParaRPr lang="en-US" sz="1600" dirty="0"/>
+          </a:p>
+        </p:txBody>
+      </p:sp>
+      <p:sp>
+        <p:nvSpPr>
+          <p:cNvPr id="9" name="Shape 7"/>
+          <p:cNvSpPr/>
+          <p:nvPr/>
+        </p:nvSpPr>
+        <p:spPr>
+          <a:xfrm>
+            <a:off x="11183112" y="2029968"/>
+            <a:ext cx="457200" cy="457200"/>
+          </a:xfrm>
+          <a:prstGeom prst="ellipse">
+            <a:avLst/>
+          </a:prstGeom>
+          <a:solidFill>
+            <a:srgbClr val="12343B"/>
+          </a:solidFill>
+          <a:ln w="12700">
+            <a:solidFill>
+              <a:srgbClr val="12343B"/>
+            </a:solidFill>
+            <a:prstDash val="solid"/>
+          </a:ln>
+        </p:spPr>
+      </p:sp>
+      <p:pic>
+        <p:nvPicPr>
+          <p:cNvPr id="10" name="Image 0" descr="preencoded.png">    </p:cNvPr>
+          <p:cNvPicPr>
+            <a:picLocks noChangeAspect="1"/>
+          </p:cNvPicPr>
+          <p:nvPr/>
+        </p:nvPicPr>
+        <p:blipFill>
+          <a:blip r:embed="rId1"/>
+          <a:stretch>
+            <a:fillRect/>
+          </a:stretch>
+        </p:blipFill>
+        <p:spPr>
+          <a:xfrm>
+            <a:off x="11297412" y="2144268"/>
+            <a:ext cx="228600" cy="228600"/>
+          </a:xfrm>
+          <a:prstGeom prst="rect">
+            <a:avLst/>
+          </a:prstGeom>
+        </p:spPr>
+      </p:pic>
+      <p:sp>
+        <p:nvSpPr>
+          <p:cNvPr id="11" name="Text 8"/>
+          <p:cNvSpPr txBox="1"/>
+          <p:nvPr/>
+        </p:nvSpPr>
+        <p:spPr>
+          <a:xfrm>
+            <a:off x="3200400" y="2011680"/>
+            <a:ext cx="7754112" cy="1280160"/>
+          </a:xfrm>
+          <a:prstGeom prst="rect">
+            <a:avLst/>
+          </a:prstGeom>
+          <a:noFill/>
+          <a:ln/>
+        </p:spPr>
+        <p:txBody>
+          <a:bodyPr wrap="square" lIns="0" tIns="0" rIns="0" bIns="0" rtlCol="0" anchor="t"/>
+          <a:lstStyle/>
+          <a:p>
+            <a:pPr algn="r" indent="0" marL="0">
+              <a:lnSpc>
+                <a:spcPct val="115000"/>
+              </a:lnSpc>
+              <a:buNone/>
+            </a:pPr>
+            <a:r>
+              <a:rPr lang="he-IL" altLang="en-US" sz="1600" b="1" dirty="0">
+                <a:solidFill>
+                  <a:srgbClr val="12343B"/>
+                </a:solidFill>
+                <a:latin typeface="Arial" pitchFamily="34" charset="0"/>
+                <a:ea typeface="Arial" pitchFamily="34" charset="-122"/>
+                <a:cs typeface="Arial" pitchFamily="34" charset="-120"/>
+              </a:rPr>
+              <a:t>נשוחח עם 12 מנהלים ומנהלות </a:t>
+            </a:r>
+            <a:pPr algn="r" indent="0" marL="0">
+              <a:lnSpc>
+                <a:spcPct val="115000"/>
+              </a:lnSpc>
+              <a:buNone/>
+            </a:pPr>
+            <a:r>
+              <a:rPr lang="he-IL" altLang="en-US" sz="1600" dirty="0">
+                <a:solidFill>
+                  <a:srgbClr val="1B2B2E"/>
+                </a:solidFill>
+                <a:latin typeface="Arial" pitchFamily="34" charset="0"/>
+                <a:ea typeface="Arial" pitchFamily="34" charset="-122"/>
+                <a:cs typeface="Arial" pitchFamily="34" charset="-120"/>
+              </a:rPr>
+              <a:t>של בתי ספר בערים בצפון הארץ, יסודיים ועל־יסודיים ובעלי ותק שונה. בחרנו במנהלים כי הם מקבלי ההחלטות בבוקר ההיעדרות, ובערים כדי לבחון את התופעה בהקשר אחיד ולהשוות בין ערים שונות.</a:t>
+            </a:r>
+            <a:endParaRPr lang="he-IL" sz="1600" dirty="0"/>
+          </a:p>
+        </p:txBody>
+      </p:sp>
+      <p:sp>
+        <p:nvSpPr>
+          <p:cNvPr id="12" name="Shape 9"/>
+          <p:cNvSpPr/>
+          <p:nvPr/>
+        </p:nvSpPr>
+        <p:spPr>
+          <a:xfrm>
+            <a:off x="11183112" y="3493008"/>
+            <a:ext cx="457200" cy="457200"/>
+          </a:xfrm>
+          <a:prstGeom prst="ellipse">
+            <a:avLst/>
+          </a:prstGeom>
+          <a:solidFill>
+            <a:srgbClr val="12343B"/>
+          </a:solidFill>
+          <a:ln w="12700">
+            <a:solidFill>
+              <a:srgbClr val="12343B"/>
+            </a:solidFill>
+            <a:prstDash val="solid"/>
+          </a:ln>
+        </p:spPr>
+      </p:sp>
+      <p:pic>
+        <p:nvPicPr>
+          <p:cNvPr id="13" name="Image 1" descr="preencoded.png">    </p:cNvPr>
+          <p:cNvPicPr>
+            <a:picLocks noChangeAspect="1"/>
+          </p:cNvPicPr>
+          <p:nvPr/>
+        </p:nvPicPr>
+        <p:blipFill>
+          <a:blip r:embed="rId2"/>
+          <a:stretch>
+            <a:fillRect/>
+          </a:stretch>
+        </p:blipFill>
+        <p:spPr>
+          <a:xfrm>
+            <a:off x="11297412" y="3607308"/>
+            <a:ext cx="228600" cy="228600"/>
+          </a:xfrm>
+          <a:prstGeom prst="rect">
+            <a:avLst/>
+          </a:prstGeom>
+        </p:spPr>
+      </p:pic>
+      <p:sp>
+        <p:nvSpPr>
+          <p:cNvPr id="14" name="Text 10"/>
+          <p:cNvSpPr txBox="1"/>
+          <p:nvPr/>
+        </p:nvSpPr>
+        <p:spPr>
+          <a:xfrm>
+            <a:off x="3200400" y="3474720"/>
+            <a:ext cx="7754112" cy="1280160"/>
+          </a:xfrm>
+          <a:prstGeom prst="rect">
+            <a:avLst/>
+          </a:prstGeom>
+          <a:noFill/>
+          <a:ln/>
+        </p:spPr>
+        <p:txBody>
+          <a:bodyPr wrap="square" lIns="0" tIns="0" rIns="0" bIns="0" rtlCol="0" anchor="t"/>
+          <a:lstStyle/>
+          <a:p>
+            <a:pPr algn="r" indent="0" marL="0">
+              <a:lnSpc>
+                <a:spcPct val="115000"/>
+              </a:lnSpc>
+              <a:buNone/>
+            </a:pPr>
+            <a:r>
+              <a:rPr lang="he-IL" altLang="en-US" sz="1600" b="1" dirty="0">
+                <a:solidFill>
+                  <a:srgbClr val="12343B"/>
+                </a:solidFill>
+                <a:latin typeface="Arial" pitchFamily="34" charset="0"/>
+                <a:ea typeface="Arial" pitchFamily="34" charset="-122"/>
+                <a:cs typeface="Arial" pitchFamily="34" charset="-120"/>
+              </a:rPr>
+              <a:t>בניתוח תמטי של הראיונות </a:t>
+            </a:r>
+            <a:pPr algn="r" indent="0" marL="0">
+              <a:lnSpc>
+                <a:spcPct val="115000"/>
+              </a:lnSpc>
+              <a:buNone/>
+            </a:pPr>
+            <a:r>
+              <a:rPr lang="he-IL" altLang="en-US" sz="1600" dirty="0">
+                <a:solidFill>
+                  <a:srgbClr val="1B2B2E"/>
+                </a:solidFill>
+                <a:latin typeface="Arial" pitchFamily="34" charset="0"/>
+                <a:ea typeface="Arial" pitchFamily="34" charset="-122"/>
+                <a:cs typeface="Arial" pitchFamily="34" charset="-120"/>
+              </a:rPr>
+              <a:t>נחפש אסטרטגיות מונעות לעומת מגיבות, הבדלים בין היעדרות קצרה לממושכת, ואת האיזון בין פדגוגיה, תקציב, הוגנות כלפי הצוות שמחליף ורווחת המורה הנעדרת.</a:t>
+            </a:r>
+            <a:endParaRPr lang="he-IL" sz="1600" dirty="0"/>
+          </a:p>
+        </p:txBody>
+      </p:sp>
+      <p:sp>
+        <p:nvSpPr>
+          <p:cNvPr id="15" name="Shape 11"/>
+          <p:cNvSpPr/>
+          <p:nvPr/>
+        </p:nvSpPr>
+        <p:spPr>
+          <a:xfrm>
+            <a:off x="11183112" y="4956048"/>
+            <a:ext cx="457200" cy="457200"/>
+          </a:xfrm>
+          <a:prstGeom prst="ellipse">
+            <a:avLst/>
+          </a:prstGeom>
+          <a:solidFill>
+            <a:srgbClr val="12343B"/>
+          </a:solidFill>
+          <a:ln w="12700">
+            <a:solidFill>
+              <a:srgbClr val="12343B"/>
+            </a:solidFill>
+            <a:prstDash val="solid"/>
+          </a:ln>
+        </p:spPr>
+      </p:sp>
+      <p:pic>
+        <p:nvPicPr>
+          <p:cNvPr id="16" name="Image 2" descr="preencoded.png">    </p:cNvPr>
+          <p:cNvPicPr>
+            <a:picLocks noChangeAspect="1"/>
+          </p:cNvPicPr>
+          <p:nvPr/>
+        </p:nvPicPr>
+        <p:blipFill>
+          <a:blip r:embed="rId3"/>
+          <a:stretch>
+            <a:fillRect/>
+          </a:stretch>
+        </p:blipFill>
+        <p:spPr>
+          <a:xfrm>
+            <a:off x="11297412" y="5070348"/>
+            <a:ext cx="228600" cy="228600"/>
+          </a:xfrm>
+          <a:prstGeom prst="rect">
+            <a:avLst/>
+          </a:prstGeom>
+        </p:spPr>
+      </p:pic>
+      <p:sp>
+        <p:nvSpPr>
+          <p:cNvPr id="17" name="Text 12"/>
+          <p:cNvSpPr txBox="1"/>
+          <p:nvPr/>
+        </p:nvSpPr>
+        <p:spPr>
+          <a:xfrm>
+            <a:off x="3200400" y="4937760"/>
+            <a:ext cx="7754112" cy="1280160"/>
+          </a:xfrm>
+          <a:prstGeom prst="rect">
+            <a:avLst/>
+          </a:prstGeom>
+          <a:noFill/>
+          <a:ln/>
+        </p:spPr>
+        <p:txBody>
+          <a:bodyPr wrap="square" lIns="0" tIns="0" rIns="0" bIns="0" rtlCol="0" anchor="t"/>
+          <a:lstStyle/>
+          <a:p>
+            <a:pPr algn="r" indent="0" marL="0">
+              <a:lnSpc>
+                <a:spcPct val="115000"/>
+              </a:lnSpc>
+              <a:buNone/>
+            </a:pPr>
+            <a:r>
+              <a:rPr lang="he-IL" altLang="en-US" sz="1600" b="1" dirty="0">
+                <a:solidFill>
+                  <a:srgbClr val="12343B"/>
+                </a:solidFill>
+                <a:latin typeface="Arial" pitchFamily="34" charset="0"/>
+                <a:ea typeface="Arial" pitchFamily="34" charset="-122"/>
+                <a:cs typeface="Arial" pitchFamily="34" charset="-120"/>
+              </a:rPr>
+              <a:t>האתגר המרכזי </a:t>
+            </a:r>
+            <a:pPr algn="r" indent="0" marL="0">
+              <a:lnSpc>
+                <a:spcPct val="115000"/>
+              </a:lnSpc>
+              <a:buNone/>
+            </a:pPr>
+            <a:r>
+              <a:rPr lang="he-IL" altLang="en-US" sz="1600" dirty="0">
+                <a:solidFill>
+                  <a:srgbClr val="1B2B2E"/>
+                </a:solidFill>
+                <a:latin typeface="Arial" pitchFamily="34" charset="0"/>
+                <a:ea typeface="Arial" pitchFamily="34" charset="-122"/>
+                <a:cs typeface="Arial" pitchFamily="34" charset="-120"/>
+              </a:rPr>
+              <a:t>הוא שמנהלים עלולים להציג תמונה יפה מהמציאות, ולכן נבקש דוגמאות מוחשיות. ממצא שיפתיע אותנו: שמה שמנחה את ההחלטה בפועל הוא השקט והסדר ולא הרצף הלימודי.</a:t>
+            </a:r>
+            <a:endParaRPr lang="he-IL" sz="1600" dirty="0"/>
+          </a:p>
+        </p:txBody>
+      </p:sp>
+    </p:spTree>
+  </p:cSld>
+  <p:clrMapOvr>
+    <a:masterClrMapping/>
+  </p:clrMapOvr>
+</p:sld>
+</file>
+
+<file path=ppt/slides/slide5.xml><?xml version="1.0" encoding="utf-8"?>
+<p:sld xmlns:a="http://schemas.openxmlformats.org/drawingml/2006/main" xmlns:r="http://schemas.openxmlformats.org/officeDocument/2006/relationships" xmlns:p="http://schemas.openxmlformats.org/presentationml/2006/main">
+  <p:cSld name="Slide 5">
+    <p:bg>
+      <p:bgPr>
+        <a:solidFill>
+          <a:srgbClr val="FFFFFF"/>
+        </a:solidFill>
+      </p:bgPr>
+    </p:bg>
+    <p:spTree>
+      <p:nvGrpSpPr>
+        <p:cNvPr id="1" name=""/>
+        <p:cNvGrpSpPr/>
+        <p:nvPr/>
+      </p:nvGrpSpPr>
+      <p:grpSpPr>
+        <a:xfrm>
+          <a:off x="0" y="0"/>
+          <a:ext cx="0" cy="0"/>
+          <a:chOff x="0" y="0"/>
+          <a:chExt cx="0" cy="0"/>
+        </a:xfrm>
+      </p:grpSpPr>
+      <p:sp>
+        <p:nvSpPr>
+          <p:cNvPr id="2" name="Shape 0"/>
+          <p:cNvSpPr/>
+          <p:nvPr/>
+        </p:nvSpPr>
+        <p:spPr>
+          <a:xfrm>
+            <a:off x="11091672" y="411480"/>
+            <a:ext cx="548640" cy="548640"/>
+          </a:xfrm>
+          <a:prstGeom prst="ellipse">
+            <a:avLst/>
+          </a:prstGeom>
+          <a:solidFill>
+            <a:srgbClr val="E9A23B"/>
+          </a:solidFill>
+          <a:ln w="12700">
+            <a:solidFill>
+              <a:srgbClr val="E9A23B"/>
+            </a:solidFill>
+            <a:prstDash val="solid"/>
+          </a:ln>
+        </p:spPr>
+      </p:sp>
+      <p:sp>
+        <p:nvSpPr>
+          <p:cNvPr id="3" name="Text 1"/>
+          <p:cNvSpPr txBox="1"/>
+          <p:nvPr/>
+        </p:nvSpPr>
+        <p:spPr>
+          <a:xfrm>
+            <a:off x="11091672" y="411480"/>
+            <a:ext cx="548640" cy="548640"/>
+          </a:xfrm>
+          <a:prstGeom prst="rect">
+            <a:avLst/>
+          </a:prstGeom>
+          <a:noFill/>
+          <a:ln/>
+        </p:spPr>
+        <p:txBody>
+          <a:bodyPr wrap="square" lIns="0" tIns="0" rIns="0" bIns="0" rtlCol="0" anchor="ctr"/>
+          <a:lstStyle/>
+          <a:p>
+            <a:pPr algn="ctr" indent="0" marL="0">
+              <a:buNone/>
+            </a:pPr>
+            <a:r>
+              <a:rPr lang="en-US" sz="2000" b="1" dirty="0">
+                <a:solidFill>
+                  <a:srgbClr val="12343B"/>
+                </a:solidFill>
+                <a:latin typeface="Arial" pitchFamily="34" charset="0"/>
+                <a:ea typeface="Arial" pitchFamily="34" charset="-122"/>
+                <a:cs typeface="Arial" pitchFamily="34" charset="-120"/>
+              </a:rPr>
+              <a:t>5</a:t>
+            </a:r>
+            <a:endParaRPr lang="en-US" sz="2000" dirty="0"/>
+          </a:p>
+        </p:txBody>
+      </p:sp>
+      <p:sp>
+        <p:nvSpPr>
+          <p:cNvPr id="4" name="Text 2"/>
+          <p:cNvSpPr txBox="1"/>
+          <p:nvPr/>
+        </p:nvSpPr>
+        <p:spPr>
+          <a:xfrm>
+            <a:off x="5943600" y="502920"/>
+            <a:ext cx="4983480" cy="365760"/>
+          </a:xfrm>
+          <a:prstGeom prst="rect">
+            <a:avLst/>
+          </a:prstGeom>
+          <a:noFill/>
+          <a:ln/>
+        </p:spPr>
+        <p:txBody>
+          <a:bodyPr wrap="square" lIns="0" tIns="0" rIns="0" bIns="0" rtlCol="0" anchor="ctr"/>
+          <a:lstStyle/>
+          <a:p>
+            <a:pPr rtl="1" algn="r" indent="0" marL="0">
+              <a:buNone/>
+            </a:pPr>
+            <a:r>
+              <a:rPr lang="he-IL" altLang="en-US" sz="1300" b="1" dirty="0">
+                <a:solidFill>
+                  <a:srgbClr val="4F6A6E"/>
+                </a:solidFill>
+                <a:latin typeface="Arial" pitchFamily="34" charset="0"/>
+                <a:ea typeface="Arial" pitchFamily="34" charset="-122"/>
+                <a:cs typeface="Arial" pitchFamily="34" charset="-120"/>
+              </a:rPr>
+              <a:t>איך ייראה הראיון</a:t>
+            </a:r>
+            <a:endParaRPr lang="he-IL" sz="1300" dirty="0"/>
+          </a:p>
+        </p:txBody>
+      </p:sp>
+      <p:sp>
+        <p:nvSpPr>
+          <p:cNvPr id="5" name="Text 3"/>
+          <p:cNvSpPr txBox="1"/>
+          <p:nvPr/>
+        </p:nvSpPr>
+        <p:spPr>
+          <a:xfrm>
+            <a:off x="548640" y="1051560"/>
+            <a:ext cx="11091672" cy="685800"/>
+          </a:xfrm>
+          <a:prstGeom prst="rect">
+            <a:avLst/>
+          </a:prstGeom>
+          <a:noFill/>
+          <a:ln/>
+        </p:spPr>
+        <p:txBody>
+          <a:bodyPr wrap="square" lIns="0" tIns="0" rIns="0" bIns="0" rtlCol="0" anchor="ctr"/>
+          <a:lstStyle/>
+          <a:p>
+            <a:pPr rtl="1" algn="r" indent="0" marL="0">
+              <a:buNone/>
+            </a:pPr>
+            <a:r>
+              <a:rPr lang="he-IL" altLang="en-US" sz="3200" b="1" dirty="0">
+                <a:solidFill>
+                  <a:srgbClr val="12343B"/>
+                </a:solidFill>
+                <a:latin typeface="Arial" pitchFamily="34" charset="0"/>
+                <a:ea typeface="Arial" pitchFamily="34" charset="-122"/>
+                <a:cs typeface="Arial" pitchFamily="34" charset="-120"/>
+              </a:rPr>
+              <a:t>"ספר/י לי על הבוקר האחרון שבו מורה לא הגיע"</a:t>
+            </a:r>
+            <a:endParaRPr lang="he-IL" sz="3200" dirty="0"/>
+          </a:p>
+        </p:txBody>
+      </p:sp>
+      <p:sp>
+        <p:nvSpPr>
+          <p:cNvPr id="6" name="Shape 4"/>
+          <p:cNvSpPr/>
+          <p:nvPr/>
+        </p:nvSpPr>
+        <p:spPr>
+          <a:xfrm>
+            <a:off x="11183112" y="2029968"/>
+            <a:ext cx="457200" cy="457200"/>
+          </a:xfrm>
+          <a:prstGeom prst="ellipse">
+            <a:avLst/>
+          </a:prstGeom>
+          <a:solidFill>
+            <a:srgbClr val="12343B"/>
+          </a:solidFill>
+          <a:ln w="12700">
+            <a:solidFill>
+              <a:srgbClr val="12343B"/>
+            </a:solidFill>
+            <a:prstDash val="solid"/>
+          </a:ln>
+        </p:spPr>
+      </p:sp>
+      <p:pic>
+        <p:nvPicPr>
+          <p:cNvPr id="7" name="Image 0" descr="preencoded.png">    </p:cNvPr>
+          <p:cNvPicPr>
+            <a:picLocks noChangeAspect="1"/>
+          </p:cNvPicPr>
+          <p:nvPr/>
+        </p:nvPicPr>
+        <p:blipFill>
+          <a:blip r:embed="rId1"/>
+          <a:stretch>
+            <a:fillRect/>
+          </a:stretch>
+        </p:blipFill>
+        <p:spPr>
+          <a:xfrm>
+            <a:off x="11297412" y="2144268"/>
+            <a:ext cx="228600" cy="228600"/>
+          </a:xfrm>
+          <a:prstGeom prst="rect">
+            <a:avLst/>
+          </a:prstGeom>
+        </p:spPr>
+      </p:pic>
+      <p:sp>
+        <p:nvSpPr>
+          <p:cNvPr id="8" name="Text 5"/>
+          <p:cNvSpPr txBox="1"/>
+          <p:nvPr/>
+        </p:nvSpPr>
+        <p:spPr>
+          <a:xfrm>
+            <a:off x="548640" y="2011680"/>
+            <a:ext cx="10405872" cy="868680"/>
+          </a:xfrm>
+          <a:prstGeom prst="rect">
+            <a:avLst/>
+          </a:prstGeom>
+          <a:noFill/>
+          <a:ln/>
+        </p:spPr>
+        <p:txBody>
+          <a:bodyPr wrap="square" lIns="0" tIns="0" rIns="0" bIns="0" rtlCol="0" anchor="t"/>
+          <a:lstStyle/>
+          <a:p>
+            <a:pPr algn="r" indent="0" marL="0">
+              <a:lnSpc>
+                <a:spcPct val="115000"/>
+              </a:lnSpc>
+              <a:buNone/>
+            </a:pPr>
+            <a:r>
+              <a:rPr lang="he-IL" altLang="en-US" sz="1600" b="1" dirty="0">
+                <a:solidFill>
+                  <a:srgbClr val="12343B"/>
+                </a:solidFill>
+                <a:latin typeface="Arial" pitchFamily="34" charset="0"/>
+                <a:ea typeface="Arial" pitchFamily="34" charset="-122"/>
+                <a:cs typeface="Arial" pitchFamily="34" charset="-120"/>
+              </a:rPr>
+              <a:t>נפתח בשאלות רקע </a:t>
+            </a:r>
+            <a:pPr algn="r" indent="0" marL="0">
+              <a:lnSpc>
+                <a:spcPct val="115000"/>
+              </a:lnSpc>
+              <a:buNone/>
+            </a:pPr>
+            <a:r>
+              <a:rPr lang="he-IL" altLang="en-US" sz="1600" dirty="0">
+                <a:solidFill>
+                  <a:srgbClr val="1B2B2E"/>
+                </a:solidFill>
+                <a:latin typeface="Arial" pitchFamily="34" charset="0"/>
+                <a:ea typeface="Arial" pitchFamily="34" charset="-122"/>
+                <a:cs typeface="Arial" pitchFamily="34" charset="-120"/>
+              </a:rPr>
+              <a:t>על בית הספר, על הצוות ועל הדרך של המנהל לתפקיד, כדי ליצור אמון ולהבין את ההקשר שבו מתקבלות ההחלטות.</a:t>
+            </a:r>
+            <a:endParaRPr lang="he-IL" sz="1600" dirty="0"/>
+          </a:p>
+        </p:txBody>
+      </p:sp>
+      <p:sp>
+        <p:nvSpPr>
+          <p:cNvPr id="9" name="Shape 6"/>
+          <p:cNvSpPr/>
+          <p:nvPr/>
+        </p:nvSpPr>
+        <p:spPr>
+          <a:xfrm>
+            <a:off x="11183112" y="2944368"/>
+            <a:ext cx="457200" cy="457200"/>
+          </a:xfrm>
+          <a:prstGeom prst="ellipse">
+            <a:avLst/>
+          </a:prstGeom>
+          <a:solidFill>
+            <a:srgbClr val="12343B"/>
+          </a:solidFill>
+          <a:ln w="12700">
+            <a:solidFill>
+              <a:srgbClr val="12343B"/>
+            </a:solidFill>
+            <a:prstDash val="solid"/>
+          </a:ln>
+        </p:spPr>
+      </p:sp>
+      <p:pic>
+        <p:nvPicPr>
+          <p:cNvPr id="10" name="Image 1" descr="preencoded.png">    </p:cNvPr>
+          <p:cNvPicPr>
+            <a:picLocks noChangeAspect="1"/>
+          </p:cNvPicPr>
+          <p:nvPr/>
+        </p:nvPicPr>
+        <p:blipFill>
+          <a:blip r:embed="rId2"/>
+          <a:stretch>
+            <a:fillRect/>
+          </a:stretch>
+        </p:blipFill>
+        <p:spPr>
+          <a:xfrm>
+            <a:off x="11297412" y="3058668"/>
+            <a:ext cx="228600" cy="228600"/>
+          </a:xfrm>
+          <a:prstGeom prst="rect">
+            <a:avLst/>
+          </a:prstGeom>
+        </p:spPr>
+      </p:pic>
+      <p:sp>
+        <p:nvSpPr>
+          <p:cNvPr id="11" name="Text 7"/>
+          <p:cNvSpPr txBox="1"/>
+          <p:nvPr/>
+        </p:nvSpPr>
+        <p:spPr>
+          <a:xfrm>
+            <a:off x="548640" y="2926080"/>
+            <a:ext cx="10405872" cy="1234440"/>
+          </a:xfrm>
+          <a:prstGeom prst="rect">
+            <a:avLst/>
+          </a:prstGeom>
+          <a:noFill/>
+          <a:ln/>
+        </p:spPr>
+        <p:txBody>
+          <a:bodyPr wrap="square" lIns="0" tIns="0" rIns="0" bIns="0" rtlCol="0" anchor="t"/>
+          <a:lstStyle/>
+          <a:p>
+            <a:pPr algn="r" indent="0" marL="0">
+              <a:lnSpc>
+                <a:spcPct val="115000"/>
+              </a:lnSpc>
+              <a:buNone/>
+            </a:pPr>
+            <a:r>
+              <a:rPr lang="he-IL" altLang="en-US" sz="1600" b="1" dirty="0">
+                <a:solidFill>
+                  <a:srgbClr val="12343B"/>
+                </a:solidFill>
+                <a:latin typeface="Arial" pitchFamily="34" charset="0"/>
+                <a:ea typeface="Arial" pitchFamily="34" charset="-122"/>
+                <a:cs typeface="Arial" pitchFamily="34" charset="-120"/>
+              </a:rPr>
+              <a:t>בלב הראיון נבקש סיפור מוחשי: </a:t>
+            </a:r>
+            <a:pPr algn="r" indent="0" marL="0">
+              <a:lnSpc>
+                <a:spcPct val="115000"/>
+              </a:lnSpc>
+              <a:buNone/>
+            </a:pPr>
+            <a:r>
+              <a:rPr lang="he-IL" altLang="en-US" sz="1600" dirty="0">
+                <a:solidFill>
+                  <a:srgbClr val="1B2B2E"/>
+                </a:solidFill>
+                <a:latin typeface="Arial" pitchFamily="34" charset="0"/>
+                <a:ea typeface="Arial" pitchFamily="34" charset="-122"/>
+                <a:cs typeface="Arial" pitchFamily="34" charset="-120"/>
+              </a:rPr>
+              <a:t>מה עשית באותו בוקר, צעד אחר צעד? מה היה שונה כשההיעדרות נמשכה כמה שבועות? במה התחשבת כשהחלטת מי יחליף? כך נשמע את השיקולים ואת הדילמות, ולא רק את הנוהל הכתוב.</a:t>
+            </a:r>
+            <a:endParaRPr lang="he-IL" sz="1600" dirty="0"/>
+          </a:p>
+        </p:txBody>
+      </p:sp>
+      <p:sp>
+        <p:nvSpPr>
+          <p:cNvPr id="12" name="Shape 8"/>
+          <p:cNvSpPr/>
+          <p:nvPr/>
+        </p:nvSpPr>
+        <p:spPr>
+          <a:xfrm>
+            <a:off x="11183112" y="3950208"/>
+            <a:ext cx="457200" cy="457200"/>
+          </a:xfrm>
+          <a:prstGeom prst="ellipse">
+            <a:avLst/>
+          </a:prstGeom>
+          <a:solidFill>
+            <a:srgbClr val="12343B"/>
+          </a:solidFill>
+          <a:ln w="12700">
+            <a:solidFill>
+              <a:srgbClr val="12343B"/>
+            </a:solidFill>
+            <a:prstDash val="solid"/>
+          </a:ln>
+        </p:spPr>
+      </p:sp>
+      <p:pic>
+        <p:nvPicPr>
+          <p:cNvPr id="13" name="Image 2" descr="preencoded.png">    </p:cNvPr>
+          <p:cNvPicPr>
+            <a:picLocks noChangeAspect="1"/>
+          </p:cNvPicPr>
+          <p:nvPr/>
+        </p:nvPicPr>
+        <p:blipFill>
+          <a:blip r:embed="rId3"/>
+          <a:stretch>
+            <a:fillRect/>
+          </a:stretch>
+        </p:blipFill>
+        <p:spPr>
+          <a:xfrm>
+            <a:off x="11297412" y="4064508"/>
+            <a:ext cx="228600" cy="228600"/>
+          </a:xfrm>
+          <a:prstGeom prst="rect">
+            <a:avLst/>
+          </a:prstGeom>
+        </p:spPr>
+      </p:pic>
+      <p:sp>
+        <p:nvSpPr>
+          <p:cNvPr id="14" name="Text 9"/>
+          <p:cNvSpPr txBox="1"/>
+          <p:nvPr/>
+        </p:nvSpPr>
+        <p:spPr>
+          <a:xfrm>
+            <a:off x="548640" y="3931920"/>
+            <a:ext cx="10405872" cy="868680"/>
+          </a:xfrm>
+          <a:prstGeom prst="rect">
+            <a:avLst/>
+          </a:prstGeom>
+          <a:noFill/>
+          <a:ln/>
+        </p:spPr>
+        <p:txBody>
+          <a:bodyPr wrap="square" lIns="0" tIns="0" rIns="0" bIns="0" rtlCol="0" anchor="t"/>
+          <a:lstStyle/>
+          <a:p>
+            <a:pPr algn="r" indent="0" marL="0">
+              <a:lnSpc>
+                <a:spcPct val="115000"/>
+              </a:lnSpc>
+              <a:buNone/>
+            </a:pPr>
+            <a:r>
+              <a:rPr lang="he-IL" altLang="en-US" sz="1600" b="1" dirty="0">
+                <a:solidFill>
+                  <a:srgbClr val="12343B"/>
+                </a:solidFill>
+                <a:latin typeface="Arial" pitchFamily="34" charset="0"/>
+                <a:ea typeface="Arial" pitchFamily="34" charset="-122"/>
+                <a:cs typeface="Arial" pitchFamily="34" charset="-120"/>
+              </a:rPr>
+              <a:t>נקפיד על אתיקה: </a:t>
+            </a:r>
+            <a:pPr algn="r" indent="0" marL="0">
+              <a:lnSpc>
+                <a:spcPct val="115000"/>
+              </a:lnSpc>
+              <a:buNone/>
+            </a:pPr>
+            <a:r>
+              <a:rPr lang="he-IL" altLang="en-US" sz="1600" dirty="0">
+                <a:solidFill>
+                  <a:srgbClr val="1B2B2E"/>
+                </a:solidFill>
+                <a:latin typeface="Arial" pitchFamily="34" charset="0"/>
+                <a:ea typeface="Arial" pitchFamily="34" charset="-122"/>
+                <a:cs typeface="Arial" pitchFamily="34" charset="-120"/>
+              </a:rPr>
+              <a:t>הסכמה מדעת, הקלטה רק באישור, ושמירה על אנונימיות, כך ששמות המנהלים, בתי הספר והערים לא יופיעו בעבודה.</a:t>
+            </a:r>
+            <a:endParaRPr lang="he-IL" sz="1600" dirty="0"/>
+          </a:p>
+        </p:txBody>
+      </p:sp>
+      <p:sp>
+        <p:nvSpPr>
+          <p:cNvPr id="15" name="Shape 10"/>
+          <p:cNvSpPr/>
+          <p:nvPr/>
+        </p:nvSpPr>
+        <p:spPr>
+          <a:xfrm>
+            <a:off x="548640" y="5257800"/>
+            <a:ext cx="11091672" cy="1051560"/>
+          </a:xfrm>
+          <a:prstGeom prst="roundRect">
+            <a:avLst>
+              <a:gd name="adj" fmla="val 10435"/>
+            </a:avLst>
+          </a:prstGeom>
+          <a:solidFill>
+            <a:srgbClr val="12343B"/>
+          </a:solidFill>
+          <a:ln w="12700">
+            <a:solidFill>
+              <a:srgbClr val="12343B"/>
+            </a:solidFill>
+            <a:prstDash val="solid"/>
+          </a:ln>
+        </p:spPr>
+      </p:sp>
+      <p:sp>
+        <p:nvSpPr>
+          <p:cNvPr id="16" name="Text 11"/>
+          <p:cNvSpPr txBox="1"/>
+          <p:nvPr/>
+        </p:nvSpPr>
+        <p:spPr>
+          <a:xfrm>
+            <a:off x="868680" y="5349240"/>
+            <a:ext cx="10451592" cy="868680"/>
           </a:xfrm>
           <a:prstGeom prst="rect">
             <a:avLst/>

</xml_diff>

<commit_message>
Force RTL paragraph direction on all Hebrew text
pptxgenjs only set rtl on some paragraphs, so punctuation landed on
the wrong side in PowerPoint. Post-process slides and notes to mark
every Hebrew paragraph rtl="1".

Co-Authored-By: Claude Opus 5.5 <noreply@anthropic.com>
Claude-Session: https://claude.ai/code/session_016buQrLRQHjtd4YGfeSnksc
</commit_message>
<xml_diff>
--- a/presentation/היעדרויות-מורים-מצגת-סיום.pptx
+++ b/presentation/היעדרויות-מורים-מצגת-סיום.pptx
@@ -504,6 +504,7 @@
           <a:bodyPr/>
           <a:lstStyle/>
           <a:p>
+            <a:pPr rtl="1"/>
             <a:r>
               <a:rPr lang="en-US" dirty="0"/>
               <a:t>[חנון | כדקה]
@@ -598,6 +599,7 @@
           <a:bodyPr/>
           <a:lstStyle/>
           <a:p>
+            <a:pPr rtl="1"/>
             <a:r>
               <a:rPr lang="en-US" dirty="0"/>
               <a:t>[אולפת | כדקה ורבע]
@@ -691,6 +693,7 @@
           <a:bodyPr/>
           <a:lstStyle/>
           <a:p>
+            <a:pPr rtl="1"/>
             <a:r>
               <a:rPr lang="en-US" dirty="0"/>
               <a:t>[חנון | כחמישים שניות]
@@ -784,6 +787,7 @@
           <a:bodyPr/>
           <a:lstStyle/>
           <a:p>
+            <a:pPr rtl="1"/>
             <a:r>
               <a:rPr lang="en-US" dirty="0"/>
               <a:t>[אולפת | כדקה]
@@ -877,6 +881,7 @@
           <a:bodyPr/>
           <a:lstStyle/>
           <a:p>
+            <a:pPr rtl="1"/>
             <a:r>
               <a:rPr lang="en-US" dirty="0"/>
               <a:t>[חנון | כארבעים שניות]
@@ -1346,7 +1351,7 @@
           <a:bodyPr wrap="square" lIns="0" tIns="0" rIns="0" bIns="0" rtlCol="0" anchor="ctr"/>
           <a:lstStyle/>
           <a:p>
-            <a:pPr rtl="1" algn="r" indent="0" marL="0">
+            <a:pPr algn="r" indent="0" marL="0" rtl="1">
               <a:buNone/>
             </a:pPr>
             <a:r>
@@ -1385,7 +1390,7 @@
           <a:bodyPr wrap="square" lIns="0" tIns="0" rIns="0" bIns="0" rtlCol="0" anchor="ctr"/>
           <a:lstStyle/>
           <a:p>
-            <a:pPr rtl="1" algn="l" indent="0" marL="0">
+            <a:pPr algn="l" indent="0" marL="0" rtl="1">
               <a:buNone/>
             </a:pPr>
             <a:r>
@@ -1424,7 +1429,7 @@
           <a:bodyPr wrap="square" lIns="0" tIns="0" rIns="0" bIns="0" rtlCol="0" anchor="ctr"/>
           <a:lstStyle/>
           <a:p>
-            <a:pPr rtl="1" algn="r" indent="0" marL="0">
+            <a:pPr algn="r" indent="0" marL="0" rtl="1">
               <a:buNone/>
             </a:pPr>
             <a:r>
@@ -1512,7 +1517,7 @@
           <a:bodyPr wrap="square" lIns="0" tIns="0" rIns="0" bIns="0" rtlCol="0" anchor="t"/>
           <a:lstStyle/>
           <a:p>
-            <a:pPr algn="r" indent="0" marL="0">
+            <a:pPr algn="r" indent="0" marL="0" rtl="1">
               <a:lnSpc>
                 <a:spcPct val="115000"/>
               </a:lnSpc>
@@ -1620,7 +1625,7 @@
           <a:bodyPr wrap="square" lIns="0" tIns="0" rIns="0" bIns="0" rtlCol="0" anchor="t"/>
           <a:lstStyle/>
           <a:p>
-            <a:pPr algn="r" indent="0" marL="0">
+            <a:pPr algn="r" indent="0" marL="0" rtl="1">
               <a:lnSpc>
                 <a:spcPct val="115000"/>
               </a:lnSpc>
@@ -1728,7 +1733,7 @@
           <a:bodyPr wrap="square" lIns="0" tIns="0" rIns="0" bIns="0" rtlCol="0" anchor="t"/>
           <a:lstStyle/>
           <a:p>
-            <a:pPr algn="r" indent="0" marL="0">
+            <a:pPr algn="r" indent="0" marL="0" rtl="1">
               <a:lnSpc>
                 <a:spcPct val="115000"/>
               </a:lnSpc>
@@ -1883,7 +1888,7 @@
           <a:bodyPr wrap="square" lIns="0" tIns="0" rIns="0" bIns="0" rtlCol="0" anchor="ctr"/>
           <a:lstStyle/>
           <a:p>
-            <a:pPr rtl="1" algn="r" indent="0" marL="0">
+            <a:pPr algn="r" indent="0" marL="0" rtl="1">
               <a:buNone/>
             </a:pPr>
             <a:r>
@@ -1922,7 +1927,7 @@
           <a:bodyPr wrap="square" lIns="0" tIns="0" rIns="0" bIns="0" rtlCol="0" anchor="ctr"/>
           <a:lstStyle/>
           <a:p>
-            <a:pPr rtl="1" algn="r" indent="0" marL="0">
+            <a:pPr algn="r" indent="0" marL="0" rtl="1">
               <a:buNone/>
             </a:pPr>
             <a:r>
@@ -2010,7 +2015,7 @@
           <a:bodyPr wrap="square" lIns="0" tIns="0" rIns="0" bIns="0" rtlCol="0" anchor="t"/>
           <a:lstStyle/>
           <a:p>
-            <a:pPr algn="r" indent="0" marL="0">
+            <a:pPr algn="r" indent="0" marL="0" rtl="1">
               <a:lnSpc>
                 <a:spcPct val="115000"/>
               </a:lnSpc>
@@ -2157,7 +2162,7 @@
           <a:bodyPr wrap="square" lIns="0" tIns="0" rIns="0" bIns="0" rtlCol="0" anchor="t"/>
           <a:lstStyle/>
           <a:p>
-            <a:pPr algn="r" indent="0" marL="0">
+            <a:pPr algn="r" indent="0" marL="0" rtl="1">
               <a:lnSpc>
                 <a:spcPct val="115000"/>
               </a:lnSpc>
@@ -2292,7 +2297,7 @@
           <a:bodyPr wrap="square" lIns="0" tIns="0" rIns="0" bIns="0" rtlCol="0" anchor="t"/>
           <a:lstStyle/>
           <a:p>
-            <a:pPr algn="r" indent="0" marL="0">
+            <a:pPr algn="r" indent="0" marL="0" rtl="1">
               <a:lnSpc>
                 <a:spcPct val="115000"/>
               </a:lnSpc>
@@ -2447,7 +2452,7 @@
           <a:bodyPr wrap="square" lIns="0" tIns="0" rIns="0" bIns="0" rtlCol="0" anchor="ctr"/>
           <a:lstStyle/>
           <a:p>
-            <a:pPr rtl="1" algn="r" indent="0" marL="0">
+            <a:pPr algn="r" indent="0" marL="0" rtl="1">
               <a:buNone/>
             </a:pPr>
             <a:r>
@@ -2486,7 +2491,7 @@
           <a:bodyPr wrap="square" lIns="0" tIns="0" rIns="0" bIns="0" rtlCol="0" anchor="ctr"/>
           <a:lstStyle/>
           <a:p>
-            <a:pPr rtl="1" algn="r" indent="0" marL="0">
+            <a:pPr algn="r" indent="0" marL="0" rtl="1">
               <a:buNone/>
             </a:pPr>
             <a:r>
@@ -2601,7 +2606,7 @@
           <a:bodyPr wrap="square" lIns="0" tIns="0" rIns="0" bIns="0" rtlCol="0" anchor="ctr"/>
           <a:lstStyle/>
           <a:p>
-            <a:pPr rtl="1" algn="ctr" indent="0" marL="0">
+            <a:pPr algn="ctr" indent="0" marL="0" rtl="1">
               <a:buNone/>
             </a:pPr>
             <a:r>
@@ -2765,7 +2770,7 @@
           <a:bodyPr wrap="square" lIns="0" tIns="0" rIns="0" bIns="0" rtlCol="0" anchor="ctr"/>
           <a:lstStyle/>
           <a:p>
-            <a:pPr rtl="1" algn="ctr" indent="0" marL="0">
+            <a:pPr algn="ctr" indent="0" marL="0" rtl="1">
               <a:buNone/>
             </a:pPr>
             <a:r>
@@ -2929,7 +2934,7 @@
           <a:bodyPr wrap="square" lIns="0" tIns="0" rIns="0" bIns="0" rtlCol="0" anchor="ctr"/>
           <a:lstStyle/>
           <a:p>
-            <a:pPr rtl="1" algn="ctr" indent="0" marL="0">
+            <a:pPr algn="ctr" indent="0" marL="0" rtl="1">
               <a:buNone/>
             </a:pPr>
             <a:r>
@@ -3093,7 +3098,7 @@
           <a:bodyPr wrap="square" lIns="0" tIns="0" rIns="0" bIns="0" rtlCol="0" anchor="ctr"/>
           <a:lstStyle/>
           <a:p>
-            <a:pPr rtl="1" algn="ctr" indent="0" marL="0">
+            <a:pPr algn="ctr" indent="0" marL="0" rtl="1">
               <a:buNone/>
             </a:pPr>
             <a:r>
@@ -3181,7 +3186,7 @@
           <a:bodyPr wrap="square" lIns="0" tIns="0" rIns="0" bIns="0" rtlCol="0" anchor="t"/>
           <a:lstStyle/>
           <a:p>
-            <a:pPr algn="r" indent="0" marL="0">
+            <a:pPr algn="r" indent="0" marL="0" rtl="1">
               <a:lnSpc>
                 <a:spcPct val="115000"/>
               </a:lnSpc>
@@ -3289,7 +3294,7 @@
           <a:bodyPr wrap="square" lIns="0" tIns="0" rIns="0" bIns="0" rtlCol="0" anchor="t"/>
           <a:lstStyle/>
           <a:p>
-            <a:pPr algn="r" indent="0" marL="0">
+            <a:pPr algn="r" indent="0" marL="0" rtl="1">
               <a:lnSpc>
                 <a:spcPct val="115000"/>
               </a:lnSpc>
@@ -3444,7 +3449,7 @@
           <a:bodyPr wrap="square" lIns="0" tIns="0" rIns="0" bIns="0" rtlCol="0" anchor="ctr"/>
           <a:lstStyle/>
           <a:p>
-            <a:pPr rtl="1" algn="r" indent="0" marL="0">
+            <a:pPr algn="r" indent="0" marL="0" rtl="1">
               <a:buNone/>
             </a:pPr>
             <a:r>
@@ -3483,7 +3488,7 @@
           <a:bodyPr wrap="square" lIns="0" tIns="0" rIns="0" bIns="0" rtlCol="0" anchor="ctr"/>
           <a:lstStyle/>
           <a:p>
-            <a:pPr rtl="1" algn="r" indent="0" marL="0">
+            <a:pPr algn="r" indent="0" marL="0" rtl="1">
               <a:buNone/>
             </a:pPr>
             <a:r>
@@ -3588,7 +3593,7 @@
           <a:bodyPr wrap="square" lIns="0" tIns="0" rIns="0" bIns="0" rtlCol="0" anchor="t"/>
           <a:lstStyle/>
           <a:p>
-            <a:pPr algn="ctr" indent="0" marL="0">
+            <a:pPr algn="ctr" indent="0" marL="0" rtl="1">
               <a:buNone/>
             </a:pPr>
             <a:r>
@@ -3605,7 +3610,7 @@
             <a:endParaRPr lang="en-US" sz="1600" dirty="0"/>
           </a:p>
           <a:p>
-            <a:pPr algn="ctr" indent="0" marL="0">
+            <a:pPr algn="ctr" indent="0" marL="0" rtl="1">
               <a:buNone/>
             </a:pPr>
             <a:r>
@@ -3693,7 +3698,7 @@
           <a:bodyPr wrap="square" lIns="0" tIns="0" rIns="0" bIns="0" rtlCol="0" anchor="t"/>
           <a:lstStyle/>
           <a:p>
-            <a:pPr algn="r" indent="0" marL="0">
+            <a:pPr algn="r" indent="0" marL="0" rtl="1">
               <a:lnSpc>
                 <a:spcPct val="115000"/>
               </a:lnSpc>
@@ -3801,7 +3806,7 @@
           <a:bodyPr wrap="square" lIns="0" tIns="0" rIns="0" bIns="0" rtlCol="0" anchor="t"/>
           <a:lstStyle/>
           <a:p>
-            <a:pPr algn="r" indent="0" marL="0">
+            <a:pPr algn="r" indent="0" marL="0" rtl="1">
               <a:lnSpc>
                 <a:spcPct val="115000"/>
               </a:lnSpc>
@@ -3909,7 +3914,7 @@
           <a:bodyPr wrap="square" lIns="0" tIns="0" rIns="0" bIns="0" rtlCol="0" anchor="t"/>
           <a:lstStyle/>
           <a:p>
-            <a:pPr algn="r" indent="0" marL="0">
+            <a:pPr algn="r" indent="0" marL="0" rtl="1">
               <a:lnSpc>
                 <a:spcPct val="115000"/>
               </a:lnSpc>
@@ -4064,7 +4069,7 @@
           <a:bodyPr wrap="square" lIns="0" tIns="0" rIns="0" bIns="0" rtlCol="0" anchor="ctr"/>
           <a:lstStyle/>
           <a:p>
-            <a:pPr rtl="1" algn="r" indent="0" marL="0">
+            <a:pPr algn="r" indent="0" marL="0" rtl="1">
               <a:buNone/>
             </a:pPr>
             <a:r>
@@ -4103,7 +4108,7 @@
           <a:bodyPr wrap="square" lIns="0" tIns="0" rIns="0" bIns="0" rtlCol="0" anchor="ctr"/>
           <a:lstStyle/>
           <a:p>
-            <a:pPr rtl="1" algn="r" indent="0" marL="0">
+            <a:pPr algn="r" indent="0" marL="0" rtl="1">
               <a:buNone/>
             </a:pPr>
             <a:r>
@@ -4191,7 +4196,7 @@
           <a:bodyPr wrap="square" lIns="0" tIns="0" rIns="0" bIns="0" rtlCol="0" anchor="t"/>
           <a:lstStyle/>
           <a:p>
-            <a:pPr algn="r" indent="0" marL="0">
+            <a:pPr algn="r" indent="0" marL="0" rtl="1">
               <a:lnSpc>
                 <a:spcPct val="115000"/>
               </a:lnSpc>
@@ -4299,7 +4304,7 @@
           <a:bodyPr wrap="square" lIns="0" tIns="0" rIns="0" bIns="0" rtlCol="0" anchor="t"/>
           <a:lstStyle/>
           <a:p>
-            <a:pPr algn="r" indent="0" marL="0">
+            <a:pPr algn="r" indent="0" marL="0" rtl="1">
               <a:lnSpc>
                 <a:spcPct val="115000"/>
               </a:lnSpc>
@@ -4407,7 +4412,7 @@
           <a:bodyPr wrap="square" lIns="0" tIns="0" rIns="0" bIns="0" rtlCol="0" anchor="t"/>
           <a:lstStyle/>
           <a:p>
-            <a:pPr algn="r" indent="0" marL="0">
+            <a:pPr algn="r" indent="0" marL="0" rtl="1">
               <a:lnSpc>
                 <a:spcPct val="115000"/>
               </a:lnSpc>
@@ -4493,7 +4498,7 @@
           <a:bodyPr wrap="square" lIns="0" tIns="0" rIns="0" bIns="0" rtlCol="0" anchor="ctr"/>
           <a:lstStyle/>
           <a:p>
-            <a:pPr algn="r" indent="0" marL="0">
+            <a:pPr algn="r" indent="0" marL="0" rtl="1">
               <a:buNone/>
             </a:pPr>
             <a:r>

</xml_diff>

<commit_message>
Keep Hebrew RTL in viewers that ignore rtl attribute
Wrap every Hebrew text run in Unicode RLE/PDF marks so punctuation and
English citations stay in place in viewers such as iOS Quick Look that
render paragraphs left to right.

Co-Authored-By: Claude Opus 5.5 <noreply@anthropic.com>
Claude-Session: https://claude.ai/code/session_016buQrLRQHjtd4YGfeSnksc
</commit_message>
<xml_diff>
--- a/presentation/היעדרויות-מורים-מצגת-סיום.pptx
+++ b/presentation/היעדרויות-מורים-מצגת-סיום.pptx
@@ -509,8 +509,8 @@
             <a:pPr rtl="1"/>
             <a:r>
               <a:rPr lang="en-US" dirty="0"/>
-              <a:t>[חנון | כעשר שניות]
-שלום לכולם. אנחנו חנון מנסור ואולפת עבד אל חי, והמחקר שלנו עוסק באסטרטגיות ניהוליות של מנהלי בתי ספר בהתמודדות עם היעדרויות מורים לשמירה על רצף לימודי.</a:t>
+              <a:t>‫[חנון | כעשר שניות]
+שלום לכולם. אנחנו חנון מנסור ואולפת עבד אל חי, והמחקר שלנו עוסק באסטרטגיות ניהוליות של מנהלי בתי ספר בהתמודדות עם היעדרויות מורים לשמירה על רצף לימודי.‬</a:t>
             </a:r>
             <a:endParaRPr lang="en-US" dirty="0"/>
           </a:p>
@@ -599,12 +599,12 @@
             <a:pPr rtl="1"/>
             <a:r>
               <a:rPr lang="en-US" dirty="0"/>
-              <a:t>[חנון | כדקה]
+              <a:t>‫[חנון | כדקה]
 בוקר רגיל, שבע וחצי. מורה מתקשרת ומודיעה שלא תגיע היום. בתוך כמה דקות המנהל צריך להחליט מי נכנס לכיתה, מה יקרה בשיעור, ומה יהיה המחיר עבור הצוות.
 ההיעדרות עצמה היא חלק מהחיים של כל בית ספר. מה שמעניין אותנו הוא ההחלטות שהיא מחייבת, ובמיוחד כשההיעדרויות מצטברות והמנהל צריך לשמור על רצף פדגוגי, ארגוני ורגשי.
 שאלת המחקר שלנו: כיצד מנהלי בתי ספר בערים בצפון הארץ מתארים את התמודדותם עם היעדרויות מורים, ואילו אסטרטגיות ושיקולים מנחים את החלטותיהם לשמירה על רצף לימודי?
 המחקר שלנו חשוב כי אותה היעדרות יכולה להסתיים בשיעור שממשיך כסדרו או בשעת השגחה בלבד, וההבדל נקבע בהחלטות של המנהל.
-[מעבר לאולפת]</a:t>
+[מעבר לאולפת]‬</a:t>
             </a:r>
             <a:endParaRPr lang="en-US" dirty="0"/>
           </a:p>
@@ -693,12 +693,12 @@
             <a:pPr rtl="1"/>
             <a:r>
               <a:rPr lang="en-US" dirty="0"/>
-              <a:t>[אולפת | כדקה ורבע]
+              <a:t>‫[אולפת | כדקה ורבע]
 מה למדנו מהספרות? מילר ואחרים וקלוטפלטר ואחרים מצאו שהיעדרויות מורים פוגעות בהישגי התלמידים, והפגיעה גדלה ככל שההיעדרויות מצטברות.
 מה שהפתיע אותנו הוא המחקר של שפירא־לישצ'ינסקי ורוזנבלט. הם מצאו שהאקלים האתי בבית הספר קשור להיקף ההיעדרויות מרצון. כלומר, המנהל משפיע על התופעה עוד לפני שהיא מתרחשת.
 והפער: רוב המחקרים בודקים כמה מורים נעדרים, למה, ומה המחיר. בתיאוריה רצף לימודי הוא עניין פדגוגי, אבל בשבע וחצי בבוקר המנהל צריך קודם כול שמישהו יהיה בכיתה. מעט ידוע על מה שהמנהל שוקל ברגע הזה.
 הקריאה שינתה גם את החשיבה שלנו. בהתחלה חשבנו שהבעיה לוגיסטית. היום אנחנו מבינים שרצף הוא פדגוגי, ארגוני ורגשי, ושהמנהל פועל גם לפני ההיעדרות.
-[מעבר לחנון]</a:t>
+[מעבר לחנון]‬</a:t>
             </a:r>
             <a:endParaRPr lang="en-US" dirty="0"/>
           </a:p>
@@ -787,11 +787,11 @@
             <a:pPr rtl="1"/>
             <a:r>
               <a:rPr lang="en-US" dirty="0"/>
-              <a:t>[חנון | כחמישים שניות]
+              <a:t>‫[חנון | כחמישים שניות]
 כך נראית המסגרת המושגית שלנו, מימין לשמאל.
 היא מתחילה בהיעדרות מורים ועוברת אל המושג המרכזי, רצף לימודי. אנחנו מבינים את הרצף בשלושה ממדים. פדגוגי, כלומר שהתוכן והלמידה ממשיכים. ארגוני, כלומר שיבוץ, מערכת שעות, והעומס על הצוות שמחליף. ורגשי, כלומר שהתלמידים נשארים עם מבוגר מוכר ומרגישים ביטחון.
 הרצף הזה תלוי בקבלת החלטות ניהולית. המנהל שוקל צרכים מתחרים, בזמן קצר ובמשאבים מוגבלים. מתוך ההחלטות נגזרות אסטרטגיות מגיבות, כמו ממלא מקום או איחוד כיתות, ואסטרטגיות מונעות, כמו מאגר קבוע של ממלאי מקום וחומרי עבודה מוכנים מראש.
-[מעבר לאולפת]</a:t>
+[מעבר לאולפת]‬</a:t>
             </a:r>
             <a:endParaRPr lang="en-US" dirty="0"/>
           </a:p>
@@ -880,11 +880,11 @@
             <a:pPr rtl="1"/>
             <a:r>
               <a:rPr lang="en-US" dirty="0"/>
-              <a:t>[אולפת | כדקה]
+              <a:t>‫[אולפת | כדקה]
 איך נבדוק את זה? נשוחח עם 12 מנהלים ומנהלות של בתי ספר יסודיים ועל־יסודיים בערים בצפון הארץ, עם ותק שונה. בחרנו במנהלים כי הם מקבלי ההחלטות בעת היעדרות, ובחרנו בערים כדי לבחון את התופעה בהקשר אחיד ולהשוות בין ערים שונות.
 את הראיונות נתמלל וננתח בניתוח תמטי. נחפש אסטרטגיות מונעות לעומת מגיבות, הבדלים בין היעדרות קצרה לממושכת, ואת האיזון בין פדגוגיה, תקציב, הוגנות כלפי הצוות שמחליף, ורווחת המורה הנעדר.
 האתגר המרכזי: מנהלים עלולים להציג תמונה יפה מהמציאות, ולכן נבקש דוגמאות מוחשיות. ומה יפתיע אותנו? אם יתברר שמה שמנחה את ההחלטות הוא בעיקר השקט והסדר בבית הספר ולא הרצף הלימודי.
-[מעבר לחנון]</a:t>
+[מעבר לחנון]‬</a:t>
             </a:r>
             <a:endParaRPr lang="en-US" dirty="0"/>
           </a:p>
@@ -973,7 +973,7 @@
             <a:pPr rtl="1"/>
             <a:r>
               <a:rPr lang="en-US" dirty="0"/>
-              <a:t>[חנון | כארבעים שניות]
+              <a:t>‫[חנון | כארבעים שניות]
 איך ייראה הראיון? נפתח בשאלות רקע על בית הספר, על הצוות ועל הדרך של המנהל לתפקיד, כדי ליצור אמון ולהבין את ההקשר.
 בהמשך נבקש מכל מנהל לתאר את הבוקר האחרון שבו מורה נעדר, צעד אחר צעד, לספר על היעדרות ממושכת, ולפרט במה התחשב כשבחר מי יחליף. כך נשמע את השיקולים ואת הדילמות, ולא רק את הנוהל הכתוב.
 ונקפיד על אתיקה: הסכמה מדעת, הקלטה רק באישור, ואנונימיות מלאה.
@@ -982,7 +982,7 @@
 תודה.
 [שאלות המשך אפשריות]
 למה רק מנהלים? כי השאלה היא על קבלת החלטות, והם אלה שמחליטים. במחקר המשך אפשר לשמוע גם את המורים המחליפים.
-למה רק ערים? כדי לבחון את התופעה בהקשר אחיד. בתי ספר בכפרים פועלים בתנאים אחרים, וזה יכול להיות כיוון למחקר המשך.</a:t>
+למה רק ערים? כדי לבחון את התופעה בהקשר אחיד. בתי ספר בכפרים פועלים בתנאים אחרים, וזה יכול להיות כיוון למחקר המשך.‬</a:t>
             </a:r>
             <a:endParaRPr lang="en-US" dirty="0"/>
           </a:p>
@@ -1071,7 +1071,7 @@
             <a:pPr rtl="1"/>
             <a:r>
               <a:rPr lang="en-US" dirty="0"/>
-              <a:t>שקף זה אינו חלק מחמש הדקות של ההצגה. הוא מצורף כדי להשלים את הכתיבה האקדמית.</a:t>
+              <a:t>‫שקף זה אינו חלק מחמש הדקות של ההצגה. הוא מצורף כדי להשלים את הכתיבה האקדמית.‬</a:t>
             </a:r>
             <a:endParaRPr lang="en-US" dirty="0"/>
           </a:p>
@@ -1501,7 +1501,7 @@
                 <a:ea typeface="Arial" pitchFamily="34" charset="-122"/>
                 <a:cs typeface="Arial" pitchFamily="34" charset="-120"/>
               </a:rPr>
-              <a:t>סמינריון בעבודת הניהול ובמנהל חינוך</a:t>
+              <a:t>‫סמינריון בעבודת הניהול ובמנהל חינוך‬</a:t>
             </a:r>
             <a:endParaRPr lang="en-US" sz="1600" dirty="0"/>
           </a:p>
@@ -1540,7 +1540,7 @@
                 <a:ea typeface="Arial" pitchFamily="34" charset="-122"/>
                 <a:cs typeface="Arial" pitchFamily="34" charset="-120"/>
               </a:rPr>
-              <a:t>אסטרטגיות ניהוליות של מנהלי בתי ספר בהתמודדות עם היעדרויות מורים לשמירה על רצף לימודי</a:t>
+              <a:t>‫אסטרטגיות ניהוליות של מנהלי בתי ספר בהתמודדות עם היעדרויות מורים לשמירה על רצף לימודי‬</a:t>
             </a:r>
             <a:endParaRPr lang="en-US" sz="3200" dirty="0"/>
           </a:p>
@@ -1579,7 +1579,7 @@
                 <a:ea typeface="Arial" pitchFamily="34" charset="-122"/>
                 <a:cs typeface="Arial" pitchFamily="34" charset="-120"/>
               </a:rPr>
-              <a:t>פרזנטציית סיום של עבודת הסמינריון</a:t>
+              <a:t>‫פרזנטציית סיום של עבודת הסמינריון‬</a:t>
             </a:r>
             <a:endParaRPr lang="en-US" sz="1700" dirty="0"/>
           </a:p>
@@ -1645,7 +1645,7 @@
                 <a:ea typeface="Arial" pitchFamily="34" charset="-122"/>
                 <a:cs typeface="Arial" pitchFamily="34" charset="-120"/>
               </a:rPr>
-              <a:t>הוגש על ידי</a:t>
+              <a:t>‫הוגש על ידי‬</a:t>
             </a:r>
             <a:endParaRPr lang="en-US" sz="1500" dirty="0"/>
           </a:p>
@@ -1662,7 +1662,7 @@
                 <a:ea typeface="Arial" pitchFamily="34" charset="-122"/>
                 <a:cs typeface="Arial" pitchFamily="34" charset="-120"/>
               </a:rPr>
-              <a:t>חנון מנסור</a:t>
+              <a:t>‫חנון מנסור‬</a:t>
             </a:r>
             <a:endParaRPr lang="en-US" sz="1500" dirty="0"/>
           </a:p>
@@ -1679,7 +1679,7 @@
                 <a:ea typeface="Arial" pitchFamily="34" charset="-122"/>
                 <a:cs typeface="Arial" pitchFamily="34" charset="-120"/>
               </a:rPr>
-              <a:t>אולפת עבד אל חי</a:t>
+              <a:t>‫אולפת עבד אל חי‬</a:t>
             </a:r>
             <a:endParaRPr lang="en-US" sz="1500" dirty="0"/>
           </a:p>
@@ -1718,7 +1718,7 @@
                 <a:ea typeface="Arial" pitchFamily="34" charset="-122"/>
                 <a:cs typeface="Arial" pitchFamily="34" charset="-120"/>
               </a:rPr>
-              <a:t>המרצה</a:t>
+              <a:t>‫המרצה‬</a:t>
             </a:r>
             <a:endParaRPr lang="en-US" sz="1500" dirty="0"/>
           </a:p>
@@ -1735,7 +1735,7 @@
                 <a:ea typeface="Arial" pitchFamily="34" charset="-122"/>
                 <a:cs typeface="Arial" pitchFamily="34" charset="-120"/>
               </a:rPr>
-              <a:t>ד״ר ליאור הלוי</a:t>
+              <a:t>‫ד״ר ליאור הלוי‬</a:t>
             </a:r>
             <a:endParaRPr lang="en-US" sz="1500" dirty="0"/>
           </a:p>
@@ -1752,7 +1752,7 @@
                 <a:ea typeface="Arial" pitchFamily="34" charset="-122"/>
                 <a:cs typeface="Arial" pitchFamily="34" charset="-120"/>
               </a:rPr>
-              <a:t>תשפ״ז, 2026</a:t>
+              <a:t>‫תשפ״ז, 2026‬</a:t>
             </a:r>
             <a:endParaRPr lang="en-US" sz="1500" dirty="0"/>
           </a:p>
@@ -1823,7 +1823,7 @@
                 <a:ea typeface="Arial" pitchFamily="34" charset="-122"/>
                 <a:cs typeface="Arial" pitchFamily="34" charset="-120"/>
               </a:rPr>
-              <a:t>הבעיה המחקרית</a:t>
+              <a:t>‫הבעיה המחקרית‬</a:t>
             </a:r>
             <a:endParaRPr lang="he-IL" sz="1300" dirty="0"/>
           </a:p>
@@ -1862,7 +1862,7 @@
                 <a:ea typeface="Arial" pitchFamily="34" charset="-122"/>
                 <a:cs typeface="Arial" pitchFamily="34" charset="-120"/>
               </a:rPr>
-              <a:t>היעדרויות מורים ורצף לימודי</a:t>
+              <a:t>‫היעדרויות מורים ורצף לימודי‬</a:t>
             </a:r>
             <a:endParaRPr lang="he-IL" sz="3400" dirty="0"/>
           </a:p>
@@ -1904,7 +1904,7 @@
                 <a:ea typeface="Arial" pitchFamily="34" charset="-122"/>
                 <a:cs typeface="Arial" pitchFamily="34" charset="-120"/>
               </a:rPr>
-              <a:t>היעדרויות מורים הן חלק קבוע מהמציאות הארגונית של בתי הספר. הקושי אינו בהיעדרות עצמה אלא בהחלטות שהיא מחייבת. בתוך זמן קצר על המנהל לקבוע מי ייכנס לכיתה, מה יתרחש בשיעור ומה יהיה המחיר עבור הצוות. כאשר ההיעדרויות מצטברות, ההנהלה נדרשת לשמור על רצף פדגוגי, ארגוני ורגשי ולא רק למצוא ממלא מקום (הלוי, 2026).</a:t>
+              <a:t>‫היעדרויות מורים הן חלק קבוע מהמציאות הארגונית של בתי הספר. הקושי אינו בהיעדרות עצמה אלא בהחלטות שהיא מחייבת. בתוך זמן קצר על המנהל לקבוע מי ייכנס לכיתה, מה יתרחש בשיעור ומה יהיה המחיר עבור הצוות. כאשר ההיעדרויות מצטברות, ההנהלה נדרשת לשמור על רצף פדגוגי, ארגוני ורגשי ולא רק למצוא ממלא מקום (הלוי, 2026).‬</a:t>
             </a:r>
             <a:endParaRPr lang="he-IL" sz="1700" dirty="0"/>
           </a:p>
@@ -1970,7 +1970,7 @@
                 <a:ea typeface="Arial" pitchFamily="34" charset="-122"/>
                 <a:cs typeface="Arial" pitchFamily="34" charset="-120"/>
               </a:rPr>
-              <a:t>שאלת המחקר</a:t>
+              <a:t>‫שאלת המחקר‬</a:t>
             </a:r>
             <a:endParaRPr lang="he-IL" sz="1500" dirty="0"/>
           </a:p>
@@ -2012,7 +2012,7 @@
                 <a:ea typeface="Arial" pitchFamily="34" charset="-122"/>
                 <a:cs typeface="Arial" pitchFamily="34" charset="-120"/>
               </a:rPr>
-              <a:t>כיצד מנהלי בתי ספר בערים בצפון הארץ מתארים את התמודדותם עם היעדרויות מורים, ואילו אסטרטגיות ושיקולים מנחים את החלטותיהם לשמירה על רצף לימודי?</a:t>
+              <a:t>‫כיצד מנהלי בתי ספר בערים בצפון הארץ מתארים את התמודדותם עם היעדרויות מורים, ואילו אסטרטגיות ושיקולים מנחים את החלטותיהם לשמירה על רצף לימודי?‬</a:t>
             </a:r>
             <a:endParaRPr lang="he-IL" sz="2000" dirty="0"/>
           </a:p>
@@ -2051,7 +2051,7 @@
                 <a:ea typeface="Arial" pitchFamily="34" charset="-122"/>
                 <a:cs typeface="Arial" pitchFamily="34" charset="-120"/>
               </a:rPr>
-              <a:t>חשיבות המחקר</a:t>
+              <a:t>‫חשיבות המחקר‬</a:t>
             </a:r>
             <a:endParaRPr lang="he-IL" sz="1500" dirty="0"/>
           </a:p>
@@ -2093,7 +2093,7 @@
                 <a:ea typeface="Arial" pitchFamily="34" charset="-122"/>
                 <a:cs typeface="Arial" pitchFamily="34" charset="-120"/>
               </a:rPr>
-              <a:t>אותה היעדרות יכולה להסתיים בשיעור שממשיך כסדרו או בשעת השגחה בלבד, וההבדל נקבע בהחלטות המנהל. הבנת השיקולים שמאחורי ההחלטות האלה עשויה לסייע למנהלים לגבש דרכי פעולה ששומרות על הלמידה.</a:t>
+              <a:t>‫אותה היעדרות יכולה להסתיים בשיעור שממשיך כסדרו או בשעת השגחה בלבד, וההבדל נקבע בהחלטות המנהל. הבנת השיקולים שמאחורי ההחלטות האלה עשויה לסייע למנהלים לגבש דרכי פעולה ששומרות על הלמידה.‬</a:t>
             </a:r>
             <a:endParaRPr lang="he-IL" sz="1700" dirty="0"/>
           </a:p>
@@ -2164,7 +2164,7 @@
                 <a:ea typeface="Arial" pitchFamily="34" charset="-122"/>
                 <a:cs typeface="Arial" pitchFamily="34" charset="-120"/>
               </a:rPr>
-              <a:t>סקירת ספרות</a:t>
+              <a:t>‫סקירת ספרות‬</a:t>
             </a:r>
             <a:endParaRPr lang="he-IL" sz="1300" dirty="0"/>
           </a:p>
@@ -2203,7 +2203,7 @@
                 <a:ea typeface="Arial" pitchFamily="34" charset="-122"/>
                 <a:cs typeface="Arial" pitchFamily="34" charset="-120"/>
               </a:rPr>
-              <a:t>מה ידוע ומה טרם נבחן</a:t>
+              <a:t>‫מה ידוע ומה טרם נבחן‬</a:t>
             </a:r>
             <a:endParaRPr lang="he-IL" sz="3400" dirty="0"/>
           </a:p>
@@ -2242,7 +2242,7 @@
                 <a:ea typeface="Arial" pitchFamily="34" charset="-122"/>
                 <a:cs typeface="Arial" pitchFamily="34" charset="-120"/>
               </a:rPr>
-              <a:t>מה ידוע</a:t>
+              <a:t>‫מה ידוע‬</a:t>
             </a:r>
             <a:endParaRPr lang="he-IL" sz="1500" dirty="0"/>
           </a:p>
@@ -2284,7 +2284,7 @@
                 <a:ea typeface="Arial" pitchFamily="34" charset="-122"/>
                 <a:cs typeface="Arial" pitchFamily="34" charset="-120"/>
               </a:rPr>
-              <a:t>מילר ואחרים (Miller et al., 2008) וקלוטפלטר ואחרים (Clotfelter et al., 2009) מצאו כי היעדרויות מורים פוגעות בהישגי התלמידים, וכי הפגיעה גדלה ככל שההיעדרויות מצטברות. שפירא־לישצ'ינסקי ורוזנבלט (Shapira-Lishchinsky &amp; Rosenblatt, 2010) הראו כי האקלים האתי בבית הספר קשור להיקף ההיעדרויות מרצון, ומכאן שהמנהל משפיע על התופעה עוד לפני שהיא מתרחשת.</a:t>
+              <a:t>‫מילר ואחרים (Miller et al., 2008) וקלוטפלטר ואחרים (Clotfelter et al., 2009) מצאו כי היעדרויות מורים פוגעות בהישגי התלמידים, וכי הפגיעה גדלה ככל שההיעדרויות מצטברות. שפירא־לישצ'ינסקי ורוזנבלט (Shapira-Lishchinsky &amp; Rosenblatt, 2010) הראו כי האקלים האתי בבית הספר קשור להיקף ההיעדרויות מרצון, ומכאן שהמנהל משפיע על התופעה עוד לפני שהיא מתרחשת.‬</a:t>
             </a:r>
             <a:endParaRPr lang="he-IL" sz="1600" dirty="0"/>
           </a:p>
@@ -2323,7 +2323,7 @@
                 <a:ea typeface="Arial" pitchFamily="34" charset="-122"/>
                 <a:cs typeface="Arial" pitchFamily="34" charset="-120"/>
               </a:rPr>
-              <a:t>הפער המחקרי</a:t>
+              <a:t>‫הפער המחקרי‬</a:t>
             </a:r>
             <a:endParaRPr lang="he-IL" sz="1500" dirty="0"/>
           </a:p>
@@ -2365,7 +2365,7 @@
                 <a:ea typeface="Arial" pitchFamily="34" charset="-122"/>
                 <a:cs typeface="Arial" pitchFamily="34" charset="-120"/>
               </a:rPr>
-              <a:t>רוב המחקרים עוסקים בהיקף ההיעדרויות, בגורמיהן ובמחירן. בתיאוריה רצף לימודי הוא עניין פדגוגי, ואילו בשגרת הבוקר המנהל נדרש קודם כול להבטיח נוכחות של מבוגר בכיתה. מעט ידוע על השיקולים שמנחים את המנהל ברגע ההיעדרות עצמו.</a:t>
+              <a:t>‫רוב המחקרים עוסקים בהיקף ההיעדרויות, בגורמיהן ובמחירן. בתיאוריה רצף לימודי הוא עניין פדגוגי, ואילו בשגרת הבוקר המנהל נדרש קודם כול להבטיח נוכחות של מבוגר בכיתה. מעט ידוע על השיקולים שמנחים את המנהל ברגע ההיעדרות עצמו.‬</a:t>
             </a:r>
             <a:endParaRPr lang="he-IL" sz="1600" dirty="0"/>
           </a:p>
@@ -2431,7 +2431,7 @@
                 <a:ea typeface="Arial" pitchFamily="34" charset="-122"/>
                 <a:cs typeface="Arial" pitchFamily="34" charset="-120"/>
               </a:rPr>
-              <a:t>שינוי בתפיסת הבעיה</a:t>
+              <a:t>‫שינוי בתפיסת הבעיה‬</a:t>
             </a:r>
             <a:endParaRPr lang="he-IL" sz="1500" dirty="0"/>
           </a:p>
@@ -2473,7 +2473,7 @@
                 <a:ea typeface="Arial" pitchFamily="34" charset="-122"/>
                 <a:cs typeface="Arial" pitchFamily="34" charset="-120"/>
               </a:rPr>
-              <a:t>בתחילת העבודה נתפסה הבעיה כעניין לוגיסטי של מציאת ממלא מקום. הקריאה הובילה להבנה שרצף לימודי הוא פדגוגי, ארגוני ורגשי, ושפעולת המנהל מתחילה עוד לפני ההיעדרות.</a:t>
+              <a:t>‫בתחילת העבודה נתפסה הבעיה כעניין לוגיסטי של מציאת ממלא מקום. הקריאה הובילה להבנה שרצף לימודי הוא פדגוגי, ארגוני ורגשי, ושפעולת המנהל מתחילה עוד לפני ההיעדרות.‬</a:t>
             </a:r>
             <a:endParaRPr lang="he-IL" sz="1600" dirty="0"/>
           </a:p>
@@ -2544,7 +2544,7 @@
                 <a:ea typeface="Arial" pitchFamily="34" charset="-122"/>
                 <a:cs typeface="Arial" pitchFamily="34" charset="-120"/>
               </a:rPr>
-              <a:t>מסגרת מושגית</a:t>
+              <a:t>‫מסגרת מושגית‬</a:t>
             </a:r>
             <a:endParaRPr lang="he-IL" sz="1300" dirty="0"/>
           </a:p>
@@ -2583,7 +2583,7 @@
                 <a:ea typeface="Arial" pitchFamily="34" charset="-122"/>
                 <a:cs typeface="Arial" pitchFamily="34" charset="-120"/>
               </a:rPr>
-              <a:t>המושגים המרכזיים והקשרים ביניהם</a:t>
+              <a:t>‫המושגים המרכזיים והקשרים ביניהם‬</a:t>
             </a:r>
             <a:endParaRPr lang="he-IL" sz="3400" dirty="0"/>
           </a:p>
@@ -2672,7 +2672,7 @@
                 <a:ea typeface="Arial" pitchFamily="34" charset="-122"/>
                 <a:cs typeface="Arial" pitchFamily="34" charset="-120"/>
               </a:rPr>
-              <a:t>היעדרות מורים</a:t>
+              <a:t>‫היעדרות מורים‬</a:t>
             </a:r>
             <a:endParaRPr lang="en-US" sz="1600" dirty="0"/>
           </a:p>
@@ -2761,7 +2761,7 @@
                 <a:ea typeface="Arial" pitchFamily="34" charset="-122"/>
                 <a:cs typeface="Arial" pitchFamily="34" charset="-120"/>
               </a:rPr>
-              <a:t>רצף לימודי</a:t>
+              <a:t>‫רצף לימודי‬</a:t>
             </a:r>
             <a:endParaRPr lang="en-US" sz="1600" dirty="0"/>
           </a:p>
@@ -2850,7 +2850,7 @@
                 <a:ea typeface="Arial" pitchFamily="34" charset="-122"/>
                 <a:cs typeface="Arial" pitchFamily="34" charset="-120"/>
               </a:rPr>
-              <a:t>קבלת החלטות ניהולית</a:t>
+              <a:t>‫קבלת החלטות ניהולית‬</a:t>
             </a:r>
             <a:endParaRPr lang="en-US" sz="1600" dirty="0"/>
           </a:p>
@@ -2916,7 +2916,7 @@
                 <a:ea typeface="Arial" pitchFamily="34" charset="-122"/>
                 <a:cs typeface="Arial" pitchFamily="34" charset="-120"/>
               </a:rPr>
-              <a:t>אסטרטגיות ניהוליות</a:t>
+              <a:t>‫אסטרטגיות ניהוליות‬</a:t>
             </a:r>
             <a:endParaRPr lang="en-US" sz="1600" dirty="0"/>
           </a:p>
@@ -2955,7 +2955,7 @@
                 <a:ea typeface="Arial" pitchFamily="34" charset="-122"/>
                 <a:cs typeface="Arial" pitchFamily="34" charset="-120"/>
               </a:rPr>
-              <a:t>רצף לימודי</a:t>
+              <a:t>‫רצף לימודי‬</a:t>
             </a:r>
             <a:endParaRPr lang="he-IL" sz="1500" dirty="0"/>
           </a:p>
@@ -2997,7 +2997,7 @@
                 <a:ea typeface="Arial" pitchFamily="34" charset="-122"/>
                 <a:cs typeface="Arial" pitchFamily="34" charset="-120"/>
               </a:rPr>
-              <a:t>המסגרת נפתחת במושג היעדרות מורים ועוברת אל הרצף הלימודי, המובן כאן בשלושה ממדים. הממד הפדגוגי עוסק בהמשך התוכן והלמידה, הממד הארגוני בשיבוץ, במערכת השעות ובעומס על הצוות, והממד הרגשי ביחסים ובתחושת הביטחון של התלמידים (הלוי, 2026).</a:t>
+              <a:t>‫המסגרת נפתחת במושג היעדרות מורים ועוברת אל הרצף הלימודי, המובן כאן בשלושה ממדים. הממד הפדגוגי עוסק בהמשך התוכן והלמידה, הממד הארגוני בשיבוץ, במערכת השעות ובעומס על הצוות, והממד הרגשי ביחסים ובתחושת הביטחון של התלמידים (הלוי, 2026).‬</a:t>
             </a:r>
             <a:endParaRPr lang="he-IL" sz="1600" dirty="0"/>
           </a:p>
@@ -3036,7 +3036,7 @@
                 <a:ea typeface="Arial" pitchFamily="34" charset="-122"/>
                 <a:cs typeface="Arial" pitchFamily="34" charset="-120"/>
               </a:rPr>
-              <a:t>מהחלטה לאסטרטגיה</a:t>
+              <a:t>‫מהחלטה לאסטרטגיה‬</a:t>
             </a:r>
             <a:endParaRPr lang="he-IL" sz="1500" dirty="0"/>
           </a:p>
@@ -3078,7 +3078,7 @@
                 <a:ea typeface="Arial" pitchFamily="34" charset="-122"/>
                 <a:cs typeface="Arial" pitchFamily="34" charset="-120"/>
               </a:rPr>
-              <a:t>הרצף תלוי בקבלת החלטות ניהולית, שבה המנהל שוקל צרכים מתחרים בזמן קצר ובמשאבים מוגבלים. מההחלטות נגזרות אסטרטגיות מגיבות, כגון ממלא מקום, איחוד כיתות ושעה פרטנית, ואסטרטגיות מונעות, כגון מאגר קבוע של ממלאי מקום וחומרי עבודה שהוכנו מראש.</a:t>
+              <a:t>‫הרצף תלוי בקבלת החלטות ניהולית, שבה המנהל שוקל צרכים מתחרים בזמן קצר ובמשאבים מוגבלים. מההחלטות נגזרות אסטרטגיות מגיבות, כגון ממלא מקום, איחוד כיתות ושעה פרטנית, ואסטרטגיות מונעות, כגון מאגר קבוע של ממלאי מקום וחומרי עבודה שהוכנו מראש.‬</a:t>
             </a:r>
             <a:endParaRPr lang="he-IL" sz="1600" dirty="0"/>
           </a:p>
@@ -3149,7 +3149,7 @@
                 <a:ea typeface="Arial" pitchFamily="34" charset="-122"/>
                 <a:cs typeface="Arial" pitchFamily="34" charset="-120"/>
               </a:rPr>
-              <a:t>שיטת המחקר</a:t>
+              <a:t>‫שיטת המחקר‬</a:t>
             </a:r>
             <a:endParaRPr lang="he-IL" sz="1300" dirty="0"/>
           </a:p>
@@ -3188,7 +3188,7 @@
                 <a:ea typeface="Arial" pitchFamily="34" charset="-122"/>
                 <a:cs typeface="Arial" pitchFamily="34" charset="-120"/>
               </a:rPr>
-              <a:t>מחקר איכותני בקרב מנהלי בתי ספר</a:t>
+              <a:t>‫מחקר איכותני בקרב מנהלי בתי ספר‬</a:t>
             </a:r>
             <a:endParaRPr lang="he-IL" sz="3400" dirty="0"/>
           </a:p>
@@ -3293,7 +3293,7 @@
                 <a:ea typeface="Arial" pitchFamily="34" charset="-122"/>
                 <a:cs typeface="Arial" pitchFamily="34" charset="-120"/>
               </a:rPr>
-              <a:t>מנהלים ומנהלות</a:t>
+              <a:t>‫מנהלים ומנהלות‬</a:t>
             </a:r>
             <a:endParaRPr lang="en-US" sz="1600" dirty="0"/>
           </a:p>
@@ -3310,7 +3310,7 @@
                 <a:ea typeface="Arial" pitchFamily="34" charset="-122"/>
                 <a:cs typeface="Arial" pitchFamily="34" charset="-120"/>
               </a:rPr>
-              <a:t>בערים בצפון הארץ</a:t>
+              <a:t>‫בערים בצפון הארץ‬</a:t>
             </a:r>
             <a:endParaRPr lang="en-US" sz="1600" dirty="0"/>
           </a:p>
@@ -3349,7 +3349,7 @@
                 <a:ea typeface="Arial" pitchFamily="34" charset="-122"/>
                 <a:cs typeface="Arial" pitchFamily="34" charset="-120"/>
               </a:rPr>
-              <a:t>אוכלוסיית המחקר</a:t>
+              <a:t>‫אוכלוסיית המחקר‬</a:t>
             </a:r>
             <a:endParaRPr lang="he-IL" sz="1500" dirty="0"/>
           </a:p>
@@ -3391,7 +3391,7 @@
                 <a:ea typeface="Arial" pitchFamily="34" charset="-122"/>
                 <a:cs typeface="Arial" pitchFamily="34" charset="-120"/>
               </a:rPr>
-              <a:t>המחקר יתבסס על ראיונות עם 12 מנהלים ומנהלות של בתי ספר יסודיים ועל־יסודיים בערים בצפון הארץ, בעלי ותק שונה בתפקיד. המנהלים נבחרו משום שהם מקבלי ההחלטות בעת היעדרות, וההתמקדות בערים מאפשרת לבחון את התופעה בהקשר אחיד ולהשוות בין ערים שונות.</a:t>
+              <a:t>‫המחקר יתבסס על ראיונות עם 12 מנהלים ומנהלות של בתי ספר יסודיים ועל־יסודיים בערים בצפון הארץ, בעלי ותק שונה בתפקיד. המנהלים נבחרו משום שהם מקבלי ההחלטות בעת היעדרות, וההתמקדות בערים מאפשרת לבחון את התופעה בהקשר אחיד ולהשוות בין ערים שונות.‬</a:t>
             </a:r>
             <a:endParaRPr lang="he-IL" sz="1500" dirty="0"/>
           </a:p>
@@ -3430,7 +3430,7 @@
                 <a:ea typeface="Arial" pitchFamily="34" charset="-122"/>
                 <a:cs typeface="Arial" pitchFamily="34" charset="-120"/>
               </a:rPr>
-              <a:t>ניתוח הנתונים</a:t>
+              <a:t>‫ניתוח הנתונים‬</a:t>
             </a:r>
             <a:endParaRPr lang="he-IL" sz="1500" dirty="0"/>
           </a:p>
@@ -3472,7 +3472,7 @@
                 <a:ea typeface="Arial" pitchFamily="34" charset="-122"/>
                 <a:cs typeface="Arial" pitchFamily="34" charset="-120"/>
               </a:rPr>
-              <a:t>הראיונות יתומללו וינותחו בניתוח תמטי. הניתוח יתמקד באסטרטגיות מונעות לעומת מגיבות, בהבדלים בין היעדרות קצרה לממושכת ובאיזון בין שיקולים פדגוגיים, שיקולי תקציב, הוגנות כלפי הצוות ורווחת המורה הנעדר.</a:t>
+              <a:t>‫הראיונות יתומללו וינותחו בניתוח תמטי. הניתוח יתמקד באסטרטגיות מונעות לעומת מגיבות, בהבדלים בין היעדרות קצרה לממושכת ובאיזון בין שיקולים פדגוגיים, שיקולי תקציב, הוגנות כלפי הצוות ורווחת המורה הנעדר.‬</a:t>
             </a:r>
             <a:endParaRPr lang="he-IL" sz="1500" dirty="0"/>
           </a:p>
@@ -3511,7 +3511,7 @@
                 <a:ea typeface="Arial" pitchFamily="34" charset="-122"/>
                 <a:cs typeface="Arial" pitchFamily="34" charset="-120"/>
               </a:rPr>
-              <a:t>אתגרים ומגבלות</a:t>
+              <a:t>‫אתגרים ומגבלות‬</a:t>
             </a:r>
             <a:endParaRPr lang="he-IL" sz="1500" dirty="0"/>
           </a:p>
@@ -3553,7 +3553,7 @@
                 <a:ea typeface="Arial" pitchFamily="34" charset="-122"/>
                 <a:cs typeface="Arial" pitchFamily="34" charset="-120"/>
               </a:rPr>
-              <a:t>מנהלים עשויים להציג תמונה חיובית מהמציאות, ולכן הראיון יתמקד בדוגמאות מוחשיות. ממצא שיערער את הנחות המוצא יהיה כי ההחלטות מונחות בעיקר על ידי שמירה על שקט וסדר ולא על ידי רצף לימודי.</a:t>
+              <a:t>‫מנהלים עשויים להציג תמונה חיובית מהמציאות, ולכן הראיון יתמקד בדוגמאות מוחשיות. ממצא שיערער את הנחות המוצא יהיה כי ההחלטות מונחות בעיקר על ידי שמירה על שקט וסדר ולא על ידי רצף לימודי.‬</a:t>
             </a:r>
             <a:endParaRPr lang="he-IL" sz="1500" dirty="0"/>
           </a:p>
@@ -3624,7 +3624,7 @@
                 <a:ea typeface="Arial" pitchFamily="34" charset="-122"/>
                 <a:cs typeface="Arial" pitchFamily="34" charset="-120"/>
               </a:rPr>
-              <a:t>כלי המחקר</a:t>
+              <a:t>‫כלי המחקר‬</a:t>
             </a:r>
             <a:endParaRPr lang="he-IL" sz="1300" dirty="0"/>
           </a:p>
@@ -3663,7 +3663,7 @@
                 <a:ea typeface="Arial" pitchFamily="34" charset="-122"/>
                 <a:cs typeface="Arial" pitchFamily="34" charset="-120"/>
               </a:rPr>
-              <a:t>הראיון החצי מובנה ושיקולים אתיים</a:t>
+              <a:t>‫הראיון החצי מובנה ושיקולים אתיים‬</a:t>
             </a:r>
             <a:endParaRPr lang="he-IL" sz="3400" dirty="0"/>
           </a:p>
@@ -3702,7 +3702,7 @@
                 <a:ea typeface="Arial" pitchFamily="34" charset="-122"/>
                 <a:cs typeface="Arial" pitchFamily="34" charset="-120"/>
               </a:rPr>
-              <a:t>מבנה הראיון</a:t>
+              <a:t>‫מבנה הראיון‬</a:t>
             </a:r>
             <a:endParaRPr lang="he-IL" sz="1500" dirty="0"/>
           </a:p>
@@ -3744,7 +3744,7 @@
                 <a:ea typeface="Arial" pitchFamily="34" charset="-122"/>
                 <a:cs typeface="Arial" pitchFamily="34" charset="-120"/>
               </a:rPr>
-              <a:t>הראיון ייפתח בשאלות רקע על בית הספר, על הצוות ועל דרכו של המנהל לתפקיד, כדי ליצור אמון ולהבין את ההקשר. בהמשך יתבקשו המנהלים לתאר את הבוקר האחרון שבו מורה נעדר, צעד אחר צעד, לספר על היעדרות ממושכת ולפרט את השיקולים שהנחו את בחירת המחליף. כך ניתן יהיה ללמוד על דילמות ועל שיקולים ולא רק על נהלים כתובים.</a:t>
+              <a:t>‫הראיון ייפתח בשאלות רקע על בית הספר, על הצוות ועל דרכו של המנהל לתפקיד, כדי ליצור אמון ולהבין את ההקשר. בהמשך יתבקשו המנהלים לתאר את הבוקר האחרון שבו מורה נעדר, צעד אחר צעד, לספר על היעדרות ממושכת ולפרט את השיקולים שהנחו את בחירת המחליף. כך ניתן יהיה ללמוד על דילמות ועל שיקולים ולא רק על נהלים כתובים.‬</a:t>
             </a:r>
             <a:endParaRPr lang="he-IL" sz="1600" dirty="0"/>
           </a:p>
@@ -3783,7 +3783,7 @@
                 <a:ea typeface="Arial" pitchFamily="34" charset="-122"/>
                 <a:cs typeface="Arial" pitchFamily="34" charset="-120"/>
               </a:rPr>
-              <a:t>שיקולים אתיים</a:t>
+              <a:t>‫שיקולים אתיים‬</a:t>
             </a:r>
             <a:endParaRPr lang="he-IL" sz="1500" dirty="0"/>
           </a:p>
@@ -3825,7 +3825,7 @@
                 <a:ea typeface="Arial" pitchFamily="34" charset="-122"/>
                 <a:cs typeface="Arial" pitchFamily="34" charset="-120"/>
               </a:rPr>
-              <a:t>המשתתפים יחתמו על טופס הסכמה מדעת, הראיונות יוקלטו רק באישורם, ושמות המנהלים, בתי הספר והערים לא יופיעו בעבודה.</a:t>
+              <a:t>‫המשתתפים יחתמו על טופס הסכמה מדעת, הראיונות יוקלטו רק באישורם, ושמות המנהלים, בתי הספר והערים לא יופיעו בעבודה.‬</a:t>
             </a:r>
             <a:endParaRPr lang="he-IL" sz="1600" dirty="0"/>
           </a:p>
@@ -3891,7 +3891,7 @@
                 <a:ea typeface="Arial" pitchFamily="34" charset="-122"/>
                 <a:cs typeface="Arial" pitchFamily="34" charset="-120"/>
               </a:rPr>
-              <a:t>התרומה הצפויה</a:t>
+              <a:t>‫התרומה הצפויה‬</a:t>
             </a:r>
             <a:endParaRPr lang="he-IL" sz="1500" dirty="0"/>
           </a:p>
@@ -3933,7 +3933,7 @@
                 <a:ea typeface="Arial" pitchFamily="34" charset="-122"/>
                 <a:cs typeface="Arial" pitchFamily="34" charset="-120"/>
               </a:rPr>
-              <a:t>בסיום המחקר צפויה להתקבל הבנה טובה יותר של האופן שבו מנהלים מאזנים, בזמן אמת, בין הצורך להבטיח נוכחות של מבוגר בכיתה ובין זכותם של התלמידים לרצף לימודי.</a:t>
+              <a:t>‫בסיום המחקר צפויה להתקבל הבנה טובה יותר של האופן שבו מנהלים מאזנים, בזמן אמת, בין הצורך להבטיח נוכחות של מבוגר בכיתה ובין זכותם של התלמידים לרצף לימודי.‬</a:t>
             </a:r>
             <a:endParaRPr lang="he-IL" sz="1600" dirty="0"/>
           </a:p>
@@ -4004,7 +4004,7 @@
                 <a:ea typeface="Arial" pitchFamily="34" charset="-122"/>
                 <a:cs typeface="Arial" pitchFamily="34" charset="-120"/>
               </a:rPr>
-              <a:t>רשימת מקורות</a:t>
+              <a:t>‫רשימת מקורות‬</a:t>
             </a:r>
             <a:endParaRPr lang="he-IL" sz="3400" dirty="0"/>
           </a:p>
@@ -4043,7 +4043,7 @@
                 <a:ea typeface="Arial" pitchFamily="34" charset="-122"/>
                 <a:cs typeface="Arial" pitchFamily="34" charset="-120"/>
               </a:rPr>
-              <a:t>הלוי, ל' (2026). </a:t>
+              <a:t>‫הלוי, ל' (2026). ‬</a:t>
             </a:r>
             <a:pPr algn="r" indent="0" marL="0">
               <a:buNone/>
@@ -4057,7 +4057,7 @@
                 <a:ea typeface="Arial" pitchFamily="34" charset="-122"/>
                 <a:cs typeface="Arial" pitchFamily="34" charset="-120"/>
               </a:rPr>
-              <a:t>המבוא בעבודה סמינריונית איכותנית</a:t>
+              <a:t>‫המבוא בעבודה סמינריונית איכותנית‬</a:t>
             </a:r>
             <a:pPr algn="r" indent="0" marL="0">
               <a:buNone/>
@@ -4071,7 +4071,7 @@
                 <a:ea typeface="Arial" pitchFamily="34" charset="-122"/>
                 <a:cs typeface="Arial" pitchFamily="34" charset="-120"/>
               </a:rPr>
-              <a:t> [מצגת הרצאה]. סמינריון בעבודת הניהול ובמנהל חינוך, הקריה האקדמית אונו.</a:t>
+              <a:t>‫ [מצגת הרצאה]. סמינריון בעבודת הניהול ובמנהל חינוך, הקריה האקדמית אונו.‬</a:t>
             </a:r>
             <a:endParaRPr lang="he-IL" sz="1500" dirty="0"/>
           </a:p>

</xml_diff>

<commit_message>
Expand to cover plus 5 content slides
Bring back the conceptual framework slide and split the field slide
into who/how (with ethics) and what we look for (with the closing
sentence). Timing and outline updated.

Co-Authored-By: Claude Opus 5.5 <noreply@anthropic.com>
Claude-Session: https://claude.ai/code/session_016buQrLRQHjtd4YGfeSnksc
</commit_message>
<xml_diff>
--- a/presentation/היעדרויות-מורים-מצגת-סיום.pptx
+++ b/presentation/היעדרויות-מורים-מצגת-סיום.pptx
@@ -9,9 +9,11 @@
     <p:sldId id="257" r:id="rId3"/>
     <p:sldId id="258" r:id="rId4"/>
     <p:sldId id="259" r:id="rId5"/>
+    <p:sldId id="260" r:id="rId6"/>
+    <p:sldId id="261" r:id="rId7"/>
   </p:sldIdLst>
   <p:notesMasterIdLst>
-    <p:notesMasterId r:id="rId6"/>
+    <p:notesMasterId r:id="rId8"/>
   </p:notesMasterIdLst>
   <p:sldSz cx="12192000" cy="6858000"/>
   <p:notesSz cx="6858000" cy="12192000"/>
@@ -596,7 +598,7 @@
             <a:pPr rtl="1"/>
             <a:r>
               <a:rPr lang="en-US" dirty="0"/>
-              <a:t>‫[חנון | כדקה ורבע]
+              <a:t>‫[חנון | כדקה]
 בוקר רגיל, שבע וחצי. מורה מתקשרת ומודיעה שלא תגיע היום. בתוך כמה דקות המנהל צריך להחליט מי נכנס לכיתה, מה יקרה בשיעור, ומה יהיה המחיר עבור הצוות.
 הנושא שלנו הוא היעדרויות מורים. ההיעדרות עצמה היא חלק מהחיים של כל בית ספר. מה שמעניין אותנו הוא ההחלטות שהיא מחייבת, ובמיוחד כשההיעדרויות מצטברות והמנהל צריך לשמור על רצף פדגוגי, ארגוני ורגשי.
 שאלת המחקר שלנו: כיצד מנהלי בתי ספר בערים בצפון הארץ מתארים את התמודדותם עם היעדרויות מורים, ואילו אסטרטגיות ושיקולים מנחים את החלטותיהם לשמירה על רצף לימודי?
@@ -691,7 +693,7 @@
             <a:pPr rtl="1"/>
             <a:r>
               <a:rPr lang="en-US" dirty="0"/>
-              <a:t>‫[אולפת | כדקה ושלושת רבעי]
+              <a:t>‫[אולפת | כדקה ורבע]
 מה למדנו מהספרות? מילר ואחרים וקלוטפלטר ואחרים מצאו שהיעדרויות מורים פוגעות בהישגי התלמידים, והפגיעה גדלה ככל שההיעדרויות מצטברות.
 מה שהפתיע אותנו הוא המחקר של שפירא־לישצ'ינסקי ורוזנבלט. הם מצאו שהאקלים האתי בבית הספר קשור להיקף ההיעדרויות מרצון. כלומר, המנהל משפיע על התופעה עוד לפני שהיא מתרחשת.
 ואיפה המתח? רוב המחקרים בודקים כמה מורים נעדרים, למה, ומה המחיר. בתיאוריה רצף לימודי הוא עניין פדגוגי, אבל בשבע וחצי בבוקר המנהל צריך קודם כול שמישהו יהיה בכיתה. מעט ידוע על מה שהמנהל שוקל ברגע הזה.
@@ -790,19 +792,11 @@
             <a:pPr rtl="1"/>
             <a:r>
               <a:rPr lang="en-US" dirty="0"/>
-              <a:t>‫[חנון | כדקה וחצי]
-איך נבדוק את זה? נשוחח עם 12 מנהלים ומנהלות של בתי ספר יסודיים ועל־יסודיים בערים בצפון הארץ, עם ותק שונה. בחרנו במנהלים כי הם מקבלי ההחלטות בעת היעדרות, ובחרנו בערים כדי לבחון את התופעה בהקשר אחיד ולהשוות בין ערים שונות.
-הכלי שלנו הוא ראיון חצי מובנה. נבקש מכל מנהל לתאר את הבוקר האחרון שבו מורה נעדר, צעד אחר צעד, ונשאל גם על היעדרות ממושכת. כך נשמע את השיקולים ואת הדילמות, ולא רק את הנוהל הכתוב. את הראיונות ננתח בניתוח תמטי.
-מה נחפש? אסטרטגיות מונעות לעומת מגיבות, הבדלים בין היעדרות קצרה לממושכת, ואת האיזון בין פדגוגיה, תקציב, הוגנות כלפי הצוות שמחליף, ורווחת המורה הנעדר.
-האתגר הגדול: מנהלים עלולים להציג תמונה יפה מהמציאות, ולכן נבקש דוגמאות מוחשיות. וגם לא יהיה פשוט למצוא זמן ביומן של מנהלים.
-[אולפת | כחצי דקה]
-ומה יפתיע אותנו? אם יתברר שמה שמנחה את ההחלטות הוא בעיקר השקט והסדר בבית הספר ולא הרצף הלימודי. זה יערער הנחה שלנו.
-אם המחקר שלנו יהיה מוצלח, בסופו נבין טוב יותר איך מנהלים מאזנים, בזמן אמת, בין הצורך שמישהו יהיה בכיתה לבין הזכות של התלמידים לרצף לימודי.
-תודה.
-[שאלות המשך אפשריות]
-למה רק מנהלים? כי השאלה היא על קבלת החלטות, והם אלה שמחליטים. במחקר המשך אפשר לשמוע גם את המורים המחליפים.
-למה רק ערים? כדי לבחון את התופעה בהקשר אחיד. בתי ספר בכפרים פועלים בתנאים אחרים, וזה יכול להיות כיוון למחקר המשך.
-למה ראיונות ולא שאלון? כי אנחנו רוצים להבין שיקולים ודילמות, ואלה עולים מסיפור מוחשי ולא מסימון תשובות.‬</a:t>
+              <a:t>‫[חנון | כחמישים שניות]
+כך נראית המסגרת המושגית שלנו, מימין לשמאל.
+היא מתחילה בהיעדרות מורים ועוברת אל המושג המרכזי, רצף לימודי. אנחנו מבינים את הרצף בשלושה ממדים. פדגוגי, כלומר שהתוכן והלמידה ממשיכים. ארגוני, כלומר שיבוץ, מערכת שעות, והעומס על הצוות שמחליף. ורגשי, כלומר שהתלמידים נשארים עם מבוגר מוכר ומרגישים ביטחון.
+הרצף הזה תלוי בקבלת החלטות ניהולית. המנהל שוקל צרכים מתחרים, בזמן קצר ובמשאבים מוגבלים. מתוך ההחלטות נגזרות אסטרטגיות מגיבות, כמו ממלא מקום או איחוד כיתות, ואסטרטגיות מונעות, כמו מאגר קבוע של ממלאי מקום וחומרי עבודה מוכנים מראש. את החוליה האחרונה הזאת, איך זה קורה בשטח, אנחנו רוצים לחקור.
+[מעבר לאולפת]‬</a:t>
             </a:r>
             <a:endParaRPr lang="en-US" dirty="0"/>
           </a:p>
@@ -826,6 +820,198 @@
             <a:fld id="{F7021451-1387-4CA6-816F-3879F97B5CBC}" type="slidenum">
               <a:rPr lang="en-US"/>
               <a:t>4</a:t>
+            </a:fld>
+            <a:endParaRPr lang="en-US"/>
+          </a:p>
+        </p:txBody>
+      </p:sp>
+    </p:spTree>
+    <p:extLst>
+      <p:ext uri="{BB962C8B-B14F-4D97-AF65-F5344CB8AC3E}">
+        <p14:creationId xmlns:p14="http://schemas.microsoft.com/office/powerpoint/2010/main" val="1024086991"/>
+      </p:ext>
+    </p:extLst>
+  </p:cSld>
+  <p:clrMapOvr>
+    <a:masterClrMapping/>
+  </p:clrMapOvr>
+</p:notes>
+</file>
+
+<file path=ppt/notesSlides/notesSlide5.xml><?xml version="1.0" encoding="utf-8"?>
+<p:notes xmlns:a="http://schemas.openxmlformats.org/drawingml/2006/main" xmlns:r="http://schemas.openxmlformats.org/officeDocument/2006/relationships" xmlns:p="http://schemas.openxmlformats.org/presentationml/2006/main">
+  <p:cSld>
+    <p:spTree>
+      <p:nvGrpSpPr>
+        <p:cNvPr id="1" name=""/>
+        <p:cNvGrpSpPr/>
+        <p:nvPr/>
+      </p:nvGrpSpPr>
+      <p:grpSpPr>
+        <a:xfrm>
+          <a:off x="0" y="0"/>
+          <a:ext cx="0" cy="0"/>
+          <a:chOff x="0" y="0"/>
+          <a:chExt cx="0" cy="0"/>
+        </a:xfrm>
+      </p:grpSpPr>
+      <p:sp>
+        <p:nvSpPr>
+          <p:cNvPr id="2" name="Slide Image Placeholder 1"/>
+          <p:cNvSpPr>
+            <a:spLocks noGrp="1" noRot="1" noChangeAspect="1"/>
+          </p:cNvSpPr>
+          <p:nvPr>
+            <p:ph type="sldImg"/>
+          </p:nvPr>
+        </p:nvSpPr>
+        <p:spPr/>
+      </p:sp>
+      <p:sp>
+        <p:nvSpPr>
+          <p:cNvPr id="3" name="Notes Placeholder 2"/>
+          <p:cNvSpPr>
+            <a:spLocks noGrp="1"/>
+          </p:cNvSpPr>
+          <p:nvPr>
+            <p:ph type="body" idx="1"/>
+          </p:nvPr>
+        </p:nvSpPr>
+        <p:spPr/>
+        <p:txBody>
+          <a:bodyPr/>
+          <a:lstStyle/>
+          <a:p>
+            <a:pPr rtl="1"/>
+            <a:r>
+              <a:rPr lang="en-US" dirty="0"/>
+              <a:t>‫[אולפת | כדקה]
+איך נבדוק את זה? נשוחח עם 12 מנהלים ומנהלות של בתי ספר יסודיים ועל־יסודיים בערים בצפון הארץ, עם ותק שונה. בחרנו במנהלים כי הם מקבלי ההחלטות בעת היעדרות, ובחרנו בערים כדי לבחון את התופעה בהקשר אחיד ולהשוות בין ערים שונות.
+הכלי שלנו הוא ראיון חצי מובנה. נפתח בשאלות רקע על בית הספר ועל הצוות, ואחר כך נבקש מכל מנהל לתאר את הבוקר האחרון שבו מורה נעדר, צעד אחר צעד, ולספר גם על היעדרות ממושכת. כך נשמע את השיקולים ואת הדילמות, ולא רק את הנוהל הכתוב. את הראיונות ננתח בניתוח תמטי.
+ונקפיד על אתיקה: הסכמה מדעת, הקלטה רק באישור, ואנונימיות מלאה.
+[מעבר לחנון]‬</a:t>
+            </a:r>
+            <a:endParaRPr lang="en-US" dirty="0"/>
+          </a:p>
+        </p:txBody>
+      </p:sp>
+      <p:sp>
+        <p:nvSpPr>
+          <p:cNvPr id="4" name="Slide Number Placeholder 3"/>
+          <p:cNvSpPr>
+            <a:spLocks noGrp="1"/>
+          </p:cNvSpPr>
+          <p:nvPr>
+            <p:ph type="sldNum" sz="quarter" idx="10"/>
+          </p:nvPr>
+        </p:nvSpPr>
+        <p:spPr/>
+        <p:txBody>
+          <a:bodyPr/>
+          <a:lstStyle/>
+          <a:p>
+            <a:fld id="{F7021451-1387-4CA6-816F-3879F97B5CBC}" type="slidenum">
+              <a:rPr lang="en-US"/>
+              <a:t>5</a:t>
+            </a:fld>
+            <a:endParaRPr lang="en-US"/>
+          </a:p>
+        </p:txBody>
+      </p:sp>
+    </p:spTree>
+    <p:extLst>
+      <p:ext uri="{BB962C8B-B14F-4D97-AF65-F5344CB8AC3E}">
+        <p14:creationId xmlns:p14="http://schemas.microsoft.com/office/powerpoint/2010/main" val="1024086991"/>
+      </p:ext>
+    </p:extLst>
+  </p:cSld>
+  <p:clrMapOvr>
+    <a:masterClrMapping/>
+  </p:clrMapOvr>
+</p:notes>
+</file>
+
+<file path=ppt/notesSlides/notesSlide6.xml><?xml version="1.0" encoding="utf-8"?>
+<p:notes xmlns:a="http://schemas.openxmlformats.org/drawingml/2006/main" xmlns:r="http://schemas.openxmlformats.org/officeDocument/2006/relationships" xmlns:p="http://schemas.openxmlformats.org/presentationml/2006/main">
+  <p:cSld>
+    <p:spTree>
+      <p:nvGrpSpPr>
+        <p:cNvPr id="1" name=""/>
+        <p:cNvGrpSpPr/>
+        <p:nvPr/>
+      </p:nvGrpSpPr>
+      <p:grpSpPr>
+        <a:xfrm>
+          <a:off x="0" y="0"/>
+          <a:ext cx="0" cy="0"/>
+          <a:chOff x="0" y="0"/>
+          <a:chExt cx="0" cy="0"/>
+        </a:xfrm>
+      </p:grpSpPr>
+      <p:sp>
+        <p:nvSpPr>
+          <p:cNvPr id="2" name="Slide Image Placeholder 1"/>
+          <p:cNvSpPr>
+            <a:spLocks noGrp="1" noRot="1" noChangeAspect="1"/>
+          </p:cNvSpPr>
+          <p:nvPr>
+            <p:ph type="sldImg"/>
+          </p:nvPr>
+        </p:nvSpPr>
+        <p:spPr/>
+      </p:sp>
+      <p:sp>
+        <p:nvSpPr>
+          <p:cNvPr id="3" name="Notes Placeholder 2"/>
+          <p:cNvSpPr>
+            <a:spLocks noGrp="1"/>
+          </p:cNvSpPr>
+          <p:nvPr>
+            <p:ph type="body" idx="1"/>
+          </p:nvPr>
+        </p:nvSpPr>
+        <p:spPr/>
+        <p:txBody>
+          <a:bodyPr/>
+          <a:lstStyle/>
+          <a:p>
+            <a:pPr rtl="1"/>
+            <a:r>
+              <a:rPr lang="en-US" dirty="0"/>
+              <a:t>‫[חנון | כארבעים שניות]
+מה נחפש בראיונות? אסטרטגיות מונעות לעומת מגיבות, הבדלים בין היעדרות קצרה לממושכת, ואת האיזון בין פדגוגיה, תקציב, הוגנות כלפי הצוות שמחליף, ורווחת המורה הנעדר.
+האתגר הגדול: מנהלים עלולים להציג תמונה יפה מהמציאות, ולכן נבקש דוגמאות מוחשיות. וגם לא יהיה פשוט למצוא זמן ביומן של מנהלים.
+ומה יפתיע אותנו? אם יתברר שמה שמנחה את ההחלטות הוא בעיקר השקט והסדר בבית הספר ולא הרצף הלימודי. זה יערער הנחה שלנו.
+[אולפת | כרבע דקה, משפט הסיום]
+אם המחקר שלנו יהיה מוצלח, בסופו נבין טוב יותר איך מנהלים מאזנים, בזמן אמת, בין הצורך שמישהו יהיה בכיתה לבין הזכות של התלמידים לרצף לימודי.
+תודה.
+[שאלות המשך אפשריות]
+למה רק מנהלים? כי השאלה היא על קבלת החלטות, והם אלה שמחליטים. במחקר המשך אפשר לשמוע גם את המורים המחליפים.
+למה רק ערים? כדי לבחון את התופעה בהקשר אחיד. בתי ספר בכפרים פועלים בתנאים אחרים, וזה יכול להיות כיוון למחקר המשך.
+למה ראיונות ולא שאלון? כי אנחנו רוצים להבין שיקולים ודילמות, ואלה עולים מסיפור מוחשי ולא מסימון תשובות.‬</a:t>
+            </a:r>
+            <a:endParaRPr lang="en-US" dirty="0"/>
+          </a:p>
+        </p:txBody>
+      </p:sp>
+      <p:sp>
+        <p:nvSpPr>
+          <p:cNvPr id="4" name="Slide Number Placeholder 3"/>
+          <p:cNvSpPr>
+            <a:spLocks noGrp="1"/>
+          </p:cNvSpPr>
+          <p:nvPr>
+            <p:ph type="sldNum" sz="quarter" idx="10"/>
+          </p:nvPr>
+        </p:nvSpPr>
+        <p:spPr/>
+        <p:txBody>
+          <a:bodyPr/>
+          <a:lstStyle/>
+          <a:p>
+            <a:fld id="{F7021451-1387-4CA6-816F-3879F97B5CBC}" type="slidenum">
+              <a:rPr lang="en-US"/>
+              <a:t>6</a:t>
             </a:fld>
             <a:endParaRPr lang="en-US"/>
           </a:p>
@@ -2314,7 +2500,7 @@
                 <a:ea typeface="Arial" pitchFamily="34" charset="-122"/>
                 <a:cs typeface="Arial" pitchFamily="34" charset="-120"/>
               </a:rPr>
-              <a:t>‫יוצאים לשטח‬</a:t>
+              <a:t>‫מסגרת מושגית‬</a:t>
             </a:r>
             <a:endParaRPr lang="he-IL" sz="1300" dirty="0"/>
           </a:p>
@@ -2353,7 +2539,7 @@
                 <a:ea typeface="Arial" pitchFamily="34" charset="-122"/>
                 <a:cs typeface="Arial" pitchFamily="34" charset="-120"/>
               </a:rPr>
-              <a:t>‫מחקר איכותני בקרב 12 מנהלי בתי ספר‬</a:t>
+              <a:t>‫המושגים המרכזיים והקשרים ביניהם‬</a:t>
             </a:r>
             <a:endParaRPr lang="he-IL" sz="3400" dirty="0"/>
           </a:p>
@@ -2361,423 +2547,285 @@
       </p:sp>
       <p:sp>
         <p:nvSpPr>
-          <p:cNvPr id="4" name="Text 2"/>
-          <p:cNvSpPr txBox="1"/>
-          <p:nvPr/>
-        </p:nvSpPr>
-        <p:spPr>
-          <a:xfrm>
-            <a:off x="6263640" y="1737360"/>
-            <a:ext cx="5376672" cy="320040"/>
-          </a:xfrm>
-          <a:prstGeom prst="rect">
-            <a:avLst/>
-          </a:prstGeom>
-          <a:noFill/>
-          <a:ln/>
-        </p:spPr>
-        <p:txBody>
-          <a:bodyPr wrap="square" lIns="0" tIns="0" rIns="0" bIns="0" rtlCol="0" anchor="t"/>
-          <a:lstStyle/>
-          <a:p>
-            <a:pPr algn="r" indent="0" marL="0" rtl="1">
-              <a:buNone/>
-            </a:pPr>
-            <a:r>
-              <a:rPr lang="he-IL" altLang="en-US" sz="1500" b="1" dirty="0">
-                <a:solidFill>
-                  <a:srgbClr val="4E7A1E"/>
-                </a:solidFill>
-                <a:latin typeface="Arial" pitchFamily="34" charset="0"/>
-                <a:ea typeface="Arial" pitchFamily="34" charset="-122"/>
-                <a:cs typeface="Arial" pitchFamily="34" charset="-120"/>
-              </a:rPr>
-              <a:t>‫את מי נחקור‬</a:t>
-            </a:r>
-            <a:endParaRPr lang="he-IL" sz="1500" dirty="0"/>
-          </a:p>
-        </p:txBody>
-      </p:sp>
-      <p:sp>
-        <p:nvSpPr>
-          <p:cNvPr id="5" name="Text 3"/>
-          <p:cNvSpPr txBox="1"/>
-          <p:nvPr/>
-        </p:nvSpPr>
-        <p:spPr>
-          <a:xfrm>
-            <a:off x="6263640" y="2103120"/>
-            <a:ext cx="5376672" cy="1005840"/>
-          </a:xfrm>
-          <a:prstGeom prst="rect">
-            <a:avLst/>
-          </a:prstGeom>
-          <a:noFill/>
-          <a:ln/>
-        </p:spPr>
-        <p:txBody>
-          <a:bodyPr wrap="square" lIns="0" tIns="0" rIns="0" bIns="0" rtlCol="0" anchor="t"/>
-          <a:lstStyle/>
-          <a:p>
-            <a:pPr algn="r" indent="0" marL="0" rtl="1">
-              <a:lnSpc>
-                <a:spcPct val="115000"/>
-              </a:lnSpc>
-              <a:buNone/>
-            </a:pPr>
-            <a:r>
-              <a:rPr lang="he-IL" altLang="en-US" sz="1350" dirty="0">
-                <a:solidFill>
-                  <a:srgbClr val="1B2B2E"/>
-                </a:solidFill>
-                <a:latin typeface="Arial" pitchFamily="34" charset="0"/>
-                <a:ea typeface="Arial" pitchFamily="34" charset="-122"/>
-                <a:cs typeface="Arial" pitchFamily="34" charset="-120"/>
-              </a:rPr>
-              <a:t>‫12 מנהלים ומנהלות של בתי ספר יסודיים ועל־יסודיים בערים בצפון הארץ, בעלי ותק שונה. המנהלים הם מקבלי ההחלטות בעת היעדרות, וההתמקדות בערים מאפשרת לבחון את התופעה בהקשר אחיד.‬</a:t>
-            </a:r>
-            <a:endParaRPr lang="he-IL" sz="1350" dirty="0"/>
-          </a:p>
-        </p:txBody>
-      </p:sp>
-      <p:sp>
-        <p:nvSpPr>
-          <p:cNvPr id="6" name="Text 4"/>
-          <p:cNvSpPr txBox="1"/>
-          <p:nvPr/>
-        </p:nvSpPr>
-        <p:spPr>
-          <a:xfrm>
-            <a:off x="6263640" y="3017520"/>
-            <a:ext cx="5376672" cy="320040"/>
-          </a:xfrm>
-          <a:prstGeom prst="rect">
-            <a:avLst/>
-          </a:prstGeom>
-          <a:noFill/>
-          <a:ln/>
-        </p:spPr>
-        <p:txBody>
-          <a:bodyPr wrap="square" lIns="0" tIns="0" rIns="0" bIns="0" rtlCol="0" anchor="t"/>
-          <a:lstStyle/>
-          <a:p>
-            <a:pPr algn="r" indent="0" marL="0" rtl="1">
-              <a:buNone/>
-            </a:pPr>
-            <a:r>
-              <a:rPr lang="he-IL" altLang="en-US" sz="1500" b="1" dirty="0">
-                <a:solidFill>
-                  <a:srgbClr val="4E7A1E"/>
-                </a:solidFill>
-                <a:latin typeface="Arial" pitchFamily="34" charset="0"/>
-                <a:ea typeface="Arial" pitchFamily="34" charset="-122"/>
-                <a:cs typeface="Arial" pitchFamily="34" charset="-120"/>
-              </a:rPr>
-              <a:t>‫איך נחקור‬</a:t>
-            </a:r>
-            <a:endParaRPr lang="he-IL" sz="1500" dirty="0"/>
-          </a:p>
-        </p:txBody>
-      </p:sp>
-      <p:sp>
-        <p:nvSpPr>
-          <p:cNvPr id="7" name="Text 5"/>
-          <p:cNvSpPr txBox="1"/>
-          <p:nvPr/>
-        </p:nvSpPr>
-        <p:spPr>
-          <a:xfrm>
-            <a:off x="6263640" y="3383280"/>
-            <a:ext cx="5376672" cy="1188720"/>
-          </a:xfrm>
-          <a:prstGeom prst="rect">
-            <a:avLst/>
-          </a:prstGeom>
-          <a:noFill/>
-          <a:ln/>
-        </p:spPr>
-        <p:txBody>
-          <a:bodyPr wrap="square" lIns="0" tIns="0" rIns="0" bIns="0" rtlCol="0" anchor="t"/>
-          <a:lstStyle/>
-          <a:p>
-            <a:pPr algn="r" indent="0" marL="0" rtl="1">
-              <a:lnSpc>
-                <a:spcPct val="115000"/>
-              </a:lnSpc>
-              <a:buNone/>
-            </a:pPr>
-            <a:r>
-              <a:rPr lang="he-IL" altLang="en-US" sz="1350" dirty="0">
-                <a:solidFill>
-                  <a:srgbClr val="1B2B2E"/>
-                </a:solidFill>
-                <a:latin typeface="Arial" pitchFamily="34" charset="0"/>
-                <a:ea typeface="Arial" pitchFamily="34" charset="-122"/>
-                <a:cs typeface="Arial" pitchFamily="34" charset="-120"/>
-              </a:rPr>
-              <a:t>‫ראיון חצי מובנה שבו כל מנהל יתאר את הבוקר האחרון שבו מורה נעדר, צעד אחר צעד, וכן היעדרות ממושכת. הראיון מאפשר ללמוד על שיקולים ודילמות ולא רק על נהלים כתובים, והנתונים ינותחו בניתוח תמטי.‬</a:t>
-            </a:r>
-            <a:endParaRPr lang="he-IL" sz="1350" dirty="0"/>
-          </a:p>
-        </p:txBody>
-      </p:sp>
-      <p:sp>
-        <p:nvSpPr>
-          <p:cNvPr id="8" name="Text 6"/>
-          <p:cNvSpPr txBox="1"/>
-          <p:nvPr/>
-        </p:nvSpPr>
-        <p:spPr>
-          <a:xfrm>
-            <a:off x="548640" y="1737360"/>
-            <a:ext cx="5376672" cy="320040"/>
-          </a:xfrm>
-          <a:prstGeom prst="rect">
-            <a:avLst/>
-          </a:prstGeom>
-          <a:noFill/>
-          <a:ln/>
-        </p:spPr>
-        <p:txBody>
-          <a:bodyPr wrap="square" lIns="0" tIns="0" rIns="0" bIns="0" rtlCol="0" anchor="t"/>
-          <a:lstStyle/>
-          <a:p>
-            <a:pPr algn="r" indent="0" marL="0" rtl="1">
-              <a:buNone/>
-            </a:pPr>
-            <a:r>
-              <a:rPr lang="he-IL" altLang="en-US" sz="1500" b="1" dirty="0">
-                <a:solidFill>
-                  <a:srgbClr val="4E7A1E"/>
-                </a:solidFill>
-                <a:latin typeface="Arial" pitchFamily="34" charset="0"/>
-                <a:ea typeface="Arial" pitchFamily="34" charset="-122"/>
-                <a:cs typeface="Arial" pitchFamily="34" charset="-120"/>
-              </a:rPr>
-              <a:t>‫מה אנחנו מחפשים‬</a:t>
-            </a:r>
-            <a:endParaRPr lang="he-IL" sz="1500" dirty="0"/>
-          </a:p>
-        </p:txBody>
-      </p:sp>
-      <p:sp>
-        <p:nvSpPr>
-          <p:cNvPr id="9" name="Text 7"/>
-          <p:cNvSpPr txBox="1"/>
-          <p:nvPr/>
-        </p:nvSpPr>
-        <p:spPr>
-          <a:xfrm>
-            <a:off x="548640" y="2103120"/>
-            <a:ext cx="5376672" cy="868680"/>
-          </a:xfrm>
-          <a:prstGeom prst="rect">
-            <a:avLst/>
-          </a:prstGeom>
-          <a:noFill/>
-          <a:ln/>
-        </p:spPr>
-        <p:txBody>
-          <a:bodyPr wrap="square" lIns="0" tIns="0" rIns="0" bIns="0" rtlCol="0" anchor="t"/>
-          <a:lstStyle/>
-          <a:p>
-            <a:pPr algn="r" indent="0" marL="0" rtl="1">
-              <a:lnSpc>
-                <a:spcPct val="115000"/>
-              </a:lnSpc>
-              <a:buNone/>
-            </a:pPr>
-            <a:r>
-              <a:rPr lang="he-IL" altLang="en-US" sz="1350" dirty="0">
-                <a:solidFill>
-                  <a:srgbClr val="1B2B2E"/>
-                </a:solidFill>
-                <a:latin typeface="Arial" pitchFamily="34" charset="0"/>
-                <a:ea typeface="Arial" pitchFamily="34" charset="-122"/>
-                <a:cs typeface="Arial" pitchFamily="34" charset="-120"/>
-              </a:rPr>
-              <a:t>‫אסטרטגיות מונעות לעומת מגיבות, הבדלים בין היעדרות קצרה לממושכת, והאיזון בין פדגוגיה, תקציב, הוגנות כלפי הצוות ורווחת המורה הנעדר.‬</a:t>
-            </a:r>
-            <a:endParaRPr lang="he-IL" sz="1350" dirty="0"/>
-          </a:p>
-        </p:txBody>
-      </p:sp>
-      <p:sp>
-        <p:nvSpPr>
-          <p:cNvPr id="10" name="Text 8"/>
-          <p:cNvSpPr txBox="1"/>
-          <p:nvPr/>
-        </p:nvSpPr>
-        <p:spPr>
-          <a:xfrm>
-            <a:off x="548640" y="2926080"/>
-            <a:ext cx="5376672" cy="320040"/>
-          </a:xfrm>
-          <a:prstGeom prst="rect">
-            <a:avLst/>
-          </a:prstGeom>
-          <a:noFill/>
-          <a:ln/>
-        </p:spPr>
-        <p:txBody>
-          <a:bodyPr wrap="square" lIns="0" tIns="0" rIns="0" bIns="0" rtlCol="0" anchor="t"/>
-          <a:lstStyle/>
-          <a:p>
-            <a:pPr algn="r" indent="0" marL="0" rtl="1">
-              <a:buNone/>
-            </a:pPr>
-            <a:r>
-              <a:rPr lang="he-IL" altLang="en-US" sz="1500" b="1" dirty="0">
-                <a:solidFill>
-                  <a:srgbClr val="4E7A1E"/>
-                </a:solidFill>
-                <a:latin typeface="Arial" pitchFamily="34" charset="0"/>
-                <a:ea typeface="Arial" pitchFamily="34" charset="-122"/>
-                <a:cs typeface="Arial" pitchFamily="34" charset="-120"/>
-              </a:rPr>
-              <a:t>‫האתגר הגדול‬</a:t>
-            </a:r>
-            <a:endParaRPr lang="he-IL" sz="1500" dirty="0"/>
-          </a:p>
-        </p:txBody>
-      </p:sp>
-      <p:sp>
-        <p:nvSpPr>
-          <p:cNvPr id="11" name="Text 9"/>
-          <p:cNvSpPr txBox="1"/>
-          <p:nvPr/>
-        </p:nvSpPr>
-        <p:spPr>
-          <a:xfrm>
-            <a:off x="548640" y="3291840"/>
-            <a:ext cx="5376672" cy="685800"/>
-          </a:xfrm>
-          <a:prstGeom prst="rect">
-            <a:avLst/>
-          </a:prstGeom>
-          <a:noFill/>
-          <a:ln/>
-        </p:spPr>
-        <p:txBody>
-          <a:bodyPr wrap="square" lIns="0" tIns="0" rIns="0" bIns="0" rtlCol="0" anchor="t"/>
-          <a:lstStyle/>
-          <a:p>
-            <a:pPr algn="r" indent="0" marL="0" rtl="1">
-              <a:lnSpc>
-                <a:spcPct val="115000"/>
-              </a:lnSpc>
-              <a:buNone/>
-            </a:pPr>
-            <a:r>
-              <a:rPr lang="he-IL" altLang="en-US" sz="1350" dirty="0">
-                <a:solidFill>
-                  <a:srgbClr val="1B2B2E"/>
-                </a:solidFill>
-                <a:latin typeface="Arial" pitchFamily="34" charset="0"/>
-                <a:ea typeface="Arial" pitchFamily="34" charset="-122"/>
-                <a:cs typeface="Arial" pitchFamily="34" charset="-120"/>
-              </a:rPr>
-              <a:t>‫מנהלים עשויים להציג תמונה חיובית מהמציאות, ולכן הראיון יתמקד בדוגמאות מוחשיות. גם תיאום זמן עם מנהלים עמוסים צפוי להיות קשה.‬</a:t>
-            </a:r>
-            <a:endParaRPr lang="he-IL" sz="1350" dirty="0"/>
-          </a:p>
-        </p:txBody>
-      </p:sp>
-      <p:sp>
-        <p:nvSpPr>
-          <p:cNvPr id="12" name="Text 10"/>
-          <p:cNvSpPr txBox="1"/>
-          <p:nvPr/>
-        </p:nvSpPr>
-        <p:spPr>
-          <a:xfrm>
-            <a:off x="548640" y="4069080"/>
-            <a:ext cx="5376672" cy="320040"/>
-          </a:xfrm>
-          <a:prstGeom prst="rect">
-            <a:avLst/>
-          </a:prstGeom>
-          <a:noFill/>
-          <a:ln/>
-        </p:spPr>
-        <p:txBody>
-          <a:bodyPr wrap="square" lIns="0" tIns="0" rIns="0" bIns="0" rtlCol="0" anchor="t"/>
-          <a:lstStyle/>
-          <a:p>
-            <a:pPr algn="r" indent="0" marL="0" rtl="1">
-              <a:buNone/>
-            </a:pPr>
-            <a:r>
-              <a:rPr lang="he-IL" altLang="en-US" sz="1500" b="1" dirty="0">
-                <a:solidFill>
-                  <a:srgbClr val="4E7A1E"/>
-                </a:solidFill>
-                <a:latin typeface="Arial" pitchFamily="34" charset="0"/>
-                <a:ea typeface="Arial" pitchFamily="34" charset="-122"/>
-                <a:cs typeface="Arial" pitchFamily="34" charset="-120"/>
-              </a:rPr>
-              <a:t>‫מה יפתיע אותנו‬</a:t>
-            </a:r>
-            <a:endParaRPr lang="he-IL" sz="1500" dirty="0"/>
-          </a:p>
-        </p:txBody>
-      </p:sp>
-      <p:sp>
-        <p:nvSpPr>
-          <p:cNvPr id="13" name="Text 11"/>
-          <p:cNvSpPr txBox="1"/>
-          <p:nvPr/>
-        </p:nvSpPr>
-        <p:spPr>
-          <a:xfrm>
-            <a:off x="548640" y="4434840"/>
-            <a:ext cx="5376672" cy="685800"/>
-          </a:xfrm>
-          <a:prstGeom prst="rect">
-            <a:avLst/>
-          </a:prstGeom>
-          <a:noFill/>
-          <a:ln/>
-        </p:spPr>
-        <p:txBody>
-          <a:bodyPr wrap="square" lIns="0" tIns="0" rIns="0" bIns="0" rtlCol="0" anchor="t"/>
-          <a:lstStyle/>
-          <a:p>
-            <a:pPr algn="r" indent="0" marL="0" rtl="1">
-              <a:lnSpc>
-                <a:spcPct val="115000"/>
-              </a:lnSpc>
-              <a:buNone/>
-            </a:pPr>
-            <a:r>
-              <a:rPr lang="he-IL" altLang="en-US" sz="1350" dirty="0">
-                <a:solidFill>
-                  <a:srgbClr val="1B2B2E"/>
-                </a:solidFill>
-                <a:latin typeface="Arial" pitchFamily="34" charset="0"/>
-                <a:ea typeface="Arial" pitchFamily="34" charset="-122"/>
-                <a:cs typeface="Arial" pitchFamily="34" charset="-120"/>
-              </a:rPr>
-              <a:t>‫ממצא שלפיו ההחלטות מונחות בעיקר על ידי שמירה על שקט וסדר ולא על ידי רצף לימודי יערער את הנחת המוצא.‬</a:t>
-            </a:r>
-            <a:endParaRPr lang="he-IL" sz="1350" dirty="0"/>
-          </a:p>
-        </p:txBody>
-      </p:sp>
-      <p:sp>
-        <p:nvSpPr>
-          <p:cNvPr id="14" name="Shape 12"/>
+          <p:cNvPr id="4" name="Shape 2"/>
           <p:cNvSpPr/>
           <p:nvPr/>
         </p:nvSpPr>
         <p:spPr>
           <a:xfrm>
-            <a:off x="548640" y="5257800"/>
-            <a:ext cx="11091672" cy="1097280"/>
+            <a:off x="8778240" y="2217420"/>
+            <a:ext cx="347472" cy="0"/>
+          </a:xfrm>
+          <a:prstGeom prst="line">
+            <a:avLst/>
+          </a:prstGeom>
+          <a:noFill/>
+          <a:ln w="19050">
+            <a:solidFill>
+              <a:srgbClr val="12343B"/>
+            </a:solidFill>
+            <a:prstDash val="solid"/>
+          </a:ln>
+        </p:spPr>
+      </p:sp>
+      <p:sp>
+        <p:nvSpPr>
+          <p:cNvPr id="5" name="Shape 3"/>
+          <p:cNvSpPr/>
+          <p:nvPr/>
+        </p:nvSpPr>
+        <p:spPr>
+          <a:xfrm>
+            <a:off x="9125712" y="1783080"/>
+            <a:ext cx="2514600" cy="868680"/>
           </a:xfrm>
           <a:prstGeom prst="roundRect">
             <a:avLst>
-              <a:gd name="adj" fmla="val 10000"/>
+              <a:gd name="adj" fmla="val 12632"/>
+            </a:avLst>
+          </a:prstGeom>
+          <a:solidFill>
+            <a:srgbClr val="E4F0F0"/>
+          </a:solidFill>
+          <a:ln w="12700">
+            <a:solidFill>
+              <a:srgbClr val="E4F0F0"/>
+            </a:solidFill>
+            <a:prstDash val="solid"/>
+          </a:ln>
+        </p:spPr>
+      </p:sp>
+      <p:sp>
+        <p:nvSpPr>
+          <p:cNvPr id="6" name="Text 4"/>
+          <p:cNvSpPr txBox="1"/>
+          <p:nvPr/>
+        </p:nvSpPr>
+        <p:spPr>
+          <a:xfrm>
+            <a:off x="9217152" y="1783080"/>
+            <a:ext cx="2331720" cy="868680"/>
+          </a:xfrm>
+          <a:prstGeom prst="rect">
+            <a:avLst/>
+          </a:prstGeom>
+          <a:noFill/>
+          <a:ln/>
+        </p:spPr>
+        <p:txBody>
+          <a:bodyPr wrap="square" lIns="0" tIns="0" rIns="0" bIns="0" rtlCol="0" anchor="ctr"/>
+          <a:lstStyle/>
+          <a:p>
+            <a:pPr algn="ctr" indent="0" marL="0" rtl="1">
+              <a:buNone/>
+            </a:pPr>
+            <a:r>
+              <a:rPr lang="en-US" sz="1600" b="1" dirty="0">
+                <a:solidFill>
+                  <a:srgbClr val="12343B"/>
+                </a:solidFill>
+                <a:latin typeface="Arial" pitchFamily="34" charset="0"/>
+                <a:ea typeface="Arial" pitchFamily="34" charset="-122"/>
+                <a:cs typeface="Arial" pitchFamily="34" charset="-120"/>
+              </a:rPr>
+              <a:t>‫היעדרות מורים‬</a:t>
+            </a:r>
+            <a:endParaRPr lang="en-US" sz="1600" dirty="0"/>
+          </a:p>
+        </p:txBody>
+      </p:sp>
+      <p:sp>
+        <p:nvSpPr>
+          <p:cNvPr id="7" name="Shape 5"/>
+          <p:cNvSpPr/>
+          <p:nvPr/>
+        </p:nvSpPr>
+        <p:spPr>
+          <a:xfrm>
+            <a:off x="5916168" y="2217420"/>
+            <a:ext cx="347472" cy="0"/>
+          </a:xfrm>
+          <a:prstGeom prst="line">
+            <a:avLst/>
+          </a:prstGeom>
+          <a:noFill/>
+          <a:ln w="19050">
+            <a:solidFill>
+              <a:srgbClr val="12343B"/>
+            </a:solidFill>
+            <a:prstDash val="solid"/>
+          </a:ln>
+        </p:spPr>
+      </p:sp>
+      <p:sp>
+        <p:nvSpPr>
+          <p:cNvPr id="8" name="Shape 6"/>
+          <p:cNvSpPr/>
+          <p:nvPr/>
+        </p:nvSpPr>
+        <p:spPr>
+          <a:xfrm>
+            <a:off x="6263640" y="1783080"/>
+            <a:ext cx="2514600" cy="868680"/>
+          </a:xfrm>
+          <a:prstGeom prst="roundRect">
+            <a:avLst>
+              <a:gd name="adj" fmla="val 12632"/>
+            </a:avLst>
+          </a:prstGeom>
+          <a:solidFill>
+            <a:srgbClr val="E4F0F0"/>
+          </a:solidFill>
+          <a:ln w="12700">
+            <a:solidFill>
+              <a:srgbClr val="E4F0F0"/>
+            </a:solidFill>
+            <a:prstDash val="solid"/>
+          </a:ln>
+        </p:spPr>
+      </p:sp>
+      <p:sp>
+        <p:nvSpPr>
+          <p:cNvPr id="9" name="Text 7"/>
+          <p:cNvSpPr txBox="1"/>
+          <p:nvPr/>
+        </p:nvSpPr>
+        <p:spPr>
+          <a:xfrm>
+            <a:off x="6355080" y="1783080"/>
+            <a:ext cx="2331720" cy="868680"/>
+          </a:xfrm>
+          <a:prstGeom prst="rect">
+            <a:avLst/>
+          </a:prstGeom>
+          <a:noFill/>
+          <a:ln/>
+        </p:spPr>
+        <p:txBody>
+          <a:bodyPr wrap="square" lIns="0" tIns="0" rIns="0" bIns="0" rtlCol="0" anchor="ctr"/>
+          <a:lstStyle/>
+          <a:p>
+            <a:pPr algn="ctr" indent="0" marL="0" rtl="1">
+              <a:buNone/>
+            </a:pPr>
+            <a:r>
+              <a:rPr lang="en-US" sz="1600" b="1" dirty="0">
+                <a:solidFill>
+                  <a:srgbClr val="12343B"/>
+                </a:solidFill>
+                <a:latin typeface="Arial" pitchFamily="34" charset="0"/>
+                <a:ea typeface="Arial" pitchFamily="34" charset="-122"/>
+                <a:cs typeface="Arial" pitchFamily="34" charset="-120"/>
+              </a:rPr>
+              <a:t>‫רצף לימודי‬</a:t>
+            </a:r>
+            <a:endParaRPr lang="en-US" sz="1600" dirty="0"/>
+          </a:p>
+        </p:txBody>
+      </p:sp>
+      <p:sp>
+        <p:nvSpPr>
+          <p:cNvPr id="10" name="Shape 8"/>
+          <p:cNvSpPr/>
+          <p:nvPr/>
+        </p:nvSpPr>
+        <p:spPr>
+          <a:xfrm>
+            <a:off x="3054096" y="2217420"/>
+            <a:ext cx="347472" cy="0"/>
+          </a:xfrm>
+          <a:prstGeom prst="line">
+            <a:avLst/>
+          </a:prstGeom>
+          <a:noFill/>
+          <a:ln w="19050">
+            <a:solidFill>
+              <a:srgbClr val="12343B"/>
+            </a:solidFill>
+            <a:prstDash val="solid"/>
+          </a:ln>
+        </p:spPr>
+      </p:sp>
+      <p:sp>
+        <p:nvSpPr>
+          <p:cNvPr id="11" name="Shape 9"/>
+          <p:cNvSpPr/>
+          <p:nvPr/>
+        </p:nvSpPr>
+        <p:spPr>
+          <a:xfrm>
+            <a:off x="3401568" y="1783080"/>
+            <a:ext cx="2514600" cy="868680"/>
+          </a:xfrm>
+          <a:prstGeom prst="roundRect">
+            <a:avLst>
+              <a:gd name="adj" fmla="val 12632"/>
+            </a:avLst>
+          </a:prstGeom>
+          <a:solidFill>
+            <a:srgbClr val="E4F0F0"/>
+          </a:solidFill>
+          <a:ln w="12700">
+            <a:solidFill>
+              <a:srgbClr val="E4F0F0"/>
+            </a:solidFill>
+            <a:prstDash val="solid"/>
+          </a:ln>
+        </p:spPr>
+      </p:sp>
+      <p:sp>
+        <p:nvSpPr>
+          <p:cNvPr id="12" name="Text 10"/>
+          <p:cNvSpPr txBox="1"/>
+          <p:nvPr/>
+        </p:nvSpPr>
+        <p:spPr>
+          <a:xfrm>
+            <a:off x="3493008" y="1783080"/>
+            <a:ext cx="2331720" cy="868680"/>
+          </a:xfrm>
+          <a:prstGeom prst="rect">
+            <a:avLst/>
+          </a:prstGeom>
+          <a:noFill/>
+          <a:ln/>
+        </p:spPr>
+        <p:txBody>
+          <a:bodyPr wrap="square" lIns="0" tIns="0" rIns="0" bIns="0" rtlCol="0" anchor="ctr"/>
+          <a:lstStyle/>
+          <a:p>
+            <a:pPr algn="ctr" indent="0" marL="0" rtl="1">
+              <a:buNone/>
+            </a:pPr>
+            <a:r>
+              <a:rPr lang="en-US" sz="1600" b="1" dirty="0">
+                <a:solidFill>
+                  <a:srgbClr val="12343B"/>
+                </a:solidFill>
+                <a:latin typeface="Arial" pitchFamily="34" charset="0"/>
+                <a:ea typeface="Arial" pitchFamily="34" charset="-122"/>
+                <a:cs typeface="Arial" pitchFamily="34" charset="-120"/>
+              </a:rPr>
+              <a:t>‫קבלת החלטות ניהולית‬</a:t>
+            </a:r>
+            <a:endParaRPr lang="en-US" sz="1600" dirty="0"/>
+          </a:p>
+        </p:txBody>
+      </p:sp>
+      <p:sp>
+        <p:nvSpPr>
+          <p:cNvPr id="13" name="Shape 11"/>
+          <p:cNvSpPr/>
+          <p:nvPr/>
+        </p:nvSpPr>
+        <p:spPr>
+          <a:xfrm>
+            <a:off x="539496" y="1783080"/>
+            <a:ext cx="2514600" cy="868680"/>
+          </a:xfrm>
+          <a:prstGeom prst="roundRect">
+            <a:avLst>
+              <a:gd name="adj" fmla="val 12632"/>
             </a:avLst>
           </a:prstGeom>
           <a:solidFill>
@@ -2793,14 +2841,1070 @@
       </p:sp>
       <p:sp>
         <p:nvSpPr>
+          <p:cNvPr id="14" name="Text 12"/>
+          <p:cNvSpPr txBox="1"/>
+          <p:nvPr/>
+        </p:nvSpPr>
+        <p:spPr>
+          <a:xfrm>
+            <a:off x="630936" y="1783080"/>
+            <a:ext cx="2331720" cy="868680"/>
+          </a:xfrm>
+          <a:prstGeom prst="rect">
+            <a:avLst/>
+          </a:prstGeom>
+          <a:noFill/>
+          <a:ln/>
+        </p:spPr>
+        <p:txBody>
+          <a:bodyPr wrap="square" lIns="0" tIns="0" rIns="0" bIns="0" rtlCol="0" anchor="ctr"/>
+          <a:lstStyle/>
+          <a:p>
+            <a:pPr algn="ctr" indent="0" marL="0" rtl="1">
+              <a:buNone/>
+            </a:pPr>
+            <a:r>
+              <a:rPr lang="en-US" sz="1600" b="1" dirty="0">
+                <a:solidFill>
+                  <a:srgbClr val="FFFFFF"/>
+                </a:solidFill>
+                <a:latin typeface="Arial" pitchFamily="34" charset="0"/>
+                <a:ea typeface="Arial" pitchFamily="34" charset="-122"/>
+                <a:cs typeface="Arial" pitchFamily="34" charset="-120"/>
+              </a:rPr>
+              <a:t>‫אסטרטגיות ניהוליות‬</a:t>
+            </a:r>
+            <a:endParaRPr lang="en-US" sz="1600" dirty="0"/>
+          </a:p>
+        </p:txBody>
+      </p:sp>
+      <p:sp>
+        <p:nvSpPr>
           <p:cNvPr id="15" name="Text 13"/>
           <p:cNvSpPr txBox="1"/>
           <p:nvPr/>
         </p:nvSpPr>
         <p:spPr>
           <a:xfrm>
-            <a:off x="868680" y="5321808"/>
-            <a:ext cx="10451592" cy="960120"/>
+            <a:off x="548640" y="2971800"/>
+            <a:ext cx="11091672" cy="320040"/>
+          </a:xfrm>
+          <a:prstGeom prst="rect">
+            <a:avLst/>
+          </a:prstGeom>
+          <a:noFill/>
+          <a:ln/>
+        </p:spPr>
+        <p:txBody>
+          <a:bodyPr wrap="square" lIns="0" tIns="0" rIns="0" bIns="0" rtlCol="0" anchor="t"/>
+          <a:lstStyle/>
+          <a:p>
+            <a:pPr algn="r" indent="0" marL="0" rtl="1">
+              <a:buNone/>
+            </a:pPr>
+            <a:r>
+              <a:rPr lang="he-IL" altLang="en-US" sz="1500" b="1" dirty="0">
+                <a:solidFill>
+                  <a:srgbClr val="4E7A1E"/>
+                </a:solidFill>
+                <a:latin typeface="Arial" pitchFamily="34" charset="0"/>
+                <a:ea typeface="Arial" pitchFamily="34" charset="-122"/>
+                <a:cs typeface="Arial" pitchFamily="34" charset="-120"/>
+              </a:rPr>
+              <a:t>‫רצף לימודי‬</a:t>
+            </a:r>
+            <a:endParaRPr lang="he-IL" sz="1500" dirty="0"/>
+          </a:p>
+        </p:txBody>
+      </p:sp>
+      <p:sp>
+        <p:nvSpPr>
+          <p:cNvPr id="16" name="Text 14"/>
+          <p:cNvSpPr txBox="1"/>
+          <p:nvPr/>
+        </p:nvSpPr>
+        <p:spPr>
+          <a:xfrm>
+            <a:off x="548640" y="3337560"/>
+            <a:ext cx="11091672" cy="1234440"/>
+          </a:xfrm>
+          <a:prstGeom prst="rect">
+            <a:avLst/>
+          </a:prstGeom>
+          <a:noFill/>
+          <a:ln/>
+        </p:spPr>
+        <p:txBody>
+          <a:bodyPr wrap="square" lIns="0" tIns="0" rIns="0" bIns="0" rtlCol="0" anchor="t"/>
+          <a:lstStyle/>
+          <a:p>
+            <a:pPr algn="r" indent="0" marL="0" rtl="1">
+              <a:lnSpc>
+                <a:spcPct val="115000"/>
+              </a:lnSpc>
+              <a:buNone/>
+            </a:pPr>
+            <a:r>
+              <a:rPr lang="he-IL" altLang="en-US" sz="1600" dirty="0">
+                <a:solidFill>
+                  <a:srgbClr val="1B2B2E"/>
+                </a:solidFill>
+                <a:latin typeface="Arial" pitchFamily="34" charset="0"/>
+                <a:ea typeface="Arial" pitchFamily="34" charset="-122"/>
+                <a:cs typeface="Arial" pitchFamily="34" charset="-120"/>
+              </a:rPr>
+              <a:t>‫המסגרת נפתחת במושג היעדרות מורים ועוברת אל הרצף הלימודי, המובן כאן בשלושה ממדים. הממד הפדגוגי עוסק בהמשך התוכן והלמידה, הממד הארגוני בשיבוץ, במערכת השעות ובעומס על הצוות, והממד הרגשי ביחסים ובתחושת הביטחון של התלמידים (הלוי, 2026).‬</a:t>
+            </a:r>
+            <a:endParaRPr lang="he-IL" sz="1600" dirty="0"/>
+          </a:p>
+        </p:txBody>
+      </p:sp>
+      <p:sp>
+        <p:nvSpPr>
+          <p:cNvPr id="17" name="Text 15"/>
+          <p:cNvSpPr txBox="1"/>
+          <p:nvPr/>
+        </p:nvSpPr>
+        <p:spPr>
+          <a:xfrm>
+            <a:off x="548640" y="4572000"/>
+            <a:ext cx="11091672" cy="320040"/>
+          </a:xfrm>
+          <a:prstGeom prst="rect">
+            <a:avLst/>
+          </a:prstGeom>
+          <a:noFill/>
+          <a:ln/>
+        </p:spPr>
+        <p:txBody>
+          <a:bodyPr wrap="square" lIns="0" tIns="0" rIns="0" bIns="0" rtlCol="0" anchor="t"/>
+          <a:lstStyle/>
+          <a:p>
+            <a:pPr algn="r" indent="0" marL="0" rtl="1">
+              <a:buNone/>
+            </a:pPr>
+            <a:r>
+              <a:rPr lang="he-IL" altLang="en-US" sz="1500" b="1" dirty="0">
+                <a:solidFill>
+                  <a:srgbClr val="4E7A1E"/>
+                </a:solidFill>
+                <a:latin typeface="Arial" pitchFamily="34" charset="0"/>
+                <a:ea typeface="Arial" pitchFamily="34" charset="-122"/>
+                <a:cs typeface="Arial" pitchFamily="34" charset="-120"/>
+              </a:rPr>
+              <a:t>‫מהחלטה לאסטרטגיה‬</a:t>
+            </a:r>
+            <a:endParaRPr lang="he-IL" sz="1500" dirty="0"/>
+          </a:p>
+        </p:txBody>
+      </p:sp>
+      <p:sp>
+        <p:nvSpPr>
+          <p:cNvPr id="18" name="Text 16"/>
+          <p:cNvSpPr txBox="1"/>
+          <p:nvPr/>
+        </p:nvSpPr>
+        <p:spPr>
+          <a:xfrm>
+            <a:off x="548640" y="4937760"/>
+            <a:ext cx="11091672" cy="1234440"/>
+          </a:xfrm>
+          <a:prstGeom prst="rect">
+            <a:avLst/>
+          </a:prstGeom>
+          <a:noFill/>
+          <a:ln/>
+        </p:spPr>
+        <p:txBody>
+          <a:bodyPr wrap="square" lIns="0" tIns="0" rIns="0" bIns="0" rtlCol="0" anchor="t"/>
+          <a:lstStyle/>
+          <a:p>
+            <a:pPr algn="r" indent="0" marL="0" rtl="1">
+              <a:lnSpc>
+                <a:spcPct val="115000"/>
+              </a:lnSpc>
+              <a:buNone/>
+            </a:pPr>
+            <a:r>
+              <a:rPr lang="he-IL" altLang="en-US" sz="1600" dirty="0">
+                <a:solidFill>
+                  <a:srgbClr val="1B2B2E"/>
+                </a:solidFill>
+                <a:latin typeface="Arial" pitchFamily="34" charset="0"/>
+                <a:ea typeface="Arial" pitchFamily="34" charset="-122"/>
+                <a:cs typeface="Arial" pitchFamily="34" charset="-120"/>
+              </a:rPr>
+              <a:t>‫הרצף תלוי בקבלת החלטות ניהולית, שבה המנהל שוקל צרכים מתחרים בזמן קצר ובמשאבים מוגבלים. מההחלטות נגזרות אסטרטגיות מגיבות, כגון ממלא מקום, איחוד כיתות ושעה פרטנית, ואסטרטגיות מונעות, כגון מאגר קבוע של ממלאי מקום וחומרי עבודה שהוכנו מראש.‬</a:t>
+            </a:r>
+            <a:endParaRPr lang="he-IL" sz="1600" dirty="0"/>
+          </a:p>
+        </p:txBody>
+      </p:sp>
+    </p:spTree>
+  </p:cSld>
+  <p:clrMapOvr>
+    <a:masterClrMapping/>
+  </p:clrMapOvr>
+</p:sld>
+</file>
+
+<file path=ppt/slides/slide5.xml><?xml version="1.0" encoding="utf-8"?>
+<p:sld xmlns:a="http://schemas.openxmlformats.org/drawingml/2006/main" xmlns:r="http://schemas.openxmlformats.org/officeDocument/2006/relationships" xmlns:p="http://schemas.openxmlformats.org/presentationml/2006/main">
+  <p:cSld name="Slide 5">
+    <p:bg>
+      <p:bgPr>
+        <a:solidFill>
+          <a:srgbClr val="FFFFFF"/>
+        </a:solidFill>
+      </p:bgPr>
+    </p:bg>
+    <p:spTree>
+      <p:nvGrpSpPr>
+        <p:cNvPr id="1" name=""/>
+        <p:cNvGrpSpPr/>
+        <p:nvPr/>
+      </p:nvGrpSpPr>
+      <p:grpSpPr>
+        <a:xfrm>
+          <a:off x="0" y="0"/>
+          <a:ext cx="0" cy="0"/>
+          <a:chOff x="0" y="0"/>
+          <a:chExt cx="0" cy="0"/>
+        </a:xfrm>
+      </p:grpSpPr>
+      <p:sp>
+        <p:nvSpPr>
+          <p:cNvPr id="2" name="Text 0"/>
+          <p:cNvSpPr txBox="1"/>
+          <p:nvPr/>
+        </p:nvSpPr>
+        <p:spPr>
+          <a:xfrm>
+            <a:off x="548640" y="457200"/>
+            <a:ext cx="11091672" cy="320040"/>
+          </a:xfrm>
+          <a:prstGeom prst="rect">
+            <a:avLst/>
+          </a:prstGeom>
+          <a:noFill/>
+          <a:ln/>
+        </p:spPr>
+        <p:txBody>
+          <a:bodyPr wrap="square" lIns="0" tIns="0" rIns="0" bIns="0" rtlCol="0" anchor="t"/>
+          <a:lstStyle/>
+          <a:p>
+            <a:pPr algn="r" indent="0" marL="0" rtl="1">
+              <a:buNone/>
+            </a:pPr>
+            <a:r>
+              <a:rPr lang="he-IL" altLang="en-US" sz="1300" b="1" dirty="0">
+                <a:solidFill>
+                  <a:srgbClr val="4E7A1E"/>
+                </a:solidFill>
+                <a:latin typeface="Arial" pitchFamily="34" charset="0"/>
+                <a:ea typeface="Arial" pitchFamily="34" charset="-122"/>
+                <a:cs typeface="Arial" pitchFamily="34" charset="-120"/>
+              </a:rPr>
+              <a:t>‫יוצאים לשטח‬</a:t>
+            </a:r>
+            <a:endParaRPr lang="he-IL" sz="1300" dirty="0"/>
+          </a:p>
+        </p:txBody>
+      </p:sp>
+      <p:sp>
+        <p:nvSpPr>
+          <p:cNvPr id="3" name="Text 1"/>
+          <p:cNvSpPr txBox="1"/>
+          <p:nvPr/>
+        </p:nvSpPr>
+        <p:spPr>
+          <a:xfrm>
+            <a:off x="548640" y="822960"/>
+            <a:ext cx="11091672" cy="731520"/>
+          </a:xfrm>
+          <a:prstGeom prst="rect">
+            <a:avLst/>
+          </a:prstGeom>
+          <a:noFill/>
+          <a:ln/>
+        </p:spPr>
+        <p:txBody>
+          <a:bodyPr wrap="square" lIns="0" tIns="0" rIns="0" bIns="0" rtlCol="0" anchor="ctr"/>
+          <a:lstStyle/>
+          <a:p>
+            <a:pPr algn="r" indent="0" marL="0" rtl="1">
+              <a:buNone/>
+            </a:pPr>
+            <a:r>
+              <a:rPr lang="he-IL" altLang="en-US" sz="3400" b="1" dirty="0">
+                <a:solidFill>
+                  <a:srgbClr val="12343B"/>
+                </a:solidFill>
+                <a:latin typeface="Arial" pitchFamily="34" charset="0"/>
+                <a:ea typeface="Arial" pitchFamily="34" charset="-122"/>
+                <a:cs typeface="Arial" pitchFamily="34" charset="-120"/>
+              </a:rPr>
+              <a:t>‫את מי נחקור ואיך‬</a:t>
+            </a:r>
+            <a:endParaRPr lang="he-IL" sz="3400" dirty="0"/>
+          </a:p>
+        </p:txBody>
+      </p:sp>
+      <p:sp>
+        <p:nvSpPr>
+          <p:cNvPr id="4" name="Shape 2"/>
+          <p:cNvSpPr/>
+          <p:nvPr/>
+        </p:nvSpPr>
+        <p:spPr>
+          <a:xfrm>
+            <a:off x="548640" y="1783080"/>
+            <a:ext cx="2377440" cy="4480560"/>
+          </a:xfrm>
+          <a:prstGeom prst="roundRect">
+            <a:avLst>
+              <a:gd name="adj" fmla="val 4615"/>
+            </a:avLst>
+          </a:prstGeom>
+          <a:solidFill>
+            <a:srgbClr val="12343B"/>
+          </a:solidFill>
+          <a:ln w="12700">
+            <a:solidFill>
+              <a:srgbClr val="12343B"/>
+            </a:solidFill>
+            <a:prstDash val="solid"/>
+          </a:ln>
+        </p:spPr>
+      </p:sp>
+      <p:sp>
+        <p:nvSpPr>
+          <p:cNvPr id="5" name="Text 3"/>
+          <p:cNvSpPr txBox="1"/>
+          <p:nvPr/>
+        </p:nvSpPr>
+        <p:spPr>
+          <a:xfrm>
+            <a:off x="548640" y="2926080"/>
+            <a:ext cx="2377440" cy="1005840"/>
+          </a:xfrm>
+          <a:prstGeom prst="rect">
+            <a:avLst/>
+          </a:prstGeom>
+          <a:noFill/>
+          <a:ln/>
+        </p:spPr>
+        <p:txBody>
+          <a:bodyPr wrap="square" lIns="0" tIns="0" rIns="0" bIns="0" rtlCol="0" anchor="ctr"/>
+          <a:lstStyle/>
+          <a:p>
+            <a:pPr algn="ctr" indent="0" marL="0">
+              <a:buNone/>
+            </a:pPr>
+            <a:r>
+              <a:rPr lang="en-US" sz="6600" b="1" dirty="0">
+                <a:solidFill>
+                  <a:srgbClr val="8CC63F"/>
+                </a:solidFill>
+                <a:latin typeface="Arial" pitchFamily="34" charset="0"/>
+                <a:ea typeface="Arial" pitchFamily="34" charset="-122"/>
+                <a:cs typeface="Arial" pitchFamily="34" charset="-120"/>
+              </a:rPr>
+              <a:t>12</a:t>
+            </a:r>
+            <a:endParaRPr lang="en-US" sz="6600" dirty="0"/>
+          </a:p>
+        </p:txBody>
+      </p:sp>
+      <p:sp>
+        <p:nvSpPr>
+          <p:cNvPr id="6" name="Text 4"/>
+          <p:cNvSpPr txBox="1"/>
+          <p:nvPr/>
+        </p:nvSpPr>
+        <p:spPr>
+          <a:xfrm>
+            <a:off x="731520" y="4023360"/>
+            <a:ext cx="2011680" cy="914400"/>
+          </a:xfrm>
+          <a:prstGeom prst="rect">
+            <a:avLst/>
+          </a:prstGeom>
+          <a:noFill/>
+          <a:ln/>
+        </p:spPr>
+        <p:txBody>
+          <a:bodyPr wrap="square" lIns="0" tIns="0" rIns="0" bIns="0" rtlCol="0" anchor="t"/>
+          <a:lstStyle/>
+          <a:p>
+            <a:pPr algn="ctr" indent="0" marL="0" rtl="1">
+              <a:buNone/>
+            </a:pPr>
+            <a:r>
+              <a:rPr lang="en-US" sz="1600" b="1" dirty="0">
+                <a:solidFill>
+                  <a:srgbClr val="FFFFFF"/>
+                </a:solidFill>
+                <a:latin typeface="Arial" pitchFamily="34" charset="0"/>
+                <a:ea typeface="Arial" pitchFamily="34" charset="-122"/>
+                <a:cs typeface="Arial" pitchFamily="34" charset="-120"/>
+              </a:rPr>
+              <a:t>‫מנהלים ומנהלות‬</a:t>
+            </a:r>
+            <a:endParaRPr lang="en-US" sz="1600" dirty="0"/>
+          </a:p>
+          <a:p>
+            <a:pPr algn="ctr" indent="0" marL="0" rtl="1">
+              <a:buNone/>
+            </a:pPr>
+            <a:r>
+              <a:rPr lang="en-US" sz="1400" dirty="0">
+                <a:solidFill>
+                  <a:srgbClr val="B7D8DB"/>
+                </a:solidFill>
+                <a:latin typeface="Arial" pitchFamily="34" charset="0"/>
+                <a:ea typeface="Arial" pitchFamily="34" charset="-122"/>
+                <a:cs typeface="Arial" pitchFamily="34" charset="-120"/>
+              </a:rPr>
+              <a:t>‫בערים בצפון הארץ‬</a:t>
+            </a:r>
+            <a:endParaRPr lang="en-US" sz="1600" dirty="0"/>
+          </a:p>
+        </p:txBody>
+      </p:sp>
+      <p:sp>
+        <p:nvSpPr>
+          <p:cNvPr id="7" name="Text 5"/>
+          <p:cNvSpPr txBox="1"/>
+          <p:nvPr/>
+        </p:nvSpPr>
+        <p:spPr>
+          <a:xfrm>
+            <a:off x="3200400" y="1783080"/>
+            <a:ext cx="8439912" cy="320040"/>
+          </a:xfrm>
+          <a:prstGeom prst="rect">
+            <a:avLst/>
+          </a:prstGeom>
+          <a:noFill/>
+          <a:ln/>
+        </p:spPr>
+        <p:txBody>
+          <a:bodyPr wrap="square" lIns="0" tIns="0" rIns="0" bIns="0" rtlCol="0" anchor="t"/>
+          <a:lstStyle/>
+          <a:p>
+            <a:pPr algn="r" indent="0" marL="0" rtl="1">
+              <a:buNone/>
+            </a:pPr>
+            <a:r>
+              <a:rPr lang="he-IL" altLang="en-US" sz="1500" b="1" dirty="0">
+                <a:solidFill>
+                  <a:srgbClr val="4E7A1E"/>
+                </a:solidFill>
+                <a:latin typeface="Arial" pitchFamily="34" charset="0"/>
+                <a:ea typeface="Arial" pitchFamily="34" charset="-122"/>
+                <a:cs typeface="Arial" pitchFamily="34" charset="-120"/>
+              </a:rPr>
+              <a:t>‫את מי נחקור‬</a:t>
+            </a:r>
+            <a:endParaRPr lang="he-IL" sz="1500" dirty="0"/>
+          </a:p>
+        </p:txBody>
+      </p:sp>
+      <p:sp>
+        <p:nvSpPr>
+          <p:cNvPr id="8" name="Text 6"/>
+          <p:cNvSpPr txBox="1"/>
+          <p:nvPr/>
+        </p:nvSpPr>
+        <p:spPr>
+          <a:xfrm>
+            <a:off x="3200400" y="2148840"/>
+            <a:ext cx="8439912" cy="1005840"/>
+          </a:xfrm>
+          <a:prstGeom prst="rect">
+            <a:avLst/>
+          </a:prstGeom>
+          <a:noFill/>
+          <a:ln/>
+        </p:spPr>
+        <p:txBody>
+          <a:bodyPr wrap="square" lIns="0" tIns="0" rIns="0" bIns="0" rtlCol="0" anchor="t"/>
+          <a:lstStyle/>
+          <a:p>
+            <a:pPr algn="r" indent="0" marL="0" rtl="1">
+              <a:lnSpc>
+                <a:spcPct val="115000"/>
+              </a:lnSpc>
+              <a:buNone/>
+            </a:pPr>
+            <a:r>
+              <a:rPr lang="he-IL" altLang="en-US" sz="1500" dirty="0">
+                <a:solidFill>
+                  <a:srgbClr val="1B2B2E"/>
+                </a:solidFill>
+                <a:latin typeface="Arial" pitchFamily="34" charset="0"/>
+                <a:ea typeface="Arial" pitchFamily="34" charset="-122"/>
+                <a:cs typeface="Arial" pitchFamily="34" charset="-120"/>
+              </a:rPr>
+              <a:t>‫המחקר יתבסס על ראיונות עם 12 מנהלים ומנהלות של בתי ספר יסודיים ועל־יסודיים בערים בצפון הארץ, בעלי ותק שונה בתפקיד. המנהלים נבחרו משום שהם מקבלי ההחלטות בעת היעדרות, וההתמקדות בערים מאפשרת לבחון את התופעה בהקשר אחיד ולהשוות בין ערים שונות.‬</a:t>
+            </a:r>
+            <a:endParaRPr lang="he-IL" sz="1500" dirty="0"/>
+          </a:p>
+        </p:txBody>
+      </p:sp>
+      <p:sp>
+        <p:nvSpPr>
+          <p:cNvPr id="9" name="Text 7"/>
+          <p:cNvSpPr txBox="1"/>
+          <p:nvPr/>
+        </p:nvSpPr>
+        <p:spPr>
+          <a:xfrm>
+            <a:off x="3200400" y="3246120"/>
+            <a:ext cx="8439912" cy="320040"/>
+          </a:xfrm>
+          <a:prstGeom prst="rect">
+            <a:avLst/>
+          </a:prstGeom>
+          <a:noFill/>
+          <a:ln/>
+        </p:spPr>
+        <p:txBody>
+          <a:bodyPr wrap="square" lIns="0" tIns="0" rIns="0" bIns="0" rtlCol="0" anchor="t"/>
+          <a:lstStyle/>
+          <a:p>
+            <a:pPr algn="r" indent="0" marL="0" rtl="1">
+              <a:buNone/>
+            </a:pPr>
+            <a:r>
+              <a:rPr lang="he-IL" altLang="en-US" sz="1500" b="1" dirty="0">
+                <a:solidFill>
+                  <a:srgbClr val="4E7A1E"/>
+                </a:solidFill>
+                <a:latin typeface="Arial" pitchFamily="34" charset="0"/>
+                <a:ea typeface="Arial" pitchFamily="34" charset="-122"/>
+                <a:cs typeface="Arial" pitchFamily="34" charset="-120"/>
+              </a:rPr>
+              <a:t>‫איך נחקור‬</a:t>
+            </a:r>
+            <a:endParaRPr lang="he-IL" sz="1500" dirty="0"/>
+          </a:p>
+        </p:txBody>
+      </p:sp>
+      <p:sp>
+        <p:nvSpPr>
+          <p:cNvPr id="10" name="Text 8"/>
+          <p:cNvSpPr txBox="1"/>
+          <p:nvPr/>
+        </p:nvSpPr>
+        <p:spPr>
+          <a:xfrm>
+            <a:off x="3200400" y="3611880"/>
+            <a:ext cx="8439912" cy="1280160"/>
+          </a:xfrm>
+          <a:prstGeom prst="rect">
+            <a:avLst/>
+          </a:prstGeom>
+          <a:noFill/>
+          <a:ln/>
+        </p:spPr>
+        <p:txBody>
+          <a:bodyPr wrap="square" lIns="0" tIns="0" rIns="0" bIns="0" rtlCol="0" anchor="t"/>
+          <a:lstStyle/>
+          <a:p>
+            <a:pPr algn="r" indent="0" marL="0" rtl="1">
+              <a:lnSpc>
+                <a:spcPct val="115000"/>
+              </a:lnSpc>
+              <a:buNone/>
+            </a:pPr>
+            <a:r>
+              <a:rPr lang="he-IL" altLang="en-US" sz="1500" dirty="0">
+                <a:solidFill>
+                  <a:srgbClr val="1B2B2E"/>
+                </a:solidFill>
+                <a:latin typeface="Arial" pitchFamily="34" charset="0"/>
+                <a:ea typeface="Arial" pitchFamily="34" charset="-122"/>
+                <a:cs typeface="Arial" pitchFamily="34" charset="-120"/>
+              </a:rPr>
+              <a:t>‫הכלי המרכזי הוא ראיון חצי מובנה. הראיון ייפתח בשאלות רקע על בית הספר ועל הצוות, ובהמשך יתבקשו המנהלים לתאר את הבוקר האחרון שבו מורה נעדר, צעד אחר צעד, ולספר על היעדרות ממושכת. הראיון מאפשר ללמוד על שיקולים ודילמות ולא רק על נהלים כתובים, והנתונים ינותחו בניתוח תמטי.‬</a:t>
+            </a:r>
+            <a:endParaRPr lang="he-IL" sz="1500" dirty="0"/>
+          </a:p>
+        </p:txBody>
+      </p:sp>
+      <p:sp>
+        <p:nvSpPr>
+          <p:cNvPr id="11" name="Text 9"/>
+          <p:cNvSpPr txBox="1"/>
+          <p:nvPr/>
+        </p:nvSpPr>
+        <p:spPr>
+          <a:xfrm>
+            <a:off x="3200400" y="4709160"/>
+            <a:ext cx="8439912" cy="320040"/>
+          </a:xfrm>
+          <a:prstGeom prst="rect">
+            <a:avLst/>
+          </a:prstGeom>
+          <a:noFill/>
+          <a:ln/>
+        </p:spPr>
+        <p:txBody>
+          <a:bodyPr wrap="square" lIns="0" tIns="0" rIns="0" bIns="0" rtlCol="0" anchor="t"/>
+          <a:lstStyle/>
+          <a:p>
+            <a:pPr algn="r" indent="0" marL="0" rtl="1">
+              <a:buNone/>
+            </a:pPr>
+            <a:r>
+              <a:rPr lang="he-IL" altLang="en-US" sz="1500" b="1" dirty="0">
+                <a:solidFill>
+                  <a:srgbClr val="4E7A1E"/>
+                </a:solidFill>
+                <a:latin typeface="Arial" pitchFamily="34" charset="0"/>
+                <a:ea typeface="Arial" pitchFamily="34" charset="-122"/>
+                <a:cs typeface="Arial" pitchFamily="34" charset="-120"/>
+              </a:rPr>
+              <a:t>‫שיקולים אתיים‬</a:t>
+            </a:r>
+            <a:endParaRPr lang="he-IL" sz="1500" dirty="0"/>
+          </a:p>
+        </p:txBody>
+      </p:sp>
+      <p:sp>
+        <p:nvSpPr>
+          <p:cNvPr id="12" name="Text 10"/>
+          <p:cNvSpPr txBox="1"/>
+          <p:nvPr/>
+        </p:nvSpPr>
+        <p:spPr>
+          <a:xfrm>
+            <a:off x="3200400" y="5074920"/>
+            <a:ext cx="8439912" cy="731520"/>
+          </a:xfrm>
+          <a:prstGeom prst="rect">
+            <a:avLst/>
+          </a:prstGeom>
+          <a:noFill/>
+          <a:ln/>
+        </p:spPr>
+        <p:txBody>
+          <a:bodyPr wrap="square" lIns="0" tIns="0" rIns="0" bIns="0" rtlCol="0" anchor="t"/>
+          <a:lstStyle/>
+          <a:p>
+            <a:pPr algn="r" indent="0" marL="0" rtl="1">
+              <a:lnSpc>
+                <a:spcPct val="115000"/>
+              </a:lnSpc>
+              <a:buNone/>
+            </a:pPr>
+            <a:r>
+              <a:rPr lang="he-IL" altLang="en-US" sz="1500" dirty="0">
+                <a:solidFill>
+                  <a:srgbClr val="1B2B2E"/>
+                </a:solidFill>
+                <a:latin typeface="Arial" pitchFamily="34" charset="0"/>
+                <a:ea typeface="Arial" pitchFamily="34" charset="-122"/>
+                <a:cs typeface="Arial" pitchFamily="34" charset="-120"/>
+              </a:rPr>
+              <a:t>‫המשתתפים יחתמו על טופס הסכמה מדעת, הראיונות יוקלטו רק באישורם, ושמות המנהלים, בתי הספר והערים לא יופיעו בעבודה.‬</a:t>
+            </a:r>
+            <a:endParaRPr lang="he-IL" sz="1500" dirty="0"/>
+          </a:p>
+        </p:txBody>
+      </p:sp>
+    </p:spTree>
+  </p:cSld>
+  <p:clrMapOvr>
+    <a:masterClrMapping/>
+  </p:clrMapOvr>
+</p:sld>
+</file>
+
+<file path=ppt/slides/slide6.xml><?xml version="1.0" encoding="utf-8"?>
+<p:sld xmlns:a="http://schemas.openxmlformats.org/drawingml/2006/main" xmlns:r="http://schemas.openxmlformats.org/officeDocument/2006/relationships" xmlns:p="http://schemas.openxmlformats.org/presentationml/2006/main">
+  <p:cSld name="Slide 6">
+    <p:bg>
+      <p:bgPr>
+        <a:solidFill>
+          <a:srgbClr val="FFFFFF"/>
+        </a:solidFill>
+      </p:bgPr>
+    </p:bg>
+    <p:spTree>
+      <p:nvGrpSpPr>
+        <p:cNvPr id="1" name=""/>
+        <p:cNvGrpSpPr/>
+        <p:nvPr/>
+      </p:nvGrpSpPr>
+      <p:grpSpPr>
+        <a:xfrm>
+          <a:off x="0" y="0"/>
+          <a:ext cx="0" cy="0"/>
+          <a:chOff x="0" y="0"/>
+          <a:chExt cx="0" cy="0"/>
+        </a:xfrm>
+      </p:grpSpPr>
+      <p:sp>
+        <p:nvSpPr>
+          <p:cNvPr id="2" name="Text 0"/>
+          <p:cNvSpPr txBox="1"/>
+          <p:nvPr/>
+        </p:nvSpPr>
+        <p:spPr>
+          <a:xfrm>
+            <a:off x="548640" y="457200"/>
+            <a:ext cx="11091672" cy="320040"/>
+          </a:xfrm>
+          <a:prstGeom prst="rect">
+            <a:avLst/>
+          </a:prstGeom>
+          <a:noFill/>
+          <a:ln/>
+        </p:spPr>
+        <p:txBody>
+          <a:bodyPr wrap="square" lIns="0" tIns="0" rIns="0" bIns="0" rtlCol="0" anchor="t"/>
+          <a:lstStyle/>
+          <a:p>
+            <a:pPr algn="r" indent="0" marL="0" rtl="1">
+              <a:buNone/>
+            </a:pPr>
+            <a:r>
+              <a:rPr lang="he-IL" altLang="en-US" sz="1300" b="1" dirty="0">
+                <a:solidFill>
+                  <a:srgbClr val="4E7A1E"/>
+                </a:solidFill>
+                <a:latin typeface="Arial" pitchFamily="34" charset="0"/>
+                <a:ea typeface="Arial" pitchFamily="34" charset="-122"/>
+                <a:cs typeface="Arial" pitchFamily="34" charset="-120"/>
+              </a:rPr>
+              <a:t>‫יוצאים לשטח‬</a:t>
+            </a:r>
+            <a:endParaRPr lang="he-IL" sz="1300" dirty="0"/>
+          </a:p>
+        </p:txBody>
+      </p:sp>
+      <p:sp>
+        <p:nvSpPr>
+          <p:cNvPr id="3" name="Text 1"/>
+          <p:cNvSpPr txBox="1"/>
+          <p:nvPr/>
+        </p:nvSpPr>
+        <p:spPr>
+          <a:xfrm>
+            <a:off x="548640" y="822960"/>
+            <a:ext cx="11091672" cy="731520"/>
+          </a:xfrm>
+          <a:prstGeom prst="rect">
+            <a:avLst/>
+          </a:prstGeom>
+          <a:noFill/>
+          <a:ln/>
+        </p:spPr>
+        <p:txBody>
+          <a:bodyPr wrap="square" lIns="0" tIns="0" rIns="0" bIns="0" rtlCol="0" anchor="ctr"/>
+          <a:lstStyle/>
+          <a:p>
+            <a:pPr algn="r" indent="0" marL="0" rtl="1">
+              <a:buNone/>
+            </a:pPr>
+            <a:r>
+              <a:rPr lang="he-IL" altLang="en-US" sz="3400" b="1" dirty="0">
+                <a:solidFill>
+                  <a:srgbClr val="12343B"/>
+                </a:solidFill>
+                <a:latin typeface="Arial" pitchFamily="34" charset="0"/>
+                <a:ea typeface="Arial" pitchFamily="34" charset="-122"/>
+                <a:cs typeface="Arial" pitchFamily="34" charset="-120"/>
+              </a:rPr>
+              <a:t>‫מה נחפש ומה עלול להפתיע‬</a:t>
+            </a:r>
+            <a:endParaRPr lang="he-IL" sz="3400" dirty="0"/>
+          </a:p>
+        </p:txBody>
+      </p:sp>
+      <p:sp>
+        <p:nvSpPr>
+          <p:cNvPr id="4" name="Text 2"/>
+          <p:cNvSpPr txBox="1"/>
+          <p:nvPr/>
+        </p:nvSpPr>
+        <p:spPr>
+          <a:xfrm>
+            <a:off x="548640" y="1783080"/>
+            <a:ext cx="11091672" cy="320040"/>
+          </a:xfrm>
+          <a:prstGeom prst="rect">
+            <a:avLst/>
+          </a:prstGeom>
+          <a:noFill/>
+          <a:ln/>
+        </p:spPr>
+        <p:txBody>
+          <a:bodyPr wrap="square" lIns="0" tIns="0" rIns="0" bIns="0" rtlCol="0" anchor="t"/>
+          <a:lstStyle/>
+          <a:p>
+            <a:pPr algn="r" indent="0" marL="0" rtl="1">
+              <a:buNone/>
+            </a:pPr>
+            <a:r>
+              <a:rPr lang="he-IL" altLang="en-US" sz="1500" b="1" dirty="0">
+                <a:solidFill>
+                  <a:srgbClr val="4E7A1E"/>
+                </a:solidFill>
+                <a:latin typeface="Arial" pitchFamily="34" charset="0"/>
+                <a:ea typeface="Arial" pitchFamily="34" charset="-122"/>
+                <a:cs typeface="Arial" pitchFamily="34" charset="-120"/>
+              </a:rPr>
+              <a:t>‫מה אנחנו מחפשים‬</a:t>
+            </a:r>
+            <a:endParaRPr lang="he-IL" sz="1500" dirty="0"/>
+          </a:p>
+        </p:txBody>
+      </p:sp>
+      <p:sp>
+        <p:nvSpPr>
+          <p:cNvPr id="5" name="Text 3"/>
+          <p:cNvSpPr txBox="1"/>
+          <p:nvPr/>
+        </p:nvSpPr>
+        <p:spPr>
+          <a:xfrm>
+            <a:off x="548640" y="2148840"/>
+            <a:ext cx="11091672" cy="777240"/>
+          </a:xfrm>
+          <a:prstGeom prst="rect">
+            <a:avLst/>
+          </a:prstGeom>
+          <a:noFill/>
+          <a:ln/>
+        </p:spPr>
+        <p:txBody>
+          <a:bodyPr wrap="square" lIns="0" tIns="0" rIns="0" bIns="0" rtlCol="0" anchor="t"/>
+          <a:lstStyle/>
+          <a:p>
+            <a:pPr algn="r" indent="0" marL="0" rtl="1">
+              <a:lnSpc>
+                <a:spcPct val="115000"/>
+              </a:lnSpc>
+              <a:buNone/>
+            </a:pPr>
+            <a:r>
+              <a:rPr lang="he-IL" altLang="en-US" sz="1600" dirty="0">
+                <a:solidFill>
+                  <a:srgbClr val="1B2B2E"/>
+                </a:solidFill>
+                <a:latin typeface="Arial" pitchFamily="34" charset="0"/>
+                <a:ea typeface="Arial" pitchFamily="34" charset="-122"/>
+                <a:cs typeface="Arial" pitchFamily="34" charset="-120"/>
+              </a:rPr>
+              <a:t>‫הניתוח יתמקד באסטרטגיות מונעות לעומת מגיבות, בהבדלים בין היעדרות קצרה לממושכת ובאיזון בין שיקולים פדגוגיים, שיקולי תקציב, הוגנות כלפי הצוות ורווחת המורה הנעדר.‬</a:t>
+            </a:r>
+            <a:endParaRPr lang="he-IL" sz="1600" dirty="0"/>
+          </a:p>
+        </p:txBody>
+      </p:sp>
+      <p:sp>
+        <p:nvSpPr>
+          <p:cNvPr id="6" name="Text 4"/>
+          <p:cNvSpPr txBox="1"/>
+          <p:nvPr/>
+        </p:nvSpPr>
+        <p:spPr>
+          <a:xfrm>
+            <a:off x="548640" y="2926080"/>
+            <a:ext cx="11091672" cy="320040"/>
+          </a:xfrm>
+          <a:prstGeom prst="rect">
+            <a:avLst/>
+          </a:prstGeom>
+          <a:noFill/>
+          <a:ln/>
+        </p:spPr>
+        <p:txBody>
+          <a:bodyPr wrap="square" lIns="0" tIns="0" rIns="0" bIns="0" rtlCol="0" anchor="t"/>
+          <a:lstStyle/>
+          <a:p>
+            <a:pPr algn="r" indent="0" marL="0" rtl="1">
+              <a:buNone/>
+            </a:pPr>
+            <a:r>
+              <a:rPr lang="he-IL" altLang="en-US" sz="1500" b="1" dirty="0">
+                <a:solidFill>
+                  <a:srgbClr val="4E7A1E"/>
+                </a:solidFill>
+                <a:latin typeface="Arial" pitchFamily="34" charset="0"/>
+                <a:ea typeface="Arial" pitchFamily="34" charset="-122"/>
+                <a:cs typeface="Arial" pitchFamily="34" charset="-120"/>
+              </a:rPr>
+              <a:t>‫האתגר הגדול‬</a:t>
+            </a:r>
+            <a:endParaRPr lang="he-IL" sz="1500" dirty="0"/>
+          </a:p>
+        </p:txBody>
+      </p:sp>
+      <p:sp>
+        <p:nvSpPr>
+          <p:cNvPr id="7" name="Text 5"/>
+          <p:cNvSpPr txBox="1"/>
+          <p:nvPr/>
+        </p:nvSpPr>
+        <p:spPr>
+          <a:xfrm>
+            <a:off x="548640" y="3291840"/>
+            <a:ext cx="11091672" cy="548640"/>
+          </a:xfrm>
+          <a:prstGeom prst="rect">
+            <a:avLst/>
+          </a:prstGeom>
+          <a:noFill/>
+          <a:ln/>
+        </p:spPr>
+        <p:txBody>
+          <a:bodyPr wrap="square" lIns="0" tIns="0" rIns="0" bIns="0" rtlCol="0" anchor="t"/>
+          <a:lstStyle/>
+          <a:p>
+            <a:pPr algn="r" indent="0" marL="0" rtl="1">
+              <a:lnSpc>
+                <a:spcPct val="115000"/>
+              </a:lnSpc>
+              <a:buNone/>
+            </a:pPr>
+            <a:r>
+              <a:rPr lang="he-IL" altLang="en-US" sz="1600" dirty="0">
+                <a:solidFill>
+                  <a:srgbClr val="1B2B2E"/>
+                </a:solidFill>
+                <a:latin typeface="Arial" pitchFamily="34" charset="0"/>
+                <a:ea typeface="Arial" pitchFamily="34" charset="-122"/>
+                <a:cs typeface="Arial" pitchFamily="34" charset="-120"/>
+              </a:rPr>
+              <a:t>‫מנהלים עשויים להציג תמונה חיובית מהמציאות, ולכן יתבקשו דוגמאות מוחשיות. גם תיאום זמן עם מנהלים עמוסים צפוי להיות קשה.‬</a:t>
+            </a:r>
+            <a:endParaRPr lang="he-IL" sz="1600" dirty="0"/>
+          </a:p>
+        </p:txBody>
+      </p:sp>
+      <p:sp>
+        <p:nvSpPr>
+          <p:cNvPr id="8" name="Text 6"/>
+          <p:cNvSpPr txBox="1"/>
+          <p:nvPr/>
+        </p:nvSpPr>
+        <p:spPr>
+          <a:xfrm>
+            <a:off x="548640" y="3931920"/>
+            <a:ext cx="11091672" cy="320040"/>
+          </a:xfrm>
+          <a:prstGeom prst="rect">
+            <a:avLst/>
+          </a:prstGeom>
+          <a:noFill/>
+          <a:ln/>
+        </p:spPr>
+        <p:txBody>
+          <a:bodyPr wrap="square" lIns="0" tIns="0" rIns="0" bIns="0" rtlCol="0" anchor="t"/>
+          <a:lstStyle/>
+          <a:p>
+            <a:pPr algn="r" indent="0" marL="0" rtl="1">
+              <a:buNone/>
+            </a:pPr>
+            <a:r>
+              <a:rPr lang="he-IL" altLang="en-US" sz="1500" b="1" dirty="0">
+                <a:solidFill>
+                  <a:srgbClr val="4E7A1E"/>
+                </a:solidFill>
+                <a:latin typeface="Arial" pitchFamily="34" charset="0"/>
+                <a:ea typeface="Arial" pitchFamily="34" charset="-122"/>
+                <a:cs typeface="Arial" pitchFamily="34" charset="-120"/>
+              </a:rPr>
+              <a:t>‫מה יפתיע אותנו‬</a:t>
+            </a:r>
+            <a:endParaRPr lang="he-IL" sz="1500" dirty="0"/>
+          </a:p>
+        </p:txBody>
+      </p:sp>
+      <p:sp>
+        <p:nvSpPr>
+          <p:cNvPr id="9" name="Text 7"/>
+          <p:cNvSpPr txBox="1"/>
+          <p:nvPr/>
+        </p:nvSpPr>
+        <p:spPr>
+          <a:xfrm>
+            <a:off x="548640" y="4297680"/>
+            <a:ext cx="11091672" cy="457200"/>
+          </a:xfrm>
+          <a:prstGeom prst="rect">
+            <a:avLst/>
+          </a:prstGeom>
+          <a:noFill/>
+          <a:ln/>
+        </p:spPr>
+        <p:txBody>
+          <a:bodyPr wrap="square" lIns="0" tIns="0" rIns="0" bIns="0" rtlCol="0" anchor="t"/>
+          <a:lstStyle/>
+          <a:p>
+            <a:pPr algn="r" indent="0" marL="0" rtl="1">
+              <a:lnSpc>
+                <a:spcPct val="115000"/>
+              </a:lnSpc>
+              <a:buNone/>
+            </a:pPr>
+            <a:r>
+              <a:rPr lang="he-IL" altLang="en-US" sz="1600" dirty="0">
+                <a:solidFill>
+                  <a:srgbClr val="1B2B2E"/>
+                </a:solidFill>
+                <a:latin typeface="Arial" pitchFamily="34" charset="0"/>
+                <a:ea typeface="Arial" pitchFamily="34" charset="-122"/>
+                <a:cs typeface="Arial" pitchFamily="34" charset="-120"/>
+              </a:rPr>
+              <a:t>‫ממצא שלפיו ההחלטות מונחות בעיקר על ידי שמירה על שקט וסדר ולא על ידי רצף לימודי יערער את הנחת המוצא.‬</a:t>
+            </a:r>
+            <a:endParaRPr lang="he-IL" sz="1600" dirty="0"/>
+          </a:p>
+        </p:txBody>
+      </p:sp>
+      <p:sp>
+        <p:nvSpPr>
+          <p:cNvPr id="10" name="Shape 8"/>
+          <p:cNvSpPr/>
+          <p:nvPr/>
+        </p:nvSpPr>
+        <p:spPr>
+          <a:xfrm>
+            <a:off x="548640" y="5074920"/>
+            <a:ext cx="11091672" cy="1188720"/>
+          </a:xfrm>
+          <a:prstGeom prst="roundRect">
+            <a:avLst>
+              <a:gd name="adj" fmla="val 9231"/>
+            </a:avLst>
+          </a:prstGeom>
+          <a:solidFill>
+            <a:srgbClr val="12343B"/>
+          </a:solidFill>
+          <a:ln w="12700">
+            <a:solidFill>
+              <a:srgbClr val="12343B"/>
+            </a:solidFill>
+            <a:prstDash val="solid"/>
+          </a:ln>
+        </p:spPr>
+      </p:sp>
+      <p:sp>
+        <p:nvSpPr>
+          <p:cNvPr id="11" name="Text 9"/>
+          <p:cNvSpPr txBox="1"/>
+          <p:nvPr/>
+        </p:nvSpPr>
+        <p:spPr>
+          <a:xfrm>
+            <a:off x="868680" y="5166360"/>
+            <a:ext cx="10451592" cy="1005840"/>
           </a:xfrm>
           <a:prstGeom prst="rect">
             <a:avLst/>
@@ -2819,7 +3923,7 @@
               <a:buNone/>
             </a:pPr>
             <a:r>
-              <a:rPr lang="he-IL" altLang="en-US" sz="1700" b="1" dirty="0">
+              <a:rPr lang="he-IL" altLang="en-US" sz="1800" b="1" dirty="0">
                 <a:solidFill>
                   <a:srgbClr val="8CC63F"/>
                 </a:solidFill>
@@ -2836,7 +3940,7 @@
               <a:buNone/>
             </a:pPr>
             <a:r>
-              <a:rPr lang="he-IL" altLang="en-US" sz="1700" dirty="0">
+              <a:rPr lang="he-IL" altLang="en-US" sz="1800" dirty="0">
                 <a:solidFill>
                   <a:srgbClr val="FFFFFF"/>
                 </a:solidFill>
@@ -2846,7 +3950,7 @@
               </a:rPr>
               <a:t>‫את האופן שבו מנהלים מאזנים, בזמן אמת, בין הצורך להבטיח נוכחות של מבוגר בכיתה ובין זכותם של התלמידים לרצף לימודי.‬</a:t>
             </a:r>
-            <a:endParaRPr lang="he-IL" sz="1700" dirty="0"/>
+            <a:endParaRPr lang="he-IL" sz="1800" dirty="0"/>
           </a:p>
         </p:txBody>
       </p:sp>

</xml_diff>

<commit_message>
Add blank ID fields next to presenters on cover slide
Co-Authored-By: Claude Opus 5.5 <noreply@anthropic.com>
Claude-Session: https://claude.ai/code/session_016buQrLRQHjtd4YGfeSnksc
</commit_message>
<xml_diff>
--- a/presentation/היעדרויות-מורים-מצגת-סיום.pptx
+++ b/presentation/היעדרויות-מורים-מצגת-סיום.pptx
@@ -1537,8 +1537,8 @@
         </p:nvSpPr>
         <p:spPr>
           <a:xfrm>
-            <a:off x="6309360" y="5120640"/>
-            <a:ext cx="3383280" cy="960120"/>
+            <a:off x="5257800" y="5120640"/>
+            <a:ext cx="4572000" cy="960120"/>
           </a:xfrm>
           <a:prstGeom prst="rect">
             <a:avLst/>
@@ -1567,7 +1567,7 @@
             <a:endParaRPr lang="en-US" sz="1500" dirty="0"/>
           </a:p>
           <a:p>
-            <a:pPr algn="ctr" indent="0" marL="0" rtl="1">
+            <a:pPr algn="ctr" indent="0" marL="0">
               <a:buNone/>
             </a:pPr>
             <a:r>
@@ -1579,12 +1579,85 @@
                 <a:ea typeface="Arial" pitchFamily="34" charset="-122"/>
                 <a:cs typeface="Arial" pitchFamily="34" charset="-120"/>
               </a:rPr>
+              <a:t> </a:t>
+            </a:r>
+            <a:endParaRPr lang="en-US" sz="1500" dirty="0"/>
+          </a:p>
+          <a:p>
+            <a:pPr algn="ctr" indent="0" marL="0">
+              <a:buNone/>
+            </a:pPr>
+            <a:r>
+              <a:rPr lang="en-US" sz="1500" dirty="0">
+                <a:solidFill>
+                  <a:srgbClr val="1B2B2E"/>
+                </a:solidFill>
+                <a:latin typeface="Arial" pitchFamily="34" charset="0"/>
+                <a:ea typeface="Arial" pitchFamily="34" charset="-122"/>
+                <a:cs typeface="Arial" pitchFamily="34" charset="-120"/>
+              </a:rPr>
+              <a:t> </a:t>
+            </a:r>
+            <a:endParaRPr lang="en-US" sz="1500" dirty="0"/>
+          </a:p>
+        </p:txBody>
+      </p:sp>
+      <p:sp>
+        <p:nvSpPr>
+          <p:cNvPr id="8" name="Text 5"/>
+          <p:cNvSpPr txBox="1"/>
+          <p:nvPr/>
+        </p:nvSpPr>
+        <p:spPr>
+          <a:xfrm>
+            <a:off x="8001000" y="5120640"/>
+            <a:ext cx="1691640" cy="960120"/>
+          </a:xfrm>
+          <a:prstGeom prst="rect">
+            <a:avLst/>
+          </a:prstGeom>
+          <a:noFill/>
+          <a:ln/>
+        </p:spPr>
+        <p:txBody>
+          <a:bodyPr wrap="square" lIns="0" tIns="0" rIns="0" bIns="0" rtlCol="0" anchor="ctr"/>
+          <a:lstStyle/>
+          <a:p>
+            <a:pPr algn="r" indent="0" marL="0">
+              <a:buNone/>
+            </a:pPr>
+            <a:r>
+              <a:rPr lang="en-US" sz="1500" dirty="0">
+                <a:solidFill>
+                  <a:srgbClr val="1B2B2E"/>
+                </a:solidFill>
+                <a:latin typeface="Arial" pitchFamily="34" charset="0"/>
+                <a:ea typeface="Arial" pitchFamily="34" charset="-122"/>
+                <a:cs typeface="Arial" pitchFamily="34" charset="-120"/>
+              </a:rPr>
+              <a:t> </a:t>
+            </a:r>
+            <a:endParaRPr lang="en-US" sz="1500" dirty="0"/>
+          </a:p>
+          <a:p>
+            <a:pPr algn="r" indent="0" marL="0" rtl="1">
+              <a:buNone/>
+            </a:pPr>
+            <a:r>
+              <a:rPr lang="en-US" sz="1500" dirty="0">
+                <a:solidFill>
+                  <a:srgbClr val="1B2B2E"/>
+                </a:solidFill>
+                <a:latin typeface="Arial" pitchFamily="34" charset="0"/>
+                <a:ea typeface="Arial" pitchFamily="34" charset="-122"/>
+                <a:cs typeface="Arial" pitchFamily="34" charset="-120"/>
+              </a:rPr>
               <a:t>‫חנון מנסור‬</a:t>
             </a:r>
             <a:endParaRPr lang="en-US" sz="1500" dirty="0"/>
           </a:p>
           <a:p>
-            <a:pPr algn="ctr" indent="0" marL="0" rtl="1">
+            <a:pPr algn="r" indent="0" marL="0" rtl="1">
               <a:buNone/>
             </a:pPr>
             <a:r>
@@ -1604,14 +1677,87 @@
       </p:sp>
       <p:sp>
         <p:nvSpPr>
-          <p:cNvPr id="8" name="Text 5"/>
-          <p:cNvSpPr txBox="1"/>
-          <p:nvPr/>
-        </p:nvSpPr>
-        <p:spPr>
-          <a:xfrm>
-            <a:off x="2496312" y="5120640"/>
-            <a:ext cx="3383280" cy="960120"/>
+          <p:cNvPr id="9" name="Text 6"/>
+          <p:cNvSpPr txBox="1"/>
+          <p:nvPr/>
+        </p:nvSpPr>
+        <p:spPr>
+          <a:xfrm>
+            <a:off x="5852160" y="5120640"/>
+            <a:ext cx="2011680" cy="960120"/>
+          </a:xfrm>
+          <a:prstGeom prst="rect">
+            <a:avLst/>
+          </a:prstGeom>
+          <a:noFill/>
+          <a:ln/>
+        </p:spPr>
+        <p:txBody>
+          <a:bodyPr wrap="square" lIns="0" tIns="0" rIns="0" bIns="0" rtlCol="0" anchor="ctr"/>
+          <a:lstStyle/>
+          <a:p>
+            <a:pPr algn="r" indent="0" marL="0">
+              <a:buNone/>
+            </a:pPr>
+            <a:r>
+              <a:rPr lang="en-US" sz="1500" dirty="0">
+                <a:solidFill>
+                  <a:srgbClr val="1B2B2E"/>
+                </a:solidFill>
+                <a:latin typeface="Arial" pitchFamily="34" charset="0"/>
+                <a:ea typeface="Arial" pitchFamily="34" charset="-122"/>
+                <a:cs typeface="Arial" pitchFamily="34" charset="-120"/>
+              </a:rPr>
+              <a:t> </a:t>
+            </a:r>
+            <a:endParaRPr lang="en-US" sz="1500" dirty="0"/>
+          </a:p>
+          <a:p>
+            <a:pPr algn="r" indent="0" marL="0" rtl="1">
+              <a:buNone/>
+            </a:pPr>
+            <a:r>
+              <a:rPr lang="en-US" sz="1500" dirty="0">
+                <a:solidFill>
+                  <a:srgbClr val="1B2B2E"/>
+                </a:solidFill>
+                <a:latin typeface="Arial" pitchFamily="34" charset="0"/>
+                <a:ea typeface="Arial" pitchFamily="34" charset="-122"/>
+                <a:cs typeface="Arial" pitchFamily="34" charset="-120"/>
+              </a:rPr>
+              <a:t>‫ת.ז. ______________‬</a:t>
+            </a:r>
+            <a:endParaRPr lang="en-US" sz="1500" dirty="0"/>
+          </a:p>
+          <a:p>
+            <a:pPr algn="r" indent="0" marL="0" rtl="1">
+              <a:buNone/>
+            </a:pPr>
+            <a:r>
+              <a:rPr lang="en-US" sz="1500" dirty="0">
+                <a:solidFill>
+                  <a:srgbClr val="1B2B2E"/>
+                </a:solidFill>
+                <a:latin typeface="Arial" pitchFamily="34" charset="0"/>
+                <a:ea typeface="Arial" pitchFamily="34" charset="-122"/>
+                <a:cs typeface="Arial" pitchFamily="34" charset="-120"/>
+              </a:rPr>
+              <a:t>‫ת.ז. ______________‬</a:t>
+            </a:r>
+            <a:endParaRPr lang="en-US" sz="1500" dirty="0"/>
+          </a:p>
+        </p:txBody>
+      </p:sp>
+      <p:sp>
+        <p:nvSpPr>
+          <p:cNvPr id="10" name="Text 7"/>
+          <p:cNvSpPr txBox="1"/>
+          <p:nvPr/>
+        </p:nvSpPr>
+        <p:spPr>
+          <a:xfrm>
+            <a:off x="2377440" y="5120640"/>
+            <a:ext cx="2651760" cy="960120"/>
           </a:xfrm>
           <a:prstGeom prst="rect">
             <a:avLst/>

</xml_diff>

<commit_message>
Rename presenter to Hanin; support ID numbers from an ignored file
The cover reads ID numbers from presentation/ids.json via IDS_FILE, which
is gitignored, so the committed deck keeps blank ID fields.

Co-Authored-By: Claude Opus 5.5 <noreply@anthropic.com>
Claude-Session: https://claude.ai/code/session_016buQrLRQHjtd4YGfeSnksc
</commit_message>
<xml_diff>
--- a/presentation/היעדרויות-מורים-מצגת-סיום.pptx
+++ b/presentation/היעדרויות-מורים-מצגת-סיום.pptx
@@ -508,8 +508,8 @@
             <a:pPr rtl="1"/>
             <a:r>
               <a:rPr lang="en-US" dirty="0"/>
-              <a:t>‫[חנון | כעשר שניות]
-שלום לכולם. אנחנו חנון מנסור ואולפת עבד אל חי, והמחקר שלנו עוסק באסטרטגיות ניהוליות של מנהלי בתי ספר בהתמודדות עם היעדרויות מורים לשמירה על רצף לימודי.‬</a:t>
+              <a:t>‫[חנין | כעשר שניות]
+שלום לכולם. אנחנו חנין מנסור ואולפת עבד אל חי, והמחקר שלנו עוסק באסטרטגיות ניהוליות של מנהלי בתי ספר בהתמודדות עם היעדרויות מורים לשמירה על רצף לימודי.‬</a:t>
             </a:r>
             <a:endParaRPr lang="en-US" dirty="0"/>
           </a:p>
@@ -598,7 +598,7 @@
             <a:pPr rtl="1"/>
             <a:r>
               <a:rPr lang="en-US" dirty="0"/>
-              <a:t>‫[חנון | כדקה]
+              <a:t>‫[חנין | כדקה]
 בוקר רגיל, שבע וחצי. מורה מתקשרת ומודיעה שלא תגיע היום. בתוך כמה דקות המנהל צריך להחליט מי נכנס לכיתה, מה יקרה בשיעור, ומה יהיה המחיר עבור הצוות.
 הנושא שלנו הוא היעדרויות מורים. ההיעדרות עצמה היא חלק מהחיים של כל בית ספר. מה שמעניין אותנו הוא ההחלטות שהיא מחייבת, ובמיוחד כשההיעדרויות מצטברות והמנהל צריך לשמור על רצף פדגוגי, ארגוני ורגשי.
 שאלת המחקר שלנו: כיצד מנהלי בתי ספר בערים בצפון הארץ מתארים את התמודדותם עם היעדרויות מורים, ואילו אסטרטגיות ושיקולים מנחים את החלטותיהם לשמירה על רצף לימודי?
@@ -698,7 +698,7 @@
 מה שהפתיע אותנו הוא המחקר של שפירא־לישצ'ינסקי ורוזנבלט. הם מצאו שהאקלים האתי בבית הספר קשור להיקף ההיעדרויות מרצון. כלומר, המנהל משפיע על התופעה עוד לפני שהיא מתרחשת.
 ואיפה המתח? רוב המחקרים בודקים כמה מורים נעדרים, למה, ומה המחיר. בתיאוריה רצף לימודי הוא עניין פדגוגי, אבל בשבע וחצי בבוקר המנהל צריך קודם כול שמישהו יהיה בכיתה. מעט ידוע על מה שהמנהל שוקל ברגע הזה.
 הקריאה שינתה גם את החשיבה שלנו. בהתחלה חשבנו שהבעיה לוגיסטית, רק למצוא ממלא מקום. היום אנחנו מבינים שרצף הוא פדגוגי, ארגוני ורגשי, ושהמנהל פועל גם לפני ההיעדרות.
-[מעבר לחנון]
+[מעבר לחנין]
 [רשימת מקורות, למקרה של שאלה]
 הלוי, ל' (2026). המבוא בעבודה סמינריונית איכותנית [מצגת הרצאה]. סמינריון בעבודת הניהול ובמנהל חינוך, הקריה האקדמית אונו.
 Clotfelter, C. T., Ladd, H. F., &amp; Vigdor, J. L. (2009). Are teacher absences worth worrying about in the United States? Education Finance and Policy, 4(2), 115-149.
@@ -792,7 +792,7 @@
             <a:pPr rtl="1"/>
             <a:r>
               <a:rPr lang="en-US" dirty="0"/>
-              <a:t>‫[חנון | כחמישים שניות]
+              <a:t>‫[חנין | כחמישים שניות]
 כך נראית המסגרת המושגית שלנו, מימין לשמאל.
 היא מתחילה בהיעדרות מורים ועוברת אל המושג המרכזי, רצף לימודי. אנחנו מבינים את הרצף בשלושה ממדים. פדגוגי, כלומר שהתוכן והלמידה ממשיכים. ארגוני, כלומר שיבוץ, מערכת שעות, והעומס על הצוות שמחליף. ורגשי, כלומר שהתלמידים נשארים עם מבוגר מוכר ומרגישים ביטחון.
 הרצף הזה תלוי בקבלת החלטות ניהולית. המנהל שוקל צרכים מתחרים, בזמן קצר ובמשאבים מוגבלים. מתוך ההחלטות נגזרות אסטרטגיות מגיבות, כמו ממלא מקום או איחוד כיתות, ואסטרטגיות מונעות, כמו מאגר קבוע של ממלאי מקום וחומרי עבודה מוכנים מראש. את החוליה האחרונה הזאת, איך זה קורה בשטח, אנחנו רוצים לחקור.
@@ -889,7 +889,7 @@
 איך נבדוק את זה? נשוחח עם 12 מנהלים ומנהלות של בתי ספר יסודיים ועל־יסודיים בערים בצפון הארץ, עם ותק שונה. בחרנו במנהלים כי הם מקבלי ההחלטות בעת היעדרות, ובחרנו בערים כדי לבחון את התופעה בהקשר אחיד ולהשוות בין ערים שונות.
 הכלי שלנו הוא ראיון חצי מובנה. נפתח בשאלות רקע על בית הספר ועל הצוות, ואחר כך נבקש מכל מנהל לתאר את הבוקר האחרון שבו מורה נעדר, צעד אחר צעד, ולספר גם על היעדרות ממושכת. כך נשמע את השיקולים ואת הדילמות, ולא רק את הנוהל הכתוב. את הראיונות ננתח בניתוח תמטי.
 ונקפיד על אתיקה: הסכמה מדעת, הקלטה רק באישור, ואנונימיות מלאה.
-[מעבר לחנון]‬</a:t>
+[מעבר לחנין]‬</a:t>
             </a:r>
             <a:endParaRPr lang="en-US" dirty="0"/>
           </a:p>
@@ -978,7 +978,7 @@
             <a:pPr rtl="1"/>
             <a:r>
               <a:rPr lang="en-US" dirty="0"/>
-              <a:t>‫[חנון | כארבעים שניות]
+              <a:t>‫[חנין | כארבעים שניות]
 מה נחפש בראיונות? אסטרטגיות מונעות לעומת מגיבות, הבדלים בין היעדרות קצרה לממושכת, ואת האיזון בין פדגוגיה, תקציב, הוגנות כלפי הצוות שמחליף, ורווחת המורה הנעדר.
 האתגר הגדול: מנהלים עלולים להציג תמונה יפה מהמציאות, ולכן נבקש דוגמאות מוחשיות. וגם לא יהיה פשוט למצוא זמן ביומן של מנהלים.
 ומה יפתיע אותנו? אם יתברר שמה שמנחה את ההחלטות הוא בעיקר השקט והסדר בבית הספר ולא הרצף הלימודי. זה יערער הנחה שלנו.
@@ -1652,7 +1652,7 @@
                 <a:ea typeface="Arial" pitchFamily="34" charset="-122"/>
                 <a:cs typeface="Arial" pitchFamily="34" charset="-120"/>
               </a:rPr>
-              <a:t>‫חנון מנסור‬</a:t>
+              <a:t>‫חנין מנסור‬</a:t>
             </a:r>
             <a:endParaRPr lang="en-US" sz="1500" dirty="0"/>
           </a:p>

</xml_diff>

<commit_message>
Cover: place presenter rows at fixed positions
Each name, ID and lecturer line is its own single-line box, so mobile
viewers no longer drop the heading onto the ID lines. Heading now reads
"מוגש על ידי".

Co-Authored-By: Claude Opus 5.5 <noreply@anthropic.com>
Claude-Session: https://claude.ai/code/session_016buQrLRQHjtd4YGfeSnksc
</commit_message>
<xml_diff>
--- a/presentation/היעדרויות-מורים-מצגת-סיום.pptx
+++ b/presentation/היעדרויות-מורים-מצגת-סיום.pptx
@@ -1537,17 +1537,17 @@
         </p:nvSpPr>
         <p:spPr>
           <a:xfrm>
-            <a:off x="5257800" y="5120640"/>
-            <a:ext cx="4572000" cy="960120"/>
-          </a:xfrm>
-          <a:prstGeom prst="rect">
-            <a:avLst/>
-          </a:prstGeom>
-          <a:noFill/>
-          <a:ln/>
-        </p:spPr>
-        <p:txBody>
-          <a:bodyPr wrap="square" lIns="0" tIns="0" rIns="0" bIns="0" rtlCol="0" anchor="ctr"/>
+            <a:off x="5257800" y="5138928"/>
+            <a:ext cx="4572000" cy="292608"/>
+          </a:xfrm>
+          <a:prstGeom prst="rect">
+            <a:avLst/>
+          </a:prstGeom>
+          <a:noFill/>
+          <a:ln/>
+        </p:spPr>
+        <p:txBody>
+          <a:bodyPr wrap="square" lIns="0" tIns="0" rIns="0" bIns="0" rtlCol="0" anchor="t"/>
           <a:lstStyle/>
           <a:p>
             <a:pPr algn="ctr" indent="0" marL="0" rtl="1">
@@ -1562,12 +1562,34 @@
                 <a:ea typeface="Arial" pitchFamily="34" charset="-122"/>
                 <a:cs typeface="Arial" pitchFamily="34" charset="-120"/>
               </a:rPr>
-              <a:t>‫הוגש על ידי‬</a:t>
+              <a:t>‫מוגש על ידי‬</a:t>
             </a:r>
             <a:endParaRPr lang="en-US" sz="1500" dirty="0"/>
           </a:p>
-          <a:p>
-            <a:pPr algn="ctr" indent="0" marL="0">
+        </p:txBody>
+      </p:sp>
+      <p:sp>
+        <p:nvSpPr>
+          <p:cNvPr id="8" name="Text 5"/>
+          <p:cNvSpPr txBox="1"/>
+          <p:nvPr/>
+        </p:nvSpPr>
+        <p:spPr>
+          <a:xfrm>
+            <a:off x="8001000" y="5458968"/>
+            <a:ext cx="1691640" cy="292608"/>
+          </a:xfrm>
+          <a:prstGeom prst="rect">
+            <a:avLst/>
+          </a:prstGeom>
+          <a:noFill/>
+          <a:ln/>
+        </p:spPr>
+        <p:txBody>
+          <a:bodyPr wrap="square" lIns="0" tIns="0" rIns="0" bIns="0" rtlCol="0" anchor="t"/>
+          <a:lstStyle/>
+          <a:p>
+            <a:pPr algn="r" indent="0" marL="0" rtl="1">
               <a:buNone/>
             </a:pPr>
             <a:r>
@@ -1579,12 +1601,34 @@
                 <a:ea typeface="Arial" pitchFamily="34" charset="-122"/>
                 <a:cs typeface="Arial" pitchFamily="34" charset="-120"/>
               </a:rPr>
-              <a:t> </a:t>
+              <a:t>‫חנין מנסור‬</a:t>
             </a:r>
             <a:endParaRPr lang="en-US" sz="1500" dirty="0"/>
           </a:p>
-          <a:p>
-            <a:pPr algn="ctr" indent="0" marL="0">
+        </p:txBody>
+      </p:sp>
+      <p:sp>
+        <p:nvSpPr>
+          <p:cNvPr id="9" name="Text 6"/>
+          <p:cNvSpPr txBox="1"/>
+          <p:nvPr/>
+        </p:nvSpPr>
+        <p:spPr>
+          <a:xfrm>
+            <a:off x="8001000" y="5760720"/>
+            <a:ext cx="1691640" cy="292608"/>
+          </a:xfrm>
+          <a:prstGeom prst="rect">
+            <a:avLst/>
+          </a:prstGeom>
+          <a:noFill/>
+          <a:ln/>
+        </p:spPr>
+        <p:txBody>
+          <a:bodyPr wrap="square" lIns="0" tIns="0" rIns="0" bIns="0" rtlCol="0" anchor="t"/>
+          <a:lstStyle/>
+          <a:p>
+            <a:pPr algn="r" indent="0" marL="0" rtl="1">
               <a:buNone/>
             </a:pPr>
             <a:r>
@@ -1596,7 +1640,7 @@
                 <a:ea typeface="Arial" pitchFamily="34" charset="-122"/>
                 <a:cs typeface="Arial" pitchFamily="34" charset="-120"/>
               </a:rPr>
-              <a:t> </a:t>
+              <a:t>‫אולפת עבד אל חי‬</a:t>
             </a:r>
             <a:endParaRPr lang="en-US" sz="1500" dirty="0"/>
           </a:p>
@@ -1604,26 +1648,26 @@
       </p:sp>
       <p:sp>
         <p:nvSpPr>
-          <p:cNvPr id="8" name="Text 5"/>
-          <p:cNvSpPr txBox="1"/>
-          <p:nvPr/>
-        </p:nvSpPr>
-        <p:spPr>
-          <a:xfrm>
-            <a:off x="8001000" y="5120640"/>
-            <a:ext cx="1691640" cy="960120"/>
-          </a:xfrm>
-          <a:prstGeom prst="rect">
-            <a:avLst/>
-          </a:prstGeom>
-          <a:noFill/>
-          <a:ln/>
-        </p:spPr>
-        <p:txBody>
-          <a:bodyPr wrap="square" lIns="0" tIns="0" rIns="0" bIns="0" rtlCol="0" anchor="ctr"/>
-          <a:lstStyle/>
-          <a:p>
-            <a:pPr algn="r" indent="0" marL="0">
+          <p:cNvPr id="10" name="Text 7"/>
+          <p:cNvSpPr txBox="1"/>
+          <p:nvPr/>
+        </p:nvSpPr>
+        <p:spPr>
+          <a:xfrm>
+            <a:off x="5852160" y="5458968"/>
+            <a:ext cx="2011680" cy="292608"/>
+          </a:xfrm>
+          <a:prstGeom prst="rect">
+            <a:avLst/>
+          </a:prstGeom>
+          <a:noFill/>
+          <a:ln/>
+        </p:spPr>
+        <p:txBody>
+          <a:bodyPr wrap="square" lIns="0" tIns="0" rIns="0" bIns="0" rtlCol="0" anchor="t"/>
+          <a:lstStyle/>
+          <a:p>
+            <a:pPr algn="r" indent="0" marL="0" rtl="1">
               <a:buNone/>
             </a:pPr>
             <a:r>
@@ -1635,10 +1679,32 @@
                 <a:ea typeface="Arial" pitchFamily="34" charset="-122"/>
                 <a:cs typeface="Arial" pitchFamily="34" charset="-120"/>
               </a:rPr>
-              <a:t> </a:t>
+              <a:t>‫ת.ז. ______________‬</a:t>
             </a:r>
             <a:endParaRPr lang="en-US" sz="1500" dirty="0"/>
           </a:p>
+        </p:txBody>
+      </p:sp>
+      <p:sp>
+        <p:nvSpPr>
+          <p:cNvPr id="11" name="Text 8"/>
+          <p:cNvSpPr txBox="1"/>
+          <p:nvPr/>
+        </p:nvSpPr>
+        <p:spPr>
+          <a:xfrm>
+            <a:off x="5852160" y="5760720"/>
+            <a:ext cx="2011680" cy="292608"/>
+          </a:xfrm>
+          <a:prstGeom prst="rect">
+            <a:avLst/>
+          </a:prstGeom>
+          <a:noFill/>
+          <a:ln/>
+        </p:spPr>
+        <p:txBody>
+          <a:bodyPr wrap="square" lIns="0" tIns="0" rIns="0" bIns="0" rtlCol="0" anchor="t"/>
+          <a:lstStyle/>
           <a:p>
             <a:pPr algn="r" indent="0" marL="0" rtl="1">
               <a:buNone/>
@@ -1652,12 +1718,73 @@
                 <a:ea typeface="Arial" pitchFamily="34" charset="-122"/>
                 <a:cs typeface="Arial" pitchFamily="34" charset="-120"/>
               </a:rPr>
-              <a:t>‫חנין מנסור‬</a:t>
+              <a:t>‫ת.ז. ______________‬</a:t>
             </a:r>
             <a:endParaRPr lang="en-US" sz="1500" dirty="0"/>
           </a:p>
-          <a:p>
-            <a:pPr algn="r" indent="0" marL="0" rtl="1">
+        </p:txBody>
+      </p:sp>
+      <p:sp>
+        <p:nvSpPr>
+          <p:cNvPr id="12" name="Text 9"/>
+          <p:cNvSpPr txBox="1"/>
+          <p:nvPr/>
+        </p:nvSpPr>
+        <p:spPr>
+          <a:xfrm>
+            <a:off x="2377440" y="5138928"/>
+            <a:ext cx="2651760" cy="292608"/>
+          </a:xfrm>
+          <a:prstGeom prst="rect">
+            <a:avLst/>
+          </a:prstGeom>
+          <a:noFill/>
+          <a:ln/>
+        </p:spPr>
+        <p:txBody>
+          <a:bodyPr wrap="square" lIns="0" tIns="0" rIns="0" bIns="0" rtlCol="0" anchor="t"/>
+          <a:lstStyle/>
+          <a:p>
+            <a:pPr algn="ctr" indent="0" marL="0" rtl="1">
+              <a:buNone/>
+            </a:pPr>
+            <a:r>
+              <a:rPr lang="en-US" sz="1500" b="1" dirty="0">
+                <a:solidFill>
+                  <a:srgbClr val="12343B"/>
+                </a:solidFill>
+                <a:latin typeface="Arial" pitchFamily="34" charset="0"/>
+                <a:ea typeface="Arial" pitchFamily="34" charset="-122"/>
+                <a:cs typeface="Arial" pitchFamily="34" charset="-120"/>
+              </a:rPr>
+              <a:t>‫המרצה‬</a:t>
+            </a:r>
+            <a:endParaRPr lang="en-US" sz="1500" dirty="0"/>
+          </a:p>
+        </p:txBody>
+      </p:sp>
+      <p:sp>
+        <p:nvSpPr>
+          <p:cNvPr id="13" name="Text 10"/>
+          <p:cNvSpPr txBox="1"/>
+          <p:nvPr/>
+        </p:nvSpPr>
+        <p:spPr>
+          <a:xfrm>
+            <a:off x="2377440" y="5458968"/>
+            <a:ext cx="2651760" cy="292608"/>
+          </a:xfrm>
+          <a:prstGeom prst="rect">
+            <a:avLst/>
+          </a:prstGeom>
+          <a:noFill/>
+          <a:ln/>
+        </p:spPr>
+        <p:txBody>
+          <a:bodyPr wrap="square" lIns="0" tIns="0" rIns="0" bIns="0" rtlCol="0" anchor="t"/>
+          <a:lstStyle/>
+          <a:p>
+            <a:pPr algn="ctr" indent="0" marL="0" rtl="1">
               <a:buNone/>
             </a:pPr>
             <a:r>
@@ -1669,7 +1796,7 @@
                 <a:ea typeface="Arial" pitchFamily="34" charset="-122"/>
                 <a:cs typeface="Arial" pitchFamily="34" charset="-120"/>
               </a:rPr>
-              <a:t>‫אולפת עבד אל חי‬</a:t>
+              <a:t>‫ד״ר ליאור הלוי‬</a:t>
             </a:r>
             <a:endParaRPr lang="en-US" sz="1500" dirty="0"/>
           </a:p>
@@ -1677,131 +1804,24 @@
       </p:sp>
       <p:sp>
         <p:nvSpPr>
-          <p:cNvPr id="9" name="Text 6"/>
-          <p:cNvSpPr txBox="1"/>
-          <p:nvPr/>
-        </p:nvSpPr>
-        <p:spPr>
-          <a:xfrm>
-            <a:off x="5852160" y="5120640"/>
-            <a:ext cx="2011680" cy="960120"/>
-          </a:xfrm>
-          <a:prstGeom prst="rect">
-            <a:avLst/>
-          </a:prstGeom>
-          <a:noFill/>
-          <a:ln/>
-        </p:spPr>
-        <p:txBody>
-          <a:bodyPr wrap="square" lIns="0" tIns="0" rIns="0" bIns="0" rtlCol="0" anchor="ctr"/>
-          <a:lstStyle/>
-          <a:p>
-            <a:pPr algn="r" indent="0" marL="0">
-              <a:buNone/>
-            </a:pPr>
-            <a:r>
-              <a:rPr lang="en-US" sz="1500" dirty="0">
-                <a:solidFill>
-                  <a:srgbClr val="1B2B2E"/>
-                </a:solidFill>
-                <a:latin typeface="Arial" pitchFamily="34" charset="0"/>
-                <a:ea typeface="Arial" pitchFamily="34" charset="-122"/>
-                <a:cs typeface="Arial" pitchFamily="34" charset="-120"/>
-              </a:rPr>
-              <a:t> </a:t>
-            </a:r>
-            <a:endParaRPr lang="en-US" sz="1500" dirty="0"/>
-          </a:p>
-          <a:p>
-            <a:pPr algn="r" indent="0" marL="0" rtl="1">
-              <a:buNone/>
-            </a:pPr>
-            <a:r>
-              <a:rPr lang="en-US" sz="1500" dirty="0">
-                <a:solidFill>
-                  <a:srgbClr val="1B2B2E"/>
-                </a:solidFill>
-                <a:latin typeface="Arial" pitchFamily="34" charset="0"/>
-                <a:ea typeface="Arial" pitchFamily="34" charset="-122"/>
-                <a:cs typeface="Arial" pitchFamily="34" charset="-120"/>
-              </a:rPr>
-              <a:t>‫ת.ז. ______________‬</a:t>
-            </a:r>
-            <a:endParaRPr lang="en-US" sz="1500" dirty="0"/>
-          </a:p>
-          <a:p>
-            <a:pPr algn="r" indent="0" marL="0" rtl="1">
-              <a:buNone/>
-            </a:pPr>
-            <a:r>
-              <a:rPr lang="en-US" sz="1500" dirty="0">
-                <a:solidFill>
-                  <a:srgbClr val="1B2B2E"/>
-                </a:solidFill>
-                <a:latin typeface="Arial" pitchFamily="34" charset="0"/>
-                <a:ea typeface="Arial" pitchFamily="34" charset="-122"/>
-                <a:cs typeface="Arial" pitchFamily="34" charset="-120"/>
-              </a:rPr>
-              <a:t>‫ת.ז. ______________‬</a:t>
-            </a:r>
-            <a:endParaRPr lang="en-US" sz="1500" dirty="0"/>
-          </a:p>
-        </p:txBody>
-      </p:sp>
-      <p:sp>
-        <p:nvSpPr>
-          <p:cNvPr id="10" name="Text 7"/>
-          <p:cNvSpPr txBox="1"/>
-          <p:nvPr/>
-        </p:nvSpPr>
-        <p:spPr>
-          <a:xfrm>
-            <a:off x="2377440" y="5120640"/>
-            <a:ext cx="2651760" cy="960120"/>
-          </a:xfrm>
-          <a:prstGeom prst="rect">
-            <a:avLst/>
-          </a:prstGeom>
-          <a:noFill/>
-          <a:ln/>
-        </p:spPr>
-        <p:txBody>
-          <a:bodyPr wrap="square" lIns="0" tIns="0" rIns="0" bIns="0" rtlCol="0" anchor="ctr"/>
-          <a:lstStyle/>
-          <a:p>
-            <a:pPr algn="ctr" indent="0" marL="0" rtl="1">
-              <a:buNone/>
-            </a:pPr>
-            <a:r>
-              <a:rPr lang="en-US" sz="1500" b="1" dirty="0">
-                <a:solidFill>
-                  <a:srgbClr val="12343B"/>
-                </a:solidFill>
-                <a:latin typeface="Arial" pitchFamily="34" charset="0"/>
-                <a:ea typeface="Arial" pitchFamily="34" charset="-122"/>
-                <a:cs typeface="Arial" pitchFamily="34" charset="-120"/>
-              </a:rPr>
-              <a:t>‫המרצה‬</a:t>
-            </a:r>
-            <a:endParaRPr lang="en-US" sz="1500" dirty="0"/>
-          </a:p>
-          <a:p>
-            <a:pPr algn="ctr" indent="0" marL="0" rtl="1">
-              <a:buNone/>
-            </a:pPr>
-            <a:r>
-              <a:rPr lang="en-US" sz="1500" dirty="0">
-                <a:solidFill>
-                  <a:srgbClr val="1B2B2E"/>
-                </a:solidFill>
-                <a:latin typeface="Arial" pitchFamily="34" charset="0"/>
-                <a:ea typeface="Arial" pitchFamily="34" charset="-122"/>
-                <a:cs typeface="Arial" pitchFamily="34" charset="-120"/>
-              </a:rPr>
-              <a:t>‫ד״ר ליאור הלוי‬</a:t>
-            </a:r>
-            <a:endParaRPr lang="en-US" sz="1500" dirty="0"/>
-          </a:p>
+          <p:cNvPr id="14" name="Text 11"/>
+          <p:cNvSpPr txBox="1"/>
+          <p:nvPr/>
+        </p:nvSpPr>
+        <p:spPr>
+          <a:xfrm>
+            <a:off x="2377440" y="5760720"/>
+            <a:ext cx="2651760" cy="292608"/>
+          </a:xfrm>
+          <a:prstGeom prst="rect">
+            <a:avLst/>
+          </a:prstGeom>
+          <a:noFill/>
+          <a:ln/>
+        </p:spPr>
+        <p:txBody>
+          <a:bodyPr wrap="square" lIns="0" tIns="0" rIns="0" bIns="0" rtlCol="0" anchor="t"/>
+          <a:lstStyle/>
           <a:p>
             <a:pPr algn="ctr" indent="0" marL="0" rtl="1">
               <a:buNone/>

</xml_diff>